<commit_message>
Add bottom padding to 102 cards
</commit_message>
<xml_diff>
--- a/presentations/102/deck/102-agent-harnesses.pptx
+++ b/presentations/102/deck/102-agent-harnesses.pptx
@@ -2,25 +2,25 @@
 <file path=ppt/presentation.xml><?xml version="1.0" encoding="utf-8"?>
 <p:presentation xmlns:p="http://schemas.openxmlformats.org/presentationml/2006/main">
   <p:sldMasterIdLst>
-    <p:sldMasterId xmlns:r="http://schemas.openxmlformats.org/officeDocument/2006/relationships" id="2147483648" r:id="R64d1935c4f4b41d6"/>
+    <p:sldMasterId xmlns:r="http://schemas.openxmlformats.org/officeDocument/2006/relationships" id="2147483648" r:id="R5b72697af73149f2"/>
   </p:sldMasterIdLst>
   <p:notesMasterIdLst>
-    <p:notesMasterId xmlns:r="http://schemas.openxmlformats.org/officeDocument/2006/relationships" r:id="R26a9b8588b5a4099"/>
+    <p:notesMasterId xmlns:r="http://schemas.openxmlformats.org/officeDocument/2006/relationships" r:id="Rbb83dfaec97b40f4"/>
   </p:notesMasterIdLst>
   <p:sldIdLst>
-    <p:sldId xmlns:r="http://schemas.openxmlformats.org/officeDocument/2006/relationships" id="256" r:id="R47aaeb746eac4eb8"/>
-    <p:sldId xmlns:r="http://schemas.openxmlformats.org/officeDocument/2006/relationships" id="257" r:id="R9950e4b5b237480e"/>
-    <p:sldId xmlns:r="http://schemas.openxmlformats.org/officeDocument/2006/relationships" id="258" r:id="Re4ad87b423874e17"/>
-    <p:sldId xmlns:r="http://schemas.openxmlformats.org/officeDocument/2006/relationships" id="259" r:id="Rb3b79f07c027480f"/>
-    <p:sldId xmlns:r="http://schemas.openxmlformats.org/officeDocument/2006/relationships" id="260" r:id="R2e7bde66128644e1"/>
-    <p:sldId xmlns:r="http://schemas.openxmlformats.org/officeDocument/2006/relationships" id="261" r:id="Rce902e633f3e49f8"/>
-    <p:sldId xmlns:r="http://schemas.openxmlformats.org/officeDocument/2006/relationships" id="262" r:id="Rdbec3ba59dd7425f"/>
-    <p:sldId xmlns:r="http://schemas.openxmlformats.org/officeDocument/2006/relationships" id="263" r:id="Rc59082b245a9468b"/>
-    <p:sldId xmlns:r="http://schemas.openxmlformats.org/officeDocument/2006/relationships" id="264" r:id="Re7801b6af5ce463d"/>
-    <p:sldId xmlns:r="http://schemas.openxmlformats.org/officeDocument/2006/relationships" id="265" r:id="R58dbb80e12694022"/>
-    <p:sldId xmlns:r="http://schemas.openxmlformats.org/officeDocument/2006/relationships" id="266" r:id="R00169ecd22844705"/>
-    <p:sldId xmlns:r="http://schemas.openxmlformats.org/officeDocument/2006/relationships" id="267" r:id="R36e3bebe99c844ec"/>
-    <p:sldId xmlns:r="http://schemas.openxmlformats.org/officeDocument/2006/relationships" id="268" r:id="R18c87c1f26cf46f1"/>
+    <p:sldId xmlns:r="http://schemas.openxmlformats.org/officeDocument/2006/relationships" id="256" r:id="R2df93340bec14a1c"/>
+    <p:sldId xmlns:r="http://schemas.openxmlformats.org/officeDocument/2006/relationships" id="257" r:id="Raaefcf21252f4787"/>
+    <p:sldId xmlns:r="http://schemas.openxmlformats.org/officeDocument/2006/relationships" id="258" r:id="R4d21f001e70c4922"/>
+    <p:sldId xmlns:r="http://schemas.openxmlformats.org/officeDocument/2006/relationships" id="259" r:id="R0508566a458d4e94"/>
+    <p:sldId xmlns:r="http://schemas.openxmlformats.org/officeDocument/2006/relationships" id="260" r:id="Rca5f3e383f174e67"/>
+    <p:sldId xmlns:r="http://schemas.openxmlformats.org/officeDocument/2006/relationships" id="261" r:id="R44630132503143f5"/>
+    <p:sldId xmlns:r="http://schemas.openxmlformats.org/officeDocument/2006/relationships" id="262" r:id="R10dfbb18997e4b60"/>
+    <p:sldId xmlns:r="http://schemas.openxmlformats.org/officeDocument/2006/relationships" id="263" r:id="R7521f5715f474167"/>
+    <p:sldId xmlns:r="http://schemas.openxmlformats.org/officeDocument/2006/relationships" id="264" r:id="R27219817188d4589"/>
+    <p:sldId xmlns:r="http://schemas.openxmlformats.org/officeDocument/2006/relationships" id="265" r:id="R701a0a9ee44f451e"/>
+    <p:sldId xmlns:r="http://schemas.openxmlformats.org/officeDocument/2006/relationships" id="266" r:id="R1fd7a082d49a47b4"/>
+    <p:sldId xmlns:r="http://schemas.openxmlformats.org/officeDocument/2006/relationships" id="267" r:id="R6d1de94901464749"/>
+    <p:sldId xmlns:r="http://schemas.openxmlformats.org/officeDocument/2006/relationships" id="268" r:id="R0e62b67f279342a1"/>
   </p:sldIdLst>
   <p:sldSz cx="12192000" cy="6858000"/>
   <p:notesSz cx="6858000" cy="9144000"/>
@@ -1359,7 +1359,7 @@
   </p:cSld>
   <p:clrMap bg1="lt1" tx1="dk1" bg2="lt2" tx2="dk2" accent1="accent1" accent2="accent2" accent3="accent3" accent4="accent4" accent5="accent5" accent6="accent6" hlink="hlink" folHlink="folHlink"/>
   <p:sldLayoutIdLst>
-    <p:sldLayoutId xmlns:r="http://schemas.openxmlformats.org/officeDocument/2006/relationships" id="2147483649" r:id="R00536ff49bfc4723"/>
+    <p:sldLayoutId xmlns:r="http://schemas.openxmlformats.org/officeDocument/2006/relationships" id="2147483649" r:id="Rc64afb9ed6b4421c"/>
   </p:sldLayoutIdLst>
   <p:txStyles>
     <p:titleStyle>
@@ -1662,7 +1662,7 @@
           <p:nvPr/>
         </p:nvPicPr>
         <p:blipFill>
-          <a:blip xmlns:r="http://schemas.openxmlformats.org/officeDocument/2006/relationships" xmlns:a="http://schemas.openxmlformats.org/drawingml/2006/main" r:embed="Raa10c03cc9684c31"/>
+          <a:blip xmlns:r="http://schemas.openxmlformats.org/officeDocument/2006/relationships" xmlns:a="http://schemas.openxmlformats.org/drawingml/2006/main" r:embed="R6a04bd021bac4df6"/>
           <a:srcRect xmlns:a="http://schemas.openxmlformats.org/drawingml/2006/main" l="1515" t="0" r="1515" b="0"/>
           <a:stretch xmlns:a="http://schemas.openxmlformats.org/drawingml/2006/main">
             <a:fillRect l="0" t="0" r="0" b="0"/>
@@ -1683,7 +1683,7 @@
           <p:cNvPr id="2" name="">
             <a:extLst xmlns:a="http://schemas.openxmlformats.org/drawingml/2006/main">
               <a:ext uri="{FF2B5EF4-FFF2-40B4-BE49-F238E27FC236}">
-                <a16:creationId xmlns:a16="http://schemas.microsoft.com/office/drawing/2014/main" id="{1E39EB98-74FD-4315-B950-D5D471FC562E}"/>
+                <a16:creationId xmlns:a16="http://schemas.microsoft.com/office/drawing/2014/main" id="{D3DF54C6-3C97-491A-9405-EAB2289FC582}"/>
               </a:ext>
             </a:extLst>
           </p:cNvPr>
@@ -1715,7 +1715,7 @@
           <p:cNvPr id="3" name="">
             <a:extLst xmlns:a="http://schemas.openxmlformats.org/drawingml/2006/main">
               <a:ext uri="{FF2B5EF4-FFF2-40B4-BE49-F238E27FC236}">
-                <a16:creationId xmlns:a16="http://schemas.microsoft.com/office/drawing/2014/main" id="{91ABCF90-17C1-4196-BB2D-0BD9D4B9BCBF}"/>
+                <a16:creationId xmlns:a16="http://schemas.microsoft.com/office/drawing/2014/main" id="{8C4399DB-5F46-4AC6-BFC0-390910063908}"/>
               </a:ext>
             </a:extLst>
           </p:cNvPr>
@@ -1749,7 +1749,7 @@
           <p:cNvPr id="4" name="">
             <a:extLst xmlns:a="http://schemas.openxmlformats.org/drawingml/2006/main">
               <a:ext uri="{FF2B5EF4-FFF2-40B4-BE49-F238E27FC236}">
-                <a16:creationId xmlns:a16="http://schemas.microsoft.com/office/drawing/2014/main" id="{EAF3EFB6-83B6-461D-82B3-70B261A440E9}"/>
+                <a16:creationId xmlns:a16="http://schemas.microsoft.com/office/drawing/2014/main" id="{BB678A96-EBF4-46BD-B65C-38EBDBA0ED35}"/>
               </a:ext>
             </a:extLst>
           </p:cNvPr>
@@ -1779,7 +1779,7 @@
           <p:cNvPr id="5" name="">
             <a:extLst xmlns:a="http://schemas.openxmlformats.org/drawingml/2006/main">
               <a:ext uri="{FF2B5EF4-FFF2-40B4-BE49-F238E27FC236}">
-                <a16:creationId xmlns:a16="http://schemas.microsoft.com/office/drawing/2014/main" id="{4E7EDF2D-4CEE-4F69-8AD0-512EB198D5BA}"/>
+                <a16:creationId xmlns:a16="http://schemas.microsoft.com/office/drawing/2014/main" id="{F3CBE953-B345-44DA-9F01-12F7BAEEC306}"/>
               </a:ext>
             </a:extLst>
           </p:cNvPr>
@@ -1811,7 +1811,7 @@
           <p:cNvPr id="6" name="">
             <a:extLst xmlns:a="http://schemas.openxmlformats.org/drawingml/2006/main">
               <a:ext uri="{FF2B5EF4-FFF2-40B4-BE49-F238E27FC236}">
-                <a16:creationId xmlns:a16="http://schemas.microsoft.com/office/drawing/2014/main" id="{68960400-4E25-4551-AA12-C03AD644CC53}"/>
+                <a16:creationId xmlns:a16="http://schemas.microsoft.com/office/drawing/2014/main" id="{15475C81-F0DE-4436-9854-A197FDD0BD14}"/>
               </a:ext>
             </a:extLst>
           </p:cNvPr>
@@ -1841,7 +1841,7 @@
           <p:cNvPr id="7" name="">
             <a:extLst xmlns:a="http://schemas.openxmlformats.org/drawingml/2006/main">
               <a:ext uri="{FF2B5EF4-FFF2-40B4-BE49-F238E27FC236}">
-                <a16:creationId xmlns:a16="http://schemas.microsoft.com/office/drawing/2014/main" id="{D805317A-E7EB-4466-AA30-A152547C0156}"/>
+                <a16:creationId xmlns:a16="http://schemas.microsoft.com/office/drawing/2014/main" id="{99B7DDF9-9D1B-4733-ADC3-525F0E72C33B}"/>
               </a:ext>
             </a:extLst>
           </p:cNvPr>
@@ -1900,7 +1900,7 @@
           <p:cNvPr id="8" name="">
             <a:extLst xmlns:a="http://schemas.openxmlformats.org/drawingml/2006/main">
               <a:ext uri="{FF2B5EF4-FFF2-40B4-BE49-F238E27FC236}">
-                <a16:creationId xmlns:a16="http://schemas.microsoft.com/office/drawing/2014/main" id="{FE220DE9-CA87-4C36-B03F-E28692826407}"/>
+                <a16:creationId xmlns:a16="http://schemas.microsoft.com/office/drawing/2014/main" id="{4067A2AC-A4D9-4D3E-BD43-BFB2BFA6A3D8}"/>
               </a:ext>
             </a:extLst>
           </p:cNvPr>
@@ -1959,7 +1959,7 @@
           <p:cNvPr id="9" name="">
             <a:extLst xmlns:a="http://schemas.openxmlformats.org/drawingml/2006/main">
               <a:ext uri="{FF2B5EF4-FFF2-40B4-BE49-F238E27FC236}">
-                <a16:creationId xmlns:a16="http://schemas.microsoft.com/office/drawing/2014/main" id="{B46DB703-FE1F-4039-AFA7-27213323E689}"/>
+                <a16:creationId xmlns:a16="http://schemas.microsoft.com/office/drawing/2014/main" id="{65770A46-F5C6-40B2-8A15-299184185C53}"/>
               </a:ext>
             </a:extLst>
           </p:cNvPr>
@@ -2018,7 +2018,7 @@
           <p:cNvPr id="10" name="">
             <a:extLst xmlns:a="http://schemas.openxmlformats.org/drawingml/2006/main">
               <a:ext uri="{FF2B5EF4-FFF2-40B4-BE49-F238E27FC236}">
-                <a16:creationId xmlns:a16="http://schemas.microsoft.com/office/drawing/2014/main" id="{EB555E58-864B-4D05-8216-AD05F52D6AE8}"/>
+                <a16:creationId xmlns:a16="http://schemas.microsoft.com/office/drawing/2014/main" id="{519FA876-9F51-4672-B590-4A9C4BAFA801}"/>
               </a:ext>
             </a:extLst>
           </p:cNvPr>
@@ -2050,7 +2050,7 @@
           <p:cNvPr id="11" name="">
             <a:extLst xmlns:a="http://schemas.openxmlformats.org/drawingml/2006/main">
               <a:ext uri="{FF2B5EF4-FFF2-40B4-BE49-F238E27FC236}">
-                <a16:creationId xmlns:a16="http://schemas.microsoft.com/office/drawing/2014/main" id="{59305750-9A76-4D88-A350-5206C5A5A017}"/>
+                <a16:creationId xmlns:a16="http://schemas.microsoft.com/office/drawing/2014/main" id="{E0FA484D-2400-4A93-89EC-006AE7A3CA4C}"/>
               </a:ext>
             </a:extLst>
           </p:cNvPr>
@@ -2109,7 +2109,7 @@
           <p:cNvPr id="12" name="">
             <a:extLst xmlns:a="http://schemas.openxmlformats.org/drawingml/2006/main">
               <a:ext uri="{FF2B5EF4-FFF2-40B4-BE49-F238E27FC236}">
-                <a16:creationId xmlns:a16="http://schemas.microsoft.com/office/drawing/2014/main" id="{06910CCC-CD8D-41AE-A518-98B0D1EEB3AF}"/>
+                <a16:creationId xmlns:a16="http://schemas.microsoft.com/office/drawing/2014/main" id="{CA233672-7BA1-44AD-AB1F-42E0F857C2F4}"/>
               </a:ext>
             </a:extLst>
           </p:cNvPr>
@@ -2141,7 +2141,7 @@
           <p:cNvPr id="13" name="">
             <a:extLst xmlns:a="http://schemas.openxmlformats.org/drawingml/2006/main">
               <a:ext uri="{FF2B5EF4-FFF2-40B4-BE49-F238E27FC236}">
-                <a16:creationId xmlns:a16="http://schemas.microsoft.com/office/drawing/2014/main" id="{9D3C9C82-7353-4AEE-89C6-AD7B20CA9491}"/>
+                <a16:creationId xmlns:a16="http://schemas.microsoft.com/office/drawing/2014/main" id="{50D18D25-5E76-4914-B56A-F6AA8102CB8A}"/>
               </a:ext>
             </a:extLst>
           </p:cNvPr>
@@ -2200,7 +2200,7 @@
           <p:cNvPr id="14" name="">
             <a:extLst xmlns:a="http://schemas.openxmlformats.org/drawingml/2006/main">
               <a:ext uri="{FF2B5EF4-FFF2-40B4-BE49-F238E27FC236}">
-                <a16:creationId xmlns:a16="http://schemas.microsoft.com/office/drawing/2014/main" id="{095DC7F9-0B94-4819-B2BE-BDC761A67F01}"/>
+                <a16:creationId xmlns:a16="http://schemas.microsoft.com/office/drawing/2014/main" id="{A8729CD5-C5B4-453A-9DA8-5C493070107C}"/>
               </a:ext>
             </a:extLst>
           </p:cNvPr>
@@ -2232,7 +2232,7 @@
           <p:cNvPr id="15" name="">
             <a:extLst xmlns:a="http://schemas.openxmlformats.org/drawingml/2006/main">
               <a:ext uri="{FF2B5EF4-FFF2-40B4-BE49-F238E27FC236}">
-                <a16:creationId xmlns:a16="http://schemas.microsoft.com/office/drawing/2014/main" id="{B9AE3CA8-A9D4-4745-8941-93A9A20E4F0F}"/>
+                <a16:creationId xmlns:a16="http://schemas.microsoft.com/office/drawing/2014/main" id="{07294463-A7FE-4C75-BD49-9EA7BB19F693}"/>
               </a:ext>
             </a:extLst>
           </p:cNvPr>
@@ -2291,7 +2291,7 @@
           <p:cNvPr id="16" name="">
             <a:extLst xmlns:a="http://schemas.openxmlformats.org/drawingml/2006/main">
               <a:ext uri="{FF2B5EF4-FFF2-40B4-BE49-F238E27FC236}">
-                <a16:creationId xmlns:a16="http://schemas.microsoft.com/office/drawing/2014/main" id="{A2DB1172-F79B-4A0B-9357-DB06B8C74B9F}"/>
+                <a16:creationId xmlns:a16="http://schemas.microsoft.com/office/drawing/2014/main" id="{37425FD6-45E6-41B1-B457-88E2D48E55FC}"/>
               </a:ext>
             </a:extLst>
           </p:cNvPr>
@@ -2323,7 +2323,7 @@
           <p:cNvPr id="17" name="">
             <a:extLst xmlns:a="http://schemas.openxmlformats.org/drawingml/2006/main">
               <a:ext uri="{FF2B5EF4-FFF2-40B4-BE49-F238E27FC236}">
-                <a16:creationId xmlns:a16="http://schemas.microsoft.com/office/drawing/2014/main" id="{493F6740-91C0-4084-B103-FAB1C52CB304}"/>
+                <a16:creationId xmlns:a16="http://schemas.microsoft.com/office/drawing/2014/main" id="{052E6703-91F2-453A-8A53-9F75487F86E7}"/>
               </a:ext>
             </a:extLst>
           </p:cNvPr>
@@ -2382,7 +2382,7 @@
           <p:cNvPr id="18" name="">
             <a:extLst xmlns:a="http://schemas.openxmlformats.org/drawingml/2006/main">
               <a:ext uri="{FF2B5EF4-FFF2-40B4-BE49-F238E27FC236}">
-                <a16:creationId xmlns:a16="http://schemas.microsoft.com/office/drawing/2014/main" id="{ECA6552A-B49C-4EE8-B718-35456B7E88D9}"/>
+                <a16:creationId xmlns:a16="http://schemas.microsoft.com/office/drawing/2014/main" id="{2AA6D311-549A-431F-B010-96790383599D}"/>
               </a:ext>
             </a:extLst>
           </p:cNvPr>
@@ -2441,7 +2441,7 @@
           <p:cNvPr id="19" name="">
             <a:extLst xmlns:a="http://schemas.openxmlformats.org/drawingml/2006/main">
               <a:ext uri="{FF2B5EF4-FFF2-40B4-BE49-F238E27FC236}">
-                <a16:creationId xmlns:a16="http://schemas.microsoft.com/office/drawing/2014/main" id="{83CE188B-D2EE-4B19-8754-5DC7CFE49F23}"/>
+                <a16:creationId xmlns:a16="http://schemas.microsoft.com/office/drawing/2014/main" id="{0AE8CC66-8A82-4A7A-AFD7-1F161D9CA2F7}"/>
               </a:ext>
             </a:extLst>
           </p:cNvPr>
@@ -2498,7 +2498,7 @@
     </p:spTree>
     <p:extLst>
       <p:ext uri="{BB962C8B-B14F-4D97-AF65-F5344CB8AC3E}">
-        <p14:creationId xmlns:p14="http://schemas.microsoft.com/office/powerpoint/2010/main" val="363779021"/>
+        <p14:creationId xmlns:p14="http://schemas.microsoft.com/office/powerpoint/2010/main" val="2127857156"/>
       </p:ext>
     </p:extLst>
   </p:cSld>
@@ -2522,7 +2522,7 @@
           <p:cNvPr id="1" name="">
             <a:extLst xmlns:a="http://schemas.openxmlformats.org/drawingml/2006/main">
               <a:ext uri="{FF2B5EF4-FFF2-40B4-BE49-F238E27FC236}">
-                <a16:creationId xmlns:a16="http://schemas.microsoft.com/office/drawing/2014/main" id="{C2632CBE-2A8E-49AC-AB67-E993B7775216}"/>
+                <a16:creationId xmlns:a16="http://schemas.microsoft.com/office/drawing/2014/main" id="{F6740108-B680-4119-84BC-400AC8C9F5C9}"/>
               </a:ext>
             </a:extLst>
           </p:cNvPr>
@@ -2552,7 +2552,7 @@
           <p:cNvPr id="2" name="">
             <a:extLst xmlns:a="http://schemas.openxmlformats.org/drawingml/2006/main">
               <a:ext uri="{FF2B5EF4-FFF2-40B4-BE49-F238E27FC236}">
-                <a16:creationId xmlns:a16="http://schemas.microsoft.com/office/drawing/2014/main" id="{AE3A7B5E-586E-41E6-B677-62755000FEA5}"/>
+                <a16:creationId xmlns:a16="http://schemas.microsoft.com/office/drawing/2014/main" id="{F9E85515-B4FF-4C92-B41F-4D7A789417F9}"/>
               </a:ext>
             </a:extLst>
           </p:cNvPr>
@@ -2582,7 +2582,7 @@
           <p:cNvPr id="3" name="">
             <a:extLst xmlns:a="http://schemas.openxmlformats.org/drawingml/2006/main">
               <a:ext uri="{FF2B5EF4-FFF2-40B4-BE49-F238E27FC236}">
-                <a16:creationId xmlns:a16="http://schemas.microsoft.com/office/drawing/2014/main" id="{6965AD51-6E18-4824-80CA-7C6BBABFC19F}"/>
+                <a16:creationId xmlns:a16="http://schemas.microsoft.com/office/drawing/2014/main" id="{8867CC03-25BD-4EF5-BAD1-BBFFA35BE1F2}"/>
               </a:ext>
             </a:extLst>
           </p:cNvPr>
@@ -2641,7 +2641,7 @@
           <p:cNvPr id="4" name="">
             <a:extLst xmlns:a="http://schemas.openxmlformats.org/drawingml/2006/main">
               <a:ext uri="{FF2B5EF4-FFF2-40B4-BE49-F238E27FC236}">
-                <a16:creationId xmlns:a16="http://schemas.microsoft.com/office/drawing/2014/main" id="{B7B4C7EB-4BD3-4AA7-9884-95C81813E25D}"/>
+                <a16:creationId xmlns:a16="http://schemas.microsoft.com/office/drawing/2014/main" id="{A36218FA-783C-41AA-890A-D44E60751B91}"/>
               </a:ext>
             </a:extLst>
           </p:cNvPr>
@@ -2700,7 +2700,7 @@
           <p:cNvPr id="5" name="">
             <a:extLst xmlns:a="http://schemas.openxmlformats.org/drawingml/2006/main">
               <a:ext uri="{FF2B5EF4-FFF2-40B4-BE49-F238E27FC236}">
-                <a16:creationId xmlns:a16="http://schemas.microsoft.com/office/drawing/2014/main" id="{548BEC1D-8CC5-46F4-A97C-40AAD695283E}"/>
+                <a16:creationId xmlns:a16="http://schemas.microsoft.com/office/drawing/2014/main" id="{6927CDA5-B319-4DD1-9652-D58C620A9F0E}"/>
               </a:ext>
             </a:extLst>
           </p:cNvPr>
@@ -2759,7 +2759,7 @@
           <p:cNvPr id="6" name="">
             <a:extLst xmlns:a="http://schemas.openxmlformats.org/drawingml/2006/main">
               <a:ext uri="{FF2B5EF4-FFF2-40B4-BE49-F238E27FC236}">
-                <a16:creationId xmlns:a16="http://schemas.microsoft.com/office/drawing/2014/main" id="{4F42F2E1-DF02-4ACE-9A18-67F46B99D487}"/>
+                <a16:creationId xmlns:a16="http://schemas.microsoft.com/office/drawing/2014/main" id="{343510B2-557A-46E9-8FB4-54B19CAB2772}"/>
               </a:ext>
             </a:extLst>
           </p:cNvPr>
@@ -2822,7 +2822,7 @@
           <p:nvPr/>
         </p:nvPicPr>
         <p:blipFill>
-          <a:blip xmlns:r="http://schemas.openxmlformats.org/officeDocument/2006/relationships" xmlns:a="http://schemas.openxmlformats.org/drawingml/2006/main" r:embed="R144deae79fe04500"/>
+          <a:blip xmlns:r="http://schemas.openxmlformats.org/officeDocument/2006/relationships" xmlns:a="http://schemas.openxmlformats.org/drawingml/2006/main" r:embed="R2f5730e568744089"/>
           <a:srcRect xmlns:a="http://schemas.openxmlformats.org/drawingml/2006/main" l="568" t="0" r="568" b="0"/>
           <a:stretch xmlns:a="http://schemas.openxmlformats.org/drawingml/2006/main">
             <a:fillRect l="0" t="0" r="0" b="0"/>
@@ -2843,7 +2843,7 @@
           <p:cNvPr id="8" name="">
             <a:extLst xmlns:a="http://schemas.openxmlformats.org/drawingml/2006/main">
               <a:ext uri="{FF2B5EF4-FFF2-40B4-BE49-F238E27FC236}">
-                <a16:creationId xmlns:a16="http://schemas.microsoft.com/office/drawing/2014/main" id="{B0A0C6F8-35AC-47FC-B7E3-1093FE4D64BB}"/>
+                <a16:creationId xmlns:a16="http://schemas.microsoft.com/office/drawing/2014/main" id="{77F70350-D7F0-4959-8D37-2F26BD4495E4}"/>
               </a:ext>
             </a:extLst>
           </p:cNvPr>
@@ -2875,7 +2875,7 @@
           <p:cNvPr id="9" name="">
             <a:extLst xmlns:a="http://schemas.openxmlformats.org/drawingml/2006/main">
               <a:ext uri="{FF2B5EF4-FFF2-40B4-BE49-F238E27FC236}">
-                <a16:creationId xmlns:a16="http://schemas.microsoft.com/office/drawing/2014/main" id="{9F07E291-26DE-4009-A829-4130D29DB998}"/>
+                <a16:creationId xmlns:a16="http://schemas.microsoft.com/office/drawing/2014/main" id="{1220FBA9-9432-4E56-A61B-793864C73823}"/>
               </a:ext>
             </a:extLst>
           </p:cNvPr>
@@ -2909,7 +2909,7 @@
           <p:cNvPr id="10" name="">
             <a:extLst xmlns:a="http://schemas.openxmlformats.org/drawingml/2006/main">
               <a:ext uri="{FF2B5EF4-FFF2-40B4-BE49-F238E27FC236}">
-                <a16:creationId xmlns:a16="http://schemas.microsoft.com/office/drawing/2014/main" id="{D2348B28-F044-434E-A0D9-D832E0EB2B75}"/>
+                <a16:creationId xmlns:a16="http://schemas.microsoft.com/office/drawing/2014/main" id="{203BE91F-89FD-4BF5-AEAA-95F304104C61}"/>
               </a:ext>
             </a:extLst>
           </p:cNvPr>
@@ -2941,7 +2941,7 @@
           <p:cNvPr id="11" name="">
             <a:extLst xmlns:a="http://schemas.openxmlformats.org/drawingml/2006/main">
               <a:ext uri="{FF2B5EF4-FFF2-40B4-BE49-F238E27FC236}">
-                <a16:creationId xmlns:a16="http://schemas.microsoft.com/office/drawing/2014/main" id="{57847CD7-BDEA-4E69-9C1C-E7E05277915B}"/>
+                <a16:creationId xmlns:a16="http://schemas.microsoft.com/office/drawing/2014/main" id="{3E56C3E1-F55A-41AF-903F-6C3C38EB45C3}"/>
               </a:ext>
             </a:extLst>
           </p:cNvPr>
@@ -2971,7 +2971,7 @@
           <p:cNvPr id="12" name="">
             <a:extLst xmlns:a="http://schemas.openxmlformats.org/drawingml/2006/main">
               <a:ext uri="{FF2B5EF4-FFF2-40B4-BE49-F238E27FC236}">
-                <a16:creationId xmlns:a16="http://schemas.microsoft.com/office/drawing/2014/main" id="{B25F9681-E7DC-4892-9AF1-B5A2F176F0A9}"/>
+                <a16:creationId xmlns:a16="http://schemas.microsoft.com/office/drawing/2014/main" id="{605E4E00-EB41-4BB4-B5D9-F0FAA7EF506C}"/>
               </a:ext>
             </a:extLst>
           </p:cNvPr>
@@ -3030,7 +3030,7 @@
           <p:cNvPr id="13" name="">
             <a:extLst xmlns:a="http://schemas.openxmlformats.org/drawingml/2006/main">
               <a:ext uri="{FF2B5EF4-FFF2-40B4-BE49-F238E27FC236}">
-                <a16:creationId xmlns:a16="http://schemas.microsoft.com/office/drawing/2014/main" id="{5A7F2CAE-287C-4FD5-9362-919D85ACE0ED}"/>
+                <a16:creationId xmlns:a16="http://schemas.microsoft.com/office/drawing/2014/main" id="{4C9DF925-DBB3-4F21-837B-2E23946B5E7C}"/>
               </a:ext>
             </a:extLst>
           </p:cNvPr>
@@ -3042,7 +3042,7 @@
         <p:spPr>
           <a:xfrm xmlns:a="http://schemas.openxmlformats.org/drawingml/2006/main">
             <a:off x="914400" y="4978241"/>
-            <a:ext cx="1905000" cy="279559"/>
+            <a:ext cx="1905000" cy="266700"/>
           </a:xfrm>
           <a:prstGeom xmlns:a="http://schemas.openxmlformats.org/drawingml/2006/main" prst="rect">
             <a:avLst/>
@@ -3061,7 +3061,7 @@
           <a:lstStyle xmlns:a="http://schemas.openxmlformats.org/drawingml/2006/main"/>
           <a:p xmlns:a="http://schemas.openxmlformats.org/drawingml/2006/main">
             <a:pPr algn="l">
-              <a:defRPr sz="982" b="0">
+              <a:defRPr sz="960" b="0">
                 <a:solidFill>
                   <a:srgbClr val="526179"/>
                 </a:solidFill>
@@ -3071,7 +3071,7 @@
               </a:defRPr>
             </a:pPr>
             <a:r>
-              <a:rPr sz="982" b="0">
+              <a:rPr sz="960" b="0">
                 <a:solidFill>
                   <a:srgbClr val="526179"/>
                 </a:solidFill>
@@ -3089,7 +3089,7 @@
           <p:cNvPr id="14" name="">
             <a:extLst xmlns:a="http://schemas.openxmlformats.org/drawingml/2006/main">
               <a:ext uri="{FF2B5EF4-FFF2-40B4-BE49-F238E27FC236}">
-                <a16:creationId xmlns:a16="http://schemas.microsoft.com/office/drawing/2014/main" id="{3C8F8D83-BEF6-4BD8-9D44-53DB48D4AB68}"/>
+                <a16:creationId xmlns:a16="http://schemas.microsoft.com/office/drawing/2014/main" id="{056E599C-A26B-4E9A-ABF6-0861597284A0}"/>
               </a:ext>
             </a:extLst>
           </p:cNvPr>
@@ -3148,7 +3148,7 @@
           <p:cNvPr id="15" name="">
             <a:extLst xmlns:a="http://schemas.openxmlformats.org/drawingml/2006/main">
               <a:ext uri="{FF2B5EF4-FFF2-40B4-BE49-F238E27FC236}">
-                <a16:creationId xmlns:a16="http://schemas.microsoft.com/office/drawing/2014/main" id="{C3FB9786-4B53-450B-B454-9F8A95781900}"/>
+                <a16:creationId xmlns:a16="http://schemas.microsoft.com/office/drawing/2014/main" id="{0171A7B5-BC80-412F-88F2-9217FC548AB5}"/>
               </a:ext>
             </a:extLst>
           </p:cNvPr>
@@ -3180,7 +3180,7 @@
           <p:cNvPr id="16" name="">
             <a:extLst xmlns:a="http://schemas.openxmlformats.org/drawingml/2006/main">
               <a:ext uri="{FF2B5EF4-FFF2-40B4-BE49-F238E27FC236}">
-                <a16:creationId xmlns:a16="http://schemas.microsoft.com/office/drawing/2014/main" id="{15326C34-2236-44FC-A2CE-78353EE109DD}"/>
+                <a16:creationId xmlns:a16="http://schemas.microsoft.com/office/drawing/2014/main" id="{57D20C35-5BF2-4894-A030-E7B97C39E2B3}"/>
               </a:ext>
             </a:extLst>
           </p:cNvPr>
@@ -3210,7 +3210,7 @@
           <p:cNvPr id="17" name="">
             <a:extLst xmlns:a="http://schemas.openxmlformats.org/drawingml/2006/main">
               <a:ext uri="{FF2B5EF4-FFF2-40B4-BE49-F238E27FC236}">
-                <a16:creationId xmlns:a16="http://schemas.microsoft.com/office/drawing/2014/main" id="{2237F7F3-E16C-49B5-AE72-E479A7EE6A19}"/>
+                <a16:creationId xmlns:a16="http://schemas.microsoft.com/office/drawing/2014/main" id="{2C21ED7B-E3D2-4BD2-ADE3-ABE4EA294F28}"/>
               </a:ext>
             </a:extLst>
           </p:cNvPr>
@@ -3269,7 +3269,7 @@
           <p:cNvPr id="18" name="">
             <a:extLst xmlns:a="http://schemas.openxmlformats.org/drawingml/2006/main">
               <a:ext uri="{FF2B5EF4-FFF2-40B4-BE49-F238E27FC236}">
-                <a16:creationId xmlns:a16="http://schemas.microsoft.com/office/drawing/2014/main" id="{99B1AE70-F8CA-4A39-8B98-0779B67E2831}"/>
+                <a16:creationId xmlns:a16="http://schemas.microsoft.com/office/drawing/2014/main" id="{A4ECBDB9-6EF4-4AD2-AC47-8466DE504684}"/>
               </a:ext>
             </a:extLst>
           </p:cNvPr>
@@ -3281,7 +3281,7 @@
         <p:spPr>
           <a:xfrm xmlns:a="http://schemas.openxmlformats.org/drawingml/2006/main">
             <a:off x="3638550" y="4978241"/>
-            <a:ext cx="1905000" cy="279559"/>
+            <a:ext cx="1905000" cy="266700"/>
           </a:xfrm>
           <a:prstGeom xmlns:a="http://schemas.openxmlformats.org/drawingml/2006/main" prst="rect">
             <a:avLst/>
@@ -3300,7 +3300,7 @@
           <a:lstStyle xmlns:a="http://schemas.openxmlformats.org/drawingml/2006/main"/>
           <a:p xmlns:a="http://schemas.openxmlformats.org/drawingml/2006/main">
             <a:pPr algn="l">
-              <a:defRPr sz="982" b="0">
+              <a:defRPr sz="960" b="0">
                 <a:solidFill>
                   <a:srgbClr val="526179"/>
                 </a:solidFill>
@@ -3310,7 +3310,7 @@
               </a:defRPr>
             </a:pPr>
             <a:r>
-              <a:rPr sz="982" b="0">
+              <a:rPr sz="960" b="0">
                 <a:solidFill>
                   <a:srgbClr val="526179"/>
                 </a:solidFill>
@@ -3328,7 +3328,7 @@
           <p:cNvPr id="19" name="">
             <a:extLst xmlns:a="http://schemas.openxmlformats.org/drawingml/2006/main">
               <a:ext uri="{FF2B5EF4-FFF2-40B4-BE49-F238E27FC236}">
-                <a16:creationId xmlns:a16="http://schemas.microsoft.com/office/drawing/2014/main" id="{282F245A-E3AA-4B21-A712-5BD8383AB385}"/>
+                <a16:creationId xmlns:a16="http://schemas.microsoft.com/office/drawing/2014/main" id="{97365FD6-0E12-483B-8D54-A63DADFD0626}"/>
               </a:ext>
             </a:extLst>
           </p:cNvPr>
@@ -3387,7 +3387,7 @@
           <p:cNvPr id="20" name="">
             <a:extLst xmlns:a="http://schemas.openxmlformats.org/drawingml/2006/main">
               <a:ext uri="{FF2B5EF4-FFF2-40B4-BE49-F238E27FC236}">
-                <a16:creationId xmlns:a16="http://schemas.microsoft.com/office/drawing/2014/main" id="{F7509907-3CC8-4FC7-A356-A3AF55C8DE48}"/>
+                <a16:creationId xmlns:a16="http://schemas.microsoft.com/office/drawing/2014/main" id="{39987DE6-E62A-4169-A1FA-B2DBE36FF043}"/>
               </a:ext>
             </a:extLst>
           </p:cNvPr>
@@ -3419,7 +3419,7 @@
           <p:cNvPr id="21" name="">
             <a:extLst xmlns:a="http://schemas.openxmlformats.org/drawingml/2006/main">
               <a:ext uri="{FF2B5EF4-FFF2-40B4-BE49-F238E27FC236}">
-                <a16:creationId xmlns:a16="http://schemas.microsoft.com/office/drawing/2014/main" id="{68DB40F7-9EA8-4C8A-AD72-5EA5EC9A8E5C}"/>
+                <a16:creationId xmlns:a16="http://schemas.microsoft.com/office/drawing/2014/main" id="{1B0A29EE-B4E6-4AFE-8E0E-3298E73FBF8A}"/>
               </a:ext>
             </a:extLst>
           </p:cNvPr>
@@ -3449,7 +3449,7 @@
           <p:cNvPr id="22" name="">
             <a:extLst xmlns:a="http://schemas.openxmlformats.org/drawingml/2006/main">
               <a:ext uri="{FF2B5EF4-FFF2-40B4-BE49-F238E27FC236}">
-                <a16:creationId xmlns:a16="http://schemas.microsoft.com/office/drawing/2014/main" id="{E0729F18-41DF-44AF-9F46-7D1EACB3C1FD}"/>
+                <a16:creationId xmlns:a16="http://schemas.microsoft.com/office/drawing/2014/main" id="{265BF7DA-CB4B-4277-BE98-D23506E7454E}"/>
               </a:ext>
             </a:extLst>
           </p:cNvPr>
@@ -3508,7 +3508,7 @@
           <p:cNvPr id="23" name="">
             <a:extLst xmlns:a="http://schemas.openxmlformats.org/drawingml/2006/main">
               <a:ext uri="{FF2B5EF4-FFF2-40B4-BE49-F238E27FC236}">
-                <a16:creationId xmlns:a16="http://schemas.microsoft.com/office/drawing/2014/main" id="{1D05A3E5-A72C-45E6-A16B-7D93CB40F249}"/>
+                <a16:creationId xmlns:a16="http://schemas.microsoft.com/office/drawing/2014/main" id="{01290E1F-1AF3-43D4-953D-4BA759839060}"/>
               </a:ext>
             </a:extLst>
           </p:cNvPr>
@@ -3520,7 +3520,7 @@
         <p:spPr>
           <a:xfrm xmlns:a="http://schemas.openxmlformats.org/drawingml/2006/main">
             <a:off x="6362700" y="4978241"/>
-            <a:ext cx="1905000" cy="279559"/>
+            <a:ext cx="1905000" cy="266700"/>
           </a:xfrm>
           <a:prstGeom xmlns:a="http://schemas.openxmlformats.org/drawingml/2006/main" prst="rect">
             <a:avLst/>
@@ -3539,7 +3539,7 @@
           <a:lstStyle xmlns:a="http://schemas.openxmlformats.org/drawingml/2006/main"/>
           <a:p xmlns:a="http://schemas.openxmlformats.org/drawingml/2006/main">
             <a:pPr algn="l">
-              <a:defRPr sz="982" b="0">
+              <a:defRPr sz="960" b="0">
                 <a:solidFill>
                   <a:srgbClr val="526179"/>
                 </a:solidFill>
@@ -3549,7 +3549,7 @@
               </a:defRPr>
             </a:pPr>
             <a:r>
-              <a:rPr sz="982" b="0">
+              <a:rPr sz="960" b="0">
                 <a:solidFill>
                   <a:srgbClr val="526179"/>
                 </a:solidFill>
@@ -3567,7 +3567,7 @@
           <p:cNvPr id="24" name="">
             <a:extLst xmlns:a="http://schemas.openxmlformats.org/drawingml/2006/main">
               <a:ext uri="{FF2B5EF4-FFF2-40B4-BE49-F238E27FC236}">
-                <a16:creationId xmlns:a16="http://schemas.microsoft.com/office/drawing/2014/main" id="{F708D0DA-EF67-46CB-8B39-9D0B085F9810}"/>
+                <a16:creationId xmlns:a16="http://schemas.microsoft.com/office/drawing/2014/main" id="{C10DE524-23D9-4F88-9FCA-447A9B458AB4}"/>
               </a:ext>
             </a:extLst>
           </p:cNvPr>
@@ -3626,7 +3626,7 @@
           <p:cNvPr id="25" name="">
             <a:extLst xmlns:a="http://schemas.openxmlformats.org/drawingml/2006/main">
               <a:ext uri="{FF2B5EF4-FFF2-40B4-BE49-F238E27FC236}">
-                <a16:creationId xmlns:a16="http://schemas.microsoft.com/office/drawing/2014/main" id="{8C89E6F1-5243-4AC6-A8D0-B9A4B47FD99A}"/>
+                <a16:creationId xmlns:a16="http://schemas.microsoft.com/office/drawing/2014/main" id="{2CAC5881-06AF-4401-A82B-FE41898BA5F4}"/>
               </a:ext>
             </a:extLst>
           </p:cNvPr>
@@ -3658,7 +3658,7 @@
           <p:cNvPr id="26" name="">
             <a:extLst xmlns:a="http://schemas.openxmlformats.org/drawingml/2006/main">
               <a:ext uri="{FF2B5EF4-FFF2-40B4-BE49-F238E27FC236}">
-                <a16:creationId xmlns:a16="http://schemas.microsoft.com/office/drawing/2014/main" id="{49993790-02FA-447F-ADAD-1182EFD5FA91}"/>
+                <a16:creationId xmlns:a16="http://schemas.microsoft.com/office/drawing/2014/main" id="{01553A75-FCA9-4532-937F-33D4371FF1C6}"/>
               </a:ext>
             </a:extLst>
           </p:cNvPr>
@@ -3688,7 +3688,7 @@
           <p:cNvPr id="27" name="">
             <a:extLst xmlns:a="http://schemas.openxmlformats.org/drawingml/2006/main">
               <a:ext uri="{FF2B5EF4-FFF2-40B4-BE49-F238E27FC236}">
-                <a16:creationId xmlns:a16="http://schemas.microsoft.com/office/drawing/2014/main" id="{90218182-71CB-42E3-A56D-253529276D1A}"/>
+                <a16:creationId xmlns:a16="http://schemas.microsoft.com/office/drawing/2014/main" id="{0F78952F-8A8A-4EC6-953F-5D118C0C9A47}"/>
               </a:ext>
             </a:extLst>
           </p:cNvPr>
@@ -3747,7 +3747,7 @@
           <p:cNvPr id="28" name="">
             <a:extLst xmlns:a="http://schemas.openxmlformats.org/drawingml/2006/main">
               <a:ext uri="{FF2B5EF4-FFF2-40B4-BE49-F238E27FC236}">
-                <a16:creationId xmlns:a16="http://schemas.microsoft.com/office/drawing/2014/main" id="{8BC86CE4-AEFD-4C00-932E-9EB9B4521415}"/>
+                <a16:creationId xmlns:a16="http://schemas.microsoft.com/office/drawing/2014/main" id="{954E074E-707E-4341-B7D6-D74786297C84}"/>
               </a:ext>
             </a:extLst>
           </p:cNvPr>
@@ -3759,7 +3759,7 @@
         <p:spPr>
           <a:xfrm xmlns:a="http://schemas.openxmlformats.org/drawingml/2006/main">
             <a:off x="9086850" y="4978241"/>
-            <a:ext cx="1905000" cy="279559"/>
+            <a:ext cx="1905000" cy="266700"/>
           </a:xfrm>
           <a:prstGeom xmlns:a="http://schemas.openxmlformats.org/drawingml/2006/main" prst="rect">
             <a:avLst/>
@@ -3778,7 +3778,7 @@
           <a:lstStyle xmlns:a="http://schemas.openxmlformats.org/drawingml/2006/main"/>
           <a:p xmlns:a="http://schemas.openxmlformats.org/drawingml/2006/main">
             <a:pPr algn="l">
-              <a:defRPr sz="982" b="0">
+              <a:defRPr sz="960" b="0">
                 <a:solidFill>
                   <a:srgbClr val="526179"/>
                 </a:solidFill>
@@ -3788,7 +3788,7 @@
               </a:defRPr>
             </a:pPr>
             <a:r>
-              <a:rPr sz="982" b="0">
+              <a:rPr sz="960" b="0">
                 <a:solidFill>
                   <a:srgbClr val="526179"/>
                 </a:solidFill>
@@ -3806,7 +3806,7 @@
           <p:cNvPr id="29" name="">
             <a:extLst xmlns:a="http://schemas.openxmlformats.org/drawingml/2006/main">
               <a:ext uri="{FF2B5EF4-FFF2-40B4-BE49-F238E27FC236}">
-                <a16:creationId xmlns:a16="http://schemas.microsoft.com/office/drawing/2014/main" id="{A61F783D-4150-4204-A26F-E932CA049B31}"/>
+                <a16:creationId xmlns:a16="http://schemas.microsoft.com/office/drawing/2014/main" id="{40D7A21F-59AC-4D53-A041-D9789393A597}"/>
               </a:ext>
             </a:extLst>
           </p:cNvPr>
@@ -3836,7 +3836,7 @@
           <p:cNvPr id="30" name="">
             <a:extLst xmlns:a="http://schemas.openxmlformats.org/drawingml/2006/main">
               <a:ext uri="{FF2B5EF4-FFF2-40B4-BE49-F238E27FC236}">
-                <a16:creationId xmlns:a16="http://schemas.microsoft.com/office/drawing/2014/main" id="{2572C23C-C177-4730-BD71-40E229D651A6}"/>
+                <a16:creationId xmlns:a16="http://schemas.microsoft.com/office/drawing/2014/main" id="{F01A9639-8425-4848-9C13-0B17A8160155}"/>
               </a:ext>
             </a:extLst>
           </p:cNvPr>
@@ -3866,7 +3866,7 @@
           <p:cNvPr id="31" name="">
             <a:extLst xmlns:a="http://schemas.openxmlformats.org/drawingml/2006/main">
               <a:ext uri="{FF2B5EF4-FFF2-40B4-BE49-F238E27FC236}">
-                <a16:creationId xmlns:a16="http://schemas.microsoft.com/office/drawing/2014/main" id="{5F6D8D82-85B1-4E0E-9AD7-8BA1CBBA531E}"/>
+                <a16:creationId xmlns:a16="http://schemas.microsoft.com/office/drawing/2014/main" id="{86B5BF7D-8802-4296-B3A6-D3B56671FA07}"/>
               </a:ext>
             </a:extLst>
           </p:cNvPr>
@@ -3923,7 +3923,7 @@
     </p:spTree>
     <p:extLst>
       <p:ext uri="{BB962C8B-B14F-4D97-AF65-F5344CB8AC3E}">
-        <p14:creationId xmlns:p14="http://schemas.microsoft.com/office/powerpoint/2010/main" val="1386722121"/>
+        <p14:creationId xmlns:p14="http://schemas.microsoft.com/office/powerpoint/2010/main" val="1116153800"/>
       </p:ext>
     </p:extLst>
   </p:cSld>
@@ -3947,7 +3947,7 @@
           <p:cNvPr id="1" name="">
             <a:extLst xmlns:a="http://schemas.openxmlformats.org/drawingml/2006/main">
               <a:ext uri="{FF2B5EF4-FFF2-40B4-BE49-F238E27FC236}">
-                <a16:creationId xmlns:a16="http://schemas.microsoft.com/office/drawing/2014/main" id="{5FDB7124-D5E1-4D8A-B793-B55DD68C4716}"/>
+                <a16:creationId xmlns:a16="http://schemas.microsoft.com/office/drawing/2014/main" id="{310EE498-7FC5-4D6E-BA2F-BCD39ED3312E}"/>
               </a:ext>
             </a:extLst>
           </p:cNvPr>
@@ -3977,7 +3977,7 @@
           <p:cNvPr id="2" name="">
             <a:extLst xmlns:a="http://schemas.openxmlformats.org/drawingml/2006/main">
               <a:ext uri="{FF2B5EF4-FFF2-40B4-BE49-F238E27FC236}">
-                <a16:creationId xmlns:a16="http://schemas.microsoft.com/office/drawing/2014/main" id="{FC439901-CFAD-4A45-BEEA-1E7DE7816EB1}"/>
+                <a16:creationId xmlns:a16="http://schemas.microsoft.com/office/drawing/2014/main" id="{BF0B9588-79D6-4FB6-A046-EC16741E13EF}"/>
               </a:ext>
             </a:extLst>
           </p:cNvPr>
@@ -4007,7 +4007,7 @@
           <p:cNvPr id="3" name="">
             <a:extLst xmlns:a="http://schemas.openxmlformats.org/drawingml/2006/main">
               <a:ext uri="{FF2B5EF4-FFF2-40B4-BE49-F238E27FC236}">
-                <a16:creationId xmlns:a16="http://schemas.microsoft.com/office/drawing/2014/main" id="{56B1F079-ED80-4095-9CE6-6189BACA114E}"/>
+                <a16:creationId xmlns:a16="http://schemas.microsoft.com/office/drawing/2014/main" id="{E7DE203A-2304-4B45-899F-D163201B158B}"/>
               </a:ext>
             </a:extLst>
           </p:cNvPr>
@@ -4066,7 +4066,7 @@
           <p:cNvPr id="4" name="">
             <a:extLst xmlns:a="http://schemas.openxmlformats.org/drawingml/2006/main">
               <a:ext uri="{FF2B5EF4-FFF2-40B4-BE49-F238E27FC236}">
-                <a16:creationId xmlns:a16="http://schemas.microsoft.com/office/drawing/2014/main" id="{82C5E72E-7E2D-4939-BE41-591713F510AB}"/>
+                <a16:creationId xmlns:a16="http://schemas.microsoft.com/office/drawing/2014/main" id="{C2DB9ACE-71B7-4785-9799-70B9F7C6CACB}"/>
               </a:ext>
             </a:extLst>
           </p:cNvPr>
@@ -4125,7 +4125,7 @@
           <p:cNvPr id="5" name="">
             <a:extLst xmlns:a="http://schemas.openxmlformats.org/drawingml/2006/main">
               <a:ext uri="{FF2B5EF4-FFF2-40B4-BE49-F238E27FC236}">
-                <a16:creationId xmlns:a16="http://schemas.microsoft.com/office/drawing/2014/main" id="{3469B80B-9F17-44DA-85B5-B8DFA950E02E}"/>
+                <a16:creationId xmlns:a16="http://schemas.microsoft.com/office/drawing/2014/main" id="{3613042A-4802-47B6-A700-98860DD4621B}"/>
               </a:ext>
             </a:extLst>
           </p:cNvPr>
@@ -4184,7 +4184,7 @@
           <p:cNvPr id="6" name="">
             <a:extLst xmlns:a="http://schemas.openxmlformats.org/drawingml/2006/main">
               <a:ext uri="{FF2B5EF4-FFF2-40B4-BE49-F238E27FC236}">
-                <a16:creationId xmlns:a16="http://schemas.microsoft.com/office/drawing/2014/main" id="{35139F4F-D604-47C3-B0A4-D79755464805}"/>
+                <a16:creationId xmlns:a16="http://schemas.microsoft.com/office/drawing/2014/main" id="{64F5C232-BC2A-46DB-9AF6-12037E4AE505}"/>
               </a:ext>
             </a:extLst>
           </p:cNvPr>
@@ -4247,7 +4247,7 @@
           <p:nvPr/>
         </p:nvPicPr>
         <p:blipFill>
-          <a:blip xmlns:r="http://schemas.openxmlformats.org/officeDocument/2006/relationships" xmlns:a="http://schemas.openxmlformats.org/drawingml/2006/main" r:embed="Rd8a4871df1644dc7"/>
+          <a:blip xmlns:r="http://schemas.openxmlformats.org/officeDocument/2006/relationships" xmlns:a="http://schemas.openxmlformats.org/drawingml/2006/main" r:embed="Rba6cb92767104e94"/>
           <a:srcRect xmlns:a="http://schemas.openxmlformats.org/drawingml/2006/main" l="0" t="1111" r="0" b="1111"/>
           <a:stretch xmlns:a="http://schemas.openxmlformats.org/drawingml/2006/main">
             <a:fillRect l="0" t="0" r="0" b="0"/>
@@ -4268,7 +4268,7 @@
           <p:cNvPr id="8" name="">
             <a:extLst xmlns:a="http://schemas.openxmlformats.org/drawingml/2006/main">
               <a:ext uri="{FF2B5EF4-FFF2-40B4-BE49-F238E27FC236}">
-                <a16:creationId xmlns:a16="http://schemas.microsoft.com/office/drawing/2014/main" id="{7BF100A6-CA1A-4464-B362-B4710AEF5DAB}"/>
+                <a16:creationId xmlns:a16="http://schemas.microsoft.com/office/drawing/2014/main" id="{13196B89-8BA3-40EA-9534-48A610804F34}"/>
               </a:ext>
             </a:extLst>
           </p:cNvPr>
@@ -4300,7 +4300,7 @@
           <p:cNvPr id="9" name="">
             <a:extLst xmlns:a="http://schemas.openxmlformats.org/drawingml/2006/main">
               <a:ext uri="{FF2B5EF4-FFF2-40B4-BE49-F238E27FC236}">
-                <a16:creationId xmlns:a16="http://schemas.microsoft.com/office/drawing/2014/main" id="{4C624C48-8EB9-40A7-A29F-F33E2EBF05EB}"/>
+                <a16:creationId xmlns:a16="http://schemas.microsoft.com/office/drawing/2014/main" id="{6C9685F1-5DBC-4159-9700-D7EC72864733}"/>
               </a:ext>
             </a:extLst>
           </p:cNvPr>
@@ -4334,7 +4334,7 @@
           <p:cNvPr id="10" name="">
             <a:extLst xmlns:a="http://schemas.openxmlformats.org/drawingml/2006/main">
               <a:ext uri="{FF2B5EF4-FFF2-40B4-BE49-F238E27FC236}">
-                <a16:creationId xmlns:a16="http://schemas.microsoft.com/office/drawing/2014/main" id="{6B43D353-7249-4D56-9207-7841B5FCE260}"/>
+                <a16:creationId xmlns:a16="http://schemas.microsoft.com/office/drawing/2014/main" id="{B5C16BAC-FB88-4A4C-BE13-9E36C49D90C0}"/>
               </a:ext>
             </a:extLst>
           </p:cNvPr>
@@ -4366,7 +4366,7 @@
           <p:cNvPr id="11" name="">
             <a:extLst xmlns:a="http://schemas.openxmlformats.org/drawingml/2006/main">
               <a:ext uri="{FF2B5EF4-FFF2-40B4-BE49-F238E27FC236}">
-                <a16:creationId xmlns:a16="http://schemas.microsoft.com/office/drawing/2014/main" id="{A491735F-4AE8-49D5-9C52-2DCD73ABF9DA}"/>
+                <a16:creationId xmlns:a16="http://schemas.microsoft.com/office/drawing/2014/main" id="{D2E7AE69-3CB5-4AA0-8A59-B9F567B02C29}"/>
               </a:ext>
             </a:extLst>
           </p:cNvPr>
@@ -4425,7 +4425,7 @@
           <p:cNvPr id="12" name="">
             <a:extLst xmlns:a="http://schemas.openxmlformats.org/drawingml/2006/main">
               <a:ext uri="{FF2B5EF4-FFF2-40B4-BE49-F238E27FC236}">
-                <a16:creationId xmlns:a16="http://schemas.microsoft.com/office/drawing/2014/main" id="{9A9452ED-3C0F-42F8-A19E-DD789D9FF65F}"/>
+                <a16:creationId xmlns:a16="http://schemas.microsoft.com/office/drawing/2014/main" id="{CE24D247-AC59-4060-81BA-2953B9FC65B9}"/>
               </a:ext>
             </a:extLst>
           </p:cNvPr>
@@ -4484,7 +4484,7 @@
           <p:cNvPr id="13" name="">
             <a:extLst xmlns:a="http://schemas.openxmlformats.org/drawingml/2006/main">
               <a:ext uri="{FF2B5EF4-FFF2-40B4-BE49-F238E27FC236}">
-                <a16:creationId xmlns:a16="http://schemas.microsoft.com/office/drawing/2014/main" id="{C8D39FF3-4A61-4E3D-8F66-5B4AF43B1BAE}"/>
+                <a16:creationId xmlns:a16="http://schemas.microsoft.com/office/drawing/2014/main" id="{775CD947-103D-445A-A302-AC823E2D64F2}"/>
               </a:ext>
             </a:extLst>
           </p:cNvPr>
@@ -4516,7 +4516,7 @@
           <p:cNvPr id="14" name="">
             <a:extLst xmlns:a="http://schemas.openxmlformats.org/drawingml/2006/main">
               <a:ext uri="{FF2B5EF4-FFF2-40B4-BE49-F238E27FC236}">
-                <a16:creationId xmlns:a16="http://schemas.microsoft.com/office/drawing/2014/main" id="{E32C97BC-EE31-4D3E-90B8-E71AD375BD7F}"/>
+                <a16:creationId xmlns:a16="http://schemas.microsoft.com/office/drawing/2014/main" id="{1D0BFEE9-A835-416F-866A-C5C6EF38EF77}"/>
               </a:ext>
             </a:extLst>
           </p:cNvPr>
@@ -4575,7 +4575,7 @@
           <p:cNvPr id="15" name="">
             <a:extLst xmlns:a="http://schemas.openxmlformats.org/drawingml/2006/main">
               <a:ext uri="{FF2B5EF4-FFF2-40B4-BE49-F238E27FC236}">
-                <a16:creationId xmlns:a16="http://schemas.microsoft.com/office/drawing/2014/main" id="{00A61680-C9C6-4306-AB1E-BE8F25CEAF02}"/>
+                <a16:creationId xmlns:a16="http://schemas.microsoft.com/office/drawing/2014/main" id="{34EA9A54-7A6F-4ACB-932D-DA3CFE89A5E8}"/>
               </a:ext>
             </a:extLst>
           </p:cNvPr>
@@ -4634,7 +4634,7 @@
           <p:cNvPr id="16" name="">
             <a:extLst xmlns:a="http://schemas.openxmlformats.org/drawingml/2006/main">
               <a:ext uri="{FF2B5EF4-FFF2-40B4-BE49-F238E27FC236}">
-                <a16:creationId xmlns:a16="http://schemas.microsoft.com/office/drawing/2014/main" id="{47C1EF1E-CCA8-4DF1-A6BF-1FEDCABD1AD2}"/>
+                <a16:creationId xmlns:a16="http://schemas.microsoft.com/office/drawing/2014/main" id="{6E546FA5-FD22-4BA3-8DA8-A6D887473F4D}"/>
               </a:ext>
             </a:extLst>
           </p:cNvPr>
@@ -4666,7 +4666,7 @@
           <p:cNvPr id="17" name="">
             <a:extLst xmlns:a="http://schemas.openxmlformats.org/drawingml/2006/main">
               <a:ext uri="{FF2B5EF4-FFF2-40B4-BE49-F238E27FC236}">
-                <a16:creationId xmlns:a16="http://schemas.microsoft.com/office/drawing/2014/main" id="{B7612EDD-D8D6-4416-9A21-E9430F55FAA7}"/>
+                <a16:creationId xmlns:a16="http://schemas.microsoft.com/office/drawing/2014/main" id="{4FBD3808-2D23-4CAC-BC1E-D9AA9405AE16}"/>
               </a:ext>
             </a:extLst>
           </p:cNvPr>
@@ -4725,7 +4725,7 @@
           <p:cNvPr id="18" name="">
             <a:extLst xmlns:a="http://schemas.openxmlformats.org/drawingml/2006/main">
               <a:ext uri="{FF2B5EF4-FFF2-40B4-BE49-F238E27FC236}">
-                <a16:creationId xmlns:a16="http://schemas.microsoft.com/office/drawing/2014/main" id="{3744586A-F8A8-4C3C-825E-F492294DC7EC}"/>
+                <a16:creationId xmlns:a16="http://schemas.microsoft.com/office/drawing/2014/main" id="{B0B69067-5FF4-46A2-9AC3-8BFA2996BF38}"/>
               </a:ext>
             </a:extLst>
           </p:cNvPr>
@@ -4784,7 +4784,7 @@
           <p:cNvPr id="19" name="">
             <a:extLst xmlns:a="http://schemas.openxmlformats.org/drawingml/2006/main">
               <a:ext uri="{FF2B5EF4-FFF2-40B4-BE49-F238E27FC236}">
-                <a16:creationId xmlns:a16="http://schemas.microsoft.com/office/drawing/2014/main" id="{C9A430F5-1AB1-4B71-A286-E992ECE4DE6B}"/>
+                <a16:creationId xmlns:a16="http://schemas.microsoft.com/office/drawing/2014/main" id="{05F4DE28-95ED-4B7D-8803-E4189C7168EE}"/>
               </a:ext>
             </a:extLst>
           </p:cNvPr>
@@ -4816,7 +4816,7 @@
           <p:cNvPr id="20" name="">
             <a:extLst xmlns:a="http://schemas.openxmlformats.org/drawingml/2006/main">
               <a:ext uri="{FF2B5EF4-FFF2-40B4-BE49-F238E27FC236}">
-                <a16:creationId xmlns:a16="http://schemas.microsoft.com/office/drawing/2014/main" id="{FDBF6D88-984A-4E9B-99A1-1C119A313E7A}"/>
+                <a16:creationId xmlns:a16="http://schemas.microsoft.com/office/drawing/2014/main" id="{6016BCFC-3839-4505-BBE7-C1E6CB8873B4}"/>
               </a:ext>
             </a:extLst>
           </p:cNvPr>
@@ -4875,7 +4875,7 @@
           <p:cNvPr id="21" name="">
             <a:extLst xmlns:a="http://schemas.openxmlformats.org/drawingml/2006/main">
               <a:ext uri="{FF2B5EF4-FFF2-40B4-BE49-F238E27FC236}">
-                <a16:creationId xmlns:a16="http://schemas.microsoft.com/office/drawing/2014/main" id="{7BF515F7-D673-406A-93AC-850D3FAC80D2}"/>
+                <a16:creationId xmlns:a16="http://schemas.microsoft.com/office/drawing/2014/main" id="{3D3673A9-EF5B-43CF-AD2F-A1425CBFDD13}"/>
               </a:ext>
             </a:extLst>
           </p:cNvPr>
@@ -4907,7 +4907,7 @@
           <p:cNvPr id="22" name="">
             <a:extLst xmlns:a="http://schemas.openxmlformats.org/drawingml/2006/main">
               <a:ext uri="{FF2B5EF4-FFF2-40B4-BE49-F238E27FC236}">
-                <a16:creationId xmlns:a16="http://schemas.microsoft.com/office/drawing/2014/main" id="{47205930-0222-4A0C-9EBA-4E157C4AB6E7}"/>
+                <a16:creationId xmlns:a16="http://schemas.microsoft.com/office/drawing/2014/main" id="{8D1B1EA5-AE2C-41CD-9088-55296D6E3F53}"/>
               </a:ext>
             </a:extLst>
           </p:cNvPr>
@@ -4937,7 +4937,7 @@
           <p:cNvPr id="23" name="">
             <a:extLst xmlns:a="http://schemas.openxmlformats.org/drawingml/2006/main">
               <a:ext uri="{FF2B5EF4-FFF2-40B4-BE49-F238E27FC236}">
-                <a16:creationId xmlns:a16="http://schemas.microsoft.com/office/drawing/2014/main" id="{A460C477-B34F-4C57-ACB9-56484F8A37B1}"/>
+                <a16:creationId xmlns:a16="http://schemas.microsoft.com/office/drawing/2014/main" id="{92555EE3-1DB7-4B5B-8776-036806694816}"/>
               </a:ext>
             </a:extLst>
           </p:cNvPr>
@@ -4996,7 +4996,7 @@
           <p:cNvPr id="24" name="">
             <a:extLst xmlns:a="http://schemas.openxmlformats.org/drawingml/2006/main">
               <a:ext uri="{FF2B5EF4-FFF2-40B4-BE49-F238E27FC236}">
-                <a16:creationId xmlns:a16="http://schemas.microsoft.com/office/drawing/2014/main" id="{4C9FC2FD-1167-4A26-BD0B-7290CD9FC89F}"/>
+                <a16:creationId xmlns:a16="http://schemas.microsoft.com/office/drawing/2014/main" id="{B7CE5750-C68A-43DF-B1A4-355C2ADD20AC}"/>
               </a:ext>
             </a:extLst>
           </p:cNvPr>
@@ -5027,7 +5027,7 @@
           <a:lstStyle xmlns:a="http://schemas.openxmlformats.org/drawingml/2006/main"/>
           <a:p xmlns:a="http://schemas.openxmlformats.org/drawingml/2006/main">
             <a:pPr algn="l">
-              <a:defRPr sz="938" b="0">
+              <a:defRPr sz="923" b="0">
                 <a:solidFill>
                   <a:srgbClr val="526179"/>
                 </a:solidFill>
@@ -5037,7 +5037,7 @@
               </a:defRPr>
             </a:pPr>
             <a:r>
-              <a:rPr sz="938" b="0">
+              <a:rPr sz="923" b="0">
                 <a:solidFill>
                   <a:srgbClr val="526179"/>
                 </a:solidFill>
@@ -5055,7 +5055,7 @@
           <p:cNvPr id="25" name="">
             <a:extLst xmlns:a="http://schemas.openxmlformats.org/drawingml/2006/main">
               <a:ext uri="{FF2B5EF4-FFF2-40B4-BE49-F238E27FC236}">
-                <a16:creationId xmlns:a16="http://schemas.microsoft.com/office/drawing/2014/main" id="{0E09F477-37E8-4CBA-9D78-A153D5AD585B}"/>
+                <a16:creationId xmlns:a16="http://schemas.microsoft.com/office/drawing/2014/main" id="{B12EBF91-562D-4871-95DE-1ABB89BD948F}"/>
               </a:ext>
             </a:extLst>
           </p:cNvPr>
@@ -5087,7 +5087,7 @@
           <p:cNvPr id="26" name="">
             <a:extLst xmlns:a="http://schemas.openxmlformats.org/drawingml/2006/main">
               <a:ext uri="{FF2B5EF4-FFF2-40B4-BE49-F238E27FC236}">
-                <a16:creationId xmlns:a16="http://schemas.microsoft.com/office/drawing/2014/main" id="{0F7BC667-EEA8-4E66-B381-6F63AC18A3FC}"/>
+                <a16:creationId xmlns:a16="http://schemas.microsoft.com/office/drawing/2014/main" id="{99C63B20-466B-4580-B76B-B5CFAF157B0A}"/>
               </a:ext>
             </a:extLst>
           </p:cNvPr>
@@ -5117,7 +5117,7 @@
           <p:cNvPr id="27" name="">
             <a:extLst xmlns:a="http://schemas.openxmlformats.org/drawingml/2006/main">
               <a:ext uri="{FF2B5EF4-FFF2-40B4-BE49-F238E27FC236}">
-                <a16:creationId xmlns:a16="http://schemas.microsoft.com/office/drawing/2014/main" id="{E23ECAA1-DAF7-4AB4-88F3-23B69F8206ED}"/>
+                <a16:creationId xmlns:a16="http://schemas.microsoft.com/office/drawing/2014/main" id="{FF0E0665-0F12-4D96-B1DB-59EAE48130B8}"/>
               </a:ext>
             </a:extLst>
           </p:cNvPr>
@@ -5176,7 +5176,7 @@
           <p:cNvPr id="28" name="">
             <a:extLst xmlns:a="http://schemas.openxmlformats.org/drawingml/2006/main">
               <a:ext uri="{FF2B5EF4-FFF2-40B4-BE49-F238E27FC236}">
-                <a16:creationId xmlns:a16="http://schemas.microsoft.com/office/drawing/2014/main" id="{EE01C38A-C7E1-4548-B9A8-9653F07C5D73}"/>
+                <a16:creationId xmlns:a16="http://schemas.microsoft.com/office/drawing/2014/main" id="{55252031-98D6-4210-990B-09069B14770B}"/>
               </a:ext>
             </a:extLst>
           </p:cNvPr>
@@ -5207,7 +5207,7 @@
           <a:lstStyle xmlns:a="http://schemas.openxmlformats.org/drawingml/2006/main"/>
           <a:p xmlns:a="http://schemas.openxmlformats.org/drawingml/2006/main">
             <a:pPr algn="l">
-              <a:defRPr sz="938" b="0">
+              <a:defRPr sz="923" b="0">
                 <a:solidFill>
                   <a:srgbClr val="526179"/>
                 </a:solidFill>
@@ -5217,7 +5217,7 @@
               </a:defRPr>
             </a:pPr>
             <a:r>
-              <a:rPr sz="938" b="0">
+              <a:rPr sz="923" b="0">
                 <a:solidFill>
                   <a:srgbClr val="526179"/>
                 </a:solidFill>
@@ -5235,7 +5235,7 @@
           <p:cNvPr id="29" name="">
             <a:extLst xmlns:a="http://schemas.openxmlformats.org/drawingml/2006/main">
               <a:ext uri="{FF2B5EF4-FFF2-40B4-BE49-F238E27FC236}">
-                <a16:creationId xmlns:a16="http://schemas.microsoft.com/office/drawing/2014/main" id="{B89F6491-BBE4-41B5-9846-12C894ECD506}"/>
+                <a16:creationId xmlns:a16="http://schemas.microsoft.com/office/drawing/2014/main" id="{50D07359-3154-4445-B1B5-A8B6391302EB}"/>
               </a:ext>
             </a:extLst>
           </p:cNvPr>
@@ -5267,7 +5267,7 @@
           <p:cNvPr id="30" name="">
             <a:extLst xmlns:a="http://schemas.openxmlformats.org/drawingml/2006/main">
               <a:ext uri="{FF2B5EF4-FFF2-40B4-BE49-F238E27FC236}">
-                <a16:creationId xmlns:a16="http://schemas.microsoft.com/office/drawing/2014/main" id="{61245951-7D61-490F-8406-1B2F35883A5C}"/>
+                <a16:creationId xmlns:a16="http://schemas.microsoft.com/office/drawing/2014/main" id="{E319AB31-1224-4DA0-BF70-506D8FB897D5}"/>
               </a:ext>
             </a:extLst>
           </p:cNvPr>
@@ -5297,7 +5297,7 @@
           <p:cNvPr id="31" name="">
             <a:extLst xmlns:a="http://schemas.openxmlformats.org/drawingml/2006/main">
               <a:ext uri="{FF2B5EF4-FFF2-40B4-BE49-F238E27FC236}">
-                <a16:creationId xmlns:a16="http://schemas.microsoft.com/office/drawing/2014/main" id="{DC852BC0-BED1-4E42-81C4-61E62437DF16}"/>
+                <a16:creationId xmlns:a16="http://schemas.microsoft.com/office/drawing/2014/main" id="{0A7C70BA-9D3F-4802-B519-1B732C62F1D0}"/>
               </a:ext>
             </a:extLst>
           </p:cNvPr>
@@ -5356,7 +5356,7 @@
           <p:cNvPr id="32" name="">
             <a:extLst xmlns:a="http://schemas.openxmlformats.org/drawingml/2006/main">
               <a:ext uri="{FF2B5EF4-FFF2-40B4-BE49-F238E27FC236}">
-                <a16:creationId xmlns:a16="http://schemas.microsoft.com/office/drawing/2014/main" id="{C9F188AC-A158-4B4B-85F0-4B5998FF53FA}"/>
+                <a16:creationId xmlns:a16="http://schemas.microsoft.com/office/drawing/2014/main" id="{21171244-632F-411B-8083-41041FBC9CD2}"/>
               </a:ext>
             </a:extLst>
           </p:cNvPr>
@@ -5387,7 +5387,7 @@
           <a:lstStyle xmlns:a="http://schemas.openxmlformats.org/drawingml/2006/main"/>
           <a:p xmlns:a="http://schemas.openxmlformats.org/drawingml/2006/main">
             <a:pPr algn="l">
-              <a:defRPr sz="938" b="0">
+              <a:defRPr sz="923" b="0">
                 <a:solidFill>
                   <a:srgbClr val="526179"/>
                 </a:solidFill>
@@ -5397,7 +5397,7 @@
               </a:defRPr>
             </a:pPr>
             <a:r>
-              <a:rPr sz="938" b="0">
+              <a:rPr sz="923" b="0">
                 <a:solidFill>
                   <a:srgbClr val="526179"/>
                 </a:solidFill>
@@ -5415,7 +5415,7 @@
           <p:cNvPr id="33" name="">
             <a:extLst xmlns:a="http://schemas.openxmlformats.org/drawingml/2006/main">
               <a:ext uri="{FF2B5EF4-FFF2-40B4-BE49-F238E27FC236}">
-                <a16:creationId xmlns:a16="http://schemas.microsoft.com/office/drawing/2014/main" id="{29931450-456E-47C3-9D20-A2AC9445FAD7}"/>
+                <a16:creationId xmlns:a16="http://schemas.microsoft.com/office/drawing/2014/main" id="{55F050FD-E02C-4BF2-A96B-93C227157855}"/>
               </a:ext>
             </a:extLst>
           </p:cNvPr>
@@ -5447,7 +5447,7 @@
           <p:cNvPr id="34" name="">
             <a:extLst xmlns:a="http://schemas.openxmlformats.org/drawingml/2006/main">
               <a:ext uri="{FF2B5EF4-FFF2-40B4-BE49-F238E27FC236}">
-                <a16:creationId xmlns:a16="http://schemas.microsoft.com/office/drawing/2014/main" id="{F94BB5E1-04CD-4852-B5B6-346A1AAEAE78}"/>
+                <a16:creationId xmlns:a16="http://schemas.microsoft.com/office/drawing/2014/main" id="{45D149FD-0DDD-4CF4-953A-121BB85E17C8}"/>
               </a:ext>
             </a:extLst>
           </p:cNvPr>
@@ -5477,7 +5477,7 @@
           <p:cNvPr id="35" name="">
             <a:extLst xmlns:a="http://schemas.openxmlformats.org/drawingml/2006/main">
               <a:ext uri="{FF2B5EF4-FFF2-40B4-BE49-F238E27FC236}">
-                <a16:creationId xmlns:a16="http://schemas.microsoft.com/office/drawing/2014/main" id="{006071B7-F7CB-46CA-9C18-007647DACFD7}"/>
+                <a16:creationId xmlns:a16="http://schemas.microsoft.com/office/drawing/2014/main" id="{C0CAEC59-F950-4F4E-9704-B19F05C10A4A}"/>
               </a:ext>
             </a:extLst>
           </p:cNvPr>
@@ -5536,7 +5536,7 @@
           <p:cNvPr id="36" name="">
             <a:extLst xmlns:a="http://schemas.openxmlformats.org/drawingml/2006/main">
               <a:ext uri="{FF2B5EF4-FFF2-40B4-BE49-F238E27FC236}">
-                <a16:creationId xmlns:a16="http://schemas.microsoft.com/office/drawing/2014/main" id="{82AA39EA-66F6-49EA-BC12-4AEC02A3D58E}"/>
+                <a16:creationId xmlns:a16="http://schemas.microsoft.com/office/drawing/2014/main" id="{E41446E7-9CB4-44E8-AFB6-E59B6CCE9A4A}"/>
               </a:ext>
             </a:extLst>
           </p:cNvPr>
@@ -5567,7 +5567,7 @@
           <a:lstStyle xmlns:a="http://schemas.openxmlformats.org/drawingml/2006/main"/>
           <a:p xmlns:a="http://schemas.openxmlformats.org/drawingml/2006/main">
             <a:pPr algn="l">
-              <a:defRPr sz="938" b="0">
+              <a:defRPr sz="923" b="0">
                 <a:solidFill>
                   <a:srgbClr val="526179"/>
                 </a:solidFill>
@@ -5577,7 +5577,7 @@
               </a:defRPr>
             </a:pPr>
             <a:r>
-              <a:rPr sz="938" b="0">
+              <a:rPr sz="923" b="0">
                 <a:solidFill>
                   <a:srgbClr val="526179"/>
                 </a:solidFill>
@@ -5595,7 +5595,7 @@
           <p:cNvPr id="37" name="">
             <a:extLst xmlns:a="http://schemas.openxmlformats.org/drawingml/2006/main">
               <a:ext uri="{FF2B5EF4-FFF2-40B4-BE49-F238E27FC236}">
-                <a16:creationId xmlns:a16="http://schemas.microsoft.com/office/drawing/2014/main" id="{2FC97265-64B1-415F-A4AF-B9B968F120E3}"/>
+                <a16:creationId xmlns:a16="http://schemas.microsoft.com/office/drawing/2014/main" id="{6C77FD35-0652-4267-BB5C-5B60BC8F8BE0}"/>
               </a:ext>
             </a:extLst>
           </p:cNvPr>
@@ -5627,7 +5627,7 @@
           <p:cNvPr id="38" name="">
             <a:extLst xmlns:a="http://schemas.openxmlformats.org/drawingml/2006/main">
               <a:ext uri="{FF2B5EF4-FFF2-40B4-BE49-F238E27FC236}">
-                <a16:creationId xmlns:a16="http://schemas.microsoft.com/office/drawing/2014/main" id="{5D915CEA-9440-495F-8E63-8962C659F295}"/>
+                <a16:creationId xmlns:a16="http://schemas.microsoft.com/office/drawing/2014/main" id="{88721B6B-C2C7-42DE-9772-FB9D41C20503}"/>
               </a:ext>
             </a:extLst>
           </p:cNvPr>
@@ -5684,7 +5684,7 @@
     </p:spTree>
     <p:extLst>
       <p:ext uri="{BB962C8B-B14F-4D97-AF65-F5344CB8AC3E}">
-        <p14:creationId xmlns:p14="http://schemas.microsoft.com/office/powerpoint/2010/main" val="45058135"/>
+        <p14:creationId xmlns:p14="http://schemas.microsoft.com/office/powerpoint/2010/main" val="765995606"/>
       </p:ext>
     </p:extLst>
   </p:cSld>
@@ -5708,7 +5708,7 @@
           <p:cNvPr id="1" name="">
             <a:extLst xmlns:a="http://schemas.openxmlformats.org/drawingml/2006/main">
               <a:ext uri="{FF2B5EF4-FFF2-40B4-BE49-F238E27FC236}">
-                <a16:creationId xmlns:a16="http://schemas.microsoft.com/office/drawing/2014/main" id="{6A4EC701-33F9-4710-A2F6-BAD1AA4910DE}"/>
+                <a16:creationId xmlns:a16="http://schemas.microsoft.com/office/drawing/2014/main" id="{C0F81682-6BC4-4EBF-99FA-05A42E979955}"/>
               </a:ext>
             </a:extLst>
           </p:cNvPr>
@@ -5738,7 +5738,7 @@
           <p:cNvPr id="2" name="">
             <a:extLst xmlns:a="http://schemas.openxmlformats.org/drawingml/2006/main">
               <a:ext uri="{FF2B5EF4-FFF2-40B4-BE49-F238E27FC236}">
-                <a16:creationId xmlns:a16="http://schemas.microsoft.com/office/drawing/2014/main" id="{16D482C6-04FC-4425-A439-94E39EF715F9}"/>
+                <a16:creationId xmlns:a16="http://schemas.microsoft.com/office/drawing/2014/main" id="{EF04125E-23F8-481E-BFE6-C12E3A24257E}"/>
               </a:ext>
             </a:extLst>
           </p:cNvPr>
@@ -5768,7 +5768,7 @@
           <p:cNvPr id="3" name="">
             <a:extLst xmlns:a="http://schemas.openxmlformats.org/drawingml/2006/main">
               <a:ext uri="{FF2B5EF4-FFF2-40B4-BE49-F238E27FC236}">
-                <a16:creationId xmlns:a16="http://schemas.microsoft.com/office/drawing/2014/main" id="{D2F0D7BE-A619-4D81-A59E-F5DD939916F7}"/>
+                <a16:creationId xmlns:a16="http://schemas.microsoft.com/office/drawing/2014/main" id="{38F79F6E-9E6F-454B-863A-F161EF35B2D6}"/>
               </a:ext>
             </a:extLst>
           </p:cNvPr>
@@ -5827,7 +5827,7 @@
           <p:cNvPr id="4" name="">
             <a:extLst xmlns:a="http://schemas.openxmlformats.org/drawingml/2006/main">
               <a:ext uri="{FF2B5EF4-FFF2-40B4-BE49-F238E27FC236}">
-                <a16:creationId xmlns:a16="http://schemas.microsoft.com/office/drawing/2014/main" id="{8D57DABA-D378-4DA3-BED4-BD52D0F1DA6E}"/>
+                <a16:creationId xmlns:a16="http://schemas.microsoft.com/office/drawing/2014/main" id="{F5609489-00DD-44BE-90E5-A2BE49AC31A1}"/>
               </a:ext>
             </a:extLst>
           </p:cNvPr>
@@ -5886,7 +5886,7 @@
           <p:cNvPr id="5" name="">
             <a:extLst xmlns:a="http://schemas.openxmlformats.org/drawingml/2006/main">
               <a:ext uri="{FF2B5EF4-FFF2-40B4-BE49-F238E27FC236}">
-                <a16:creationId xmlns:a16="http://schemas.microsoft.com/office/drawing/2014/main" id="{EEE9D18C-0823-47BD-A98E-8A35FA01CA40}"/>
+                <a16:creationId xmlns:a16="http://schemas.microsoft.com/office/drawing/2014/main" id="{D5614061-F018-420D-8474-1C9D38921EFF}"/>
               </a:ext>
             </a:extLst>
           </p:cNvPr>
@@ -5945,7 +5945,7 @@
           <p:cNvPr id="6" name="">
             <a:extLst xmlns:a="http://schemas.openxmlformats.org/drawingml/2006/main">
               <a:ext uri="{FF2B5EF4-FFF2-40B4-BE49-F238E27FC236}">
-                <a16:creationId xmlns:a16="http://schemas.microsoft.com/office/drawing/2014/main" id="{FC4093E3-88A9-49BD-8105-633477762137}"/>
+                <a16:creationId xmlns:a16="http://schemas.microsoft.com/office/drawing/2014/main" id="{A0AD69D2-F8B5-48F4-8AAF-CF1F4D1E4FAF}"/>
               </a:ext>
             </a:extLst>
           </p:cNvPr>
@@ -6008,7 +6008,7 @@
           <p:nvPr/>
         </p:nvPicPr>
         <p:blipFill>
-          <a:blip xmlns:r="http://schemas.openxmlformats.org/officeDocument/2006/relationships" xmlns:a="http://schemas.openxmlformats.org/drawingml/2006/main" r:embed="R0a20c01481f74b47"/>
+          <a:blip xmlns:r="http://schemas.openxmlformats.org/officeDocument/2006/relationships" xmlns:a="http://schemas.openxmlformats.org/drawingml/2006/main" r:embed="R926b541c7c5e412b"/>
           <a:srcRect xmlns:a="http://schemas.openxmlformats.org/drawingml/2006/main" l="0" t="914" r="0" b="914"/>
           <a:stretch xmlns:a="http://schemas.openxmlformats.org/drawingml/2006/main">
             <a:fillRect l="0" t="0" r="0" b="0"/>
@@ -6029,7 +6029,7 @@
           <p:cNvPr id="8" name="">
             <a:extLst xmlns:a="http://schemas.openxmlformats.org/drawingml/2006/main">
               <a:ext uri="{FF2B5EF4-FFF2-40B4-BE49-F238E27FC236}">
-                <a16:creationId xmlns:a16="http://schemas.microsoft.com/office/drawing/2014/main" id="{4E18DB34-4B2E-4B66-8B4A-EE643E50C7D5}"/>
+                <a16:creationId xmlns:a16="http://schemas.microsoft.com/office/drawing/2014/main" id="{09354B63-E563-4520-A330-BD27C5E2573F}"/>
               </a:ext>
             </a:extLst>
           </p:cNvPr>
@@ -6061,7 +6061,7 @@
           <p:cNvPr id="9" name="">
             <a:extLst xmlns:a="http://schemas.openxmlformats.org/drawingml/2006/main">
               <a:ext uri="{FF2B5EF4-FFF2-40B4-BE49-F238E27FC236}">
-                <a16:creationId xmlns:a16="http://schemas.microsoft.com/office/drawing/2014/main" id="{1AA5DEC4-035F-4D9C-9811-F7B57A85E176}"/>
+                <a16:creationId xmlns:a16="http://schemas.microsoft.com/office/drawing/2014/main" id="{CC8D14D8-82DD-4E43-B2CD-3F638BA688E9}"/>
               </a:ext>
             </a:extLst>
           </p:cNvPr>
@@ -6095,7 +6095,7 @@
           <p:cNvPr id="10" name="">
             <a:extLst xmlns:a="http://schemas.openxmlformats.org/drawingml/2006/main">
               <a:ext uri="{FF2B5EF4-FFF2-40B4-BE49-F238E27FC236}">
-                <a16:creationId xmlns:a16="http://schemas.microsoft.com/office/drawing/2014/main" id="{4B8CE790-CA3B-4D83-858B-E6ACBC2DACC8}"/>
+                <a16:creationId xmlns:a16="http://schemas.microsoft.com/office/drawing/2014/main" id="{477C12E9-0B8C-44D9-B552-1F27D56BC76E}"/>
               </a:ext>
             </a:extLst>
           </p:cNvPr>
@@ -6127,7 +6127,7 @@
           <p:cNvPr id="11" name="">
             <a:extLst xmlns:a="http://schemas.openxmlformats.org/drawingml/2006/main">
               <a:ext uri="{FF2B5EF4-FFF2-40B4-BE49-F238E27FC236}">
-                <a16:creationId xmlns:a16="http://schemas.microsoft.com/office/drawing/2014/main" id="{9E52495B-A7C1-4B44-BB9A-C0AE40DC72FE}"/>
+                <a16:creationId xmlns:a16="http://schemas.microsoft.com/office/drawing/2014/main" id="{889CD8CD-D4F0-4DF5-B2B6-024ADFDCADC9}"/>
               </a:ext>
             </a:extLst>
           </p:cNvPr>
@@ -6157,7 +6157,7 @@
           <p:cNvPr id="12" name="">
             <a:extLst xmlns:a="http://schemas.openxmlformats.org/drawingml/2006/main">
               <a:ext uri="{FF2B5EF4-FFF2-40B4-BE49-F238E27FC236}">
-                <a16:creationId xmlns:a16="http://schemas.microsoft.com/office/drawing/2014/main" id="{5D388E03-D684-4E2F-96B8-C3B2D87BBFB8}"/>
+                <a16:creationId xmlns:a16="http://schemas.microsoft.com/office/drawing/2014/main" id="{1F1A7446-1B4A-4832-9952-50F69EC09E45}"/>
               </a:ext>
             </a:extLst>
           </p:cNvPr>
@@ -6216,7 +6216,7 @@
           <p:cNvPr id="13" name="">
             <a:extLst xmlns:a="http://schemas.openxmlformats.org/drawingml/2006/main">
               <a:ext uri="{FF2B5EF4-FFF2-40B4-BE49-F238E27FC236}">
-                <a16:creationId xmlns:a16="http://schemas.microsoft.com/office/drawing/2014/main" id="{C18C89FD-9947-4A6B-9B7A-CB4FD953292B}"/>
+                <a16:creationId xmlns:a16="http://schemas.microsoft.com/office/drawing/2014/main" id="{7CB60FF2-7665-4BE3-8043-D96B8AD1622A}"/>
               </a:ext>
             </a:extLst>
           </p:cNvPr>
@@ -6247,7 +6247,7 @@
           <a:lstStyle xmlns:a="http://schemas.openxmlformats.org/drawingml/2006/main"/>
           <a:p xmlns:a="http://schemas.openxmlformats.org/drawingml/2006/main">
             <a:pPr algn="l">
-              <a:defRPr sz="938" b="0">
+              <a:defRPr sz="923" b="0">
                 <a:solidFill>
                   <a:srgbClr val="526179"/>
                 </a:solidFill>
@@ -6257,7 +6257,7 @@
               </a:defRPr>
             </a:pPr>
             <a:r>
-              <a:rPr sz="938" b="0">
+              <a:rPr sz="923" b="0">
                 <a:solidFill>
                   <a:srgbClr val="526179"/>
                 </a:solidFill>
@@ -6275,7 +6275,7 @@
           <p:cNvPr id="14" name="">
             <a:extLst xmlns:a="http://schemas.openxmlformats.org/drawingml/2006/main">
               <a:ext uri="{FF2B5EF4-FFF2-40B4-BE49-F238E27FC236}">
-                <a16:creationId xmlns:a16="http://schemas.microsoft.com/office/drawing/2014/main" id="{E357385C-CBFE-4CEE-852E-22334C04E209}"/>
+                <a16:creationId xmlns:a16="http://schemas.microsoft.com/office/drawing/2014/main" id="{64A41E25-94FC-49E1-B336-C46DAC53AE68}"/>
               </a:ext>
             </a:extLst>
           </p:cNvPr>
@@ -6307,7 +6307,7 @@
           <p:cNvPr id="15" name="">
             <a:extLst xmlns:a="http://schemas.openxmlformats.org/drawingml/2006/main">
               <a:ext uri="{FF2B5EF4-FFF2-40B4-BE49-F238E27FC236}">
-                <a16:creationId xmlns:a16="http://schemas.microsoft.com/office/drawing/2014/main" id="{BA65FE9F-4810-42BF-9932-F8A25607F772}"/>
+                <a16:creationId xmlns:a16="http://schemas.microsoft.com/office/drawing/2014/main" id="{C9C51CB2-CD6D-4E08-B919-5D27A4F44260}"/>
               </a:ext>
             </a:extLst>
           </p:cNvPr>
@@ -6337,7 +6337,7 @@
           <p:cNvPr id="16" name="">
             <a:extLst xmlns:a="http://schemas.openxmlformats.org/drawingml/2006/main">
               <a:ext uri="{FF2B5EF4-FFF2-40B4-BE49-F238E27FC236}">
-                <a16:creationId xmlns:a16="http://schemas.microsoft.com/office/drawing/2014/main" id="{970E21D2-38B8-42BA-924A-23FEDD259B9E}"/>
+                <a16:creationId xmlns:a16="http://schemas.microsoft.com/office/drawing/2014/main" id="{A9F8BBA5-EC22-461A-9FFC-78F06A9F9EF0}"/>
               </a:ext>
             </a:extLst>
           </p:cNvPr>
@@ -6396,7 +6396,7 @@
           <p:cNvPr id="17" name="">
             <a:extLst xmlns:a="http://schemas.openxmlformats.org/drawingml/2006/main">
               <a:ext uri="{FF2B5EF4-FFF2-40B4-BE49-F238E27FC236}">
-                <a16:creationId xmlns:a16="http://schemas.microsoft.com/office/drawing/2014/main" id="{F254023A-80E6-42B2-B6E4-560954B7AD07}"/>
+                <a16:creationId xmlns:a16="http://schemas.microsoft.com/office/drawing/2014/main" id="{EB6DBB16-ECB7-4E8C-9964-4D3B9CBB0A15}"/>
               </a:ext>
             </a:extLst>
           </p:cNvPr>
@@ -6427,7 +6427,7 @@
           <a:lstStyle xmlns:a="http://schemas.openxmlformats.org/drawingml/2006/main"/>
           <a:p xmlns:a="http://schemas.openxmlformats.org/drawingml/2006/main">
             <a:pPr algn="l">
-              <a:defRPr sz="938" b="0">
+              <a:defRPr sz="923" b="0">
                 <a:solidFill>
                   <a:srgbClr val="526179"/>
                 </a:solidFill>
@@ -6437,7 +6437,7 @@
               </a:defRPr>
             </a:pPr>
             <a:r>
-              <a:rPr sz="938" b="0">
+              <a:rPr sz="923" b="0">
                 <a:solidFill>
                   <a:srgbClr val="526179"/>
                 </a:solidFill>
@@ -6455,7 +6455,7 @@
           <p:cNvPr id="18" name="">
             <a:extLst xmlns:a="http://schemas.openxmlformats.org/drawingml/2006/main">
               <a:ext uri="{FF2B5EF4-FFF2-40B4-BE49-F238E27FC236}">
-                <a16:creationId xmlns:a16="http://schemas.microsoft.com/office/drawing/2014/main" id="{4878BAE3-1014-40B0-9C80-E56AF501B072}"/>
+                <a16:creationId xmlns:a16="http://schemas.microsoft.com/office/drawing/2014/main" id="{1A8091F5-78F1-4745-9AFD-42A689CE2BF7}"/>
               </a:ext>
             </a:extLst>
           </p:cNvPr>
@@ -6487,7 +6487,7 @@
           <p:cNvPr id="19" name="">
             <a:extLst xmlns:a="http://schemas.openxmlformats.org/drawingml/2006/main">
               <a:ext uri="{FF2B5EF4-FFF2-40B4-BE49-F238E27FC236}">
-                <a16:creationId xmlns:a16="http://schemas.microsoft.com/office/drawing/2014/main" id="{EA0E1C8E-5F36-4A8B-B1E5-07863040CE62}"/>
+                <a16:creationId xmlns:a16="http://schemas.microsoft.com/office/drawing/2014/main" id="{C6A419F1-90D2-4A4C-950B-677CFBE08D83}"/>
               </a:ext>
             </a:extLst>
           </p:cNvPr>
@@ -6517,7 +6517,7 @@
           <p:cNvPr id="20" name="">
             <a:extLst xmlns:a="http://schemas.openxmlformats.org/drawingml/2006/main">
               <a:ext uri="{FF2B5EF4-FFF2-40B4-BE49-F238E27FC236}">
-                <a16:creationId xmlns:a16="http://schemas.microsoft.com/office/drawing/2014/main" id="{DAC68E16-8470-4F31-8274-CB4947490922}"/>
+                <a16:creationId xmlns:a16="http://schemas.microsoft.com/office/drawing/2014/main" id="{9977C6DF-4D58-412E-9B35-B3DD0FBAFCED}"/>
               </a:ext>
             </a:extLst>
           </p:cNvPr>
@@ -6576,7 +6576,7 @@
           <p:cNvPr id="21" name="">
             <a:extLst xmlns:a="http://schemas.openxmlformats.org/drawingml/2006/main">
               <a:ext uri="{FF2B5EF4-FFF2-40B4-BE49-F238E27FC236}">
-                <a16:creationId xmlns:a16="http://schemas.microsoft.com/office/drawing/2014/main" id="{D74D0E7B-97EE-4E14-9785-A49D700A1004}"/>
+                <a16:creationId xmlns:a16="http://schemas.microsoft.com/office/drawing/2014/main" id="{BF7933FD-F786-43C1-BA1C-142358F8D1AD}"/>
               </a:ext>
             </a:extLst>
           </p:cNvPr>
@@ -6607,7 +6607,7 @@
           <a:lstStyle xmlns:a="http://schemas.openxmlformats.org/drawingml/2006/main"/>
           <a:p xmlns:a="http://schemas.openxmlformats.org/drawingml/2006/main">
             <a:pPr algn="l">
-              <a:defRPr sz="938" b="0">
+              <a:defRPr sz="923" b="0">
                 <a:solidFill>
                   <a:srgbClr val="526179"/>
                 </a:solidFill>
@@ -6617,7 +6617,7 @@
               </a:defRPr>
             </a:pPr>
             <a:r>
-              <a:rPr sz="938" b="0">
+              <a:rPr sz="923" b="0">
                 <a:solidFill>
                   <a:srgbClr val="526179"/>
                 </a:solidFill>
@@ -6635,7 +6635,7 @@
           <p:cNvPr id="22" name="">
             <a:extLst xmlns:a="http://schemas.openxmlformats.org/drawingml/2006/main">
               <a:ext uri="{FF2B5EF4-FFF2-40B4-BE49-F238E27FC236}">
-                <a16:creationId xmlns:a16="http://schemas.microsoft.com/office/drawing/2014/main" id="{C43851BA-9D9B-4F68-9F46-CC34D65997D0}"/>
+                <a16:creationId xmlns:a16="http://schemas.microsoft.com/office/drawing/2014/main" id="{015BD43A-D8BB-46BD-B56C-20F11D6AC9B9}"/>
               </a:ext>
             </a:extLst>
           </p:cNvPr>
@@ -6665,7 +6665,7 @@
           <p:cNvPr id="23" name="">
             <a:extLst xmlns:a="http://schemas.openxmlformats.org/drawingml/2006/main">
               <a:ext uri="{FF2B5EF4-FFF2-40B4-BE49-F238E27FC236}">
-                <a16:creationId xmlns:a16="http://schemas.microsoft.com/office/drawing/2014/main" id="{1A57F9F3-A40A-4A41-831F-A6E5801F4078}"/>
+                <a16:creationId xmlns:a16="http://schemas.microsoft.com/office/drawing/2014/main" id="{A0F354FD-AF37-4B78-94BB-B04DA3466653}"/>
               </a:ext>
             </a:extLst>
           </p:cNvPr>
@@ -6695,7 +6695,7 @@
           <p:cNvPr id="24" name="">
             <a:extLst xmlns:a="http://schemas.openxmlformats.org/drawingml/2006/main">
               <a:ext uri="{FF2B5EF4-FFF2-40B4-BE49-F238E27FC236}">
-                <a16:creationId xmlns:a16="http://schemas.microsoft.com/office/drawing/2014/main" id="{43F79F9B-7068-4A3D-B212-6FECD61D890C}"/>
+                <a16:creationId xmlns:a16="http://schemas.microsoft.com/office/drawing/2014/main" id="{59DFBE31-7E1B-4720-8089-684048693700}"/>
               </a:ext>
             </a:extLst>
           </p:cNvPr>
@@ -6752,7 +6752,7 @@
     </p:spTree>
     <p:extLst>
       <p:ext uri="{BB962C8B-B14F-4D97-AF65-F5344CB8AC3E}">
-        <p14:creationId xmlns:p14="http://schemas.microsoft.com/office/powerpoint/2010/main" val="1327291709"/>
+        <p14:creationId xmlns:p14="http://schemas.microsoft.com/office/powerpoint/2010/main" val="844174266"/>
       </p:ext>
     </p:extLst>
   </p:cSld>
@@ -6776,7 +6776,7 @@
           <p:cNvPr id="1" name="">
             <a:extLst xmlns:a="http://schemas.openxmlformats.org/drawingml/2006/main">
               <a:ext uri="{FF2B5EF4-FFF2-40B4-BE49-F238E27FC236}">
-                <a16:creationId xmlns:a16="http://schemas.microsoft.com/office/drawing/2014/main" id="{84D1AA2D-6D7A-45ED-A78B-356D09FA34EF}"/>
+                <a16:creationId xmlns:a16="http://schemas.microsoft.com/office/drawing/2014/main" id="{85B00199-47FB-4E5C-9DC6-5F6C71AA24BC}"/>
               </a:ext>
             </a:extLst>
           </p:cNvPr>
@@ -6806,7 +6806,7 @@
           <p:cNvPr id="2" name="">
             <a:extLst xmlns:a="http://schemas.openxmlformats.org/drawingml/2006/main">
               <a:ext uri="{FF2B5EF4-FFF2-40B4-BE49-F238E27FC236}">
-                <a16:creationId xmlns:a16="http://schemas.microsoft.com/office/drawing/2014/main" id="{5D292D44-F552-4389-A78A-F9CF6951B48D}"/>
+                <a16:creationId xmlns:a16="http://schemas.microsoft.com/office/drawing/2014/main" id="{6D1EEEAE-E55D-44B2-9698-1E3D96B1BE67}"/>
               </a:ext>
             </a:extLst>
           </p:cNvPr>
@@ -6836,7 +6836,7 @@
           <p:cNvPr id="3" name="">
             <a:extLst xmlns:a="http://schemas.openxmlformats.org/drawingml/2006/main">
               <a:ext uri="{FF2B5EF4-FFF2-40B4-BE49-F238E27FC236}">
-                <a16:creationId xmlns:a16="http://schemas.microsoft.com/office/drawing/2014/main" id="{A5EA6D36-4D75-431E-9FEB-79FE331FC0A1}"/>
+                <a16:creationId xmlns:a16="http://schemas.microsoft.com/office/drawing/2014/main" id="{831E9431-F000-4684-B32E-F83137E9EDC6}"/>
               </a:ext>
             </a:extLst>
           </p:cNvPr>
@@ -6895,7 +6895,7 @@
           <p:cNvPr id="4" name="">
             <a:extLst xmlns:a="http://schemas.openxmlformats.org/drawingml/2006/main">
               <a:ext uri="{FF2B5EF4-FFF2-40B4-BE49-F238E27FC236}">
-                <a16:creationId xmlns:a16="http://schemas.microsoft.com/office/drawing/2014/main" id="{CCF0CAE1-67B8-43F2-9278-108D4ED706BA}"/>
+                <a16:creationId xmlns:a16="http://schemas.microsoft.com/office/drawing/2014/main" id="{7D4F1A75-94F0-4539-B154-DDA860B45154}"/>
               </a:ext>
             </a:extLst>
           </p:cNvPr>
@@ -6954,7 +6954,7 @@
           <p:cNvPr id="5" name="">
             <a:extLst xmlns:a="http://schemas.openxmlformats.org/drawingml/2006/main">
               <a:ext uri="{FF2B5EF4-FFF2-40B4-BE49-F238E27FC236}">
-                <a16:creationId xmlns:a16="http://schemas.microsoft.com/office/drawing/2014/main" id="{D3745AB6-45F5-436E-83E3-7269876C14E2}"/>
+                <a16:creationId xmlns:a16="http://schemas.microsoft.com/office/drawing/2014/main" id="{0663E109-3FF3-41F2-9245-6004853C2EF1}"/>
               </a:ext>
             </a:extLst>
           </p:cNvPr>
@@ -7013,7 +7013,7 @@
           <p:cNvPr id="6" name="">
             <a:extLst xmlns:a="http://schemas.openxmlformats.org/drawingml/2006/main">
               <a:ext uri="{FF2B5EF4-FFF2-40B4-BE49-F238E27FC236}">
-                <a16:creationId xmlns:a16="http://schemas.microsoft.com/office/drawing/2014/main" id="{020E2E3E-8B36-476C-9D1A-9EA3F0CB69E7}"/>
+                <a16:creationId xmlns:a16="http://schemas.microsoft.com/office/drawing/2014/main" id="{C7A2AB37-7A28-48A3-8911-20FB5CF4FB82}"/>
               </a:ext>
             </a:extLst>
           </p:cNvPr>
@@ -7072,7 +7072,7 @@
           <p:cNvPr id="7" name="">
             <a:extLst xmlns:a="http://schemas.openxmlformats.org/drawingml/2006/main">
               <a:ext uri="{FF2B5EF4-FFF2-40B4-BE49-F238E27FC236}">
-                <a16:creationId xmlns:a16="http://schemas.microsoft.com/office/drawing/2014/main" id="{78ED0961-6A9B-49CC-B7E9-69194F852B49}"/>
+                <a16:creationId xmlns:a16="http://schemas.microsoft.com/office/drawing/2014/main" id="{4BD91FE9-82BE-4007-86B8-5777EC9FE6BA}"/>
               </a:ext>
             </a:extLst>
           </p:cNvPr>
@@ -7102,7 +7102,7 @@
           <p:cNvPr id="8" name="">
             <a:extLst xmlns:a="http://schemas.openxmlformats.org/drawingml/2006/main">
               <a:ext uri="{FF2B5EF4-FFF2-40B4-BE49-F238E27FC236}">
-                <a16:creationId xmlns:a16="http://schemas.microsoft.com/office/drawing/2014/main" id="{DD7D70E9-B0FF-4C80-A894-1EC454B09FD1}"/>
+                <a16:creationId xmlns:a16="http://schemas.microsoft.com/office/drawing/2014/main" id="{2870B502-114A-4498-9DF2-73E54C4868E5}"/>
               </a:ext>
             </a:extLst>
           </p:cNvPr>
@@ -7132,7 +7132,7 @@
           <p:cNvPr id="9" name="">
             <a:extLst xmlns:a="http://schemas.openxmlformats.org/drawingml/2006/main">
               <a:ext uri="{FF2B5EF4-FFF2-40B4-BE49-F238E27FC236}">
-                <a16:creationId xmlns:a16="http://schemas.microsoft.com/office/drawing/2014/main" id="{64AB81AB-01B9-4E2F-8A49-45D597A8300D}"/>
+                <a16:creationId xmlns:a16="http://schemas.microsoft.com/office/drawing/2014/main" id="{833BAD5E-4BB9-44F8-A21E-0A2FC6659315}"/>
               </a:ext>
             </a:extLst>
           </p:cNvPr>
@@ -7191,7 +7191,7 @@
           <p:cNvPr id="10" name="">
             <a:extLst xmlns:a="http://schemas.openxmlformats.org/drawingml/2006/main">
               <a:ext uri="{FF2B5EF4-FFF2-40B4-BE49-F238E27FC236}">
-                <a16:creationId xmlns:a16="http://schemas.microsoft.com/office/drawing/2014/main" id="{D2FF977E-066F-424B-8372-94EEE0F54ECA}"/>
+                <a16:creationId xmlns:a16="http://schemas.microsoft.com/office/drawing/2014/main" id="{F433216F-1F13-4D2C-83A1-9D937B02AEF8}"/>
               </a:ext>
             </a:extLst>
           </p:cNvPr>
@@ -7223,7 +7223,7 @@
           <p:cNvPr id="11" name="">
             <a:extLst xmlns:a="http://schemas.openxmlformats.org/drawingml/2006/main">
               <a:ext uri="{FF2B5EF4-FFF2-40B4-BE49-F238E27FC236}">
-                <a16:creationId xmlns:a16="http://schemas.microsoft.com/office/drawing/2014/main" id="{6C7A77CD-6F50-48BF-96BC-2C2239C803FE}"/>
+                <a16:creationId xmlns:a16="http://schemas.microsoft.com/office/drawing/2014/main" id="{15B5E4BE-290A-4320-830F-2B3B4BDC69E7}"/>
               </a:ext>
             </a:extLst>
           </p:cNvPr>
@@ -7253,7 +7253,7 @@
           <p:cNvPr id="12" name="">
             <a:extLst xmlns:a="http://schemas.openxmlformats.org/drawingml/2006/main">
               <a:ext uri="{FF2B5EF4-FFF2-40B4-BE49-F238E27FC236}">
-                <a16:creationId xmlns:a16="http://schemas.microsoft.com/office/drawing/2014/main" id="{15A33723-9319-4893-90E6-17118398A388}"/>
+                <a16:creationId xmlns:a16="http://schemas.microsoft.com/office/drawing/2014/main" id="{8030BC76-B672-430B-A32B-73F5A610A71D}"/>
               </a:ext>
             </a:extLst>
           </p:cNvPr>
@@ -7312,7 +7312,7 @@
           <p:cNvPr id="13" name="">
             <a:extLst xmlns:a="http://schemas.openxmlformats.org/drawingml/2006/main">
               <a:ext uri="{FF2B5EF4-FFF2-40B4-BE49-F238E27FC236}">
-                <a16:creationId xmlns:a16="http://schemas.microsoft.com/office/drawing/2014/main" id="{5AB9F58F-3890-4429-A500-30CA769A5274}"/>
+                <a16:creationId xmlns:a16="http://schemas.microsoft.com/office/drawing/2014/main" id="{9AFF342D-BC2B-45B2-AD3D-789A18911FB1}"/>
               </a:ext>
             </a:extLst>
           </p:cNvPr>
@@ -7324,7 +7324,7 @@
         <p:spPr>
           <a:xfrm xmlns:a="http://schemas.openxmlformats.org/drawingml/2006/main">
             <a:off x="1123950" y="3282791"/>
-            <a:ext cx="4229100" cy="317659"/>
+            <a:ext cx="4229100" cy="266700"/>
           </a:xfrm>
           <a:prstGeom xmlns:a="http://schemas.openxmlformats.org/drawingml/2006/main" prst="rect">
             <a:avLst/>
@@ -7343,7 +7343,7 @@
           <a:lstStyle xmlns:a="http://schemas.openxmlformats.org/drawingml/2006/main"/>
           <a:p xmlns:a="http://schemas.openxmlformats.org/drawingml/2006/main">
             <a:pPr algn="l">
-              <a:defRPr sz="982" b="0">
+              <a:defRPr sz="960" b="0">
                 <a:solidFill>
                   <a:srgbClr val="526179"/>
                 </a:solidFill>
@@ -7353,7 +7353,7 @@
               </a:defRPr>
             </a:pPr>
             <a:r>
-              <a:rPr sz="982" b="0">
+              <a:rPr sz="960" b="0">
                 <a:solidFill>
                   <a:srgbClr val="526179"/>
                 </a:solidFill>
@@ -7371,7 +7371,7 @@
           <p:cNvPr id="14" name="">
             <a:extLst xmlns:a="http://schemas.openxmlformats.org/drawingml/2006/main">
               <a:ext uri="{FF2B5EF4-FFF2-40B4-BE49-F238E27FC236}">
-                <a16:creationId xmlns:a16="http://schemas.microsoft.com/office/drawing/2014/main" id="{BEC8041B-826F-4782-A138-ADC1B3C439D9}"/>
+                <a16:creationId xmlns:a16="http://schemas.microsoft.com/office/drawing/2014/main" id="{3C60868B-F738-4028-A491-385128A20DCF}"/>
               </a:ext>
             </a:extLst>
           </p:cNvPr>
@@ -7403,7 +7403,7 @@
           <p:cNvPr id="15" name="">
             <a:extLst xmlns:a="http://schemas.openxmlformats.org/drawingml/2006/main">
               <a:ext uri="{FF2B5EF4-FFF2-40B4-BE49-F238E27FC236}">
-                <a16:creationId xmlns:a16="http://schemas.microsoft.com/office/drawing/2014/main" id="{4047D558-F71E-4AEE-A7F9-82EDA09B4317}"/>
+                <a16:creationId xmlns:a16="http://schemas.microsoft.com/office/drawing/2014/main" id="{9FC95186-2CA2-41C0-A4DA-8D8B87155552}"/>
               </a:ext>
             </a:extLst>
           </p:cNvPr>
@@ -7433,7 +7433,7 @@
           <p:cNvPr id="16" name="">
             <a:extLst xmlns:a="http://schemas.openxmlformats.org/drawingml/2006/main">
               <a:ext uri="{FF2B5EF4-FFF2-40B4-BE49-F238E27FC236}">
-                <a16:creationId xmlns:a16="http://schemas.microsoft.com/office/drawing/2014/main" id="{6D0096C8-B27F-483A-9F7C-603199894D32}"/>
+                <a16:creationId xmlns:a16="http://schemas.microsoft.com/office/drawing/2014/main" id="{9112A08E-4558-471F-B945-66F0AE9AD9E5}"/>
               </a:ext>
             </a:extLst>
           </p:cNvPr>
@@ -7492,7 +7492,7 @@
           <p:cNvPr id="17" name="">
             <a:extLst xmlns:a="http://schemas.openxmlformats.org/drawingml/2006/main">
               <a:ext uri="{FF2B5EF4-FFF2-40B4-BE49-F238E27FC236}">
-                <a16:creationId xmlns:a16="http://schemas.microsoft.com/office/drawing/2014/main" id="{B22AFA36-9290-4BA4-B14D-36D08B42CA6D}"/>
+                <a16:creationId xmlns:a16="http://schemas.microsoft.com/office/drawing/2014/main" id="{E3E1E1EB-ADBC-4256-960B-FC7CFAF433B4}"/>
               </a:ext>
             </a:extLst>
           </p:cNvPr>
@@ -7504,7 +7504,7 @@
         <p:spPr>
           <a:xfrm xmlns:a="http://schemas.openxmlformats.org/drawingml/2006/main">
             <a:off x="6400800" y="3282791"/>
-            <a:ext cx="4229100" cy="317659"/>
+            <a:ext cx="4229100" cy="266700"/>
           </a:xfrm>
           <a:prstGeom xmlns:a="http://schemas.openxmlformats.org/drawingml/2006/main" prst="rect">
             <a:avLst/>
@@ -7523,7 +7523,7 @@
           <a:lstStyle xmlns:a="http://schemas.openxmlformats.org/drawingml/2006/main"/>
           <a:p xmlns:a="http://schemas.openxmlformats.org/drawingml/2006/main">
             <a:pPr algn="l">
-              <a:defRPr sz="982" b="0">
+              <a:defRPr sz="960" b="0">
                 <a:solidFill>
                   <a:srgbClr val="526179"/>
                 </a:solidFill>
@@ -7533,7 +7533,7 @@
               </a:defRPr>
             </a:pPr>
             <a:r>
-              <a:rPr sz="982" b="0">
+              <a:rPr sz="960" b="0">
                 <a:solidFill>
                   <a:srgbClr val="526179"/>
                 </a:solidFill>
@@ -7551,7 +7551,7 @@
           <p:cNvPr id="18" name="">
             <a:extLst xmlns:a="http://schemas.openxmlformats.org/drawingml/2006/main">
               <a:ext uri="{FF2B5EF4-FFF2-40B4-BE49-F238E27FC236}">
-                <a16:creationId xmlns:a16="http://schemas.microsoft.com/office/drawing/2014/main" id="{042DC5DC-D7AC-439C-B7A8-673098B5E4CB}"/>
+                <a16:creationId xmlns:a16="http://schemas.microsoft.com/office/drawing/2014/main" id="{11CA839B-AD54-4552-9126-540B82B92A65}"/>
               </a:ext>
             </a:extLst>
           </p:cNvPr>
@@ -7583,7 +7583,7 @@
           <p:cNvPr id="19" name="">
             <a:extLst xmlns:a="http://schemas.openxmlformats.org/drawingml/2006/main">
               <a:ext uri="{FF2B5EF4-FFF2-40B4-BE49-F238E27FC236}">
-                <a16:creationId xmlns:a16="http://schemas.microsoft.com/office/drawing/2014/main" id="{588209F8-D8EE-458C-9C78-94F403A401EC}"/>
+                <a16:creationId xmlns:a16="http://schemas.microsoft.com/office/drawing/2014/main" id="{168AB2F1-A361-4EEB-8D20-8037D868C933}"/>
               </a:ext>
             </a:extLst>
           </p:cNvPr>
@@ -7613,7 +7613,7 @@
           <p:cNvPr id="20" name="">
             <a:extLst xmlns:a="http://schemas.openxmlformats.org/drawingml/2006/main">
               <a:ext uri="{FF2B5EF4-FFF2-40B4-BE49-F238E27FC236}">
-                <a16:creationId xmlns:a16="http://schemas.microsoft.com/office/drawing/2014/main" id="{EDDE1E26-CAC2-4DC7-9A8B-5306B8E6EC97}"/>
+                <a16:creationId xmlns:a16="http://schemas.microsoft.com/office/drawing/2014/main" id="{5DE5F3C6-C5E1-480C-B87F-5900B211D1EC}"/>
               </a:ext>
             </a:extLst>
           </p:cNvPr>
@@ -7672,7 +7672,7 @@
           <p:cNvPr id="21" name="">
             <a:extLst xmlns:a="http://schemas.openxmlformats.org/drawingml/2006/main">
               <a:ext uri="{FF2B5EF4-FFF2-40B4-BE49-F238E27FC236}">
-                <a16:creationId xmlns:a16="http://schemas.microsoft.com/office/drawing/2014/main" id="{F68B9957-895E-4510-BF8C-4E703BE519D0}"/>
+                <a16:creationId xmlns:a16="http://schemas.microsoft.com/office/drawing/2014/main" id="{99069926-5350-45B5-99A5-96054278D7D0}"/>
               </a:ext>
             </a:extLst>
           </p:cNvPr>
@@ -7684,7 +7684,7 @@
         <p:spPr>
           <a:xfrm xmlns:a="http://schemas.openxmlformats.org/drawingml/2006/main">
             <a:off x="1123950" y="4463891"/>
-            <a:ext cx="4229100" cy="317659"/>
+            <a:ext cx="4229100" cy="266700"/>
           </a:xfrm>
           <a:prstGeom xmlns:a="http://schemas.openxmlformats.org/drawingml/2006/main" prst="rect">
             <a:avLst/>
@@ -7703,7 +7703,7 @@
           <a:lstStyle xmlns:a="http://schemas.openxmlformats.org/drawingml/2006/main"/>
           <a:p xmlns:a="http://schemas.openxmlformats.org/drawingml/2006/main">
             <a:pPr algn="l">
-              <a:defRPr sz="982" b="0">
+              <a:defRPr sz="960" b="0">
                 <a:solidFill>
                   <a:srgbClr val="526179"/>
                 </a:solidFill>
@@ -7713,7 +7713,7 @@
               </a:defRPr>
             </a:pPr>
             <a:r>
-              <a:rPr sz="982" b="0">
+              <a:rPr sz="960" b="0">
                 <a:solidFill>
                   <a:srgbClr val="526179"/>
                 </a:solidFill>
@@ -7731,7 +7731,7 @@
           <p:cNvPr id="22" name="">
             <a:extLst xmlns:a="http://schemas.openxmlformats.org/drawingml/2006/main">
               <a:ext uri="{FF2B5EF4-FFF2-40B4-BE49-F238E27FC236}">
-                <a16:creationId xmlns:a16="http://schemas.microsoft.com/office/drawing/2014/main" id="{1768D568-B501-420B-BC7E-B7CBF544E674}"/>
+                <a16:creationId xmlns:a16="http://schemas.microsoft.com/office/drawing/2014/main" id="{03800874-1DF2-4686-A211-B0C2268E947F}"/>
               </a:ext>
             </a:extLst>
           </p:cNvPr>
@@ -7763,7 +7763,7 @@
           <p:cNvPr id="23" name="">
             <a:extLst xmlns:a="http://schemas.openxmlformats.org/drawingml/2006/main">
               <a:ext uri="{FF2B5EF4-FFF2-40B4-BE49-F238E27FC236}">
-                <a16:creationId xmlns:a16="http://schemas.microsoft.com/office/drawing/2014/main" id="{4C28DAA5-85EE-4BE6-BB8C-757ABF4BF5E8}"/>
+                <a16:creationId xmlns:a16="http://schemas.microsoft.com/office/drawing/2014/main" id="{99C12B99-BA8A-4BC0-838A-C872E1E199AC}"/>
               </a:ext>
             </a:extLst>
           </p:cNvPr>
@@ -7793,7 +7793,7 @@
           <p:cNvPr id="24" name="">
             <a:extLst xmlns:a="http://schemas.openxmlformats.org/drawingml/2006/main">
               <a:ext uri="{FF2B5EF4-FFF2-40B4-BE49-F238E27FC236}">
-                <a16:creationId xmlns:a16="http://schemas.microsoft.com/office/drawing/2014/main" id="{0B72E3F4-545C-450F-AF36-3DDF62D1C541}"/>
+                <a16:creationId xmlns:a16="http://schemas.microsoft.com/office/drawing/2014/main" id="{1D7E13F5-FEC5-48CA-810A-3C5004C18D24}"/>
               </a:ext>
             </a:extLst>
           </p:cNvPr>
@@ -7852,7 +7852,7 @@
           <p:cNvPr id="25" name="">
             <a:extLst xmlns:a="http://schemas.openxmlformats.org/drawingml/2006/main">
               <a:ext uri="{FF2B5EF4-FFF2-40B4-BE49-F238E27FC236}">
-                <a16:creationId xmlns:a16="http://schemas.microsoft.com/office/drawing/2014/main" id="{55CEDE2B-1654-433B-B564-5C269F50DA1B}"/>
+                <a16:creationId xmlns:a16="http://schemas.microsoft.com/office/drawing/2014/main" id="{72072156-45E5-44C6-92EF-CB1EE409CC79}"/>
               </a:ext>
             </a:extLst>
           </p:cNvPr>
@@ -7864,7 +7864,7 @@
         <p:spPr>
           <a:xfrm xmlns:a="http://schemas.openxmlformats.org/drawingml/2006/main">
             <a:off x="6400800" y="4463891"/>
-            <a:ext cx="4229100" cy="317659"/>
+            <a:ext cx="4229100" cy="266700"/>
           </a:xfrm>
           <a:prstGeom xmlns:a="http://schemas.openxmlformats.org/drawingml/2006/main" prst="rect">
             <a:avLst/>
@@ -7883,7 +7883,7 @@
           <a:lstStyle xmlns:a="http://schemas.openxmlformats.org/drawingml/2006/main"/>
           <a:p xmlns:a="http://schemas.openxmlformats.org/drawingml/2006/main">
             <a:pPr algn="l">
-              <a:defRPr sz="982" b="0">
+              <a:defRPr sz="960" b="0">
                 <a:solidFill>
                   <a:srgbClr val="526179"/>
                 </a:solidFill>
@@ -7893,7 +7893,7 @@
               </a:defRPr>
             </a:pPr>
             <a:r>
-              <a:rPr sz="982" b="0">
+              <a:rPr sz="960" b="0">
                 <a:solidFill>
                   <a:srgbClr val="526179"/>
                 </a:solidFill>
@@ -7911,7 +7911,7 @@
           <p:cNvPr id="26" name="">
             <a:extLst xmlns:a="http://schemas.openxmlformats.org/drawingml/2006/main">
               <a:ext uri="{FF2B5EF4-FFF2-40B4-BE49-F238E27FC236}">
-                <a16:creationId xmlns:a16="http://schemas.microsoft.com/office/drawing/2014/main" id="{1BCDEC4F-426E-4223-8C01-01D47158E974}"/>
+                <a16:creationId xmlns:a16="http://schemas.microsoft.com/office/drawing/2014/main" id="{E4F53751-FABF-482F-9496-8E6C8FB1231A}"/>
               </a:ext>
             </a:extLst>
           </p:cNvPr>
@@ -7968,7 +7968,7 @@
     </p:spTree>
     <p:extLst>
       <p:ext uri="{BB962C8B-B14F-4D97-AF65-F5344CB8AC3E}">
-        <p14:creationId xmlns:p14="http://schemas.microsoft.com/office/powerpoint/2010/main" val="1912503671"/>
+        <p14:creationId xmlns:p14="http://schemas.microsoft.com/office/powerpoint/2010/main" val="2068687304"/>
       </p:ext>
     </p:extLst>
   </p:cSld>
@@ -7992,7 +7992,7 @@
           <p:cNvPr id="1" name="">
             <a:extLst xmlns:a="http://schemas.openxmlformats.org/drawingml/2006/main">
               <a:ext uri="{FF2B5EF4-FFF2-40B4-BE49-F238E27FC236}">
-                <a16:creationId xmlns:a16="http://schemas.microsoft.com/office/drawing/2014/main" id="{3DDF8A3B-9EDD-4CB3-AD95-82DE55E2F15C}"/>
+                <a16:creationId xmlns:a16="http://schemas.microsoft.com/office/drawing/2014/main" id="{65FCD863-9F5F-4506-BE66-0889C6EBE879}"/>
               </a:ext>
             </a:extLst>
           </p:cNvPr>
@@ -8022,7 +8022,7 @@
           <p:cNvPr id="2" name="">
             <a:extLst xmlns:a="http://schemas.openxmlformats.org/drawingml/2006/main">
               <a:ext uri="{FF2B5EF4-FFF2-40B4-BE49-F238E27FC236}">
-                <a16:creationId xmlns:a16="http://schemas.microsoft.com/office/drawing/2014/main" id="{84C5F0DF-081F-4770-BB52-DCF5BB13F683}"/>
+                <a16:creationId xmlns:a16="http://schemas.microsoft.com/office/drawing/2014/main" id="{1D565D83-02ED-40D5-BE80-902C60179CFD}"/>
               </a:ext>
             </a:extLst>
           </p:cNvPr>
@@ -8052,7 +8052,7 @@
           <p:cNvPr id="3" name="">
             <a:extLst xmlns:a="http://schemas.openxmlformats.org/drawingml/2006/main">
               <a:ext uri="{FF2B5EF4-FFF2-40B4-BE49-F238E27FC236}">
-                <a16:creationId xmlns:a16="http://schemas.microsoft.com/office/drawing/2014/main" id="{B4D38F89-62F2-4742-B8EE-A2CD87F55985}"/>
+                <a16:creationId xmlns:a16="http://schemas.microsoft.com/office/drawing/2014/main" id="{E9A7BE99-5CD4-43E9-B8A7-E708E3E52C6C}"/>
               </a:ext>
             </a:extLst>
           </p:cNvPr>
@@ -8111,7 +8111,7 @@
           <p:cNvPr id="4" name="">
             <a:extLst xmlns:a="http://schemas.openxmlformats.org/drawingml/2006/main">
               <a:ext uri="{FF2B5EF4-FFF2-40B4-BE49-F238E27FC236}">
-                <a16:creationId xmlns:a16="http://schemas.microsoft.com/office/drawing/2014/main" id="{072E4D38-68F0-498C-BBA9-D21ACDF91C91}"/>
+                <a16:creationId xmlns:a16="http://schemas.microsoft.com/office/drawing/2014/main" id="{0AC22BCB-A22D-4A59-87BB-654A9DC3ADA6}"/>
               </a:ext>
             </a:extLst>
           </p:cNvPr>
@@ -8170,7 +8170,7 @@
           <p:cNvPr id="5" name="">
             <a:extLst xmlns:a="http://schemas.openxmlformats.org/drawingml/2006/main">
               <a:ext uri="{FF2B5EF4-FFF2-40B4-BE49-F238E27FC236}">
-                <a16:creationId xmlns:a16="http://schemas.microsoft.com/office/drawing/2014/main" id="{5949A4C3-40C2-4EA2-9C39-62BD57FA1AD1}"/>
+                <a16:creationId xmlns:a16="http://schemas.microsoft.com/office/drawing/2014/main" id="{14F97515-C574-420E-BD07-833687427F72}"/>
               </a:ext>
             </a:extLst>
           </p:cNvPr>
@@ -8229,7 +8229,7 @@
           <p:cNvPr id="6" name="">
             <a:extLst xmlns:a="http://schemas.openxmlformats.org/drawingml/2006/main">
               <a:ext uri="{FF2B5EF4-FFF2-40B4-BE49-F238E27FC236}">
-                <a16:creationId xmlns:a16="http://schemas.microsoft.com/office/drawing/2014/main" id="{CBA82D4C-4F61-4EC0-A2FD-E6C162BA01A8}"/>
+                <a16:creationId xmlns:a16="http://schemas.microsoft.com/office/drawing/2014/main" id="{AD57E3E9-4D83-4275-A298-79BA4925491F}"/>
               </a:ext>
             </a:extLst>
           </p:cNvPr>
@@ -8292,7 +8292,7 @@
           <p:nvPr/>
         </p:nvPicPr>
         <p:blipFill>
-          <a:blip xmlns:r="http://schemas.openxmlformats.org/officeDocument/2006/relationships" xmlns:a="http://schemas.openxmlformats.org/drawingml/2006/main" r:embed="R9d5f8be238bb4e1b"/>
+          <a:blip xmlns:r="http://schemas.openxmlformats.org/officeDocument/2006/relationships" xmlns:a="http://schemas.openxmlformats.org/drawingml/2006/main" r:embed="R64c46c9be1954662"/>
           <a:srcRect xmlns:a="http://schemas.openxmlformats.org/drawingml/2006/main" l="2184" t="0" r="2184" b="0"/>
           <a:stretch xmlns:a="http://schemas.openxmlformats.org/drawingml/2006/main">
             <a:fillRect l="0" t="0" r="0" b="0"/>
@@ -8313,7 +8313,7 @@
           <p:cNvPr id="8" name="">
             <a:extLst xmlns:a="http://schemas.openxmlformats.org/drawingml/2006/main">
               <a:ext uri="{FF2B5EF4-FFF2-40B4-BE49-F238E27FC236}">
-                <a16:creationId xmlns:a16="http://schemas.microsoft.com/office/drawing/2014/main" id="{9E1F3F10-8D1C-4E8E-AE41-FC500B539158}"/>
+                <a16:creationId xmlns:a16="http://schemas.microsoft.com/office/drawing/2014/main" id="{5D34F900-F6F3-42AE-92D5-638576299346}"/>
               </a:ext>
             </a:extLst>
           </p:cNvPr>
@@ -8345,7 +8345,7 @@
           <p:cNvPr id="9" name="">
             <a:extLst xmlns:a="http://schemas.openxmlformats.org/drawingml/2006/main">
               <a:ext uri="{FF2B5EF4-FFF2-40B4-BE49-F238E27FC236}">
-                <a16:creationId xmlns:a16="http://schemas.microsoft.com/office/drawing/2014/main" id="{7D259761-0A84-4C76-9F8F-D1D14A041A90}"/>
+                <a16:creationId xmlns:a16="http://schemas.microsoft.com/office/drawing/2014/main" id="{2DAF6FE6-B603-4D88-B67C-238690CA8D8D}"/>
               </a:ext>
             </a:extLst>
           </p:cNvPr>
@@ -8379,7 +8379,7 @@
           <p:cNvPr id="10" name="">
             <a:extLst xmlns:a="http://schemas.openxmlformats.org/drawingml/2006/main">
               <a:ext uri="{FF2B5EF4-FFF2-40B4-BE49-F238E27FC236}">
-                <a16:creationId xmlns:a16="http://schemas.microsoft.com/office/drawing/2014/main" id="{4E67B3A7-89A8-400E-8F92-253738181D2F}"/>
+                <a16:creationId xmlns:a16="http://schemas.microsoft.com/office/drawing/2014/main" id="{7B2D0508-6E2B-48BC-B7D4-88D915D23FF2}"/>
               </a:ext>
             </a:extLst>
           </p:cNvPr>
@@ -8409,7 +8409,7 @@
           <p:cNvPr id="11" name="">
             <a:extLst xmlns:a="http://schemas.openxmlformats.org/drawingml/2006/main">
               <a:ext uri="{FF2B5EF4-FFF2-40B4-BE49-F238E27FC236}">
-                <a16:creationId xmlns:a16="http://schemas.microsoft.com/office/drawing/2014/main" id="{78A92154-F45E-40D8-A84F-1D4185730783}"/>
+                <a16:creationId xmlns:a16="http://schemas.microsoft.com/office/drawing/2014/main" id="{86ABEF52-87F4-4666-A4E7-49C84E52750C}"/>
               </a:ext>
             </a:extLst>
           </p:cNvPr>
@@ -8468,7 +8468,7 @@
           <p:cNvPr id="12" name="">
             <a:extLst xmlns:a="http://schemas.openxmlformats.org/drawingml/2006/main">
               <a:ext uri="{FF2B5EF4-FFF2-40B4-BE49-F238E27FC236}">
-                <a16:creationId xmlns:a16="http://schemas.microsoft.com/office/drawing/2014/main" id="{5D1AD199-EFA3-417C-9ACD-D54513F27B75}"/>
+                <a16:creationId xmlns:a16="http://schemas.microsoft.com/office/drawing/2014/main" id="{E414710D-ED2B-439E-8167-2FE75BDCCA10}"/>
               </a:ext>
             </a:extLst>
           </p:cNvPr>
@@ -8500,7 +8500,7 @@
           <p:cNvPr id="13" name="">
             <a:extLst xmlns:a="http://schemas.openxmlformats.org/drawingml/2006/main">
               <a:ext uri="{FF2B5EF4-FFF2-40B4-BE49-F238E27FC236}">
-                <a16:creationId xmlns:a16="http://schemas.microsoft.com/office/drawing/2014/main" id="{DD9A9911-9718-4BFE-9F61-92E51D9A4B83}"/>
+                <a16:creationId xmlns:a16="http://schemas.microsoft.com/office/drawing/2014/main" id="{67C6AE66-05B0-487B-A6B0-D9FF9381D262}"/>
               </a:ext>
             </a:extLst>
           </p:cNvPr>
@@ -8530,7 +8530,7 @@
           <p:cNvPr id="14" name="">
             <a:extLst xmlns:a="http://schemas.openxmlformats.org/drawingml/2006/main">
               <a:ext uri="{FF2B5EF4-FFF2-40B4-BE49-F238E27FC236}">
-                <a16:creationId xmlns:a16="http://schemas.microsoft.com/office/drawing/2014/main" id="{98F139B8-EA84-49E0-BEB7-3AC4BE879E51}"/>
+                <a16:creationId xmlns:a16="http://schemas.microsoft.com/office/drawing/2014/main" id="{84C4E7FB-52BC-4AA7-9DBB-BAF4105767B3}"/>
               </a:ext>
             </a:extLst>
           </p:cNvPr>
@@ -8589,7 +8589,7 @@
           <p:cNvPr id="15" name="">
             <a:extLst xmlns:a="http://schemas.openxmlformats.org/drawingml/2006/main">
               <a:ext uri="{FF2B5EF4-FFF2-40B4-BE49-F238E27FC236}">
-                <a16:creationId xmlns:a16="http://schemas.microsoft.com/office/drawing/2014/main" id="{0C00B6DB-61B5-45C5-8CED-88E23A09C5D9}"/>
+                <a16:creationId xmlns:a16="http://schemas.microsoft.com/office/drawing/2014/main" id="{69DF3D3D-C71A-4C52-B5DB-B4B8E171AB08}"/>
               </a:ext>
             </a:extLst>
           </p:cNvPr>
@@ -8601,7 +8601,7 @@
         <p:spPr>
           <a:xfrm xmlns:a="http://schemas.openxmlformats.org/drawingml/2006/main">
             <a:off x="914400" y="3854291"/>
-            <a:ext cx="1905000" cy="470059"/>
+            <a:ext cx="1905000" cy="355759"/>
           </a:xfrm>
           <a:prstGeom xmlns:a="http://schemas.openxmlformats.org/drawingml/2006/main" prst="rect">
             <a:avLst/>
@@ -8620,7 +8620,7 @@
           <a:lstStyle xmlns:a="http://schemas.openxmlformats.org/drawingml/2006/main"/>
           <a:p xmlns:a="http://schemas.openxmlformats.org/drawingml/2006/main">
             <a:pPr algn="l">
-              <a:defRPr sz="1050" b="0">
+              <a:defRPr sz="1028" b="0">
                 <a:solidFill>
                   <a:srgbClr val="526179"/>
                 </a:solidFill>
@@ -8630,7 +8630,7 @@
               </a:defRPr>
             </a:pPr>
             <a:r>
-              <a:rPr sz="1050" b="0">
+              <a:rPr sz="1028" b="0">
                 <a:solidFill>
                   <a:srgbClr val="526179"/>
                 </a:solidFill>
@@ -8648,7 +8648,7 @@
           <p:cNvPr id="16" name="">
             <a:extLst xmlns:a="http://schemas.openxmlformats.org/drawingml/2006/main">
               <a:ext uri="{FF2B5EF4-FFF2-40B4-BE49-F238E27FC236}">
-                <a16:creationId xmlns:a16="http://schemas.microsoft.com/office/drawing/2014/main" id="{F0E76C37-8B71-489D-8570-0490BFD6A897}"/>
+                <a16:creationId xmlns:a16="http://schemas.microsoft.com/office/drawing/2014/main" id="{95255632-3033-40FE-8B38-8AE389FA2505}"/>
               </a:ext>
             </a:extLst>
           </p:cNvPr>
@@ -8680,7 +8680,7 @@
           <p:cNvPr id="17" name="">
             <a:extLst xmlns:a="http://schemas.openxmlformats.org/drawingml/2006/main">
               <a:ext uri="{FF2B5EF4-FFF2-40B4-BE49-F238E27FC236}">
-                <a16:creationId xmlns:a16="http://schemas.microsoft.com/office/drawing/2014/main" id="{35F513B0-56D9-4106-8FE5-C765CCE89FD8}"/>
+                <a16:creationId xmlns:a16="http://schemas.microsoft.com/office/drawing/2014/main" id="{7C537A93-CBBC-4061-BCD6-577206109BC4}"/>
               </a:ext>
             </a:extLst>
           </p:cNvPr>
@@ -8710,7 +8710,7 @@
           <p:cNvPr id="18" name="">
             <a:extLst xmlns:a="http://schemas.openxmlformats.org/drawingml/2006/main">
               <a:ext uri="{FF2B5EF4-FFF2-40B4-BE49-F238E27FC236}">
-                <a16:creationId xmlns:a16="http://schemas.microsoft.com/office/drawing/2014/main" id="{C35F9061-1772-42B4-8DE3-BA9FA4C909C7}"/>
+                <a16:creationId xmlns:a16="http://schemas.microsoft.com/office/drawing/2014/main" id="{AA8CE70D-C1E6-4FC1-9208-64A3E2A7151A}"/>
               </a:ext>
             </a:extLst>
           </p:cNvPr>
@@ -8769,7 +8769,7 @@
           <p:cNvPr id="19" name="">
             <a:extLst xmlns:a="http://schemas.openxmlformats.org/drawingml/2006/main">
               <a:ext uri="{FF2B5EF4-FFF2-40B4-BE49-F238E27FC236}">
-                <a16:creationId xmlns:a16="http://schemas.microsoft.com/office/drawing/2014/main" id="{451C3013-1005-4C7C-A619-BEAA3823EA29}"/>
+                <a16:creationId xmlns:a16="http://schemas.microsoft.com/office/drawing/2014/main" id="{567DC6BC-5DE0-481C-A583-EF500B778499}"/>
               </a:ext>
             </a:extLst>
           </p:cNvPr>
@@ -8781,7 +8781,7 @@
         <p:spPr>
           <a:xfrm xmlns:a="http://schemas.openxmlformats.org/drawingml/2006/main">
             <a:off x="3543300" y="3854291"/>
-            <a:ext cx="1905000" cy="470059"/>
+            <a:ext cx="1905000" cy="355759"/>
           </a:xfrm>
           <a:prstGeom xmlns:a="http://schemas.openxmlformats.org/drawingml/2006/main" prst="rect">
             <a:avLst/>
@@ -8800,7 +8800,7 @@
           <a:lstStyle xmlns:a="http://schemas.openxmlformats.org/drawingml/2006/main"/>
           <a:p xmlns:a="http://schemas.openxmlformats.org/drawingml/2006/main">
             <a:pPr algn="l">
-              <a:defRPr sz="1050" b="0">
+              <a:defRPr sz="1028" b="0">
                 <a:solidFill>
                   <a:srgbClr val="526179"/>
                 </a:solidFill>
@@ -8810,7 +8810,7 @@
               </a:defRPr>
             </a:pPr>
             <a:r>
-              <a:rPr sz="1050" b="0">
+              <a:rPr sz="1028" b="0">
                 <a:solidFill>
                   <a:srgbClr val="526179"/>
                 </a:solidFill>
@@ -8828,7 +8828,7 @@
           <p:cNvPr id="20" name="">
             <a:extLst xmlns:a="http://schemas.openxmlformats.org/drawingml/2006/main">
               <a:ext uri="{FF2B5EF4-FFF2-40B4-BE49-F238E27FC236}">
-                <a16:creationId xmlns:a16="http://schemas.microsoft.com/office/drawing/2014/main" id="{4F860F6A-DBF3-4E05-A2B4-712A9BB3B9ED}"/>
+                <a16:creationId xmlns:a16="http://schemas.microsoft.com/office/drawing/2014/main" id="{5878B142-BD64-48D2-AA3F-AC21F5C2AE33}"/>
               </a:ext>
             </a:extLst>
           </p:cNvPr>
@@ -8860,7 +8860,7 @@
           <p:cNvPr id="21" name="">
             <a:extLst xmlns:a="http://schemas.openxmlformats.org/drawingml/2006/main">
               <a:ext uri="{FF2B5EF4-FFF2-40B4-BE49-F238E27FC236}">
-                <a16:creationId xmlns:a16="http://schemas.microsoft.com/office/drawing/2014/main" id="{69F8C6E7-EF3A-40DE-9B96-158DC7A0D2BA}"/>
+                <a16:creationId xmlns:a16="http://schemas.microsoft.com/office/drawing/2014/main" id="{950DC6C1-3306-49CB-BC13-E6EB695C1480}"/>
               </a:ext>
             </a:extLst>
           </p:cNvPr>
@@ -8917,7 +8917,7 @@
     </p:spTree>
     <p:extLst>
       <p:ext uri="{BB962C8B-B14F-4D97-AF65-F5344CB8AC3E}">
-        <p14:creationId xmlns:p14="http://schemas.microsoft.com/office/powerpoint/2010/main" val="1103490721"/>
+        <p14:creationId xmlns:p14="http://schemas.microsoft.com/office/powerpoint/2010/main" val="2007800949"/>
       </p:ext>
     </p:extLst>
   </p:cSld>
@@ -8941,7 +8941,7 @@
           <p:cNvPr id="1" name="">
             <a:extLst xmlns:a="http://schemas.openxmlformats.org/drawingml/2006/main">
               <a:ext uri="{FF2B5EF4-FFF2-40B4-BE49-F238E27FC236}">
-                <a16:creationId xmlns:a16="http://schemas.microsoft.com/office/drawing/2014/main" id="{18A4B24B-5016-4B97-8317-9723AB21CD8E}"/>
+                <a16:creationId xmlns:a16="http://schemas.microsoft.com/office/drawing/2014/main" id="{42372E64-F84D-4D13-96A3-7901E7AAA3EE}"/>
               </a:ext>
             </a:extLst>
           </p:cNvPr>
@@ -8971,7 +8971,7 @@
           <p:cNvPr id="2" name="">
             <a:extLst xmlns:a="http://schemas.openxmlformats.org/drawingml/2006/main">
               <a:ext uri="{FF2B5EF4-FFF2-40B4-BE49-F238E27FC236}">
-                <a16:creationId xmlns:a16="http://schemas.microsoft.com/office/drawing/2014/main" id="{C6888838-8C76-4633-B98B-66D82207A0F2}"/>
+                <a16:creationId xmlns:a16="http://schemas.microsoft.com/office/drawing/2014/main" id="{A80F3A43-0D21-49B2-A180-597F432E73DD}"/>
               </a:ext>
             </a:extLst>
           </p:cNvPr>
@@ -9001,7 +9001,7 @@
           <p:cNvPr id="3" name="">
             <a:extLst xmlns:a="http://schemas.openxmlformats.org/drawingml/2006/main">
               <a:ext uri="{FF2B5EF4-FFF2-40B4-BE49-F238E27FC236}">
-                <a16:creationId xmlns:a16="http://schemas.microsoft.com/office/drawing/2014/main" id="{E09422EB-83A6-47FA-A486-AD436C8BBD6A}"/>
+                <a16:creationId xmlns:a16="http://schemas.microsoft.com/office/drawing/2014/main" id="{BF6B1EAE-7B03-4633-A90C-4A5A299B45F4}"/>
               </a:ext>
             </a:extLst>
           </p:cNvPr>
@@ -9060,7 +9060,7 @@
           <p:cNvPr id="4" name="">
             <a:extLst xmlns:a="http://schemas.openxmlformats.org/drawingml/2006/main">
               <a:ext uri="{FF2B5EF4-FFF2-40B4-BE49-F238E27FC236}">
-                <a16:creationId xmlns:a16="http://schemas.microsoft.com/office/drawing/2014/main" id="{6951C9FE-00A6-4A20-8217-64F4D21298DF}"/>
+                <a16:creationId xmlns:a16="http://schemas.microsoft.com/office/drawing/2014/main" id="{FE2A4125-3424-40C0-B640-E38B112FF5D7}"/>
               </a:ext>
             </a:extLst>
           </p:cNvPr>
@@ -9119,7 +9119,7 @@
           <p:cNvPr id="5" name="">
             <a:extLst xmlns:a="http://schemas.openxmlformats.org/drawingml/2006/main">
               <a:ext uri="{FF2B5EF4-FFF2-40B4-BE49-F238E27FC236}">
-                <a16:creationId xmlns:a16="http://schemas.microsoft.com/office/drawing/2014/main" id="{95801503-902F-416D-8C0D-D525FD0CCDC4}"/>
+                <a16:creationId xmlns:a16="http://schemas.microsoft.com/office/drawing/2014/main" id="{05AAEED5-9EFE-42DA-A64F-7AF63B456160}"/>
               </a:ext>
             </a:extLst>
           </p:cNvPr>
@@ -9178,7 +9178,7 @@
           <p:cNvPr id="6" name="">
             <a:extLst xmlns:a="http://schemas.openxmlformats.org/drawingml/2006/main">
               <a:ext uri="{FF2B5EF4-FFF2-40B4-BE49-F238E27FC236}">
-                <a16:creationId xmlns:a16="http://schemas.microsoft.com/office/drawing/2014/main" id="{3E9B0E68-B667-4E98-B0FA-B694624B6A27}"/>
+                <a16:creationId xmlns:a16="http://schemas.microsoft.com/office/drawing/2014/main" id="{7FFFC9B9-E855-40DD-846A-53BE6E4AE6BF}"/>
               </a:ext>
             </a:extLst>
           </p:cNvPr>
@@ -9241,7 +9241,7 @@
           <p:nvPr/>
         </p:nvPicPr>
         <p:blipFill>
-          <a:blip xmlns:r="http://schemas.openxmlformats.org/officeDocument/2006/relationships" xmlns:a="http://schemas.openxmlformats.org/drawingml/2006/main" r:embed="R254a7ea8cf634acf"/>
+          <a:blip xmlns:r="http://schemas.openxmlformats.org/officeDocument/2006/relationships" xmlns:a="http://schemas.openxmlformats.org/drawingml/2006/main" r:embed="R31a1e48f9059485d"/>
           <a:srcRect xmlns:a="http://schemas.openxmlformats.org/drawingml/2006/main" l="4380" t="0" r="4380" b="0"/>
           <a:stretch xmlns:a="http://schemas.openxmlformats.org/drawingml/2006/main">
             <a:fillRect l="0" t="0" r="0" b="0"/>
@@ -9262,7 +9262,7 @@
           <p:cNvPr id="8" name="">
             <a:extLst xmlns:a="http://schemas.openxmlformats.org/drawingml/2006/main">
               <a:ext uri="{FF2B5EF4-FFF2-40B4-BE49-F238E27FC236}">
-                <a16:creationId xmlns:a16="http://schemas.microsoft.com/office/drawing/2014/main" id="{924DDC1D-C0E5-4E6E-AFA9-2449673A9D5D}"/>
+                <a16:creationId xmlns:a16="http://schemas.microsoft.com/office/drawing/2014/main" id="{4EA08B64-9CFF-4A1D-AC66-8754E9DC215A}"/>
               </a:ext>
             </a:extLst>
           </p:cNvPr>
@@ -9294,7 +9294,7 @@
           <p:cNvPr id="9" name="">
             <a:extLst xmlns:a="http://schemas.openxmlformats.org/drawingml/2006/main">
               <a:ext uri="{FF2B5EF4-FFF2-40B4-BE49-F238E27FC236}">
-                <a16:creationId xmlns:a16="http://schemas.microsoft.com/office/drawing/2014/main" id="{5B144D52-C500-47B2-88CC-82E7A1A525CE}"/>
+                <a16:creationId xmlns:a16="http://schemas.microsoft.com/office/drawing/2014/main" id="{9EBAE281-8239-44E6-800C-E7E3F2DFF350}"/>
               </a:ext>
             </a:extLst>
           </p:cNvPr>
@@ -9328,7 +9328,7 @@
           <p:cNvPr id="10" name="">
             <a:extLst xmlns:a="http://schemas.openxmlformats.org/drawingml/2006/main">
               <a:ext uri="{FF2B5EF4-FFF2-40B4-BE49-F238E27FC236}">
-                <a16:creationId xmlns:a16="http://schemas.microsoft.com/office/drawing/2014/main" id="{A80223A8-54AC-4DE2-8A48-673D0478E58A}"/>
+                <a16:creationId xmlns:a16="http://schemas.microsoft.com/office/drawing/2014/main" id="{C3F34BB1-5C88-4453-AE1F-38319FC12606}"/>
               </a:ext>
             </a:extLst>
           </p:cNvPr>
@@ -9360,7 +9360,7 @@
           <p:cNvPr id="11" name="">
             <a:extLst xmlns:a="http://schemas.openxmlformats.org/drawingml/2006/main">
               <a:ext uri="{FF2B5EF4-FFF2-40B4-BE49-F238E27FC236}">
-                <a16:creationId xmlns:a16="http://schemas.microsoft.com/office/drawing/2014/main" id="{90C5C3FF-D174-48DB-A779-AA4079186A90}"/>
+                <a16:creationId xmlns:a16="http://schemas.microsoft.com/office/drawing/2014/main" id="{3E7E06CD-093C-4917-BC79-F3BA70194040}"/>
               </a:ext>
             </a:extLst>
           </p:cNvPr>
@@ -9390,7 +9390,7 @@
           <p:cNvPr id="12" name="">
             <a:extLst xmlns:a="http://schemas.openxmlformats.org/drawingml/2006/main">
               <a:ext uri="{FF2B5EF4-FFF2-40B4-BE49-F238E27FC236}">
-                <a16:creationId xmlns:a16="http://schemas.microsoft.com/office/drawing/2014/main" id="{B5CC5BE3-8C27-43CE-B395-4E44D135820F}"/>
+                <a16:creationId xmlns:a16="http://schemas.microsoft.com/office/drawing/2014/main" id="{FD0A059A-B26E-4C8C-B426-0DB2F952D04E}"/>
               </a:ext>
             </a:extLst>
           </p:cNvPr>
@@ -9449,7 +9449,7 @@
           <p:cNvPr id="13" name="">
             <a:extLst xmlns:a="http://schemas.openxmlformats.org/drawingml/2006/main">
               <a:ext uri="{FF2B5EF4-FFF2-40B4-BE49-F238E27FC236}">
-                <a16:creationId xmlns:a16="http://schemas.microsoft.com/office/drawing/2014/main" id="{C98038C1-90AC-4FE7-9246-B0966C63D3A1}"/>
+                <a16:creationId xmlns:a16="http://schemas.microsoft.com/office/drawing/2014/main" id="{F8FBD620-A848-453F-A798-487569ED30C2}"/>
               </a:ext>
             </a:extLst>
           </p:cNvPr>
@@ -9461,7 +9461,7 @@
         <p:spPr>
           <a:xfrm xmlns:a="http://schemas.openxmlformats.org/drawingml/2006/main">
             <a:off x="914400" y="2558891"/>
-            <a:ext cx="1752600" cy="336709"/>
+            <a:ext cx="1752600" cy="266700"/>
           </a:xfrm>
           <a:prstGeom xmlns:a="http://schemas.openxmlformats.org/drawingml/2006/main" prst="rect">
             <a:avLst/>
@@ -9480,7 +9480,7 @@
           <a:lstStyle xmlns:a="http://schemas.openxmlformats.org/drawingml/2006/main"/>
           <a:p xmlns:a="http://schemas.openxmlformats.org/drawingml/2006/main">
             <a:pPr algn="l">
-              <a:defRPr sz="982" b="0">
+              <a:defRPr sz="960" b="0">
                 <a:solidFill>
                   <a:srgbClr val="526179"/>
                 </a:solidFill>
@@ -9490,7 +9490,7 @@
               </a:defRPr>
             </a:pPr>
             <a:r>
-              <a:rPr sz="982" b="0">
+              <a:rPr sz="960" b="0">
                 <a:solidFill>
                   <a:srgbClr val="526179"/>
                 </a:solidFill>
@@ -9508,7 +9508,7 @@
           <p:cNvPr id="14" name="">
             <a:extLst xmlns:a="http://schemas.openxmlformats.org/drawingml/2006/main">
               <a:ext uri="{FF2B5EF4-FFF2-40B4-BE49-F238E27FC236}">
-                <a16:creationId xmlns:a16="http://schemas.microsoft.com/office/drawing/2014/main" id="{F47523E3-3F6D-4857-88E8-E0ADB3EABA06}"/>
+                <a16:creationId xmlns:a16="http://schemas.microsoft.com/office/drawing/2014/main" id="{027F371B-FF6C-45A3-A6CF-992F3A62FDB4}"/>
               </a:ext>
             </a:extLst>
           </p:cNvPr>
@@ -9540,7 +9540,7 @@
           <p:cNvPr id="15" name="">
             <a:extLst xmlns:a="http://schemas.openxmlformats.org/drawingml/2006/main">
               <a:ext uri="{FF2B5EF4-FFF2-40B4-BE49-F238E27FC236}">
-                <a16:creationId xmlns:a16="http://schemas.microsoft.com/office/drawing/2014/main" id="{A3EEE5B7-D3AD-429D-819E-BB8DCEE07DA7}"/>
+                <a16:creationId xmlns:a16="http://schemas.microsoft.com/office/drawing/2014/main" id="{974C8A86-3AB3-4997-9535-F60275674851}"/>
               </a:ext>
             </a:extLst>
           </p:cNvPr>
@@ -9570,7 +9570,7 @@
           <p:cNvPr id="16" name="">
             <a:extLst xmlns:a="http://schemas.openxmlformats.org/drawingml/2006/main">
               <a:ext uri="{FF2B5EF4-FFF2-40B4-BE49-F238E27FC236}">
-                <a16:creationId xmlns:a16="http://schemas.microsoft.com/office/drawing/2014/main" id="{D4BAD846-7C2B-45EF-8F17-0747D77019DA}"/>
+                <a16:creationId xmlns:a16="http://schemas.microsoft.com/office/drawing/2014/main" id="{6CAFF1B8-72D6-4257-88DF-1CB2A42B2490}"/>
               </a:ext>
             </a:extLst>
           </p:cNvPr>
@@ -9629,7 +9629,7 @@
           <p:cNvPr id="17" name="">
             <a:extLst xmlns:a="http://schemas.openxmlformats.org/drawingml/2006/main">
               <a:ext uri="{FF2B5EF4-FFF2-40B4-BE49-F238E27FC236}">
-                <a16:creationId xmlns:a16="http://schemas.microsoft.com/office/drawing/2014/main" id="{EAB5E580-41B1-448D-8F82-150CDFA82D10}"/>
+                <a16:creationId xmlns:a16="http://schemas.microsoft.com/office/drawing/2014/main" id="{42AE636D-A20D-4DF6-8CF7-5FF921B2088E}"/>
               </a:ext>
             </a:extLst>
           </p:cNvPr>
@@ -9641,7 +9641,7 @@
         <p:spPr>
           <a:xfrm xmlns:a="http://schemas.openxmlformats.org/drawingml/2006/main">
             <a:off x="3467100" y="2558891"/>
-            <a:ext cx="1752600" cy="336709"/>
+            <a:ext cx="1752600" cy="266700"/>
           </a:xfrm>
           <a:prstGeom xmlns:a="http://schemas.openxmlformats.org/drawingml/2006/main" prst="rect">
             <a:avLst/>
@@ -9660,7 +9660,7 @@
           <a:lstStyle xmlns:a="http://schemas.openxmlformats.org/drawingml/2006/main"/>
           <a:p xmlns:a="http://schemas.openxmlformats.org/drawingml/2006/main">
             <a:pPr algn="l">
-              <a:defRPr sz="982" b="0">
+              <a:defRPr sz="960" b="0">
                 <a:solidFill>
                   <a:srgbClr val="526179"/>
                 </a:solidFill>
@@ -9670,7 +9670,7 @@
               </a:defRPr>
             </a:pPr>
             <a:r>
-              <a:rPr sz="982" b="0">
+              <a:rPr sz="960" b="0">
                 <a:solidFill>
                   <a:srgbClr val="526179"/>
                 </a:solidFill>
@@ -9688,7 +9688,7 @@
           <p:cNvPr id="18" name="">
             <a:extLst xmlns:a="http://schemas.openxmlformats.org/drawingml/2006/main">
               <a:ext uri="{FF2B5EF4-FFF2-40B4-BE49-F238E27FC236}">
-                <a16:creationId xmlns:a16="http://schemas.microsoft.com/office/drawing/2014/main" id="{C3189C3B-F9C5-49F5-BEAC-080AEA73961D}"/>
+                <a16:creationId xmlns:a16="http://schemas.microsoft.com/office/drawing/2014/main" id="{0EEFEBCB-F324-4559-B285-E9F2CB57888A}"/>
               </a:ext>
             </a:extLst>
           </p:cNvPr>
@@ -9720,7 +9720,7 @@
           <p:cNvPr id="19" name="">
             <a:extLst xmlns:a="http://schemas.openxmlformats.org/drawingml/2006/main">
               <a:ext uri="{FF2B5EF4-FFF2-40B4-BE49-F238E27FC236}">
-                <a16:creationId xmlns:a16="http://schemas.microsoft.com/office/drawing/2014/main" id="{80E10B90-6423-4D8A-B67B-C3D401ED45B2}"/>
+                <a16:creationId xmlns:a16="http://schemas.microsoft.com/office/drawing/2014/main" id="{B967C870-FD6B-4C5C-B2D0-BF4230CB186B}"/>
               </a:ext>
             </a:extLst>
           </p:cNvPr>
@@ -9750,7 +9750,7 @@
           <p:cNvPr id="20" name="">
             <a:extLst xmlns:a="http://schemas.openxmlformats.org/drawingml/2006/main">
               <a:ext uri="{FF2B5EF4-FFF2-40B4-BE49-F238E27FC236}">
-                <a16:creationId xmlns:a16="http://schemas.microsoft.com/office/drawing/2014/main" id="{6F0FC336-5BDC-4C8D-8E0A-98988AAE92BC}"/>
+                <a16:creationId xmlns:a16="http://schemas.microsoft.com/office/drawing/2014/main" id="{BD432DEF-60AD-465B-9A95-C70674CE6B05}"/>
               </a:ext>
             </a:extLst>
           </p:cNvPr>
@@ -9809,7 +9809,7 @@
           <p:cNvPr id="21" name="">
             <a:extLst xmlns:a="http://schemas.openxmlformats.org/drawingml/2006/main">
               <a:ext uri="{FF2B5EF4-FFF2-40B4-BE49-F238E27FC236}">
-                <a16:creationId xmlns:a16="http://schemas.microsoft.com/office/drawing/2014/main" id="{DDE2A83B-AB63-49D2-9D70-A5DDA4F48F7D}"/>
+                <a16:creationId xmlns:a16="http://schemas.microsoft.com/office/drawing/2014/main" id="{5BD5DDCD-DF7B-423C-A456-62311CFEEFB6}"/>
               </a:ext>
             </a:extLst>
           </p:cNvPr>
@@ -9821,7 +9821,7 @@
         <p:spPr>
           <a:xfrm xmlns:a="http://schemas.openxmlformats.org/drawingml/2006/main">
             <a:off x="914400" y="3816191"/>
-            <a:ext cx="1752600" cy="336709"/>
+            <a:ext cx="1752600" cy="266700"/>
           </a:xfrm>
           <a:prstGeom xmlns:a="http://schemas.openxmlformats.org/drawingml/2006/main" prst="rect">
             <a:avLst/>
@@ -9840,7 +9840,7 @@
           <a:lstStyle xmlns:a="http://schemas.openxmlformats.org/drawingml/2006/main"/>
           <a:p xmlns:a="http://schemas.openxmlformats.org/drawingml/2006/main">
             <a:pPr algn="l">
-              <a:defRPr sz="982" b="0">
+              <a:defRPr sz="960" b="0">
                 <a:solidFill>
                   <a:srgbClr val="526179"/>
                 </a:solidFill>
@@ -9850,7 +9850,7 @@
               </a:defRPr>
             </a:pPr>
             <a:r>
-              <a:rPr sz="982" b="0">
+              <a:rPr sz="960" b="0">
                 <a:solidFill>
                   <a:srgbClr val="526179"/>
                 </a:solidFill>
@@ -9868,7 +9868,7 @@
           <p:cNvPr id="22" name="">
             <a:extLst xmlns:a="http://schemas.openxmlformats.org/drawingml/2006/main">
               <a:ext uri="{FF2B5EF4-FFF2-40B4-BE49-F238E27FC236}">
-                <a16:creationId xmlns:a16="http://schemas.microsoft.com/office/drawing/2014/main" id="{265A19C0-6BF5-4DF0-9A5D-831FE3FCD846}"/>
+                <a16:creationId xmlns:a16="http://schemas.microsoft.com/office/drawing/2014/main" id="{2DFD6B7C-333E-4808-A55C-496E4436F724}"/>
               </a:ext>
             </a:extLst>
           </p:cNvPr>
@@ -9900,7 +9900,7 @@
           <p:cNvPr id="23" name="">
             <a:extLst xmlns:a="http://schemas.openxmlformats.org/drawingml/2006/main">
               <a:ext uri="{FF2B5EF4-FFF2-40B4-BE49-F238E27FC236}">
-                <a16:creationId xmlns:a16="http://schemas.microsoft.com/office/drawing/2014/main" id="{B09DB227-A149-426C-8D69-C57EB369CD99}"/>
+                <a16:creationId xmlns:a16="http://schemas.microsoft.com/office/drawing/2014/main" id="{3AB18A32-8D80-424C-8D91-F9B69E32D35E}"/>
               </a:ext>
             </a:extLst>
           </p:cNvPr>
@@ -9930,7 +9930,7 @@
           <p:cNvPr id="24" name="">
             <a:extLst xmlns:a="http://schemas.openxmlformats.org/drawingml/2006/main">
               <a:ext uri="{FF2B5EF4-FFF2-40B4-BE49-F238E27FC236}">
-                <a16:creationId xmlns:a16="http://schemas.microsoft.com/office/drawing/2014/main" id="{8CF8A7C3-145F-4015-8FFB-DBD73683D62A}"/>
+                <a16:creationId xmlns:a16="http://schemas.microsoft.com/office/drawing/2014/main" id="{DE9A063C-1DEF-4761-8173-BF388EAAB4F6}"/>
               </a:ext>
             </a:extLst>
           </p:cNvPr>
@@ -9989,7 +9989,7 @@
           <p:cNvPr id="25" name="">
             <a:extLst xmlns:a="http://schemas.openxmlformats.org/drawingml/2006/main">
               <a:ext uri="{FF2B5EF4-FFF2-40B4-BE49-F238E27FC236}">
-                <a16:creationId xmlns:a16="http://schemas.microsoft.com/office/drawing/2014/main" id="{EA1DA0B2-B3DB-4505-AAD5-CF4DDDB96B46}"/>
+                <a16:creationId xmlns:a16="http://schemas.microsoft.com/office/drawing/2014/main" id="{A332D009-4BD3-4B5F-A745-EDCAAF8A5356}"/>
               </a:ext>
             </a:extLst>
           </p:cNvPr>
@@ -10001,7 +10001,7 @@
         <p:spPr>
           <a:xfrm xmlns:a="http://schemas.openxmlformats.org/drawingml/2006/main">
             <a:off x="3467100" y="3816191"/>
-            <a:ext cx="1752600" cy="336709"/>
+            <a:ext cx="1752600" cy="266700"/>
           </a:xfrm>
           <a:prstGeom xmlns:a="http://schemas.openxmlformats.org/drawingml/2006/main" prst="rect">
             <a:avLst/>
@@ -10020,7 +10020,7 @@
           <a:lstStyle xmlns:a="http://schemas.openxmlformats.org/drawingml/2006/main"/>
           <a:p xmlns:a="http://schemas.openxmlformats.org/drawingml/2006/main">
             <a:pPr algn="l">
-              <a:defRPr sz="982" b="0">
+              <a:defRPr sz="960" b="0">
                 <a:solidFill>
                   <a:srgbClr val="526179"/>
                 </a:solidFill>
@@ -10030,7 +10030,7 @@
               </a:defRPr>
             </a:pPr>
             <a:r>
-              <a:rPr sz="982" b="0">
+              <a:rPr sz="960" b="0">
                 <a:solidFill>
                   <a:srgbClr val="526179"/>
                 </a:solidFill>
@@ -10048,7 +10048,7 @@
           <p:cNvPr id="26" name="">
             <a:extLst xmlns:a="http://schemas.openxmlformats.org/drawingml/2006/main">
               <a:ext uri="{FF2B5EF4-FFF2-40B4-BE49-F238E27FC236}">
-                <a16:creationId xmlns:a16="http://schemas.microsoft.com/office/drawing/2014/main" id="{2E8B0477-6715-45CC-8F28-6A733969A4CA}"/>
+                <a16:creationId xmlns:a16="http://schemas.microsoft.com/office/drawing/2014/main" id="{E918308A-8719-4349-A96C-98A46320088D}"/>
               </a:ext>
             </a:extLst>
           </p:cNvPr>
@@ -10078,7 +10078,7 @@
           <p:cNvPr id="27" name="">
             <a:extLst xmlns:a="http://schemas.openxmlformats.org/drawingml/2006/main">
               <a:ext uri="{FF2B5EF4-FFF2-40B4-BE49-F238E27FC236}">
-                <a16:creationId xmlns:a16="http://schemas.microsoft.com/office/drawing/2014/main" id="{14440609-C005-4F2F-B5D4-C9E893DDB415}"/>
+                <a16:creationId xmlns:a16="http://schemas.microsoft.com/office/drawing/2014/main" id="{F9B5DE6C-918E-47E3-BE87-1FDB8BEA7E3C}"/>
               </a:ext>
             </a:extLst>
           </p:cNvPr>
@@ -10108,7 +10108,7 @@
           <p:cNvPr id="28" name="">
             <a:extLst xmlns:a="http://schemas.openxmlformats.org/drawingml/2006/main">
               <a:ext uri="{FF2B5EF4-FFF2-40B4-BE49-F238E27FC236}">
-                <a16:creationId xmlns:a16="http://schemas.microsoft.com/office/drawing/2014/main" id="{893E4FD1-4069-4ED5-B3A7-EC9352B7B567}"/>
+                <a16:creationId xmlns:a16="http://schemas.microsoft.com/office/drawing/2014/main" id="{1D6A56C4-B2A2-4471-9315-B15C67AA2897}"/>
               </a:ext>
             </a:extLst>
           </p:cNvPr>
@@ -10165,7 +10165,7 @@
     </p:spTree>
     <p:extLst>
       <p:ext uri="{BB962C8B-B14F-4D97-AF65-F5344CB8AC3E}">
-        <p14:creationId xmlns:p14="http://schemas.microsoft.com/office/powerpoint/2010/main" val="188688062"/>
+        <p14:creationId xmlns:p14="http://schemas.microsoft.com/office/powerpoint/2010/main" val="1157937816"/>
       </p:ext>
     </p:extLst>
   </p:cSld>
@@ -10189,7 +10189,7 @@
           <p:cNvPr id="1" name="">
             <a:extLst xmlns:a="http://schemas.openxmlformats.org/drawingml/2006/main">
               <a:ext uri="{FF2B5EF4-FFF2-40B4-BE49-F238E27FC236}">
-                <a16:creationId xmlns:a16="http://schemas.microsoft.com/office/drawing/2014/main" id="{FDAACCCE-296F-4F0A-833A-4C31277162FC}"/>
+                <a16:creationId xmlns:a16="http://schemas.microsoft.com/office/drawing/2014/main" id="{796AC90A-398A-4477-94A8-329BF24DFAAA}"/>
               </a:ext>
             </a:extLst>
           </p:cNvPr>
@@ -10219,7 +10219,7 @@
           <p:cNvPr id="2" name="">
             <a:extLst xmlns:a="http://schemas.openxmlformats.org/drawingml/2006/main">
               <a:ext uri="{FF2B5EF4-FFF2-40B4-BE49-F238E27FC236}">
-                <a16:creationId xmlns:a16="http://schemas.microsoft.com/office/drawing/2014/main" id="{AC3F8B08-98B4-436E-AAF9-11583E60F98A}"/>
+                <a16:creationId xmlns:a16="http://schemas.microsoft.com/office/drawing/2014/main" id="{9FC09008-8D6B-4E80-9357-7E06B52002BC}"/>
               </a:ext>
             </a:extLst>
           </p:cNvPr>
@@ -10249,7 +10249,7 @@
           <p:cNvPr id="3" name="">
             <a:extLst xmlns:a="http://schemas.openxmlformats.org/drawingml/2006/main">
               <a:ext uri="{FF2B5EF4-FFF2-40B4-BE49-F238E27FC236}">
-                <a16:creationId xmlns:a16="http://schemas.microsoft.com/office/drawing/2014/main" id="{82096D80-02C0-4190-97DE-D3F00E6BD7BA}"/>
+                <a16:creationId xmlns:a16="http://schemas.microsoft.com/office/drawing/2014/main" id="{7539164F-38BD-45DA-B8F3-F7ED13C5CDA3}"/>
               </a:ext>
             </a:extLst>
           </p:cNvPr>
@@ -10308,7 +10308,7 @@
           <p:cNvPr id="4" name="">
             <a:extLst xmlns:a="http://schemas.openxmlformats.org/drawingml/2006/main">
               <a:ext uri="{FF2B5EF4-FFF2-40B4-BE49-F238E27FC236}">
-                <a16:creationId xmlns:a16="http://schemas.microsoft.com/office/drawing/2014/main" id="{14DA7D74-AFFF-4479-8542-DCAF10E321CC}"/>
+                <a16:creationId xmlns:a16="http://schemas.microsoft.com/office/drawing/2014/main" id="{087537C5-F0CD-45E6-A053-FE8A99E89AA6}"/>
               </a:ext>
             </a:extLst>
           </p:cNvPr>
@@ -10367,7 +10367,7 @@
           <p:cNvPr id="5" name="">
             <a:extLst xmlns:a="http://schemas.openxmlformats.org/drawingml/2006/main">
               <a:ext uri="{FF2B5EF4-FFF2-40B4-BE49-F238E27FC236}">
-                <a16:creationId xmlns:a16="http://schemas.microsoft.com/office/drawing/2014/main" id="{8BEA8A11-1F06-42AC-9B03-26D408B6B189}"/>
+                <a16:creationId xmlns:a16="http://schemas.microsoft.com/office/drawing/2014/main" id="{09F2725F-D5C4-4D75-B552-CBBD7D7E181E}"/>
               </a:ext>
             </a:extLst>
           </p:cNvPr>
@@ -10426,7 +10426,7 @@
           <p:cNvPr id="6" name="">
             <a:extLst xmlns:a="http://schemas.openxmlformats.org/drawingml/2006/main">
               <a:ext uri="{FF2B5EF4-FFF2-40B4-BE49-F238E27FC236}">
-                <a16:creationId xmlns:a16="http://schemas.microsoft.com/office/drawing/2014/main" id="{C76CC3DE-39E1-4873-9D3E-FF3F52625AEE}"/>
+                <a16:creationId xmlns:a16="http://schemas.microsoft.com/office/drawing/2014/main" id="{039AAB20-66C8-4880-B635-1BAF55369DB4}"/>
               </a:ext>
             </a:extLst>
           </p:cNvPr>
@@ -10489,7 +10489,7 @@
           <p:nvPr/>
         </p:nvPicPr>
         <p:blipFill>
-          <a:blip xmlns:r="http://schemas.openxmlformats.org/officeDocument/2006/relationships" xmlns:a="http://schemas.openxmlformats.org/drawingml/2006/main" r:embed="R04dfec2ee3564831"/>
+          <a:blip xmlns:r="http://schemas.openxmlformats.org/officeDocument/2006/relationships" xmlns:a="http://schemas.openxmlformats.org/drawingml/2006/main" r:embed="R1e3b9ffd952f49db"/>
           <a:srcRect xmlns:a="http://schemas.openxmlformats.org/drawingml/2006/main" l="0" t="410" r="0" b="410"/>
           <a:stretch xmlns:a="http://schemas.openxmlformats.org/drawingml/2006/main">
             <a:fillRect l="0" t="0" r="0" b="0"/>
@@ -10510,7 +10510,7 @@
           <p:cNvPr id="8" name="">
             <a:extLst xmlns:a="http://schemas.openxmlformats.org/drawingml/2006/main">
               <a:ext uri="{FF2B5EF4-FFF2-40B4-BE49-F238E27FC236}">
-                <a16:creationId xmlns:a16="http://schemas.microsoft.com/office/drawing/2014/main" id="{6B5048CA-6A94-412C-9621-CD4E6C695810}"/>
+                <a16:creationId xmlns:a16="http://schemas.microsoft.com/office/drawing/2014/main" id="{F98CE58D-D687-4210-B919-5C7C6542C803}"/>
               </a:ext>
             </a:extLst>
           </p:cNvPr>
@@ -10542,7 +10542,7 @@
           <p:cNvPr id="9" name="">
             <a:extLst xmlns:a="http://schemas.openxmlformats.org/drawingml/2006/main">
               <a:ext uri="{FF2B5EF4-FFF2-40B4-BE49-F238E27FC236}">
-                <a16:creationId xmlns:a16="http://schemas.microsoft.com/office/drawing/2014/main" id="{69A714D0-DFD2-4D25-9252-1977002274A5}"/>
+                <a16:creationId xmlns:a16="http://schemas.microsoft.com/office/drawing/2014/main" id="{9181A712-BB0F-4F28-ADED-8581F25E0653}"/>
               </a:ext>
             </a:extLst>
           </p:cNvPr>
@@ -10576,7 +10576,7 @@
           <p:cNvPr id="10" name="">
             <a:extLst xmlns:a="http://schemas.openxmlformats.org/drawingml/2006/main">
               <a:ext uri="{FF2B5EF4-FFF2-40B4-BE49-F238E27FC236}">
-                <a16:creationId xmlns:a16="http://schemas.microsoft.com/office/drawing/2014/main" id="{A2FAB0AB-CD03-42C5-AF3E-77D27B453EFE}"/>
+                <a16:creationId xmlns:a16="http://schemas.microsoft.com/office/drawing/2014/main" id="{392F3EB8-9E71-4C1C-8F49-D01BF863DC07}"/>
               </a:ext>
             </a:extLst>
           </p:cNvPr>
@@ -10606,7 +10606,7 @@
           <p:cNvPr id="11" name="">
             <a:extLst xmlns:a="http://schemas.openxmlformats.org/drawingml/2006/main">
               <a:ext uri="{FF2B5EF4-FFF2-40B4-BE49-F238E27FC236}">
-                <a16:creationId xmlns:a16="http://schemas.microsoft.com/office/drawing/2014/main" id="{4A0486C2-C0A6-4AA8-AD52-A2A6B6F0A1B7}"/>
+                <a16:creationId xmlns:a16="http://schemas.microsoft.com/office/drawing/2014/main" id="{B3C6903C-C7C9-4925-901D-BDE9B54E24AC}"/>
               </a:ext>
             </a:extLst>
           </p:cNvPr>
@@ -10665,7 +10665,7 @@
           <p:cNvPr id="12" name="">
             <a:extLst xmlns:a="http://schemas.openxmlformats.org/drawingml/2006/main">
               <a:ext uri="{FF2B5EF4-FFF2-40B4-BE49-F238E27FC236}">
-                <a16:creationId xmlns:a16="http://schemas.microsoft.com/office/drawing/2014/main" id="{966A1F1E-1A62-49AC-B577-3A8CF8EE84E6}"/>
+                <a16:creationId xmlns:a16="http://schemas.microsoft.com/office/drawing/2014/main" id="{285CDC0B-B023-4500-B4D8-C0BD1390A43F}"/>
               </a:ext>
             </a:extLst>
           </p:cNvPr>
@@ -10695,7 +10695,7 @@
           <p:cNvPr id="13" name="">
             <a:extLst xmlns:a="http://schemas.openxmlformats.org/drawingml/2006/main">
               <a:ext uri="{FF2B5EF4-FFF2-40B4-BE49-F238E27FC236}">
-                <a16:creationId xmlns:a16="http://schemas.microsoft.com/office/drawing/2014/main" id="{D960C6BA-E41C-4435-9AE5-2D2069CCCCA9}"/>
+                <a16:creationId xmlns:a16="http://schemas.microsoft.com/office/drawing/2014/main" id="{3A70A067-203F-4712-9BD8-D7E1120C4006}"/>
               </a:ext>
             </a:extLst>
           </p:cNvPr>
@@ -10725,7 +10725,7 @@
           <p:cNvPr id="14" name="">
             <a:extLst xmlns:a="http://schemas.openxmlformats.org/drawingml/2006/main">
               <a:ext uri="{FF2B5EF4-FFF2-40B4-BE49-F238E27FC236}">
-                <a16:creationId xmlns:a16="http://schemas.microsoft.com/office/drawing/2014/main" id="{AE984A3E-737C-4F87-984A-36EADCD25DC0}"/>
+                <a16:creationId xmlns:a16="http://schemas.microsoft.com/office/drawing/2014/main" id="{89CE5481-2DC6-4B59-ABAE-B777A82AFAD1}"/>
               </a:ext>
             </a:extLst>
           </p:cNvPr>
@@ -10784,7 +10784,7 @@
           <p:cNvPr id="15" name="">
             <a:extLst xmlns:a="http://schemas.openxmlformats.org/drawingml/2006/main">
               <a:ext uri="{FF2B5EF4-FFF2-40B4-BE49-F238E27FC236}">
-                <a16:creationId xmlns:a16="http://schemas.microsoft.com/office/drawing/2014/main" id="{9FC270AF-B17B-4D86-880A-A0CB1E458442}"/>
+                <a16:creationId xmlns:a16="http://schemas.microsoft.com/office/drawing/2014/main" id="{3A1CA335-82B9-4D34-84BA-9B116BD30AFF}"/>
               </a:ext>
             </a:extLst>
           </p:cNvPr>
@@ -10816,7 +10816,7 @@
           <p:cNvPr id="16" name="">
             <a:extLst xmlns:a="http://schemas.openxmlformats.org/drawingml/2006/main">
               <a:ext uri="{FF2B5EF4-FFF2-40B4-BE49-F238E27FC236}">
-                <a16:creationId xmlns:a16="http://schemas.microsoft.com/office/drawing/2014/main" id="{B078D517-B63E-45EC-BB05-4274F4016D74}"/>
+                <a16:creationId xmlns:a16="http://schemas.microsoft.com/office/drawing/2014/main" id="{DE0754B9-A3C8-44B6-845C-3E57A67643C1}"/>
               </a:ext>
             </a:extLst>
           </p:cNvPr>
@@ -10846,7 +10846,7 @@
           <p:cNvPr id="17" name="">
             <a:extLst xmlns:a="http://schemas.openxmlformats.org/drawingml/2006/main">
               <a:ext uri="{FF2B5EF4-FFF2-40B4-BE49-F238E27FC236}">
-                <a16:creationId xmlns:a16="http://schemas.microsoft.com/office/drawing/2014/main" id="{4F3979D3-C9B5-4711-8E14-F751858EF9D2}"/>
+                <a16:creationId xmlns:a16="http://schemas.microsoft.com/office/drawing/2014/main" id="{EFE8A660-14FB-4A6F-B185-1B70449DAD96}"/>
               </a:ext>
             </a:extLst>
           </p:cNvPr>
@@ -10905,7 +10905,7 @@
           <p:cNvPr id="18" name="">
             <a:extLst xmlns:a="http://schemas.openxmlformats.org/drawingml/2006/main">
               <a:ext uri="{FF2B5EF4-FFF2-40B4-BE49-F238E27FC236}">
-                <a16:creationId xmlns:a16="http://schemas.microsoft.com/office/drawing/2014/main" id="{4A299EF0-CC04-4EB8-AEEE-F1518D176228}"/>
+                <a16:creationId xmlns:a16="http://schemas.microsoft.com/office/drawing/2014/main" id="{1A3D673C-DFD9-4F60-B57D-5578D215734A}"/>
               </a:ext>
             </a:extLst>
           </p:cNvPr>
@@ -10917,7 +10917,7 @@
         <p:spPr>
           <a:xfrm xmlns:a="http://schemas.openxmlformats.org/drawingml/2006/main">
             <a:off x="914400" y="4463891"/>
-            <a:ext cx="1905000" cy="317659"/>
+            <a:ext cx="1905000" cy="266700"/>
           </a:xfrm>
           <a:prstGeom xmlns:a="http://schemas.openxmlformats.org/drawingml/2006/main" prst="rect">
             <a:avLst/>
@@ -10936,7 +10936,7 @@
           <a:lstStyle xmlns:a="http://schemas.openxmlformats.org/drawingml/2006/main"/>
           <a:p xmlns:a="http://schemas.openxmlformats.org/drawingml/2006/main">
             <a:pPr algn="l">
-              <a:defRPr sz="982" b="0">
+              <a:defRPr sz="960" b="0">
                 <a:solidFill>
                   <a:srgbClr val="526179"/>
                 </a:solidFill>
@@ -10946,7 +10946,7 @@
               </a:defRPr>
             </a:pPr>
             <a:r>
-              <a:rPr sz="982" b="0">
+              <a:rPr sz="960" b="0">
                 <a:solidFill>
                   <a:srgbClr val="526179"/>
                 </a:solidFill>
@@ -10954,7 +10954,7 @@
                 <a:ea typeface="Aptos"/>
                 <a:cs typeface="Aptos"/>
               </a:rPr>
-              <a:t>Package manager, install, build, lint, test, and safe local checks.</a:t>
+              <a:t>Install, build, lint, test, and local checks.</a:t>
             </a:r>
           </a:p>
         </p:txBody>
@@ -10964,7 +10964,7 @@
           <p:cNvPr id="19" name="">
             <a:extLst xmlns:a="http://schemas.openxmlformats.org/drawingml/2006/main">
               <a:ext uri="{FF2B5EF4-FFF2-40B4-BE49-F238E27FC236}">
-                <a16:creationId xmlns:a16="http://schemas.microsoft.com/office/drawing/2014/main" id="{6A3059D7-A89D-4017-9836-2795AB3DF4D0}"/>
+                <a16:creationId xmlns:a16="http://schemas.microsoft.com/office/drawing/2014/main" id="{279DC393-FFA0-4703-9FD9-9B3F323816C5}"/>
               </a:ext>
             </a:extLst>
           </p:cNvPr>
@@ -10996,7 +10996,7 @@
           <p:cNvPr id="20" name="">
             <a:extLst xmlns:a="http://schemas.openxmlformats.org/drawingml/2006/main">
               <a:ext uri="{FF2B5EF4-FFF2-40B4-BE49-F238E27FC236}">
-                <a16:creationId xmlns:a16="http://schemas.microsoft.com/office/drawing/2014/main" id="{F76538F0-7CB5-4FBF-BA60-B1CDA7235A08}"/>
+                <a16:creationId xmlns:a16="http://schemas.microsoft.com/office/drawing/2014/main" id="{C8AB1B67-75C0-4FFE-A6EB-E4585105A378}"/>
               </a:ext>
             </a:extLst>
           </p:cNvPr>
@@ -11026,7 +11026,7 @@
           <p:cNvPr id="21" name="">
             <a:extLst xmlns:a="http://schemas.openxmlformats.org/drawingml/2006/main">
               <a:ext uri="{FF2B5EF4-FFF2-40B4-BE49-F238E27FC236}">
-                <a16:creationId xmlns:a16="http://schemas.microsoft.com/office/drawing/2014/main" id="{816045BB-59AB-41F9-8224-917DEB707D9B}"/>
+                <a16:creationId xmlns:a16="http://schemas.microsoft.com/office/drawing/2014/main" id="{5B5C798E-DB99-44CC-B268-6A7C1FB1F10C}"/>
               </a:ext>
             </a:extLst>
           </p:cNvPr>
@@ -11085,7 +11085,7 @@
           <p:cNvPr id="22" name="">
             <a:extLst xmlns:a="http://schemas.openxmlformats.org/drawingml/2006/main">
               <a:ext uri="{FF2B5EF4-FFF2-40B4-BE49-F238E27FC236}">
-                <a16:creationId xmlns:a16="http://schemas.microsoft.com/office/drawing/2014/main" id="{A71EB42A-FB49-4F25-99CA-D01C5C4749C8}"/>
+                <a16:creationId xmlns:a16="http://schemas.microsoft.com/office/drawing/2014/main" id="{8AA33A28-15A8-4111-8200-3DC712FD06EC}"/>
               </a:ext>
             </a:extLst>
           </p:cNvPr>
@@ -11097,7 +11097,7 @@
         <p:spPr>
           <a:xfrm xmlns:a="http://schemas.openxmlformats.org/drawingml/2006/main">
             <a:off x="3638550" y="4463891"/>
-            <a:ext cx="1905000" cy="317659"/>
+            <a:ext cx="1905000" cy="266700"/>
           </a:xfrm>
           <a:prstGeom xmlns:a="http://schemas.openxmlformats.org/drawingml/2006/main" prst="rect">
             <a:avLst/>
@@ -11116,7 +11116,7 @@
           <a:lstStyle xmlns:a="http://schemas.openxmlformats.org/drawingml/2006/main"/>
           <a:p xmlns:a="http://schemas.openxmlformats.org/drawingml/2006/main">
             <a:pPr algn="l">
-              <a:defRPr sz="982" b="0">
+              <a:defRPr sz="960" b="0">
                 <a:solidFill>
                   <a:srgbClr val="526179"/>
                 </a:solidFill>
@@ -11126,7 +11126,7 @@
               </a:defRPr>
             </a:pPr>
             <a:r>
-              <a:rPr sz="982" b="0">
+              <a:rPr sz="960" b="0">
                 <a:solidFill>
                   <a:srgbClr val="526179"/>
                 </a:solidFill>
@@ -11134,7 +11134,7 @@
                 <a:ea typeface="Aptos"/>
                 <a:cs typeface="Aptos"/>
               </a:rPr>
-              <a:t>Architecture patterns, preferred helpers, naming, errors, and logging.</a:t>
+              <a:t>Patterns, helpers, naming, errors, and logging.</a:t>
             </a:r>
           </a:p>
         </p:txBody>
@@ -11144,7 +11144,7 @@
           <p:cNvPr id="23" name="">
             <a:extLst xmlns:a="http://schemas.openxmlformats.org/drawingml/2006/main">
               <a:ext uri="{FF2B5EF4-FFF2-40B4-BE49-F238E27FC236}">
-                <a16:creationId xmlns:a16="http://schemas.microsoft.com/office/drawing/2014/main" id="{7A931AA0-3E0B-47D9-88E6-46278DC35849}"/>
+                <a16:creationId xmlns:a16="http://schemas.microsoft.com/office/drawing/2014/main" id="{C71791A0-ACD2-4475-AEA8-280D8BDA8B38}"/>
               </a:ext>
             </a:extLst>
           </p:cNvPr>
@@ -11176,7 +11176,7 @@
           <p:cNvPr id="24" name="">
             <a:extLst xmlns:a="http://schemas.openxmlformats.org/drawingml/2006/main">
               <a:ext uri="{FF2B5EF4-FFF2-40B4-BE49-F238E27FC236}">
-                <a16:creationId xmlns:a16="http://schemas.microsoft.com/office/drawing/2014/main" id="{CCD8D27C-9A56-4BD3-A65A-A404516EE878}"/>
+                <a16:creationId xmlns:a16="http://schemas.microsoft.com/office/drawing/2014/main" id="{39E28B89-58E1-49DD-BA8B-7DE7307D39CA}"/>
               </a:ext>
             </a:extLst>
           </p:cNvPr>
@@ -11206,7 +11206,7 @@
           <p:cNvPr id="25" name="">
             <a:extLst xmlns:a="http://schemas.openxmlformats.org/drawingml/2006/main">
               <a:ext uri="{FF2B5EF4-FFF2-40B4-BE49-F238E27FC236}">
-                <a16:creationId xmlns:a16="http://schemas.microsoft.com/office/drawing/2014/main" id="{116DF504-384F-4262-A4C3-F2D6FAE409E2}"/>
+                <a16:creationId xmlns:a16="http://schemas.microsoft.com/office/drawing/2014/main" id="{8E288396-2A7D-41C8-A601-9D676AB837C3}"/>
               </a:ext>
             </a:extLst>
           </p:cNvPr>
@@ -11265,7 +11265,7 @@
           <p:cNvPr id="26" name="">
             <a:extLst xmlns:a="http://schemas.openxmlformats.org/drawingml/2006/main">
               <a:ext uri="{FF2B5EF4-FFF2-40B4-BE49-F238E27FC236}">
-                <a16:creationId xmlns:a16="http://schemas.microsoft.com/office/drawing/2014/main" id="{B5C291D7-5E05-4817-AFD7-BAEB45F68002}"/>
+                <a16:creationId xmlns:a16="http://schemas.microsoft.com/office/drawing/2014/main" id="{EF04C5B9-84D7-461A-B923-519B5B806411}"/>
               </a:ext>
             </a:extLst>
           </p:cNvPr>
@@ -11277,7 +11277,7 @@
         <p:spPr>
           <a:xfrm xmlns:a="http://schemas.openxmlformats.org/drawingml/2006/main">
             <a:off x="914400" y="5492591"/>
-            <a:ext cx="1905000" cy="317659"/>
+            <a:ext cx="1905000" cy="266700"/>
           </a:xfrm>
           <a:prstGeom xmlns:a="http://schemas.openxmlformats.org/drawingml/2006/main" prst="rect">
             <a:avLst/>
@@ -11296,7 +11296,7 @@
           <a:lstStyle xmlns:a="http://schemas.openxmlformats.org/drawingml/2006/main"/>
           <a:p xmlns:a="http://schemas.openxmlformats.org/drawingml/2006/main">
             <a:pPr algn="l">
-              <a:defRPr sz="982" b="0">
+              <a:defRPr sz="960" b="0">
                 <a:solidFill>
                   <a:srgbClr val="526179"/>
                 </a:solidFill>
@@ -11306,7 +11306,7 @@
               </a:defRPr>
             </a:pPr>
             <a:r>
-              <a:rPr sz="982" b="0">
+              <a:rPr sz="960" b="0">
                 <a:solidFill>
                   <a:srgbClr val="526179"/>
                 </a:solidFill>
@@ -11314,7 +11314,7 @@
                 <a:ea typeface="Aptos"/>
                 <a:cs typeface="Aptos"/>
               </a:rPr>
-              <a:t>Generated files, risky paths, public APIs, secrets, migrations, and deploys.</a:t>
+              <a:t>Risky paths, APIs, secrets, migrations, and deploys.</a:t>
             </a:r>
           </a:p>
         </p:txBody>
@@ -11324,7 +11324,7 @@
           <p:cNvPr id="27" name="">
             <a:extLst xmlns:a="http://schemas.openxmlformats.org/drawingml/2006/main">
               <a:ext uri="{FF2B5EF4-FFF2-40B4-BE49-F238E27FC236}">
-                <a16:creationId xmlns:a16="http://schemas.microsoft.com/office/drawing/2014/main" id="{9FB47EF3-9521-47C5-9B5C-5F6F9330375E}"/>
+                <a16:creationId xmlns:a16="http://schemas.microsoft.com/office/drawing/2014/main" id="{2260A95E-107A-441C-8CE5-467016DFE314}"/>
               </a:ext>
             </a:extLst>
           </p:cNvPr>
@@ -11356,7 +11356,7 @@
           <p:cNvPr id="28" name="">
             <a:extLst xmlns:a="http://schemas.openxmlformats.org/drawingml/2006/main">
               <a:ext uri="{FF2B5EF4-FFF2-40B4-BE49-F238E27FC236}">
-                <a16:creationId xmlns:a16="http://schemas.microsoft.com/office/drawing/2014/main" id="{3EA2E6E0-4C44-4501-8385-12652BF6D1EE}"/>
+                <a16:creationId xmlns:a16="http://schemas.microsoft.com/office/drawing/2014/main" id="{92E1B024-CD96-4C2F-A3B7-E9804060C910}"/>
               </a:ext>
             </a:extLst>
           </p:cNvPr>
@@ -11386,7 +11386,7 @@
           <p:cNvPr id="29" name="">
             <a:extLst xmlns:a="http://schemas.openxmlformats.org/drawingml/2006/main">
               <a:ext uri="{FF2B5EF4-FFF2-40B4-BE49-F238E27FC236}">
-                <a16:creationId xmlns:a16="http://schemas.microsoft.com/office/drawing/2014/main" id="{D863719D-1602-4067-916E-30637ECB4603}"/>
+                <a16:creationId xmlns:a16="http://schemas.microsoft.com/office/drawing/2014/main" id="{832CC6B5-119C-4E03-A5C4-472A97872B86}"/>
               </a:ext>
             </a:extLst>
           </p:cNvPr>
@@ -11445,7 +11445,7 @@
           <p:cNvPr id="30" name="">
             <a:extLst xmlns:a="http://schemas.openxmlformats.org/drawingml/2006/main">
               <a:ext uri="{FF2B5EF4-FFF2-40B4-BE49-F238E27FC236}">
-                <a16:creationId xmlns:a16="http://schemas.microsoft.com/office/drawing/2014/main" id="{994125D8-D0FD-4450-8D82-D598A6943AB5}"/>
+                <a16:creationId xmlns:a16="http://schemas.microsoft.com/office/drawing/2014/main" id="{26991D18-0CEC-42C0-9E36-DA079AA82BEE}"/>
               </a:ext>
             </a:extLst>
           </p:cNvPr>
@@ -11457,7 +11457,7 @@
         <p:spPr>
           <a:xfrm xmlns:a="http://schemas.openxmlformats.org/drawingml/2006/main">
             <a:off x="3638550" y="5492591"/>
-            <a:ext cx="1905000" cy="317659"/>
+            <a:ext cx="1905000" cy="266700"/>
           </a:xfrm>
           <a:prstGeom xmlns:a="http://schemas.openxmlformats.org/drawingml/2006/main" prst="rect">
             <a:avLst/>
@@ -11476,7 +11476,7 @@
           <a:lstStyle xmlns:a="http://schemas.openxmlformats.org/drawingml/2006/main"/>
           <a:p xmlns:a="http://schemas.openxmlformats.org/drawingml/2006/main">
             <a:pPr algn="l">
-              <a:defRPr sz="982" b="0">
+              <a:defRPr sz="960" b="0">
                 <a:solidFill>
                   <a:srgbClr val="526179"/>
                 </a:solidFill>
@@ -11486,7 +11486,7 @@
               </a:defRPr>
             </a:pPr>
             <a:r>
-              <a:rPr sz="982" b="0">
+              <a:rPr sz="960" b="0">
                 <a:solidFill>
                   <a:srgbClr val="526179"/>
                 </a:solidFill>
@@ -11494,7 +11494,7 @@
                 <a:ea typeface="Aptos"/>
                 <a:cs typeface="Aptos"/>
               </a:rPr>
-              <a:t>What must be verified before Copilot says the work is complete.</a:t>
+              <a:t>Required checks before Copilot says complete.</a:t>
             </a:r>
           </a:p>
         </p:txBody>
@@ -11502,7 +11502,7 @@
     </p:spTree>
     <p:extLst>
       <p:ext uri="{BB962C8B-B14F-4D97-AF65-F5344CB8AC3E}">
-        <p14:creationId xmlns:p14="http://schemas.microsoft.com/office/powerpoint/2010/main" val="664930010"/>
+        <p14:creationId xmlns:p14="http://schemas.microsoft.com/office/powerpoint/2010/main" val="960013846"/>
       </p:ext>
     </p:extLst>
   </p:cSld>
@@ -11526,7 +11526,7 @@
           <p:cNvPr id="1" name="">
             <a:extLst xmlns:a="http://schemas.openxmlformats.org/drawingml/2006/main">
               <a:ext uri="{FF2B5EF4-FFF2-40B4-BE49-F238E27FC236}">
-                <a16:creationId xmlns:a16="http://schemas.microsoft.com/office/drawing/2014/main" id="{3A6896A5-B720-4003-87AF-5D7C0A198A94}"/>
+                <a16:creationId xmlns:a16="http://schemas.microsoft.com/office/drawing/2014/main" id="{17486668-4FF9-44F7-B330-9C54A73D0A75}"/>
               </a:ext>
             </a:extLst>
           </p:cNvPr>
@@ -11556,7 +11556,7 @@
           <p:cNvPr id="2" name="">
             <a:extLst xmlns:a="http://schemas.openxmlformats.org/drawingml/2006/main">
               <a:ext uri="{FF2B5EF4-FFF2-40B4-BE49-F238E27FC236}">
-                <a16:creationId xmlns:a16="http://schemas.microsoft.com/office/drawing/2014/main" id="{B0B14C59-F9C9-4022-BFE4-EDC0E99084F5}"/>
+                <a16:creationId xmlns:a16="http://schemas.microsoft.com/office/drawing/2014/main" id="{8283901E-D7BD-4F2D-8A3A-590C77578137}"/>
               </a:ext>
             </a:extLst>
           </p:cNvPr>
@@ -11586,7 +11586,7 @@
           <p:cNvPr id="3" name="">
             <a:extLst xmlns:a="http://schemas.openxmlformats.org/drawingml/2006/main">
               <a:ext uri="{FF2B5EF4-FFF2-40B4-BE49-F238E27FC236}">
-                <a16:creationId xmlns:a16="http://schemas.microsoft.com/office/drawing/2014/main" id="{E7C4A547-2CCE-4663-AFF9-F1E92EC41240}"/>
+                <a16:creationId xmlns:a16="http://schemas.microsoft.com/office/drawing/2014/main" id="{C70E5486-3C76-438F-B731-22DCA82125C8}"/>
               </a:ext>
             </a:extLst>
           </p:cNvPr>
@@ -11645,7 +11645,7 @@
           <p:cNvPr id="4" name="">
             <a:extLst xmlns:a="http://schemas.openxmlformats.org/drawingml/2006/main">
               <a:ext uri="{FF2B5EF4-FFF2-40B4-BE49-F238E27FC236}">
-                <a16:creationId xmlns:a16="http://schemas.microsoft.com/office/drawing/2014/main" id="{D9C5E5AC-3DE9-4221-BE0B-8BBB2BF4FE21}"/>
+                <a16:creationId xmlns:a16="http://schemas.microsoft.com/office/drawing/2014/main" id="{1627BC6A-CB4F-4893-8C05-6BCF6563032A}"/>
               </a:ext>
             </a:extLst>
           </p:cNvPr>
@@ -11704,7 +11704,7 @@
           <p:cNvPr id="5" name="">
             <a:extLst xmlns:a="http://schemas.openxmlformats.org/drawingml/2006/main">
               <a:ext uri="{FF2B5EF4-FFF2-40B4-BE49-F238E27FC236}">
-                <a16:creationId xmlns:a16="http://schemas.microsoft.com/office/drawing/2014/main" id="{27D6F8D2-313C-4D0B-A2C5-95C5193EFE3D}"/>
+                <a16:creationId xmlns:a16="http://schemas.microsoft.com/office/drawing/2014/main" id="{FB597D4E-7F5B-4F09-A77A-1C3FB8DF36B8}"/>
               </a:ext>
             </a:extLst>
           </p:cNvPr>
@@ -11763,7 +11763,7 @@
           <p:cNvPr id="6" name="">
             <a:extLst xmlns:a="http://schemas.openxmlformats.org/drawingml/2006/main">
               <a:ext uri="{FF2B5EF4-FFF2-40B4-BE49-F238E27FC236}">
-                <a16:creationId xmlns:a16="http://schemas.microsoft.com/office/drawing/2014/main" id="{85E35CCE-7F38-4050-B3B0-2349A1303F19}"/>
+                <a16:creationId xmlns:a16="http://schemas.microsoft.com/office/drawing/2014/main" id="{91A36302-5F89-4120-B07C-8BCB47BE315D}"/>
               </a:ext>
             </a:extLst>
           </p:cNvPr>
@@ -11826,7 +11826,7 @@
           <p:nvPr/>
         </p:nvPicPr>
         <p:blipFill>
-          <a:blip xmlns:r="http://schemas.openxmlformats.org/officeDocument/2006/relationships" xmlns:a="http://schemas.openxmlformats.org/drawingml/2006/main" r:embed="Rc865379d1fc547f3"/>
+          <a:blip xmlns:r="http://schemas.openxmlformats.org/officeDocument/2006/relationships" xmlns:a="http://schemas.openxmlformats.org/drawingml/2006/main" r:embed="Rd5bfd379c0ba44ec"/>
           <a:srcRect xmlns:a="http://schemas.openxmlformats.org/drawingml/2006/main" l="568" t="0" r="568" b="0"/>
           <a:stretch xmlns:a="http://schemas.openxmlformats.org/drawingml/2006/main">
             <a:fillRect l="0" t="0" r="0" b="0"/>
@@ -11847,7 +11847,7 @@
           <p:cNvPr id="8" name="">
             <a:extLst xmlns:a="http://schemas.openxmlformats.org/drawingml/2006/main">
               <a:ext uri="{FF2B5EF4-FFF2-40B4-BE49-F238E27FC236}">
-                <a16:creationId xmlns:a16="http://schemas.microsoft.com/office/drawing/2014/main" id="{B94675CB-F6B0-459D-8E5A-8B55820A421C}"/>
+                <a16:creationId xmlns:a16="http://schemas.microsoft.com/office/drawing/2014/main" id="{9C6A4456-4E8E-4AEA-8520-2290DAB803E2}"/>
               </a:ext>
             </a:extLst>
           </p:cNvPr>
@@ -11879,7 +11879,7 @@
           <p:cNvPr id="9" name="">
             <a:extLst xmlns:a="http://schemas.openxmlformats.org/drawingml/2006/main">
               <a:ext uri="{FF2B5EF4-FFF2-40B4-BE49-F238E27FC236}">
-                <a16:creationId xmlns:a16="http://schemas.microsoft.com/office/drawing/2014/main" id="{B5B21FDB-433E-4A79-A44E-10562624DA84}"/>
+                <a16:creationId xmlns:a16="http://schemas.microsoft.com/office/drawing/2014/main" id="{F15173CC-03BE-4B21-8BCF-863F7E9C5A3A}"/>
               </a:ext>
             </a:extLst>
           </p:cNvPr>
@@ -11913,7 +11913,7 @@
           <p:cNvPr id="10" name="">
             <a:extLst xmlns:a="http://schemas.openxmlformats.org/drawingml/2006/main">
               <a:ext uri="{FF2B5EF4-FFF2-40B4-BE49-F238E27FC236}">
-                <a16:creationId xmlns:a16="http://schemas.microsoft.com/office/drawing/2014/main" id="{0A7EAAD6-7489-4B12-9FF5-EBDE595F2947}"/>
+                <a16:creationId xmlns:a16="http://schemas.microsoft.com/office/drawing/2014/main" id="{0B9D6470-2B0D-403C-9CA6-F7670DEEAE67}"/>
               </a:ext>
             </a:extLst>
           </p:cNvPr>
@@ -11945,7 +11945,7 @@
           <p:cNvPr id="11" name="">
             <a:extLst xmlns:a="http://schemas.openxmlformats.org/drawingml/2006/main">
               <a:ext uri="{FF2B5EF4-FFF2-40B4-BE49-F238E27FC236}">
-                <a16:creationId xmlns:a16="http://schemas.microsoft.com/office/drawing/2014/main" id="{5686A97F-AEB8-47B9-B81C-7562AC58009F}"/>
+                <a16:creationId xmlns:a16="http://schemas.microsoft.com/office/drawing/2014/main" id="{C4537C02-E320-4EA4-94DF-4FD1E2401C09}"/>
               </a:ext>
             </a:extLst>
           </p:cNvPr>
@@ -12004,7 +12004,7 @@
           <p:cNvPr id="12" name="">
             <a:extLst xmlns:a="http://schemas.openxmlformats.org/drawingml/2006/main">
               <a:ext uri="{FF2B5EF4-FFF2-40B4-BE49-F238E27FC236}">
-                <a16:creationId xmlns:a16="http://schemas.microsoft.com/office/drawing/2014/main" id="{0E0A5AF1-1EE3-496E-9F4D-CB28CE850EA0}"/>
+                <a16:creationId xmlns:a16="http://schemas.microsoft.com/office/drawing/2014/main" id="{0788A661-47F5-417D-B4A4-493B5C75D887}"/>
               </a:ext>
             </a:extLst>
           </p:cNvPr>
@@ -12063,7 +12063,7 @@
           <p:cNvPr id="13" name="">
             <a:extLst xmlns:a="http://schemas.openxmlformats.org/drawingml/2006/main">
               <a:ext uri="{FF2B5EF4-FFF2-40B4-BE49-F238E27FC236}">
-                <a16:creationId xmlns:a16="http://schemas.microsoft.com/office/drawing/2014/main" id="{A636945C-2E40-46E3-8FF5-387566E9B2B7}"/>
+                <a16:creationId xmlns:a16="http://schemas.microsoft.com/office/drawing/2014/main" id="{B38216C6-E757-4F54-8D1E-54517E8E65CB}"/>
               </a:ext>
             </a:extLst>
           </p:cNvPr>
@@ -12095,7 +12095,7 @@
           <p:cNvPr id="14" name="">
             <a:extLst xmlns:a="http://schemas.openxmlformats.org/drawingml/2006/main">
               <a:ext uri="{FF2B5EF4-FFF2-40B4-BE49-F238E27FC236}">
-                <a16:creationId xmlns:a16="http://schemas.microsoft.com/office/drawing/2014/main" id="{FD42DB4A-35C1-40D1-882F-5C009177A87F}"/>
+                <a16:creationId xmlns:a16="http://schemas.microsoft.com/office/drawing/2014/main" id="{33F0F3A0-E1E9-41A1-8606-25B29E8DF1CC}"/>
               </a:ext>
             </a:extLst>
           </p:cNvPr>
@@ -12154,7 +12154,7 @@
           <p:cNvPr id="15" name="">
             <a:extLst xmlns:a="http://schemas.openxmlformats.org/drawingml/2006/main">
               <a:ext uri="{FF2B5EF4-FFF2-40B4-BE49-F238E27FC236}">
-                <a16:creationId xmlns:a16="http://schemas.microsoft.com/office/drawing/2014/main" id="{2FA46EB2-FD8A-47FC-BA7B-0C7D73A07F36}"/>
+                <a16:creationId xmlns:a16="http://schemas.microsoft.com/office/drawing/2014/main" id="{C65744F6-C5BF-437F-840A-C8EC3B1B48BD}"/>
               </a:ext>
             </a:extLst>
           </p:cNvPr>
@@ -12213,7 +12213,7 @@
           <p:cNvPr id="16" name="">
             <a:extLst xmlns:a="http://schemas.openxmlformats.org/drawingml/2006/main">
               <a:ext uri="{FF2B5EF4-FFF2-40B4-BE49-F238E27FC236}">
-                <a16:creationId xmlns:a16="http://schemas.microsoft.com/office/drawing/2014/main" id="{EC60D462-6BD8-4E92-BCD3-2D153F753169}"/>
+                <a16:creationId xmlns:a16="http://schemas.microsoft.com/office/drawing/2014/main" id="{689364A6-79F2-4123-B638-27047B881937}"/>
               </a:ext>
             </a:extLst>
           </p:cNvPr>
@@ -12245,7 +12245,7 @@
           <p:cNvPr id="17" name="">
             <a:extLst xmlns:a="http://schemas.openxmlformats.org/drawingml/2006/main">
               <a:ext uri="{FF2B5EF4-FFF2-40B4-BE49-F238E27FC236}">
-                <a16:creationId xmlns:a16="http://schemas.microsoft.com/office/drawing/2014/main" id="{1276A227-A398-4B95-B0DF-079B1DBA3891}"/>
+                <a16:creationId xmlns:a16="http://schemas.microsoft.com/office/drawing/2014/main" id="{05CDBDBD-88EE-41DE-B4BE-9AB135AC5ECF}"/>
               </a:ext>
             </a:extLst>
           </p:cNvPr>
@@ -12304,7 +12304,7 @@
           <p:cNvPr id="18" name="">
             <a:extLst xmlns:a="http://schemas.openxmlformats.org/drawingml/2006/main">
               <a:ext uri="{FF2B5EF4-FFF2-40B4-BE49-F238E27FC236}">
-                <a16:creationId xmlns:a16="http://schemas.microsoft.com/office/drawing/2014/main" id="{A4FDB07B-037D-47A5-8076-54CCCB334BDF}"/>
+                <a16:creationId xmlns:a16="http://schemas.microsoft.com/office/drawing/2014/main" id="{C9EDF68E-43BD-43D2-9920-5544898E6E28}"/>
               </a:ext>
             </a:extLst>
           </p:cNvPr>
@@ -12363,7 +12363,7 @@
           <p:cNvPr id="19" name="">
             <a:extLst xmlns:a="http://schemas.openxmlformats.org/drawingml/2006/main">
               <a:ext uri="{FF2B5EF4-FFF2-40B4-BE49-F238E27FC236}">
-                <a16:creationId xmlns:a16="http://schemas.microsoft.com/office/drawing/2014/main" id="{BC1BEF74-9800-4E50-B623-020B40FFD087}"/>
+                <a16:creationId xmlns:a16="http://schemas.microsoft.com/office/drawing/2014/main" id="{0D447B7C-B43A-4AD3-889C-F01A982FA361}"/>
               </a:ext>
             </a:extLst>
           </p:cNvPr>
@@ -12395,7 +12395,7 @@
           <p:cNvPr id="20" name="">
             <a:extLst xmlns:a="http://schemas.openxmlformats.org/drawingml/2006/main">
               <a:ext uri="{FF2B5EF4-FFF2-40B4-BE49-F238E27FC236}">
-                <a16:creationId xmlns:a16="http://schemas.microsoft.com/office/drawing/2014/main" id="{266D9956-203F-4398-B741-209ABA4AC088}"/>
+                <a16:creationId xmlns:a16="http://schemas.microsoft.com/office/drawing/2014/main" id="{D84F115E-926B-44F1-8679-417FAA21D72D}"/>
               </a:ext>
             </a:extLst>
           </p:cNvPr>
@@ -12454,7 +12454,7 @@
           <p:cNvPr id="21" name="">
             <a:extLst xmlns:a="http://schemas.openxmlformats.org/drawingml/2006/main">
               <a:ext uri="{FF2B5EF4-FFF2-40B4-BE49-F238E27FC236}">
-                <a16:creationId xmlns:a16="http://schemas.microsoft.com/office/drawing/2014/main" id="{8159FA85-ABB5-4178-B71C-4C163ABACEA1}"/>
+                <a16:creationId xmlns:a16="http://schemas.microsoft.com/office/drawing/2014/main" id="{DBFB9B2C-7C19-4925-92A9-AE063168E4BE}"/>
               </a:ext>
             </a:extLst>
           </p:cNvPr>
@@ -12513,7 +12513,7 @@
           <p:cNvPr id="22" name="">
             <a:extLst xmlns:a="http://schemas.openxmlformats.org/drawingml/2006/main">
               <a:ext uri="{FF2B5EF4-FFF2-40B4-BE49-F238E27FC236}">
-                <a16:creationId xmlns:a16="http://schemas.microsoft.com/office/drawing/2014/main" id="{5849E81A-29EF-4744-912D-EE1001876394}"/>
+                <a16:creationId xmlns:a16="http://schemas.microsoft.com/office/drawing/2014/main" id="{30D49BAA-C3FC-417A-88EE-22C5E7876F4E}"/>
               </a:ext>
             </a:extLst>
           </p:cNvPr>
@@ -12545,7 +12545,7 @@
           <p:cNvPr id="23" name="">
             <a:extLst xmlns:a="http://schemas.openxmlformats.org/drawingml/2006/main">
               <a:ext uri="{FF2B5EF4-FFF2-40B4-BE49-F238E27FC236}">
-                <a16:creationId xmlns:a16="http://schemas.microsoft.com/office/drawing/2014/main" id="{250FBD6B-889D-4CB1-B45D-B035DC7D4940}"/>
+                <a16:creationId xmlns:a16="http://schemas.microsoft.com/office/drawing/2014/main" id="{A826D7EB-9E56-4AF1-A872-74709C219E60}"/>
               </a:ext>
             </a:extLst>
           </p:cNvPr>
@@ -12575,7 +12575,7 @@
           <p:cNvPr id="24" name="">
             <a:extLst xmlns:a="http://schemas.openxmlformats.org/drawingml/2006/main">
               <a:ext uri="{FF2B5EF4-FFF2-40B4-BE49-F238E27FC236}">
-                <a16:creationId xmlns:a16="http://schemas.microsoft.com/office/drawing/2014/main" id="{2C997D63-3EFD-4B14-8F40-B38FBF972B6B}"/>
+                <a16:creationId xmlns:a16="http://schemas.microsoft.com/office/drawing/2014/main" id="{5F274629-3B32-4C47-BDA9-01C4845BA676}"/>
               </a:ext>
             </a:extLst>
           </p:cNvPr>
@@ -12634,7 +12634,7 @@
           <p:cNvPr id="25" name="">
             <a:extLst xmlns:a="http://schemas.openxmlformats.org/drawingml/2006/main">
               <a:ext uri="{FF2B5EF4-FFF2-40B4-BE49-F238E27FC236}">
-                <a16:creationId xmlns:a16="http://schemas.microsoft.com/office/drawing/2014/main" id="{8981001F-620A-471F-9FA0-E53A653CBF9F}"/>
+                <a16:creationId xmlns:a16="http://schemas.microsoft.com/office/drawing/2014/main" id="{80993AD1-46CE-47AC-90AA-16F1D0323523}"/>
               </a:ext>
             </a:extLst>
           </p:cNvPr>
@@ -12646,7 +12646,7 @@
         <p:spPr>
           <a:xfrm xmlns:a="http://schemas.openxmlformats.org/drawingml/2006/main">
             <a:off x="914400" y="4616291"/>
-            <a:ext cx="2724150" cy="393859"/>
+            <a:ext cx="2724150" cy="279559"/>
           </a:xfrm>
           <a:prstGeom xmlns:a="http://schemas.openxmlformats.org/drawingml/2006/main" prst="rect">
             <a:avLst/>
@@ -12665,7 +12665,7 @@
           <a:lstStyle xmlns:a="http://schemas.openxmlformats.org/drawingml/2006/main"/>
           <a:p xmlns:a="http://schemas.openxmlformats.org/drawingml/2006/main">
             <a:pPr algn="l">
-              <a:defRPr sz="1050" b="0">
+              <a:defRPr sz="1028" b="0">
                 <a:solidFill>
                   <a:srgbClr val="526179"/>
                 </a:solidFill>
@@ -12675,7 +12675,7 @@
               </a:defRPr>
             </a:pPr>
             <a:r>
-              <a:rPr sz="1050" b="0">
+              <a:rPr sz="1028" b="0">
                 <a:solidFill>
                   <a:srgbClr val="526179"/>
                 </a:solidFill>
@@ -12693,7 +12693,7 @@
           <p:cNvPr id="26" name="">
             <a:extLst xmlns:a="http://schemas.openxmlformats.org/drawingml/2006/main">
               <a:ext uri="{FF2B5EF4-FFF2-40B4-BE49-F238E27FC236}">
-                <a16:creationId xmlns:a16="http://schemas.microsoft.com/office/drawing/2014/main" id="{F642B25E-89E5-4DF5-A225-E29B5C1E4E7F}"/>
+                <a16:creationId xmlns:a16="http://schemas.microsoft.com/office/drawing/2014/main" id="{20BC6C59-549D-48EB-B160-8642F7BFCAB0}"/>
               </a:ext>
             </a:extLst>
           </p:cNvPr>
@@ -12725,7 +12725,7 @@
           <p:cNvPr id="27" name="">
             <a:extLst xmlns:a="http://schemas.openxmlformats.org/drawingml/2006/main">
               <a:ext uri="{FF2B5EF4-FFF2-40B4-BE49-F238E27FC236}">
-                <a16:creationId xmlns:a16="http://schemas.microsoft.com/office/drawing/2014/main" id="{66ED80AC-3263-4250-ABEB-4A3E6768082F}"/>
+                <a16:creationId xmlns:a16="http://schemas.microsoft.com/office/drawing/2014/main" id="{55BF6FFB-F42A-4B2C-955E-2B63C6DCC191}"/>
               </a:ext>
             </a:extLst>
           </p:cNvPr>
@@ -12755,7 +12755,7 @@
           <p:cNvPr id="28" name="">
             <a:extLst xmlns:a="http://schemas.openxmlformats.org/drawingml/2006/main">
               <a:ext uri="{FF2B5EF4-FFF2-40B4-BE49-F238E27FC236}">
-                <a16:creationId xmlns:a16="http://schemas.microsoft.com/office/drawing/2014/main" id="{97408481-2D5A-474E-A916-06FC3CFA9C02}"/>
+                <a16:creationId xmlns:a16="http://schemas.microsoft.com/office/drawing/2014/main" id="{CE3E272D-FA1E-4ABD-9EE0-B3EF6D81F5E2}"/>
               </a:ext>
             </a:extLst>
           </p:cNvPr>
@@ -12814,7 +12814,7 @@
           <p:cNvPr id="29" name="">
             <a:extLst xmlns:a="http://schemas.openxmlformats.org/drawingml/2006/main">
               <a:ext uri="{FF2B5EF4-FFF2-40B4-BE49-F238E27FC236}">
-                <a16:creationId xmlns:a16="http://schemas.microsoft.com/office/drawing/2014/main" id="{12D3D531-6655-47E4-BBF1-2243AF93491F}"/>
+                <a16:creationId xmlns:a16="http://schemas.microsoft.com/office/drawing/2014/main" id="{BE413BBB-E940-4D7E-A72C-4AAEF8541292}"/>
               </a:ext>
             </a:extLst>
           </p:cNvPr>
@@ -12826,7 +12826,7 @@
         <p:spPr>
           <a:xfrm xmlns:a="http://schemas.openxmlformats.org/drawingml/2006/main">
             <a:off x="4591050" y="4616291"/>
-            <a:ext cx="2724150" cy="393859"/>
+            <a:ext cx="2724150" cy="279559"/>
           </a:xfrm>
           <a:prstGeom xmlns:a="http://schemas.openxmlformats.org/drawingml/2006/main" prst="rect">
             <a:avLst/>
@@ -12845,7 +12845,7 @@
           <a:lstStyle xmlns:a="http://schemas.openxmlformats.org/drawingml/2006/main"/>
           <a:p xmlns:a="http://schemas.openxmlformats.org/drawingml/2006/main">
             <a:pPr algn="l">
-              <a:defRPr sz="1050" b="0">
+              <a:defRPr sz="1028" b="0">
                 <a:solidFill>
                   <a:srgbClr val="526179"/>
                 </a:solidFill>
@@ -12855,7 +12855,7 @@
               </a:defRPr>
             </a:pPr>
             <a:r>
-              <a:rPr sz="1050" b="0">
+              <a:rPr sz="1028" b="0">
                 <a:solidFill>
                   <a:srgbClr val="526179"/>
                 </a:solidFill>
@@ -12863,7 +12863,7 @@
                 <a:ea typeface="Aptos"/>
                 <a:cs typeface="Aptos"/>
               </a:rPr>
-              <a:t>Install packages, delete files, run migrations, change public APIs.</a:t>
+              <a:t>Install packages, delete files, migrations, or public API changes.</a:t>
             </a:r>
           </a:p>
         </p:txBody>
@@ -12873,7 +12873,7 @@
           <p:cNvPr id="30" name="">
             <a:extLst xmlns:a="http://schemas.openxmlformats.org/drawingml/2006/main">
               <a:ext uri="{FF2B5EF4-FFF2-40B4-BE49-F238E27FC236}">
-                <a16:creationId xmlns:a16="http://schemas.microsoft.com/office/drawing/2014/main" id="{59F27F22-ADD1-4AD1-B45B-9E30F0F7551F}"/>
+                <a16:creationId xmlns:a16="http://schemas.microsoft.com/office/drawing/2014/main" id="{F79EEFE3-D505-4E74-B2FA-C3B81AC68B2B}"/>
               </a:ext>
             </a:extLst>
           </p:cNvPr>
@@ -12905,7 +12905,7 @@
           <p:cNvPr id="31" name="">
             <a:extLst xmlns:a="http://schemas.openxmlformats.org/drawingml/2006/main">
               <a:ext uri="{FF2B5EF4-FFF2-40B4-BE49-F238E27FC236}">
-                <a16:creationId xmlns:a16="http://schemas.microsoft.com/office/drawing/2014/main" id="{65719F76-D9DB-4679-A578-E56BAF10D260}"/>
+                <a16:creationId xmlns:a16="http://schemas.microsoft.com/office/drawing/2014/main" id="{919E35D7-DDD8-43F4-BC34-15DD2B54920A}"/>
               </a:ext>
             </a:extLst>
           </p:cNvPr>
@@ -12935,7 +12935,7 @@
           <p:cNvPr id="32" name="">
             <a:extLst xmlns:a="http://schemas.openxmlformats.org/drawingml/2006/main">
               <a:ext uri="{FF2B5EF4-FFF2-40B4-BE49-F238E27FC236}">
-                <a16:creationId xmlns:a16="http://schemas.microsoft.com/office/drawing/2014/main" id="{0FD51187-EF96-4195-B4A6-1BF2F188ED9F}"/>
+                <a16:creationId xmlns:a16="http://schemas.microsoft.com/office/drawing/2014/main" id="{0384AC86-8272-4714-8D05-FDE6D2C47A1B}"/>
               </a:ext>
             </a:extLst>
           </p:cNvPr>
@@ -12994,7 +12994,7 @@
           <p:cNvPr id="33" name="">
             <a:extLst xmlns:a="http://schemas.openxmlformats.org/drawingml/2006/main">
               <a:ext uri="{FF2B5EF4-FFF2-40B4-BE49-F238E27FC236}">
-                <a16:creationId xmlns:a16="http://schemas.microsoft.com/office/drawing/2014/main" id="{54BF6F8C-D5C3-47E8-844A-F22277EBEFEC}"/>
+                <a16:creationId xmlns:a16="http://schemas.microsoft.com/office/drawing/2014/main" id="{C1870208-533F-48FC-9B81-329377841836}"/>
               </a:ext>
             </a:extLst>
           </p:cNvPr>
@@ -13006,7 +13006,7 @@
         <p:spPr>
           <a:xfrm xmlns:a="http://schemas.openxmlformats.org/drawingml/2006/main">
             <a:off x="8267700" y="4616291"/>
-            <a:ext cx="2724150" cy="393859"/>
+            <a:ext cx="2724150" cy="279559"/>
           </a:xfrm>
           <a:prstGeom xmlns:a="http://schemas.openxmlformats.org/drawingml/2006/main" prst="rect">
             <a:avLst/>
@@ -13025,7 +13025,7 @@
           <a:lstStyle xmlns:a="http://schemas.openxmlformats.org/drawingml/2006/main"/>
           <a:p xmlns:a="http://schemas.openxmlformats.org/drawingml/2006/main">
             <a:pPr algn="l">
-              <a:defRPr sz="1050" b="0">
+              <a:defRPr sz="1028" b="0">
                 <a:solidFill>
                   <a:srgbClr val="526179"/>
                 </a:solidFill>
@@ -13035,7 +13035,7 @@
               </a:defRPr>
             </a:pPr>
             <a:r>
-              <a:rPr sz="1050" b="0">
+              <a:rPr sz="1028" b="0">
                 <a:solidFill>
                   <a:srgbClr val="526179"/>
                 </a:solidFill>
@@ -13043,7 +13043,7 @@
                 <a:ea typeface="Aptos"/>
                 <a:cs typeface="Aptos"/>
               </a:rPr>
-              <a:t>Touch secrets, production data, releases, or protected branches.</a:t>
+              <a:t>Secrets, production data, releases, or protected branches.</a:t>
             </a:r>
           </a:p>
         </p:txBody>
@@ -13053,7 +13053,7 @@
           <p:cNvPr id="34" name="">
             <a:extLst xmlns:a="http://schemas.openxmlformats.org/drawingml/2006/main">
               <a:ext uri="{FF2B5EF4-FFF2-40B4-BE49-F238E27FC236}">
-                <a16:creationId xmlns:a16="http://schemas.microsoft.com/office/drawing/2014/main" id="{2B8C7348-0CE2-42CC-B389-918EFF6942A2}"/>
+                <a16:creationId xmlns:a16="http://schemas.microsoft.com/office/drawing/2014/main" id="{7EE4E0B6-1DB8-41F6-A935-74D1AA9F6E8A}"/>
               </a:ext>
             </a:extLst>
           </p:cNvPr>
@@ -13085,7 +13085,7 @@
           <p:cNvPr id="35" name="">
             <a:extLst xmlns:a="http://schemas.openxmlformats.org/drawingml/2006/main">
               <a:ext uri="{FF2B5EF4-FFF2-40B4-BE49-F238E27FC236}">
-                <a16:creationId xmlns:a16="http://schemas.microsoft.com/office/drawing/2014/main" id="{4A226F93-A954-41C1-B94E-75D916B4520B}"/>
+                <a16:creationId xmlns:a16="http://schemas.microsoft.com/office/drawing/2014/main" id="{62C10CE5-698C-41DE-B454-A848EEE38550}"/>
               </a:ext>
             </a:extLst>
           </p:cNvPr>
@@ -13142,7 +13142,7 @@
     </p:spTree>
     <p:extLst>
       <p:ext uri="{BB962C8B-B14F-4D97-AF65-F5344CB8AC3E}">
-        <p14:creationId xmlns:p14="http://schemas.microsoft.com/office/powerpoint/2010/main" val="454968430"/>
+        <p14:creationId xmlns:p14="http://schemas.microsoft.com/office/powerpoint/2010/main" val="1497820234"/>
       </p:ext>
     </p:extLst>
   </p:cSld>
@@ -13166,7 +13166,7 @@
           <p:cNvPr id="1" name="">
             <a:extLst xmlns:a="http://schemas.openxmlformats.org/drawingml/2006/main">
               <a:ext uri="{FF2B5EF4-FFF2-40B4-BE49-F238E27FC236}">
-                <a16:creationId xmlns:a16="http://schemas.microsoft.com/office/drawing/2014/main" id="{CD56EAD0-2BA7-4444-8797-15280C4A5B3D}"/>
+                <a16:creationId xmlns:a16="http://schemas.microsoft.com/office/drawing/2014/main" id="{48C80C64-8FE1-42CE-8187-D15C18E10771}"/>
               </a:ext>
             </a:extLst>
           </p:cNvPr>
@@ -13196,7 +13196,7 @@
           <p:cNvPr id="2" name="">
             <a:extLst xmlns:a="http://schemas.openxmlformats.org/drawingml/2006/main">
               <a:ext uri="{FF2B5EF4-FFF2-40B4-BE49-F238E27FC236}">
-                <a16:creationId xmlns:a16="http://schemas.microsoft.com/office/drawing/2014/main" id="{9E9DB05F-0E83-4B8A-A136-5457DFB392B1}"/>
+                <a16:creationId xmlns:a16="http://schemas.microsoft.com/office/drawing/2014/main" id="{E7ACB8BD-D817-49A2-B05C-5B41810C5E67}"/>
               </a:ext>
             </a:extLst>
           </p:cNvPr>
@@ -13226,7 +13226,7 @@
           <p:cNvPr id="3" name="">
             <a:extLst xmlns:a="http://schemas.openxmlformats.org/drawingml/2006/main">
               <a:ext uri="{FF2B5EF4-FFF2-40B4-BE49-F238E27FC236}">
-                <a16:creationId xmlns:a16="http://schemas.microsoft.com/office/drawing/2014/main" id="{C63CDF14-1223-4CFB-9355-558684DC2C68}"/>
+                <a16:creationId xmlns:a16="http://schemas.microsoft.com/office/drawing/2014/main" id="{7AD23AF9-4E1E-428C-8E1A-ADA2211C8812}"/>
               </a:ext>
             </a:extLst>
           </p:cNvPr>
@@ -13285,7 +13285,7 @@
           <p:cNvPr id="4" name="">
             <a:extLst xmlns:a="http://schemas.openxmlformats.org/drawingml/2006/main">
               <a:ext uri="{FF2B5EF4-FFF2-40B4-BE49-F238E27FC236}">
-                <a16:creationId xmlns:a16="http://schemas.microsoft.com/office/drawing/2014/main" id="{A0939BCE-FC94-4766-99B8-CF49239A2428}"/>
+                <a16:creationId xmlns:a16="http://schemas.microsoft.com/office/drawing/2014/main" id="{009B167D-D0FA-472B-B703-9907279AEBED}"/>
               </a:ext>
             </a:extLst>
           </p:cNvPr>
@@ -13344,7 +13344,7 @@
           <p:cNvPr id="5" name="">
             <a:extLst xmlns:a="http://schemas.openxmlformats.org/drawingml/2006/main">
               <a:ext uri="{FF2B5EF4-FFF2-40B4-BE49-F238E27FC236}">
-                <a16:creationId xmlns:a16="http://schemas.microsoft.com/office/drawing/2014/main" id="{643B7952-1C76-42DC-B6A1-4E2125846E2C}"/>
+                <a16:creationId xmlns:a16="http://schemas.microsoft.com/office/drawing/2014/main" id="{096E94CA-EE34-4CDF-AA49-CEBF570727AD}"/>
               </a:ext>
             </a:extLst>
           </p:cNvPr>
@@ -13403,7 +13403,7 @@
           <p:cNvPr id="6" name="">
             <a:extLst xmlns:a="http://schemas.openxmlformats.org/drawingml/2006/main">
               <a:ext uri="{FF2B5EF4-FFF2-40B4-BE49-F238E27FC236}">
-                <a16:creationId xmlns:a16="http://schemas.microsoft.com/office/drawing/2014/main" id="{68C036C5-8DD9-4BC4-9E20-74723C071800}"/>
+                <a16:creationId xmlns:a16="http://schemas.microsoft.com/office/drawing/2014/main" id="{87924974-E43A-4662-B42A-2F5685D52E7A}"/>
               </a:ext>
             </a:extLst>
           </p:cNvPr>
@@ -13466,7 +13466,7 @@
           <p:nvPr/>
         </p:nvPicPr>
         <p:blipFill>
-          <a:blip xmlns:r="http://schemas.openxmlformats.org/officeDocument/2006/relationships" xmlns:a="http://schemas.openxmlformats.org/drawingml/2006/main" r:embed="Rff921e1e3db9428c"/>
+          <a:blip xmlns:r="http://schemas.openxmlformats.org/officeDocument/2006/relationships" xmlns:a="http://schemas.openxmlformats.org/drawingml/2006/main" r:embed="R7aa6a3553f7e4844"/>
           <a:srcRect xmlns:a="http://schemas.openxmlformats.org/drawingml/2006/main" l="413" t="0" r="413" b="0"/>
           <a:stretch xmlns:a="http://schemas.openxmlformats.org/drawingml/2006/main">
             <a:fillRect l="0" t="0" r="0" b="0"/>
@@ -13487,7 +13487,7 @@
           <p:cNvPr id="8" name="">
             <a:extLst xmlns:a="http://schemas.openxmlformats.org/drawingml/2006/main">
               <a:ext uri="{FF2B5EF4-FFF2-40B4-BE49-F238E27FC236}">
-                <a16:creationId xmlns:a16="http://schemas.microsoft.com/office/drawing/2014/main" id="{0E171D67-7B4E-4F66-B3FC-2E16F5ED0A29}"/>
+                <a16:creationId xmlns:a16="http://schemas.microsoft.com/office/drawing/2014/main" id="{93704DB8-429B-4718-9B31-6FA45DEA0BC0}"/>
               </a:ext>
             </a:extLst>
           </p:cNvPr>
@@ -13519,7 +13519,7 @@
           <p:cNvPr id="9" name="">
             <a:extLst xmlns:a="http://schemas.openxmlformats.org/drawingml/2006/main">
               <a:ext uri="{FF2B5EF4-FFF2-40B4-BE49-F238E27FC236}">
-                <a16:creationId xmlns:a16="http://schemas.microsoft.com/office/drawing/2014/main" id="{8DFF4358-22B3-4868-9E1D-5AE5D4A58C72}"/>
+                <a16:creationId xmlns:a16="http://schemas.microsoft.com/office/drawing/2014/main" id="{D60ECF03-DDB5-4B9D-ADB5-A5351C9AB64E}"/>
               </a:ext>
             </a:extLst>
           </p:cNvPr>
@@ -13553,7 +13553,7 @@
           <p:cNvPr id="10" name="">
             <a:extLst xmlns:a="http://schemas.openxmlformats.org/drawingml/2006/main">
               <a:ext uri="{FF2B5EF4-FFF2-40B4-BE49-F238E27FC236}">
-                <a16:creationId xmlns:a16="http://schemas.microsoft.com/office/drawing/2014/main" id="{C48FBAB9-6A02-4FD7-B3D9-B9C133239217}"/>
+                <a16:creationId xmlns:a16="http://schemas.microsoft.com/office/drawing/2014/main" id="{EFC507BF-5EA7-45A8-B0ED-F4D13C5DB297}"/>
               </a:ext>
             </a:extLst>
           </p:cNvPr>
@@ -13583,7 +13583,7 @@
           <p:cNvPr id="11" name="">
             <a:extLst xmlns:a="http://schemas.openxmlformats.org/drawingml/2006/main">
               <a:ext uri="{FF2B5EF4-FFF2-40B4-BE49-F238E27FC236}">
-                <a16:creationId xmlns:a16="http://schemas.microsoft.com/office/drawing/2014/main" id="{77213F46-77B6-4223-8059-97BA40EA95A2}"/>
+                <a16:creationId xmlns:a16="http://schemas.microsoft.com/office/drawing/2014/main" id="{AE702EBE-026B-48EC-A315-491DA96C4EE3}"/>
               </a:ext>
             </a:extLst>
           </p:cNvPr>
@@ -13613,7 +13613,7 @@
           <p:cNvPr id="12" name="">
             <a:extLst xmlns:a="http://schemas.openxmlformats.org/drawingml/2006/main">
               <a:ext uri="{FF2B5EF4-FFF2-40B4-BE49-F238E27FC236}">
-                <a16:creationId xmlns:a16="http://schemas.microsoft.com/office/drawing/2014/main" id="{ED2887DF-62F2-402A-97E8-9ABD01B3456D}"/>
+                <a16:creationId xmlns:a16="http://schemas.microsoft.com/office/drawing/2014/main" id="{1BEEC4E7-2BA3-4599-BE47-8900A27DEE3F}"/>
               </a:ext>
             </a:extLst>
           </p:cNvPr>
@@ -13672,7 +13672,7 @@
           <p:cNvPr id="13" name="">
             <a:extLst xmlns:a="http://schemas.openxmlformats.org/drawingml/2006/main">
               <a:ext uri="{FF2B5EF4-FFF2-40B4-BE49-F238E27FC236}">
-                <a16:creationId xmlns:a16="http://schemas.microsoft.com/office/drawing/2014/main" id="{1CE00C17-176C-4196-810F-86F483B4E69D}"/>
+                <a16:creationId xmlns:a16="http://schemas.microsoft.com/office/drawing/2014/main" id="{DE22BE0C-07E4-404E-8839-B12F63F7E06E}"/>
               </a:ext>
             </a:extLst>
           </p:cNvPr>
@@ -13704,7 +13704,7 @@
           <p:cNvPr id="14" name="">
             <a:extLst xmlns:a="http://schemas.openxmlformats.org/drawingml/2006/main">
               <a:ext uri="{FF2B5EF4-FFF2-40B4-BE49-F238E27FC236}">
-                <a16:creationId xmlns:a16="http://schemas.microsoft.com/office/drawing/2014/main" id="{D25B8B8D-A935-4D15-977A-CEA3EA0CBC1F}"/>
+                <a16:creationId xmlns:a16="http://schemas.microsoft.com/office/drawing/2014/main" id="{250C888C-B79A-4F59-97DE-84B2FE334F37}"/>
               </a:ext>
             </a:extLst>
           </p:cNvPr>
@@ -13734,7 +13734,7 @@
           <p:cNvPr id="15" name="">
             <a:extLst xmlns:a="http://schemas.openxmlformats.org/drawingml/2006/main">
               <a:ext uri="{FF2B5EF4-FFF2-40B4-BE49-F238E27FC236}">
-                <a16:creationId xmlns:a16="http://schemas.microsoft.com/office/drawing/2014/main" id="{B759F73C-A2C4-49F2-A346-213448BE7004}"/>
+                <a16:creationId xmlns:a16="http://schemas.microsoft.com/office/drawing/2014/main" id="{AB2560A6-AE2E-4DA8-82B4-4D89E76F5BFE}"/>
               </a:ext>
             </a:extLst>
           </p:cNvPr>
@@ -13793,7 +13793,7 @@
           <p:cNvPr id="16" name="">
             <a:extLst xmlns:a="http://schemas.openxmlformats.org/drawingml/2006/main">
               <a:ext uri="{FF2B5EF4-FFF2-40B4-BE49-F238E27FC236}">
-                <a16:creationId xmlns:a16="http://schemas.microsoft.com/office/drawing/2014/main" id="{E7B75BB5-4796-4C2F-AA4E-EC7B501C91B7}"/>
+                <a16:creationId xmlns:a16="http://schemas.microsoft.com/office/drawing/2014/main" id="{8EA1CBCA-A1AA-4339-BBE0-6EB2201B0D53}"/>
               </a:ext>
             </a:extLst>
           </p:cNvPr>
@@ -13824,7 +13824,7 @@
           <a:lstStyle xmlns:a="http://schemas.openxmlformats.org/drawingml/2006/main"/>
           <a:p xmlns:a="http://schemas.openxmlformats.org/drawingml/2006/main">
             <a:pPr algn="l">
-              <a:defRPr sz="938" b="0">
+              <a:defRPr sz="923" b="0">
                 <a:solidFill>
                   <a:srgbClr val="526179"/>
                 </a:solidFill>
@@ -13834,7 +13834,7 @@
               </a:defRPr>
             </a:pPr>
             <a:r>
-              <a:rPr sz="938" b="0">
+              <a:rPr sz="923" b="0">
                 <a:solidFill>
                   <a:srgbClr val="526179"/>
                 </a:solidFill>
@@ -13852,7 +13852,7 @@
           <p:cNvPr id="17" name="">
             <a:extLst xmlns:a="http://schemas.openxmlformats.org/drawingml/2006/main">
               <a:ext uri="{FF2B5EF4-FFF2-40B4-BE49-F238E27FC236}">
-                <a16:creationId xmlns:a16="http://schemas.microsoft.com/office/drawing/2014/main" id="{0D380117-7BF2-4058-982F-03614CF6F0CF}"/>
+                <a16:creationId xmlns:a16="http://schemas.microsoft.com/office/drawing/2014/main" id="{6BD91107-2309-4153-9579-896BF7E24F23}"/>
               </a:ext>
             </a:extLst>
           </p:cNvPr>
@@ -13884,7 +13884,7 @@
           <p:cNvPr id="18" name="">
             <a:extLst xmlns:a="http://schemas.openxmlformats.org/drawingml/2006/main">
               <a:ext uri="{FF2B5EF4-FFF2-40B4-BE49-F238E27FC236}">
-                <a16:creationId xmlns:a16="http://schemas.microsoft.com/office/drawing/2014/main" id="{10DC43F7-DAD5-4DF7-BE03-0BBE628B8CCF}"/>
+                <a16:creationId xmlns:a16="http://schemas.microsoft.com/office/drawing/2014/main" id="{568DFD8D-E0CA-4D94-8AD8-888E51891C0C}"/>
               </a:ext>
             </a:extLst>
           </p:cNvPr>
@@ -13914,7 +13914,7 @@
           <p:cNvPr id="19" name="">
             <a:extLst xmlns:a="http://schemas.openxmlformats.org/drawingml/2006/main">
               <a:ext uri="{FF2B5EF4-FFF2-40B4-BE49-F238E27FC236}">
-                <a16:creationId xmlns:a16="http://schemas.microsoft.com/office/drawing/2014/main" id="{69088AF3-F928-4BD2-838E-ABE7E0B52302}"/>
+                <a16:creationId xmlns:a16="http://schemas.microsoft.com/office/drawing/2014/main" id="{E15B2A80-D9F7-48DB-9CF2-AF9136D6E664}"/>
               </a:ext>
             </a:extLst>
           </p:cNvPr>
@@ -13973,7 +13973,7 @@
           <p:cNvPr id="20" name="">
             <a:extLst xmlns:a="http://schemas.openxmlformats.org/drawingml/2006/main">
               <a:ext uri="{FF2B5EF4-FFF2-40B4-BE49-F238E27FC236}">
-                <a16:creationId xmlns:a16="http://schemas.microsoft.com/office/drawing/2014/main" id="{CA31DBCB-8E62-4494-9C52-6BE60347CFAD}"/>
+                <a16:creationId xmlns:a16="http://schemas.microsoft.com/office/drawing/2014/main" id="{7B082445-276A-4B45-8EA3-5004A17FE6FC}"/>
               </a:ext>
             </a:extLst>
           </p:cNvPr>
@@ -14004,7 +14004,7 @@
           <a:lstStyle xmlns:a="http://schemas.openxmlformats.org/drawingml/2006/main"/>
           <a:p xmlns:a="http://schemas.openxmlformats.org/drawingml/2006/main">
             <a:pPr algn="l">
-              <a:defRPr sz="938" b="0">
+              <a:defRPr sz="923" b="0">
                 <a:solidFill>
                   <a:srgbClr val="526179"/>
                 </a:solidFill>
@@ -14014,7 +14014,7 @@
               </a:defRPr>
             </a:pPr>
             <a:r>
-              <a:rPr sz="938" b="0">
+              <a:rPr sz="923" b="0">
                 <a:solidFill>
                   <a:srgbClr val="526179"/>
                 </a:solidFill>
@@ -14032,7 +14032,7 @@
           <p:cNvPr id="21" name="">
             <a:extLst xmlns:a="http://schemas.openxmlformats.org/drawingml/2006/main">
               <a:ext uri="{FF2B5EF4-FFF2-40B4-BE49-F238E27FC236}">
-                <a16:creationId xmlns:a16="http://schemas.microsoft.com/office/drawing/2014/main" id="{82AEC563-FDEB-452C-BE1F-9B136B7C614E}"/>
+                <a16:creationId xmlns:a16="http://schemas.microsoft.com/office/drawing/2014/main" id="{04EECC10-D62A-4EDD-A047-B7321175AA4D}"/>
               </a:ext>
             </a:extLst>
           </p:cNvPr>
@@ -14064,7 +14064,7 @@
           <p:cNvPr id="22" name="">
             <a:extLst xmlns:a="http://schemas.openxmlformats.org/drawingml/2006/main">
               <a:ext uri="{FF2B5EF4-FFF2-40B4-BE49-F238E27FC236}">
-                <a16:creationId xmlns:a16="http://schemas.microsoft.com/office/drawing/2014/main" id="{9E461625-364E-4236-93D5-1C802CB21B44}"/>
+                <a16:creationId xmlns:a16="http://schemas.microsoft.com/office/drawing/2014/main" id="{93C0A2E5-439A-4E7B-8D75-98C6DCDECB7A}"/>
               </a:ext>
             </a:extLst>
           </p:cNvPr>
@@ -14094,7 +14094,7 @@
           <p:cNvPr id="23" name="">
             <a:extLst xmlns:a="http://schemas.openxmlformats.org/drawingml/2006/main">
               <a:ext uri="{FF2B5EF4-FFF2-40B4-BE49-F238E27FC236}">
-                <a16:creationId xmlns:a16="http://schemas.microsoft.com/office/drawing/2014/main" id="{42C72BF0-29E3-4EAE-9CFB-C66C24DAF0AB}"/>
+                <a16:creationId xmlns:a16="http://schemas.microsoft.com/office/drawing/2014/main" id="{83B8B70A-16E3-4C8C-A2A7-67BDBD04420D}"/>
               </a:ext>
             </a:extLst>
           </p:cNvPr>
@@ -14153,7 +14153,7 @@
           <p:cNvPr id="24" name="">
             <a:extLst xmlns:a="http://schemas.openxmlformats.org/drawingml/2006/main">
               <a:ext uri="{FF2B5EF4-FFF2-40B4-BE49-F238E27FC236}">
-                <a16:creationId xmlns:a16="http://schemas.microsoft.com/office/drawing/2014/main" id="{C576A3D7-7AD4-461B-A8FE-6D7C667093BD}"/>
+                <a16:creationId xmlns:a16="http://schemas.microsoft.com/office/drawing/2014/main" id="{036F8CDA-3B85-4C97-A7FF-575ADC008828}"/>
               </a:ext>
             </a:extLst>
           </p:cNvPr>
@@ -14184,7 +14184,7 @@
           <a:lstStyle xmlns:a="http://schemas.openxmlformats.org/drawingml/2006/main"/>
           <a:p xmlns:a="http://schemas.openxmlformats.org/drawingml/2006/main">
             <a:pPr algn="l">
-              <a:defRPr sz="938" b="0">
+              <a:defRPr sz="923" b="0">
                 <a:solidFill>
                   <a:srgbClr val="526179"/>
                 </a:solidFill>
@@ -14194,7 +14194,7 @@
               </a:defRPr>
             </a:pPr>
             <a:r>
-              <a:rPr sz="938" b="0">
+              <a:rPr sz="923" b="0">
                 <a:solidFill>
                   <a:srgbClr val="526179"/>
                 </a:solidFill>
@@ -14212,7 +14212,7 @@
           <p:cNvPr id="25" name="">
             <a:extLst xmlns:a="http://schemas.openxmlformats.org/drawingml/2006/main">
               <a:ext uri="{FF2B5EF4-FFF2-40B4-BE49-F238E27FC236}">
-                <a16:creationId xmlns:a16="http://schemas.microsoft.com/office/drawing/2014/main" id="{F6D8DA58-AC09-4E81-9CF2-079507F9487E}"/>
+                <a16:creationId xmlns:a16="http://schemas.microsoft.com/office/drawing/2014/main" id="{F02D46E7-60FE-4656-BDD9-3DF0C19EA840}"/>
               </a:ext>
             </a:extLst>
           </p:cNvPr>
@@ -14244,7 +14244,7 @@
           <p:cNvPr id="26" name="">
             <a:extLst xmlns:a="http://schemas.openxmlformats.org/drawingml/2006/main">
               <a:ext uri="{FF2B5EF4-FFF2-40B4-BE49-F238E27FC236}">
-                <a16:creationId xmlns:a16="http://schemas.microsoft.com/office/drawing/2014/main" id="{D5CFA856-E960-4780-9F6B-15DB64C6D3E3}"/>
+                <a16:creationId xmlns:a16="http://schemas.microsoft.com/office/drawing/2014/main" id="{03C8278F-5044-412F-B484-1DFDC256E5E7}"/>
               </a:ext>
             </a:extLst>
           </p:cNvPr>
@@ -14303,7 +14303,7 @@
           <p:cNvPr id="27" name="">
             <a:extLst xmlns:a="http://schemas.openxmlformats.org/drawingml/2006/main">
               <a:ext uri="{FF2B5EF4-FFF2-40B4-BE49-F238E27FC236}">
-                <a16:creationId xmlns:a16="http://schemas.microsoft.com/office/drawing/2014/main" id="{75A7D05E-AA2C-499F-A471-B9318E29A367}"/>
+                <a16:creationId xmlns:a16="http://schemas.microsoft.com/office/drawing/2014/main" id="{EA4E99FE-E19C-4E07-8AD1-38547C5463A3}"/>
               </a:ext>
             </a:extLst>
           </p:cNvPr>
@@ -14335,7 +14335,7 @@
           <p:cNvPr id="28" name="">
             <a:extLst xmlns:a="http://schemas.openxmlformats.org/drawingml/2006/main">
               <a:ext uri="{FF2B5EF4-FFF2-40B4-BE49-F238E27FC236}">
-                <a16:creationId xmlns:a16="http://schemas.microsoft.com/office/drawing/2014/main" id="{C310675C-8315-45C0-B66C-3CA18C7EAA35}"/>
+                <a16:creationId xmlns:a16="http://schemas.microsoft.com/office/drawing/2014/main" id="{3729EC91-9075-4993-AD66-D0633AD5212A}"/>
               </a:ext>
             </a:extLst>
           </p:cNvPr>
@@ -14394,7 +14394,7 @@
           <p:cNvPr id="29" name="">
             <a:extLst xmlns:a="http://schemas.openxmlformats.org/drawingml/2006/main">
               <a:ext uri="{FF2B5EF4-FFF2-40B4-BE49-F238E27FC236}">
-                <a16:creationId xmlns:a16="http://schemas.microsoft.com/office/drawing/2014/main" id="{C8677B5B-36B0-4665-86BD-1E3D98CEB1CC}"/>
+                <a16:creationId xmlns:a16="http://schemas.microsoft.com/office/drawing/2014/main" id="{E1F224E9-C049-4193-9F2C-9AC63951AB71}"/>
               </a:ext>
             </a:extLst>
           </p:cNvPr>
@@ -14426,7 +14426,7 @@
           <p:cNvPr id="30" name="">
             <a:extLst xmlns:a="http://schemas.openxmlformats.org/drawingml/2006/main">
               <a:ext uri="{FF2B5EF4-FFF2-40B4-BE49-F238E27FC236}">
-                <a16:creationId xmlns:a16="http://schemas.microsoft.com/office/drawing/2014/main" id="{9C30AF43-4935-454B-9081-FC11B3E31A9B}"/>
+                <a16:creationId xmlns:a16="http://schemas.microsoft.com/office/drawing/2014/main" id="{40038B83-2C12-462F-82FE-ED689AC23FBE}"/>
               </a:ext>
             </a:extLst>
           </p:cNvPr>
@@ -14485,7 +14485,7 @@
           <p:cNvPr id="31" name="">
             <a:extLst xmlns:a="http://schemas.openxmlformats.org/drawingml/2006/main">
               <a:ext uri="{FF2B5EF4-FFF2-40B4-BE49-F238E27FC236}">
-                <a16:creationId xmlns:a16="http://schemas.microsoft.com/office/drawing/2014/main" id="{2C5CB7B2-EBCD-48F4-91D6-E58A4010CC47}"/>
+                <a16:creationId xmlns:a16="http://schemas.microsoft.com/office/drawing/2014/main" id="{F13AF3E4-E333-42F0-B7F0-EA958DCFF5EB}"/>
               </a:ext>
             </a:extLst>
           </p:cNvPr>
@@ -14517,7 +14517,7 @@
           <p:cNvPr id="32" name="">
             <a:extLst xmlns:a="http://schemas.openxmlformats.org/drawingml/2006/main">
               <a:ext uri="{FF2B5EF4-FFF2-40B4-BE49-F238E27FC236}">
-                <a16:creationId xmlns:a16="http://schemas.microsoft.com/office/drawing/2014/main" id="{E86FD126-F54D-4C0C-A566-0B6B44ED83FB}"/>
+                <a16:creationId xmlns:a16="http://schemas.microsoft.com/office/drawing/2014/main" id="{A9189C9A-CDCB-4A76-BB72-3D8DE889771A}"/>
               </a:ext>
             </a:extLst>
           </p:cNvPr>
@@ -14574,7 +14574,7 @@
     </p:spTree>
     <p:extLst>
       <p:ext uri="{BB962C8B-B14F-4D97-AF65-F5344CB8AC3E}">
-        <p14:creationId xmlns:p14="http://schemas.microsoft.com/office/powerpoint/2010/main" val="1574672066"/>
+        <p14:creationId xmlns:p14="http://schemas.microsoft.com/office/powerpoint/2010/main" val="1029189049"/>
       </p:ext>
     </p:extLst>
   </p:cSld>
@@ -14598,7 +14598,7 @@
           <p:cNvPr id="1" name="">
             <a:extLst xmlns:a="http://schemas.openxmlformats.org/drawingml/2006/main">
               <a:ext uri="{FF2B5EF4-FFF2-40B4-BE49-F238E27FC236}">
-                <a16:creationId xmlns:a16="http://schemas.microsoft.com/office/drawing/2014/main" id="{61096186-0B81-4953-9158-CE32CECE162E}"/>
+                <a16:creationId xmlns:a16="http://schemas.microsoft.com/office/drawing/2014/main" id="{38C76B2D-0363-47D8-9050-AF3AE4215FCD}"/>
               </a:ext>
             </a:extLst>
           </p:cNvPr>
@@ -14628,7 +14628,7 @@
           <p:cNvPr id="2" name="">
             <a:extLst xmlns:a="http://schemas.openxmlformats.org/drawingml/2006/main">
               <a:ext uri="{FF2B5EF4-FFF2-40B4-BE49-F238E27FC236}">
-                <a16:creationId xmlns:a16="http://schemas.microsoft.com/office/drawing/2014/main" id="{0FCA42CB-35BE-4F2D-8111-1BFE73DE450E}"/>
+                <a16:creationId xmlns:a16="http://schemas.microsoft.com/office/drawing/2014/main" id="{380695FB-8CF6-42E2-BFBE-4BC6FADC309B}"/>
               </a:ext>
             </a:extLst>
           </p:cNvPr>
@@ -14658,7 +14658,7 @@
           <p:cNvPr id="3" name="">
             <a:extLst xmlns:a="http://schemas.openxmlformats.org/drawingml/2006/main">
               <a:ext uri="{FF2B5EF4-FFF2-40B4-BE49-F238E27FC236}">
-                <a16:creationId xmlns:a16="http://schemas.microsoft.com/office/drawing/2014/main" id="{212AD291-7390-4AFE-BD10-3797862DBC3D}"/>
+                <a16:creationId xmlns:a16="http://schemas.microsoft.com/office/drawing/2014/main" id="{3379189B-A34F-46BE-A853-796A57B06483}"/>
               </a:ext>
             </a:extLst>
           </p:cNvPr>
@@ -14717,7 +14717,7 @@
           <p:cNvPr id="4" name="">
             <a:extLst xmlns:a="http://schemas.openxmlformats.org/drawingml/2006/main">
               <a:ext uri="{FF2B5EF4-FFF2-40B4-BE49-F238E27FC236}">
-                <a16:creationId xmlns:a16="http://schemas.microsoft.com/office/drawing/2014/main" id="{E49001FC-BA64-4E18-92A3-6FC4B3D377D3}"/>
+                <a16:creationId xmlns:a16="http://schemas.microsoft.com/office/drawing/2014/main" id="{213C4A84-604D-46F9-B4CE-C988FC55A5F0}"/>
               </a:ext>
             </a:extLst>
           </p:cNvPr>
@@ -14776,7 +14776,7 @@
           <p:cNvPr id="5" name="">
             <a:extLst xmlns:a="http://schemas.openxmlformats.org/drawingml/2006/main">
               <a:ext uri="{FF2B5EF4-FFF2-40B4-BE49-F238E27FC236}">
-                <a16:creationId xmlns:a16="http://schemas.microsoft.com/office/drawing/2014/main" id="{1F2BCDB7-50A6-4D0D-A27E-49FDDD3A7E1A}"/>
+                <a16:creationId xmlns:a16="http://schemas.microsoft.com/office/drawing/2014/main" id="{0FF39C6C-FFED-4C2F-816F-2FB7B575775F}"/>
               </a:ext>
             </a:extLst>
           </p:cNvPr>
@@ -14835,7 +14835,7 @@
           <p:cNvPr id="6" name="">
             <a:extLst xmlns:a="http://schemas.openxmlformats.org/drawingml/2006/main">
               <a:ext uri="{FF2B5EF4-FFF2-40B4-BE49-F238E27FC236}">
-                <a16:creationId xmlns:a16="http://schemas.microsoft.com/office/drawing/2014/main" id="{25E27EF0-36FF-4A98-82DE-A375AEA108A9}"/>
+                <a16:creationId xmlns:a16="http://schemas.microsoft.com/office/drawing/2014/main" id="{6315DC62-826F-48D6-A14D-0F4B430F2632}"/>
               </a:ext>
             </a:extLst>
           </p:cNvPr>
@@ -14898,7 +14898,7 @@
           <p:nvPr/>
         </p:nvPicPr>
         <p:blipFill>
-          <a:blip xmlns:r="http://schemas.openxmlformats.org/officeDocument/2006/relationships" xmlns:a="http://schemas.openxmlformats.org/drawingml/2006/main" r:embed="R0330e2d7aab548e9"/>
+          <a:blip xmlns:r="http://schemas.openxmlformats.org/officeDocument/2006/relationships" xmlns:a="http://schemas.openxmlformats.org/drawingml/2006/main" r:embed="Rbf45841091324c30"/>
           <a:srcRect xmlns:a="http://schemas.openxmlformats.org/drawingml/2006/main" l="0" t="1738" r="0" b="1738"/>
           <a:stretch xmlns:a="http://schemas.openxmlformats.org/drawingml/2006/main">
             <a:fillRect l="0" t="0" r="0" b="0"/>
@@ -14919,7 +14919,7 @@
           <p:cNvPr id="8" name="">
             <a:extLst xmlns:a="http://schemas.openxmlformats.org/drawingml/2006/main">
               <a:ext uri="{FF2B5EF4-FFF2-40B4-BE49-F238E27FC236}">
-                <a16:creationId xmlns:a16="http://schemas.microsoft.com/office/drawing/2014/main" id="{295A164D-BDDF-4CA3-8E88-8BF822DD686C}"/>
+                <a16:creationId xmlns:a16="http://schemas.microsoft.com/office/drawing/2014/main" id="{FFFE6028-2E0C-43BA-83FF-93CF1498FF23}"/>
               </a:ext>
             </a:extLst>
           </p:cNvPr>
@@ -14951,7 +14951,7 @@
           <p:cNvPr id="9" name="">
             <a:extLst xmlns:a="http://schemas.openxmlformats.org/drawingml/2006/main">
               <a:ext uri="{FF2B5EF4-FFF2-40B4-BE49-F238E27FC236}">
-                <a16:creationId xmlns:a16="http://schemas.microsoft.com/office/drawing/2014/main" id="{FC55B6D9-7C3E-4F0B-8F02-38CAF54F0818}"/>
+                <a16:creationId xmlns:a16="http://schemas.microsoft.com/office/drawing/2014/main" id="{2B670B9C-85B0-4CAC-802E-386DD9B4426D}"/>
               </a:ext>
             </a:extLst>
           </p:cNvPr>
@@ -14985,7 +14985,7 @@
           <p:cNvPr id="10" name="">
             <a:extLst xmlns:a="http://schemas.openxmlformats.org/drawingml/2006/main">
               <a:ext uri="{FF2B5EF4-FFF2-40B4-BE49-F238E27FC236}">
-                <a16:creationId xmlns:a16="http://schemas.microsoft.com/office/drawing/2014/main" id="{23A93A93-7C93-4954-B1E4-6AF9E2EE5038}"/>
+                <a16:creationId xmlns:a16="http://schemas.microsoft.com/office/drawing/2014/main" id="{389DCC84-D713-44D4-9A6C-C04FC92433E9}"/>
               </a:ext>
             </a:extLst>
           </p:cNvPr>
@@ -15017,7 +15017,7 @@
           <p:cNvPr id="11" name="">
             <a:extLst xmlns:a="http://schemas.openxmlformats.org/drawingml/2006/main">
               <a:ext uri="{FF2B5EF4-FFF2-40B4-BE49-F238E27FC236}">
-                <a16:creationId xmlns:a16="http://schemas.microsoft.com/office/drawing/2014/main" id="{B0D50A32-C570-47F3-AF54-B0CA46667FB2}"/>
+                <a16:creationId xmlns:a16="http://schemas.microsoft.com/office/drawing/2014/main" id="{CC41CB53-FB8C-4842-879D-559EA0D44180}"/>
               </a:ext>
             </a:extLst>
           </p:cNvPr>
@@ -15047,7 +15047,7 @@
           <p:cNvPr id="12" name="">
             <a:extLst xmlns:a="http://schemas.openxmlformats.org/drawingml/2006/main">
               <a:ext uri="{FF2B5EF4-FFF2-40B4-BE49-F238E27FC236}">
-                <a16:creationId xmlns:a16="http://schemas.microsoft.com/office/drawing/2014/main" id="{47A5EB51-5F8E-416F-88F1-69EAD62EE1ED}"/>
+                <a16:creationId xmlns:a16="http://schemas.microsoft.com/office/drawing/2014/main" id="{5249FF4B-E80E-47FB-B7F6-CD7EA2444F0E}"/>
               </a:ext>
             </a:extLst>
           </p:cNvPr>
@@ -15106,7 +15106,7 @@
           <p:cNvPr id="13" name="">
             <a:extLst xmlns:a="http://schemas.openxmlformats.org/drawingml/2006/main">
               <a:ext uri="{FF2B5EF4-FFF2-40B4-BE49-F238E27FC236}">
-                <a16:creationId xmlns:a16="http://schemas.microsoft.com/office/drawing/2014/main" id="{6A61E042-4FC6-48F2-91A8-230B308980C0}"/>
+                <a16:creationId xmlns:a16="http://schemas.microsoft.com/office/drawing/2014/main" id="{1496845A-9F7F-4BA1-999E-D62C1B325640}"/>
               </a:ext>
             </a:extLst>
           </p:cNvPr>
@@ -15118,7 +15118,7 @@
         <p:spPr>
           <a:xfrm xmlns:a="http://schemas.openxmlformats.org/drawingml/2006/main">
             <a:off x="914400" y="2463641"/>
-            <a:ext cx="1924050" cy="317659"/>
+            <a:ext cx="1924050" cy="266700"/>
           </a:xfrm>
           <a:prstGeom xmlns:a="http://schemas.openxmlformats.org/drawingml/2006/main" prst="rect">
             <a:avLst/>
@@ -15137,7 +15137,7 @@
           <a:lstStyle xmlns:a="http://schemas.openxmlformats.org/drawingml/2006/main"/>
           <a:p xmlns:a="http://schemas.openxmlformats.org/drawingml/2006/main">
             <a:pPr algn="l">
-              <a:defRPr sz="982" b="0">
+              <a:defRPr sz="960" b="0">
                 <a:solidFill>
                   <a:srgbClr val="526179"/>
                 </a:solidFill>
@@ -15147,7 +15147,7 @@
               </a:defRPr>
             </a:pPr>
             <a:r>
-              <a:rPr sz="982" b="0">
+              <a:rPr sz="960" b="0">
                 <a:solidFill>
                   <a:srgbClr val="526179"/>
                 </a:solidFill>
@@ -15165,7 +15165,7 @@
           <p:cNvPr id="14" name="">
             <a:extLst xmlns:a="http://schemas.openxmlformats.org/drawingml/2006/main">
               <a:ext uri="{FF2B5EF4-FFF2-40B4-BE49-F238E27FC236}">
-                <a16:creationId xmlns:a16="http://schemas.microsoft.com/office/drawing/2014/main" id="{EE75E46A-E5FB-4B1B-AABD-8C1FAFF7629F}"/>
+                <a16:creationId xmlns:a16="http://schemas.microsoft.com/office/drawing/2014/main" id="{26BCB31A-4A62-4476-874B-D0CC3C56A829}"/>
               </a:ext>
             </a:extLst>
           </p:cNvPr>
@@ -15197,7 +15197,7 @@
           <p:cNvPr id="15" name="">
             <a:extLst xmlns:a="http://schemas.openxmlformats.org/drawingml/2006/main">
               <a:ext uri="{FF2B5EF4-FFF2-40B4-BE49-F238E27FC236}">
-                <a16:creationId xmlns:a16="http://schemas.microsoft.com/office/drawing/2014/main" id="{FAA91771-D8F6-4A56-86D3-943B9CC7FF6E}"/>
+                <a16:creationId xmlns:a16="http://schemas.microsoft.com/office/drawing/2014/main" id="{7873F959-D5A0-4C20-B121-1CAA107779A0}"/>
               </a:ext>
             </a:extLst>
           </p:cNvPr>
@@ -15227,7 +15227,7 @@
           <p:cNvPr id="16" name="">
             <a:extLst xmlns:a="http://schemas.openxmlformats.org/drawingml/2006/main">
               <a:ext uri="{FF2B5EF4-FFF2-40B4-BE49-F238E27FC236}">
-                <a16:creationId xmlns:a16="http://schemas.microsoft.com/office/drawing/2014/main" id="{FF64B478-F6A8-43F0-A5B9-5A0F8AA8D5DE}"/>
+                <a16:creationId xmlns:a16="http://schemas.microsoft.com/office/drawing/2014/main" id="{61037E21-0705-4C7D-9417-707B8148ABAD}"/>
               </a:ext>
             </a:extLst>
           </p:cNvPr>
@@ -15286,7 +15286,7 @@
           <p:cNvPr id="17" name="">
             <a:extLst xmlns:a="http://schemas.openxmlformats.org/drawingml/2006/main">
               <a:ext uri="{FF2B5EF4-FFF2-40B4-BE49-F238E27FC236}">
-                <a16:creationId xmlns:a16="http://schemas.microsoft.com/office/drawing/2014/main" id="{8ECD41BC-A9B5-4FF1-B725-48B0B0FDD1FC}"/>
+                <a16:creationId xmlns:a16="http://schemas.microsoft.com/office/drawing/2014/main" id="{E0F6D775-FC1D-4651-8E78-A4190413BD11}"/>
               </a:ext>
             </a:extLst>
           </p:cNvPr>
@@ -15298,7 +15298,7 @@
         <p:spPr>
           <a:xfrm xmlns:a="http://schemas.openxmlformats.org/drawingml/2006/main">
             <a:off x="3581400" y="2463641"/>
-            <a:ext cx="1924050" cy="317659"/>
+            <a:ext cx="1924050" cy="266700"/>
           </a:xfrm>
           <a:prstGeom xmlns:a="http://schemas.openxmlformats.org/drawingml/2006/main" prst="rect">
             <a:avLst/>
@@ -15317,7 +15317,7 @@
           <a:lstStyle xmlns:a="http://schemas.openxmlformats.org/drawingml/2006/main"/>
           <a:p xmlns:a="http://schemas.openxmlformats.org/drawingml/2006/main">
             <a:pPr algn="l">
-              <a:defRPr sz="982" b="0">
+              <a:defRPr sz="960" b="0">
                 <a:solidFill>
                   <a:srgbClr val="526179"/>
                 </a:solidFill>
@@ -15327,7 +15327,7 @@
               </a:defRPr>
             </a:pPr>
             <a:r>
-              <a:rPr sz="982" b="0">
+              <a:rPr sz="960" b="0">
                 <a:solidFill>
                   <a:srgbClr val="526179"/>
                 </a:solidFill>
@@ -15345,7 +15345,7 @@
           <p:cNvPr id="18" name="">
             <a:extLst xmlns:a="http://schemas.openxmlformats.org/drawingml/2006/main">
               <a:ext uri="{FF2B5EF4-FFF2-40B4-BE49-F238E27FC236}">
-                <a16:creationId xmlns:a16="http://schemas.microsoft.com/office/drawing/2014/main" id="{C82CF4FB-61B9-46BE-982A-C900100F2A20}"/>
+                <a16:creationId xmlns:a16="http://schemas.microsoft.com/office/drawing/2014/main" id="{7F504005-1189-45C2-B7F8-2681D72A6F90}"/>
               </a:ext>
             </a:extLst>
           </p:cNvPr>
@@ -15377,7 +15377,7 @@
           <p:cNvPr id="19" name="">
             <a:extLst xmlns:a="http://schemas.openxmlformats.org/drawingml/2006/main">
               <a:ext uri="{FF2B5EF4-FFF2-40B4-BE49-F238E27FC236}">
-                <a16:creationId xmlns:a16="http://schemas.microsoft.com/office/drawing/2014/main" id="{01AFCD71-257A-40AA-B1FD-F4352DAB1FF7}"/>
+                <a16:creationId xmlns:a16="http://schemas.microsoft.com/office/drawing/2014/main" id="{D0A22DD4-AC88-4EF3-8BE7-FC35154BF459}"/>
               </a:ext>
             </a:extLst>
           </p:cNvPr>
@@ -15407,7 +15407,7 @@
           <p:cNvPr id="20" name="">
             <a:extLst xmlns:a="http://schemas.openxmlformats.org/drawingml/2006/main">
               <a:ext uri="{FF2B5EF4-FFF2-40B4-BE49-F238E27FC236}">
-                <a16:creationId xmlns:a16="http://schemas.microsoft.com/office/drawing/2014/main" id="{2F3E7FE1-2848-4973-9FD4-4A7421738D46}"/>
+                <a16:creationId xmlns:a16="http://schemas.microsoft.com/office/drawing/2014/main" id="{EFA3E9FB-35EF-41A2-B5F8-E8D135AD883C}"/>
               </a:ext>
             </a:extLst>
           </p:cNvPr>
@@ -15466,7 +15466,7 @@
           <p:cNvPr id="21" name="">
             <a:extLst xmlns:a="http://schemas.openxmlformats.org/drawingml/2006/main">
               <a:ext uri="{FF2B5EF4-FFF2-40B4-BE49-F238E27FC236}">
-                <a16:creationId xmlns:a16="http://schemas.microsoft.com/office/drawing/2014/main" id="{511DE78A-9412-40E2-82A8-2D6B8D9E4170}"/>
+                <a16:creationId xmlns:a16="http://schemas.microsoft.com/office/drawing/2014/main" id="{0B08B83E-6897-41ED-8F08-B93CA560CE0B}"/>
               </a:ext>
             </a:extLst>
           </p:cNvPr>
@@ -15478,7 +15478,7 @@
         <p:spPr>
           <a:xfrm xmlns:a="http://schemas.openxmlformats.org/drawingml/2006/main">
             <a:off x="914400" y="3644741"/>
-            <a:ext cx="1924050" cy="317659"/>
+            <a:ext cx="1924050" cy="266700"/>
           </a:xfrm>
           <a:prstGeom xmlns:a="http://schemas.openxmlformats.org/drawingml/2006/main" prst="rect">
             <a:avLst/>
@@ -15497,7 +15497,7 @@
           <a:lstStyle xmlns:a="http://schemas.openxmlformats.org/drawingml/2006/main"/>
           <a:p xmlns:a="http://schemas.openxmlformats.org/drawingml/2006/main">
             <a:pPr algn="l">
-              <a:defRPr sz="982" b="0">
+              <a:defRPr sz="960" b="0">
                 <a:solidFill>
                   <a:srgbClr val="526179"/>
                 </a:solidFill>
@@ -15507,7 +15507,7 @@
               </a:defRPr>
             </a:pPr>
             <a:r>
-              <a:rPr sz="982" b="0">
+              <a:rPr sz="960" b="0">
                 <a:solidFill>
                   <a:srgbClr val="526179"/>
                 </a:solidFill>
@@ -15525,7 +15525,7 @@
           <p:cNvPr id="22" name="">
             <a:extLst xmlns:a="http://schemas.openxmlformats.org/drawingml/2006/main">
               <a:ext uri="{FF2B5EF4-FFF2-40B4-BE49-F238E27FC236}">
-                <a16:creationId xmlns:a16="http://schemas.microsoft.com/office/drawing/2014/main" id="{0085D7D3-F3E7-4D57-86C2-99388873FB3A}"/>
+                <a16:creationId xmlns:a16="http://schemas.microsoft.com/office/drawing/2014/main" id="{A6764F1F-0919-4F29-9350-3988AD97B5A5}"/>
               </a:ext>
             </a:extLst>
           </p:cNvPr>
@@ -15557,7 +15557,7 @@
           <p:cNvPr id="23" name="">
             <a:extLst xmlns:a="http://schemas.openxmlformats.org/drawingml/2006/main">
               <a:ext uri="{FF2B5EF4-FFF2-40B4-BE49-F238E27FC236}">
-                <a16:creationId xmlns:a16="http://schemas.microsoft.com/office/drawing/2014/main" id="{F5329515-8357-437E-8D49-6470120C38E8}"/>
+                <a16:creationId xmlns:a16="http://schemas.microsoft.com/office/drawing/2014/main" id="{B5F56476-AAAB-42A7-85F8-A165325086AD}"/>
               </a:ext>
             </a:extLst>
           </p:cNvPr>
@@ -15587,7 +15587,7 @@
           <p:cNvPr id="24" name="">
             <a:extLst xmlns:a="http://schemas.openxmlformats.org/drawingml/2006/main">
               <a:ext uri="{FF2B5EF4-FFF2-40B4-BE49-F238E27FC236}">
-                <a16:creationId xmlns:a16="http://schemas.microsoft.com/office/drawing/2014/main" id="{2B0A01B2-239E-4C95-8A9D-52753465A2B6}"/>
+                <a16:creationId xmlns:a16="http://schemas.microsoft.com/office/drawing/2014/main" id="{74742B0E-81DE-44F8-9CF6-A73FD2890983}"/>
               </a:ext>
             </a:extLst>
           </p:cNvPr>
@@ -15646,7 +15646,7 @@
           <p:cNvPr id="25" name="">
             <a:extLst xmlns:a="http://schemas.openxmlformats.org/drawingml/2006/main">
               <a:ext uri="{FF2B5EF4-FFF2-40B4-BE49-F238E27FC236}">
-                <a16:creationId xmlns:a16="http://schemas.microsoft.com/office/drawing/2014/main" id="{1E3EC2C1-E5AA-4EB8-A727-3D2971C5E7A6}"/>
+                <a16:creationId xmlns:a16="http://schemas.microsoft.com/office/drawing/2014/main" id="{397C7B8C-CDCC-4CE8-AFF8-645A71B97F3D}"/>
               </a:ext>
             </a:extLst>
           </p:cNvPr>
@@ -15658,7 +15658,7 @@
         <p:spPr>
           <a:xfrm xmlns:a="http://schemas.openxmlformats.org/drawingml/2006/main">
             <a:off x="3581400" y="3644741"/>
-            <a:ext cx="1924050" cy="317659"/>
+            <a:ext cx="1924050" cy="266700"/>
           </a:xfrm>
           <a:prstGeom xmlns:a="http://schemas.openxmlformats.org/drawingml/2006/main" prst="rect">
             <a:avLst/>
@@ -15677,7 +15677,7 @@
           <a:lstStyle xmlns:a="http://schemas.openxmlformats.org/drawingml/2006/main"/>
           <a:p xmlns:a="http://schemas.openxmlformats.org/drawingml/2006/main">
             <a:pPr algn="l">
-              <a:defRPr sz="982" b="0">
+              <a:defRPr sz="960" b="0">
                 <a:solidFill>
                   <a:srgbClr val="526179"/>
                 </a:solidFill>
@@ -15687,7 +15687,7 @@
               </a:defRPr>
             </a:pPr>
             <a:r>
-              <a:rPr sz="982" b="0">
+              <a:rPr sz="960" b="0">
                 <a:solidFill>
                   <a:srgbClr val="526179"/>
                 </a:solidFill>
@@ -15695,7 +15695,7 @@
                 <a:ea typeface="Aptos"/>
                 <a:cs typeface="Aptos"/>
               </a:rPr>
-              <a:t>Summarize evidence, changed behavior, checks, and remaining risk.</a:t>
+              <a:t>Summarize evidence, behavior changes, checks, and risk.</a:t>
             </a:r>
           </a:p>
         </p:txBody>
@@ -15705,7 +15705,7 @@
           <p:cNvPr id="26" name="">
             <a:extLst xmlns:a="http://schemas.openxmlformats.org/drawingml/2006/main">
               <a:ext uri="{FF2B5EF4-FFF2-40B4-BE49-F238E27FC236}">
-                <a16:creationId xmlns:a16="http://schemas.microsoft.com/office/drawing/2014/main" id="{320BE4EC-5460-4953-ACE4-F0B82E003A85}"/>
+                <a16:creationId xmlns:a16="http://schemas.microsoft.com/office/drawing/2014/main" id="{4BC168F6-A7B4-4A57-AF1A-E70CDFA68026}"/>
               </a:ext>
             </a:extLst>
           </p:cNvPr>
@@ -15737,7 +15737,7 @@
           <p:cNvPr id="27" name="">
             <a:extLst xmlns:a="http://schemas.openxmlformats.org/drawingml/2006/main">
               <a:ext uri="{FF2B5EF4-FFF2-40B4-BE49-F238E27FC236}">
-                <a16:creationId xmlns:a16="http://schemas.microsoft.com/office/drawing/2014/main" id="{0573A4C0-491A-4E95-9D41-347A684D3ACC}"/>
+                <a16:creationId xmlns:a16="http://schemas.microsoft.com/office/drawing/2014/main" id="{4FE80E17-026B-4687-BD54-A37ED9516B9C}"/>
               </a:ext>
             </a:extLst>
           </p:cNvPr>
@@ -15794,7 +15794,7 @@
     </p:spTree>
     <p:extLst>
       <p:ext uri="{BB962C8B-B14F-4D97-AF65-F5344CB8AC3E}">
-        <p14:creationId xmlns:p14="http://schemas.microsoft.com/office/powerpoint/2010/main" val="2145078641"/>
+        <p14:creationId xmlns:p14="http://schemas.microsoft.com/office/powerpoint/2010/main" val="1491759993"/>
       </p:ext>
     </p:extLst>
   </p:cSld>
@@ -15818,7 +15818,7 @@
           <p:cNvPr id="1" name="">
             <a:extLst xmlns:a="http://schemas.openxmlformats.org/drawingml/2006/main">
               <a:ext uri="{FF2B5EF4-FFF2-40B4-BE49-F238E27FC236}">
-                <a16:creationId xmlns:a16="http://schemas.microsoft.com/office/drawing/2014/main" id="{530BC4BC-8904-4D4D-9A85-A8C987792A07}"/>
+                <a16:creationId xmlns:a16="http://schemas.microsoft.com/office/drawing/2014/main" id="{416B166F-4754-4BFB-8DB1-882786582947}"/>
               </a:ext>
             </a:extLst>
           </p:cNvPr>
@@ -15848,7 +15848,7 @@
           <p:cNvPr id="2" name="">
             <a:extLst xmlns:a="http://schemas.openxmlformats.org/drawingml/2006/main">
               <a:ext uri="{FF2B5EF4-FFF2-40B4-BE49-F238E27FC236}">
-                <a16:creationId xmlns:a16="http://schemas.microsoft.com/office/drawing/2014/main" id="{EDF6FC7F-CDBE-4856-A485-5857AFC5F9A8}"/>
+                <a16:creationId xmlns:a16="http://schemas.microsoft.com/office/drawing/2014/main" id="{287B447B-BFC5-4D03-8F92-85A65C8F2F22}"/>
               </a:ext>
             </a:extLst>
           </p:cNvPr>
@@ -15878,7 +15878,7 @@
           <p:cNvPr id="3" name="">
             <a:extLst xmlns:a="http://schemas.openxmlformats.org/drawingml/2006/main">
               <a:ext uri="{FF2B5EF4-FFF2-40B4-BE49-F238E27FC236}">
-                <a16:creationId xmlns:a16="http://schemas.microsoft.com/office/drawing/2014/main" id="{198009F2-99C6-4ED8-A22C-CAC558E26125}"/>
+                <a16:creationId xmlns:a16="http://schemas.microsoft.com/office/drawing/2014/main" id="{D698C82B-330A-42EE-BAFC-8B975211A5E4}"/>
               </a:ext>
             </a:extLst>
           </p:cNvPr>
@@ -15937,7 +15937,7 @@
           <p:cNvPr id="4" name="">
             <a:extLst xmlns:a="http://schemas.openxmlformats.org/drawingml/2006/main">
               <a:ext uri="{FF2B5EF4-FFF2-40B4-BE49-F238E27FC236}">
-                <a16:creationId xmlns:a16="http://schemas.microsoft.com/office/drawing/2014/main" id="{5436A488-CEF8-460A-B3CF-39FE1FCB4B3E}"/>
+                <a16:creationId xmlns:a16="http://schemas.microsoft.com/office/drawing/2014/main" id="{73BCC154-808E-43A1-AB6E-CB67CBA9C6F8}"/>
               </a:ext>
             </a:extLst>
           </p:cNvPr>
@@ -15996,7 +15996,7 @@
           <p:cNvPr id="5" name="">
             <a:extLst xmlns:a="http://schemas.openxmlformats.org/drawingml/2006/main">
               <a:ext uri="{FF2B5EF4-FFF2-40B4-BE49-F238E27FC236}">
-                <a16:creationId xmlns:a16="http://schemas.microsoft.com/office/drawing/2014/main" id="{C9EFDD44-517D-4E8C-855F-70CCBB2E05C8}"/>
+                <a16:creationId xmlns:a16="http://schemas.microsoft.com/office/drawing/2014/main" id="{949C908F-2C8E-4368-9E5B-520910CDDF0D}"/>
               </a:ext>
             </a:extLst>
           </p:cNvPr>
@@ -16055,7 +16055,7 @@
           <p:cNvPr id="6" name="">
             <a:extLst xmlns:a="http://schemas.openxmlformats.org/drawingml/2006/main">
               <a:ext uri="{FF2B5EF4-FFF2-40B4-BE49-F238E27FC236}">
-                <a16:creationId xmlns:a16="http://schemas.microsoft.com/office/drawing/2014/main" id="{B5C70E35-7F83-4B4E-8E38-3C8899D6441D}"/>
+                <a16:creationId xmlns:a16="http://schemas.microsoft.com/office/drawing/2014/main" id="{74757386-8C35-4C3F-8706-1D6FD25FFAA4}"/>
               </a:ext>
             </a:extLst>
           </p:cNvPr>
@@ -16118,7 +16118,7 @@
           <p:nvPr/>
         </p:nvPicPr>
         <p:blipFill>
-          <a:blip xmlns:r="http://schemas.openxmlformats.org/officeDocument/2006/relationships" xmlns:a="http://schemas.openxmlformats.org/drawingml/2006/main" r:embed="R40de014983294252"/>
+          <a:blip xmlns:r="http://schemas.openxmlformats.org/officeDocument/2006/relationships" xmlns:a="http://schemas.openxmlformats.org/drawingml/2006/main" r:embed="R65abe3070cf94655"/>
           <a:srcRect xmlns:a="http://schemas.openxmlformats.org/drawingml/2006/main" l="0" t="1435" r="0" b="1435"/>
           <a:stretch xmlns:a="http://schemas.openxmlformats.org/drawingml/2006/main">
             <a:fillRect l="0" t="0" r="0" b="0"/>
@@ -16139,7 +16139,7 @@
           <p:cNvPr id="8" name="">
             <a:extLst xmlns:a="http://schemas.openxmlformats.org/drawingml/2006/main">
               <a:ext uri="{FF2B5EF4-FFF2-40B4-BE49-F238E27FC236}">
-                <a16:creationId xmlns:a16="http://schemas.microsoft.com/office/drawing/2014/main" id="{657610FA-372C-4D45-819F-50468E78F821}"/>
+                <a16:creationId xmlns:a16="http://schemas.microsoft.com/office/drawing/2014/main" id="{B5887948-DB62-4AB1-A805-7EFE064FFFD6}"/>
               </a:ext>
             </a:extLst>
           </p:cNvPr>
@@ -16171,7 +16171,7 @@
           <p:cNvPr id="9" name="">
             <a:extLst xmlns:a="http://schemas.openxmlformats.org/drawingml/2006/main">
               <a:ext uri="{FF2B5EF4-FFF2-40B4-BE49-F238E27FC236}">
-                <a16:creationId xmlns:a16="http://schemas.microsoft.com/office/drawing/2014/main" id="{CA788129-E49F-461E-B6D3-EC185DEF2854}"/>
+                <a16:creationId xmlns:a16="http://schemas.microsoft.com/office/drawing/2014/main" id="{654F1F08-1CBA-456F-A782-A373B8FF94C6}"/>
               </a:ext>
             </a:extLst>
           </p:cNvPr>
@@ -16205,7 +16205,7 @@
           <p:cNvPr id="10" name="">
             <a:extLst xmlns:a="http://schemas.openxmlformats.org/drawingml/2006/main">
               <a:ext uri="{FF2B5EF4-FFF2-40B4-BE49-F238E27FC236}">
-                <a16:creationId xmlns:a16="http://schemas.microsoft.com/office/drawing/2014/main" id="{1711D295-E804-4787-9EA2-9C14F9648CA5}"/>
+                <a16:creationId xmlns:a16="http://schemas.microsoft.com/office/drawing/2014/main" id="{C1F98F3E-4C81-4EC1-8C1F-28AA67F4733A}"/>
               </a:ext>
             </a:extLst>
           </p:cNvPr>
@@ -16235,7 +16235,7 @@
           <p:cNvPr id="11" name="">
             <a:extLst xmlns:a="http://schemas.openxmlformats.org/drawingml/2006/main">
               <a:ext uri="{FF2B5EF4-FFF2-40B4-BE49-F238E27FC236}">
-                <a16:creationId xmlns:a16="http://schemas.microsoft.com/office/drawing/2014/main" id="{A3AC56E6-5685-444E-BCC1-0D2C16339034}"/>
+                <a16:creationId xmlns:a16="http://schemas.microsoft.com/office/drawing/2014/main" id="{341DC21A-B6B5-4A13-873A-2370F083B55D}"/>
               </a:ext>
             </a:extLst>
           </p:cNvPr>
@@ -16265,7 +16265,7 @@
           <p:cNvPr id="12" name="">
             <a:extLst xmlns:a="http://schemas.openxmlformats.org/drawingml/2006/main">
               <a:ext uri="{FF2B5EF4-FFF2-40B4-BE49-F238E27FC236}">
-                <a16:creationId xmlns:a16="http://schemas.microsoft.com/office/drawing/2014/main" id="{59B0A6D2-D0B1-44DE-86A7-A77F1186800A}"/>
+                <a16:creationId xmlns:a16="http://schemas.microsoft.com/office/drawing/2014/main" id="{800D608B-042C-4171-ADF1-67AA552E926E}"/>
               </a:ext>
             </a:extLst>
           </p:cNvPr>
@@ -16324,7 +16324,7 @@
           <p:cNvPr id="13" name="">
             <a:extLst xmlns:a="http://schemas.openxmlformats.org/drawingml/2006/main">
               <a:ext uri="{FF2B5EF4-FFF2-40B4-BE49-F238E27FC236}">
-                <a16:creationId xmlns:a16="http://schemas.microsoft.com/office/drawing/2014/main" id="{A35FEE29-26CC-4C8F-A0A0-27CEEF48A49F}"/>
+                <a16:creationId xmlns:a16="http://schemas.microsoft.com/office/drawing/2014/main" id="{4EF5B75E-1A4D-4D5E-8EE5-D65EEB95CE53}"/>
               </a:ext>
             </a:extLst>
           </p:cNvPr>
@@ -16356,7 +16356,7 @@
           <p:cNvPr id="14" name="">
             <a:extLst xmlns:a="http://schemas.openxmlformats.org/drawingml/2006/main">
               <a:ext uri="{FF2B5EF4-FFF2-40B4-BE49-F238E27FC236}">
-                <a16:creationId xmlns:a16="http://schemas.microsoft.com/office/drawing/2014/main" id="{81D7A8EB-23D8-4F42-9934-80F6068B6FBD}"/>
+                <a16:creationId xmlns:a16="http://schemas.microsoft.com/office/drawing/2014/main" id="{25795040-B4F9-4D93-9D90-96063B8BFF02}"/>
               </a:ext>
             </a:extLst>
           </p:cNvPr>
@@ -16415,7 +16415,7 @@
           <p:cNvPr id="15" name="">
             <a:extLst xmlns:a="http://schemas.openxmlformats.org/drawingml/2006/main">
               <a:ext uri="{FF2B5EF4-FFF2-40B4-BE49-F238E27FC236}">
-                <a16:creationId xmlns:a16="http://schemas.microsoft.com/office/drawing/2014/main" id="{A2193136-ED92-40C1-BED6-0D3D4C5F8DC9}"/>
+                <a16:creationId xmlns:a16="http://schemas.microsoft.com/office/drawing/2014/main" id="{69CFB475-AE7E-4EAC-B376-1E03D0B37EE2}"/>
               </a:ext>
             </a:extLst>
           </p:cNvPr>
@@ -16474,7 +16474,7 @@
           <p:cNvPr id="16" name="">
             <a:extLst xmlns:a="http://schemas.openxmlformats.org/drawingml/2006/main">
               <a:ext uri="{FF2B5EF4-FFF2-40B4-BE49-F238E27FC236}">
-                <a16:creationId xmlns:a16="http://schemas.microsoft.com/office/drawing/2014/main" id="{C5F6D4B1-47C3-4365-A7BE-BF785ED47748}"/>
+                <a16:creationId xmlns:a16="http://schemas.microsoft.com/office/drawing/2014/main" id="{CC7B3212-5098-4E81-B8B8-710C6682601F}"/>
               </a:ext>
             </a:extLst>
           </p:cNvPr>
@@ -16506,7 +16506,7 @@
           <p:cNvPr id="17" name="">
             <a:extLst xmlns:a="http://schemas.openxmlformats.org/drawingml/2006/main">
               <a:ext uri="{FF2B5EF4-FFF2-40B4-BE49-F238E27FC236}">
-                <a16:creationId xmlns:a16="http://schemas.microsoft.com/office/drawing/2014/main" id="{D21E3FD9-4661-4BD3-B06A-9416F8C4979F}"/>
+                <a16:creationId xmlns:a16="http://schemas.microsoft.com/office/drawing/2014/main" id="{E568D2E9-4A18-4FAC-A687-25C530D5CF4A}"/>
               </a:ext>
             </a:extLst>
           </p:cNvPr>
@@ -16565,7 +16565,7 @@
           <p:cNvPr id="18" name="">
             <a:extLst xmlns:a="http://schemas.openxmlformats.org/drawingml/2006/main">
               <a:ext uri="{FF2B5EF4-FFF2-40B4-BE49-F238E27FC236}">
-                <a16:creationId xmlns:a16="http://schemas.microsoft.com/office/drawing/2014/main" id="{A8CFFBB8-5A9E-4DBF-BDA7-77D2AB642F1E}"/>
+                <a16:creationId xmlns:a16="http://schemas.microsoft.com/office/drawing/2014/main" id="{12EE83B8-148D-4AF2-96A6-9FFA20A2975A}"/>
               </a:ext>
             </a:extLst>
           </p:cNvPr>
@@ -16614,7 +16614,7 @@
                 <a:ea typeface="Aptos"/>
                 <a:cs typeface="Aptos"/>
               </a:rPr>
-              <a:t>Bundle typecheck, lint report, focused tests, and smoke checks.</a:t>
+              <a:t>Bundle typecheck, lint report, tests, and smoke checks.</a:t>
             </a:r>
           </a:p>
         </p:txBody>
@@ -16624,7 +16624,7 @@
           <p:cNvPr id="19" name="">
             <a:extLst xmlns:a="http://schemas.openxmlformats.org/drawingml/2006/main">
               <a:ext uri="{FF2B5EF4-FFF2-40B4-BE49-F238E27FC236}">
-                <a16:creationId xmlns:a16="http://schemas.microsoft.com/office/drawing/2014/main" id="{4479332C-B633-45FD-851D-7CFC1B6EEAFC}"/>
+                <a16:creationId xmlns:a16="http://schemas.microsoft.com/office/drawing/2014/main" id="{7BEEF06C-334F-4C9F-ABD3-74E984CC0784}"/>
               </a:ext>
             </a:extLst>
           </p:cNvPr>
@@ -16656,7 +16656,7 @@
           <p:cNvPr id="20" name="">
             <a:extLst xmlns:a="http://schemas.openxmlformats.org/drawingml/2006/main">
               <a:ext uri="{FF2B5EF4-FFF2-40B4-BE49-F238E27FC236}">
-                <a16:creationId xmlns:a16="http://schemas.microsoft.com/office/drawing/2014/main" id="{F65D452E-0D00-4C15-AD6E-EE0AFA8BF247}"/>
+                <a16:creationId xmlns:a16="http://schemas.microsoft.com/office/drawing/2014/main" id="{E41A6A36-CD53-4613-8384-3D751094CF35}"/>
               </a:ext>
             </a:extLst>
           </p:cNvPr>
@@ -16715,7 +16715,7 @@
           <p:cNvPr id="21" name="">
             <a:extLst xmlns:a="http://schemas.openxmlformats.org/drawingml/2006/main">
               <a:ext uri="{FF2B5EF4-FFF2-40B4-BE49-F238E27FC236}">
-                <a16:creationId xmlns:a16="http://schemas.microsoft.com/office/drawing/2014/main" id="{F06F81FB-A5EB-46CC-81B3-99497D8DE1CA}"/>
+                <a16:creationId xmlns:a16="http://schemas.microsoft.com/office/drawing/2014/main" id="{7642C7FA-C2E5-4B79-87DB-7991926B30BE}"/>
               </a:ext>
             </a:extLst>
           </p:cNvPr>
@@ -16774,7 +16774,7 @@
           <p:cNvPr id="22" name="">
             <a:extLst xmlns:a="http://schemas.openxmlformats.org/drawingml/2006/main">
               <a:ext uri="{FF2B5EF4-FFF2-40B4-BE49-F238E27FC236}">
-                <a16:creationId xmlns:a16="http://schemas.microsoft.com/office/drawing/2014/main" id="{17D70CE0-08D8-4A19-B38F-C8590CE040FC}"/>
+                <a16:creationId xmlns:a16="http://schemas.microsoft.com/office/drawing/2014/main" id="{05FE3691-062E-46AB-95FB-51F20E1BE9BE}"/>
               </a:ext>
             </a:extLst>
           </p:cNvPr>
@@ -16806,7 +16806,7 @@
           <p:cNvPr id="23" name="">
             <a:extLst xmlns:a="http://schemas.openxmlformats.org/drawingml/2006/main">
               <a:ext uri="{FF2B5EF4-FFF2-40B4-BE49-F238E27FC236}">
-                <a16:creationId xmlns:a16="http://schemas.microsoft.com/office/drawing/2014/main" id="{9E5F9C0A-C821-451B-938E-E1457C267B8A}"/>
+                <a16:creationId xmlns:a16="http://schemas.microsoft.com/office/drawing/2014/main" id="{9098F091-17C9-49A1-8260-5557A22DDC83}"/>
               </a:ext>
             </a:extLst>
           </p:cNvPr>
@@ -16865,7 +16865,7 @@
           <p:cNvPr id="24" name="">
             <a:extLst xmlns:a="http://schemas.openxmlformats.org/drawingml/2006/main">
               <a:ext uri="{FF2B5EF4-FFF2-40B4-BE49-F238E27FC236}">
-                <a16:creationId xmlns:a16="http://schemas.microsoft.com/office/drawing/2014/main" id="{E849BA8F-B2E8-4C91-9DB2-C26CBF4A9EAF}"/>
+                <a16:creationId xmlns:a16="http://schemas.microsoft.com/office/drawing/2014/main" id="{CF31BF2D-E1DA-4D12-BFA8-1C394364381F}"/>
               </a:ext>
             </a:extLst>
           </p:cNvPr>
@@ -16914,7 +16914,7 @@
                 <a:ea typeface="Aptos"/>
                 <a:cs typeface="Aptos"/>
               </a:rPr>
-              <a:t>Collect the review evidence a human needs before merging.</a:t>
+              <a:t>Collect review evidence before merging.</a:t>
             </a:r>
           </a:p>
         </p:txBody>
@@ -16922,7 +16922,7 @@
     </p:spTree>
     <p:extLst>
       <p:ext uri="{BB962C8B-B14F-4D97-AF65-F5344CB8AC3E}">
-        <p14:creationId xmlns:p14="http://schemas.microsoft.com/office/powerpoint/2010/main" val="206257756"/>
+        <p14:creationId xmlns:p14="http://schemas.microsoft.com/office/powerpoint/2010/main" val="1654347277"/>
       </p:ext>
     </p:extLst>
   </p:cSld>
@@ -16946,7 +16946,7 @@
           <p:cNvPr id="1" name="">
             <a:extLst xmlns:a="http://schemas.openxmlformats.org/drawingml/2006/main">
               <a:ext uri="{FF2B5EF4-FFF2-40B4-BE49-F238E27FC236}">
-                <a16:creationId xmlns:a16="http://schemas.microsoft.com/office/drawing/2014/main" id="{036BB2BA-3C42-44C1-96F7-C632A1838078}"/>
+                <a16:creationId xmlns:a16="http://schemas.microsoft.com/office/drawing/2014/main" id="{83AB1EC9-2650-49B6-B825-EBAC86E8AB1F}"/>
               </a:ext>
             </a:extLst>
           </p:cNvPr>
@@ -16976,7 +16976,7 @@
           <p:cNvPr id="2" name="">
             <a:extLst xmlns:a="http://schemas.openxmlformats.org/drawingml/2006/main">
               <a:ext uri="{FF2B5EF4-FFF2-40B4-BE49-F238E27FC236}">
-                <a16:creationId xmlns:a16="http://schemas.microsoft.com/office/drawing/2014/main" id="{A25EABF5-C752-4BF7-BEF6-73735C462E89}"/>
+                <a16:creationId xmlns:a16="http://schemas.microsoft.com/office/drawing/2014/main" id="{6CCFF7ED-7981-4F79-9EFC-D39121C7BC18}"/>
               </a:ext>
             </a:extLst>
           </p:cNvPr>
@@ -17006,7 +17006,7 @@
           <p:cNvPr id="3" name="">
             <a:extLst xmlns:a="http://schemas.openxmlformats.org/drawingml/2006/main">
               <a:ext uri="{FF2B5EF4-FFF2-40B4-BE49-F238E27FC236}">
-                <a16:creationId xmlns:a16="http://schemas.microsoft.com/office/drawing/2014/main" id="{B104B5B1-948E-4DB0-9459-C8387FE31CA3}"/>
+                <a16:creationId xmlns:a16="http://schemas.microsoft.com/office/drawing/2014/main" id="{31F7B3BD-A578-4E77-BF3F-FDFE0BD9673F}"/>
               </a:ext>
             </a:extLst>
           </p:cNvPr>
@@ -17065,7 +17065,7 @@
           <p:cNvPr id="4" name="">
             <a:extLst xmlns:a="http://schemas.openxmlformats.org/drawingml/2006/main">
               <a:ext uri="{FF2B5EF4-FFF2-40B4-BE49-F238E27FC236}">
-                <a16:creationId xmlns:a16="http://schemas.microsoft.com/office/drawing/2014/main" id="{EB739634-581C-4FBD-BF26-43D5B0D31E0B}"/>
+                <a16:creationId xmlns:a16="http://schemas.microsoft.com/office/drawing/2014/main" id="{B1C4EC2F-7520-4182-BB66-26E76E62C296}"/>
               </a:ext>
             </a:extLst>
           </p:cNvPr>
@@ -17124,7 +17124,7 @@
           <p:cNvPr id="5" name="">
             <a:extLst xmlns:a="http://schemas.openxmlformats.org/drawingml/2006/main">
               <a:ext uri="{FF2B5EF4-FFF2-40B4-BE49-F238E27FC236}">
-                <a16:creationId xmlns:a16="http://schemas.microsoft.com/office/drawing/2014/main" id="{90FEE328-BF61-46F3-B0FC-434842E85E71}"/>
+                <a16:creationId xmlns:a16="http://schemas.microsoft.com/office/drawing/2014/main" id="{BA20CC1F-5805-42C3-9B8F-48B0C53CC692}"/>
               </a:ext>
             </a:extLst>
           </p:cNvPr>
@@ -17183,7 +17183,7 @@
           <p:cNvPr id="6" name="">
             <a:extLst xmlns:a="http://schemas.openxmlformats.org/drawingml/2006/main">
               <a:ext uri="{FF2B5EF4-FFF2-40B4-BE49-F238E27FC236}">
-                <a16:creationId xmlns:a16="http://schemas.microsoft.com/office/drawing/2014/main" id="{0AAF5B2D-0B17-4A17-91D4-FA8222E775BF}"/>
+                <a16:creationId xmlns:a16="http://schemas.microsoft.com/office/drawing/2014/main" id="{DDFADEEB-D15D-4180-B81B-21AB51692335}"/>
               </a:ext>
             </a:extLst>
           </p:cNvPr>
@@ -17246,7 +17246,7 @@
           <p:nvPr/>
         </p:nvPicPr>
         <p:blipFill>
-          <a:blip xmlns:r="http://schemas.openxmlformats.org/officeDocument/2006/relationships" xmlns:a="http://schemas.openxmlformats.org/drawingml/2006/main" r:embed="R0e9c4ea2a4464a74"/>
+          <a:blip xmlns:r="http://schemas.openxmlformats.org/officeDocument/2006/relationships" xmlns:a="http://schemas.openxmlformats.org/drawingml/2006/main" r:embed="Rce55846775464057"/>
           <a:srcRect xmlns:a="http://schemas.openxmlformats.org/drawingml/2006/main" l="0" t="282" r="0" b="282"/>
           <a:stretch xmlns:a="http://schemas.openxmlformats.org/drawingml/2006/main">
             <a:fillRect l="0" t="0" r="0" b="0"/>
@@ -17267,7 +17267,7 @@
           <p:cNvPr id="8" name="">
             <a:extLst xmlns:a="http://schemas.openxmlformats.org/drawingml/2006/main">
               <a:ext uri="{FF2B5EF4-FFF2-40B4-BE49-F238E27FC236}">
-                <a16:creationId xmlns:a16="http://schemas.microsoft.com/office/drawing/2014/main" id="{161D769A-CD21-4CD6-9F70-373258B3D580}"/>
+                <a16:creationId xmlns:a16="http://schemas.microsoft.com/office/drawing/2014/main" id="{EDC95FBB-CCF7-4E67-8FC9-8C8617B22BB9}"/>
               </a:ext>
             </a:extLst>
           </p:cNvPr>
@@ -17299,7 +17299,7 @@
           <p:cNvPr id="9" name="">
             <a:extLst xmlns:a="http://schemas.openxmlformats.org/drawingml/2006/main">
               <a:ext uri="{FF2B5EF4-FFF2-40B4-BE49-F238E27FC236}">
-                <a16:creationId xmlns:a16="http://schemas.microsoft.com/office/drawing/2014/main" id="{06960963-8BCB-4318-A4B7-3D57C46B21A0}"/>
+                <a16:creationId xmlns:a16="http://schemas.microsoft.com/office/drawing/2014/main" id="{0E3B032D-62E6-49D1-B1D2-C1ED6D7C1523}"/>
               </a:ext>
             </a:extLst>
           </p:cNvPr>
@@ -17333,7 +17333,7 @@
           <p:cNvPr id="10" name="">
             <a:extLst xmlns:a="http://schemas.openxmlformats.org/drawingml/2006/main">
               <a:ext uri="{FF2B5EF4-FFF2-40B4-BE49-F238E27FC236}">
-                <a16:creationId xmlns:a16="http://schemas.microsoft.com/office/drawing/2014/main" id="{45FCE9E1-B0CC-4DFB-86A4-254D282DDE6B}"/>
+                <a16:creationId xmlns:a16="http://schemas.microsoft.com/office/drawing/2014/main" id="{518FBA20-B2B9-4F53-AC67-FE80436093EA}"/>
               </a:ext>
             </a:extLst>
           </p:cNvPr>
@@ -17363,7 +17363,7 @@
           <p:cNvPr id="11" name="">
             <a:extLst xmlns:a="http://schemas.openxmlformats.org/drawingml/2006/main">
               <a:ext uri="{FF2B5EF4-FFF2-40B4-BE49-F238E27FC236}">
-                <a16:creationId xmlns:a16="http://schemas.microsoft.com/office/drawing/2014/main" id="{B89D6F03-3DF1-448E-BCEF-D93EF06BCFA1}"/>
+                <a16:creationId xmlns:a16="http://schemas.microsoft.com/office/drawing/2014/main" id="{4A05070B-3BEE-499F-B427-33744843FDBA}"/>
               </a:ext>
             </a:extLst>
           </p:cNvPr>
@@ -17393,7 +17393,7 @@
           <p:cNvPr id="12" name="">
             <a:extLst xmlns:a="http://schemas.openxmlformats.org/drawingml/2006/main">
               <a:ext uri="{FF2B5EF4-FFF2-40B4-BE49-F238E27FC236}">
-                <a16:creationId xmlns:a16="http://schemas.microsoft.com/office/drawing/2014/main" id="{4109E2A3-B2C8-4957-9248-EAE333D5F72D}"/>
+                <a16:creationId xmlns:a16="http://schemas.microsoft.com/office/drawing/2014/main" id="{8D3B7A63-BA86-4A6C-8477-76B5E195FEB5}"/>
               </a:ext>
             </a:extLst>
           </p:cNvPr>
@@ -17452,7 +17452,7 @@
           <p:cNvPr id="13" name="">
             <a:extLst xmlns:a="http://schemas.openxmlformats.org/drawingml/2006/main">
               <a:ext uri="{FF2B5EF4-FFF2-40B4-BE49-F238E27FC236}">
-                <a16:creationId xmlns:a16="http://schemas.microsoft.com/office/drawing/2014/main" id="{2E061A36-7A01-4C47-A3D3-EAD660D50EF1}"/>
+                <a16:creationId xmlns:a16="http://schemas.microsoft.com/office/drawing/2014/main" id="{351E90EA-C1E8-4FA5-9271-E8D75F861F68}"/>
               </a:ext>
             </a:extLst>
           </p:cNvPr>
@@ -17484,7 +17484,7 @@
           <p:cNvPr id="14" name="">
             <a:extLst xmlns:a="http://schemas.openxmlformats.org/drawingml/2006/main">
               <a:ext uri="{FF2B5EF4-FFF2-40B4-BE49-F238E27FC236}">
-                <a16:creationId xmlns:a16="http://schemas.microsoft.com/office/drawing/2014/main" id="{47B9FF90-BF3C-4262-B79E-1A63D2365FD3}"/>
+                <a16:creationId xmlns:a16="http://schemas.microsoft.com/office/drawing/2014/main" id="{FEF69A1A-613E-42D1-835B-52DEE1B6DCB0}"/>
               </a:ext>
             </a:extLst>
           </p:cNvPr>
@@ -17514,7 +17514,7 @@
           <p:cNvPr id="15" name="">
             <a:extLst xmlns:a="http://schemas.openxmlformats.org/drawingml/2006/main">
               <a:ext uri="{FF2B5EF4-FFF2-40B4-BE49-F238E27FC236}">
-                <a16:creationId xmlns:a16="http://schemas.microsoft.com/office/drawing/2014/main" id="{F4E8B8A0-76AB-4BB6-8D28-29DB3D3C8912}"/>
+                <a16:creationId xmlns:a16="http://schemas.microsoft.com/office/drawing/2014/main" id="{F9044062-0853-4568-A490-DAA432646C54}"/>
               </a:ext>
             </a:extLst>
           </p:cNvPr>
@@ -17573,7 +17573,7 @@
           <p:cNvPr id="16" name="">
             <a:extLst xmlns:a="http://schemas.openxmlformats.org/drawingml/2006/main">
               <a:ext uri="{FF2B5EF4-FFF2-40B4-BE49-F238E27FC236}">
-                <a16:creationId xmlns:a16="http://schemas.microsoft.com/office/drawing/2014/main" id="{43EA647A-BEAA-4B12-8DC8-50A727D939AE}"/>
+                <a16:creationId xmlns:a16="http://schemas.microsoft.com/office/drawing/2014/main" id="{88BD42B3-087D-4A3E-AF90-D1D934818D59}"/>
               </a:ext>
             </a:extLst>
           </p:cNvPr>
@@ -17585,7 +17585,7 @@
         <p:spPr>
           <a:xfrm xmlns:a="http://schemas.openxmlformats.org/drawingml/2006/main">
             <a:off x="914400" y="3568541"/>
-            <a:ext cx="1638300" cy="470059"/>
+            <a:ext cx="1638300" cy="355759"/>
           </a:xfrm>
           <a:prstGeom xmlns:a="http://schemas.openxmlformats.org/drawingml/2006/main" prst="rect">
             <a:avLst/>
@@ -17604,7 +17604,7 @@
           <a:lstStyle xmlns:a="http://schemas.openxmlformats.org/drawingml/2006/main"/>
           <a:p xmlns:a="http://schemas.openxmlformats.org/drawingml/2006/main">
             <a:pPr algn="l">
-              <a:defRPr sz="1050" b="0">
+              <a:defRPr sz="1028" b="0">
                 <a:solidFill>
                   <a:srgbClr val="526179"/>
                 </a:solidFill>
@@ -17614,7 +17614,7 @@
               </a:defRPr>
             </a:pPr>
             <a:r>
-              <a:rPr sz="1050" b="0">
+              <a:rPr sz="1028" b="0">
                 <a:solidFill>
                   <a:srgbClr val="526179"/>
                 </a:solidFill>
@@ -17632,7 +17632,7 @@
           <p:cNvPr id="17" name="">
             <a:extLst xmlns:a="http://schemas.openxmlformats.org/drawingml/2006/main">
               <a:ext uri="{FF2B5EF4-FFF2-40B4-BE49-F238E27FC236}">
-                <a16:creationId xmlns:a16="http://schemas.microsoft.com/office/drawing/2014/main" id="{EC542279-846D-4A3E-A941-CF42C0EF6E2A}"/>
+                <a16:creationId xmlns:a16="http://schemas.microsoft.com/office/drawing/2014/main" id="{C4113A1C-A98A-4519-A1E3-E580412DD8CD}"/>
               </a:ext>
             </a:extLst>
           </p:cNvPr>
@@ -17664,7 +17664,7 @@
           <p:cNvPr id="18" name="">
             <a:extLst xmlns:a="http://schemas.openxmlformats.org/drawingml/2006/main">
               <a:ext uri="{FF2B5EF4-FFF2-40B4-BE49-F238E27FC236}">
-                <a16:creationId xmlns:a16="http://schemas.microsoft.com/office/drawing/2014/main" id="{6E68BA61-B0EB-4BC8-A351-4871E531E106}"/>
+                <a16:creationId xmlns:a16="http://schemas.microsoft.com/office/drawing/2014/main" id="{04DF91F4-6D65-45FB-B106-F2054FF87431}"/>
               </a:ext>
             </a:extLst>
           </p:cNvPr>
@@ -17694,7 +17694,7 @@
           <p:cNvPr id="19" name="">
             <a:extLst xmlns:a="http://schemas.openxmlformats.org/drawingml/2006/main">
               <a:ext uri="{FF2B5EF4-FFF2-40B4-BE49-F238E27FC236}">
-                <a16:creationId xmlns:a16="http://schemas.microsoft.com/office/drawing/2014/main" id="{6EF03AE1-3B94-4CD7-9D3B-0DD258CF9FD2}"/>
+                <a16:creationId xmlns:a16="http://schemas.microsoft.com/office/drawing/2014/main" id="{5FF6187C-7C02-4AE2-B76D-012897CDD92D}"/>
               </a:ext>
             </a:extLst>
           </p:cNvPr>
@@ -17753,7 +17753,7 @@
           <p:cNvPr id="20" name="">
             <a:extLst xmlns:a="http://schemas.openxmlformats.org/drawingml/2006/main">
               <a:ext uri="{FF2B5EF4-FFF2-40B4-BE49-F238E27FC236}">
-                <a16:creationId xmlns:a16="http://schemas.microsoft.com/office/drawing/2014/main" id="{87C44051-4DE3-4DC5-9014-ABF93871BFE1}"/>
+                <a16:creationId xmlns:a16="http://schemas.microsoft.com/office/drawing/2014/main" id="{ADF9A8D3-BBFB-4C0C-9DBD-5657F20973F1}"/>
               </a:ext>
             </a:extLst>
           </p:cNvPr>
@@ -17765,7 +17765,7 @@
         <p:spPr>
           <a:xfrm xmlns:a="http://schemas.openxmlformats.org/drawingml/2006/main">
             <a:off x="3295650" y="3568541"/>
-            <a:ext cx="1638300" cy="470059"/>
+            <a:ext cx="1638300" cy="355759"/>
           </a:xfrm>
           <a:prstGeom xmlns:a="http://schemas.openxmlformats.org/drawingml/2006/main" prst="rect">
             <a:avLst/>
@@ -17784,7 +17784,7 @@
           <a:lstStyle xmlns:a="http://schemas.openxmlformats.org/drawingml/2006/main"/>
           <a:p xmlns:a="http://schemas.openxmlformats.org/drawingml/2006/main">
             <a:pPr algn="l">
-              <a:defRPr sz="1050" b="0">
+              <a:defRPr sz="1028" b="0">
                 <a:solidFill>
                   <a:srgbClr val="526179"/>
                 </a:solidFill>
@@ -17794,7 +17794,7 @@
               </a:defRPr>
             </a:pPr>
             <a:r>
-              <a:rPr sz="1050" b="0">
+              <a:rPr sz="1028" b="0">
                 <a:solidFill>
                   <a:srgbClr val="526179"/>
                 </a:solidFill>
@@ -17802,7 +17802,7 @@
                 <a:ea typeface="Aptos"/>
                 <a:cs typeface="Aptos"/>
               </a:rPr>
-              <a:t>Returns warnings so Copilot can fix obvious issues without stopping the whole session.</a:t>
+              <a:t>Returns warnings so Copilot can fix obvious issues without stopping.</a:t>
             </a:r>
           </a:p>
         </p:txBody>
@@ -17812,7 +17812,7 @@
           <p:cNvPr id="21" name="">
             <a:extLst xmlns:a="http://schemas.openxmlformats.org/drawingml/2006/main">
               <a:ext uri="{FF2B5EF4-FFF2-40B4-BE49-F238E27FC236}">
-                <a16:creationId xmlns:a16="http://schemas.microsoft.com/office/drawing/2014/main" id="{3A29FE6F-C2FC-4702-B26C-121705DAD6EA}"/>
+                <a16:creationId xmlns:a16="http://schemas.microsoft.com/office/drawing/2014/main" id="{17132F90-45B1-4A29-96E2-077E629E5D99}"/>
               </a:ext>
             </a:extLst>
           </p:cNvPr>
@@ -17844,7 +17844,7 @@
           <p:cNvPr id="22" name="">
             <a:extLst xmlns:a="http://schemas.openxmlformats.org/drawingml/2006/main">
               <a:ext uri="{FF2B5EF4-FFF2-40B4-BE49-F238E27FC236}">
-                <a16:creationId xmlns:a16="http://schemas.microsoft.com/office/drawing/2014/main" id="{E4086F22-0F22-4EED-8766-11CB4031E126}"/>
+                <a16:creationId xmlns:a16="http://schemas.microsoft.com/office/drawing/2014/main" id="{B158C943-FC09-44F9-BDBC-2E5D0B95B887}"/>
               </a:ext>
             </a:extLst>
           </p:cNvPr>
@@ -17903,7 +17903,7 @@
           <p:cNvPr id="23" name="">
             <a:extLst xmlns:a="http://schemas.openxmlformats.org/drawingml/2006/main">
               <a:ext uri="{FF2B5EF4-FFF2-40B4-BE49-F238E27FC236}">
-                <a16:creationId xmlns:a16="http://schemas.microsoft.com/office/drawing/2014/main" id="{5F0F99FE-ADAE-4670-924C-5C48ABF7816C}"/>
+                <a16:creationId xmlns:a16="http://schemas.microsoft.com/office/drawing/2014/main" id="{46C4CD4D-4DD4-4B6A-80AA-ACBE2DB21143}"/>
               </a:ext>
             </a:extLst>
           </p:cNvPr>
@@ -17935,7 +17935,7 @@
           <p:cNvPr id="24" name="">
             <a:extLst xmlns:a="http://schemas.openxmlformats.org/drawingml/2006/main">
               <a:ext uri="{FF2B5EF4-FFF2-40B4-BE49-F238E27FC236}">
-                <a16:creationId xmlns:a16="http://schemas.microsoft.com/office/drawing/2014/main" id="{8B5499D5-FCB2-4EE5-9829-874E43C4DE91}"/>
+                <a16:creationId xmlns:a16="http://schemas.microsoft.com/office/drawing/2014/main" id="{08E336D8-FB86-4163-95ED-E4B05ACE6B60}"/>
               </a:ext>
             </a:extLst>
           </p:cNvPr>
@@ -17994,7 +17994,7 @@
           <p:cNvPr id="25" name="">
             <a:extLst xmlns:a="http://schemas.openxmlformats.org/drawingml/2006/main">
               <a:ext uri="{FF2B5EF4-FFF2-40B4-BE49-F238E27FC236}">
-                <a16:creationId xmlns:a16="http://schemas.microsoft.com/office/drawing/2014/main" id="{2FEE4BC8-54CB-429C-8D2F-0BA36AA52B09}"/>
+                <a16:creationId xmlns:a16="http://schemas.microsoft.com/office/drawing/2014/main" id="{119D75E7-2169-4713-88CE-B28596E00E36}"/>
               </a:ext>
             </a:extLst>
           </p:cNvPr>
@@ -18026,7 +18026,7 @@
           <p:cNvPr id="26" name="">
             <a:extLst xmlns:a="http://schemas.openxmlformats.org/drawingml/2006/main">
               <a:ext uri="{FF2B5EF4-FFF2-40B4-BE49-F238E27FC236}">
-                <a16:creationId xmlns:a16="http://schemas.microsoft.com/office/drawing/2014/main" id="{2117A92E-59EF-4A1E-A8E6-FA12F35FACBF}"/>
+                <a16:creationId xmlns:a16="http://schemas.microsoft.com/office/drawing/2014/main" id="{7034C1F0-FF29-4516-9C8E-31DF5FE41BAE}"/>
               </a:ext>
             </a:extLst>
           </p:cNvPr>
@@ -18085,7 +18085,7 @@
           <p:cNvPr id="27" name="">
             <a:extLst xmlns:a="http://schemas.openxmlformats.org/drawingml/2006/main">
               <a:ext uri="{FF2B5EF4-FFF2-40B4-BE49-F238E27FC236}">
-                <a16:creationId xmlns:a16="http://schemas.microsoft.com/office/drawing/2014/main" id="{4103AF8A-E078-4A4D-82D0-41921C5FC5F0}"/>
+                <a16:creationId xmlns:a16="http://schemas.microsoft.com/office/drawing/2014/main" id="{42D511CB-514B-4547-B1E1-1DFD4395CE01}"/>
               </a:ext>
             </a:extLst>
           </p:cNvPr>
@@ -18117,7 +18117,7 @@
           <p:cNvPr id="28" name="">
             <a:extLst xmlns:a="http://schemas.openxmlformats.org/drawingml/2006/main">
               <a:ext uri="{FF2B5EF4-FFF2-40B4-BE49-F238E27FC236}">
-                <a16:creationId xmlns:a16="http://schemas.microsoft.com/office/drawing/2014/main" id="{B61AFCB3-1600-4AB0-B192-636F08CEBEAD}"/>
+                <a16:creationId xmlns:a16="http://schemas.microsoft.com/office/drawing/2014/main" id="{B5875E74-284F-4474-9E2F-253AFC370D15}"/>
               </a:ext>
             </a:extLst>
           </p:cNvPr>
@@ -18176,7 +18176,7 @@
           <p:cNvPr id="29" name="">
             <a:extLst xmlns:a="http://schemas.openxmlformats.org/drawingml/2006/main">
               <a:ext uri="{FF2B5EF4-FFF2-40B4-BE49-F238E27FC236}">
-                <a16:creationId xmlns:a16="http://schemas.microsoft.com/office/drawing/2014/main" id="{FFC5C72F-E54E-49D6-A092-6C4551ED5BA4}"/>
+                <a16:creationId xmlns:a16="http://schemas.microsoft.com/office/drawing/2014/main" id="{BCC6B335-90E0-4919-9AA3-F764C26FD204}"/>
               </a:ext>
             </a:extLst>
           </p:cNvPr>
@@ -18208,7 +18208,7 @@
           <p:cNvPr id="30" name="">
             <a:extLst xmlns:a="http://schemas.openxmlformats.org/drawingml/2006/main">
               <a:ext uri="{FF2B5EF4-FFF2-40B4-BE49-F238E27FC236}">
-                <a16:creationId xmlns:a16="http://schemas.microsoft.com/office/drawing/2014/main" id="{DEB7F732-F269-4C58-BFF9-6E0919F0FE51}"/>
+                <a16:creationId xmlns:a16="http://schemas.microsoft.com/office/drawing/2014/main" id="{03D4B967-0A65-4F9F-9E7D-753BE9432658}"/>
               </a:ext>
             </a:extLst>
           </p:cNvPr>
@@ -18267,7 +18267,7 @@
           <p:cNvPr id="31" name="">
             <a:extLst xmlns:a="http://schemas.openxmlformats.org/drawingml/2006/main">
               <a:ext uri="{FF2B5EF4-FFF2-40B4-BE49-F238E27FC236}">
-                <a16:creationId xmlns:a16="http://schemas.microsoft.com/office/drawing/2014/main" id="{09F72E51-AF0C-472F-A4B6-3495407A0388}"/>
+                <a16:creationId xmlns:a16="http://schemas.microsoft.com/office/drawing/2014/main" id="{058661E8-978F-42E5-AC50-D693FDFD5030}"/>
               </a:ext>
             </a:extLst>
           </p:cNvPr>
@@ -18299,7 +18299,7 @@
           <p:cNvPr id="32" name="">
             <a:extLst xmlns:a="http://schemas.openxmlformats.org/drawingml/2006/main">
               <a:ext uri="{FF2B5EF4-FFF2-40B4-BE49-F238E27FC236}">
-                <a16:creationId xmlns:a16="http://schemas.microsoft.com/office/drawing/2014/main" id="{430701B5-7D08-481C-B06E-15279C98DCDB}"/>
+                <a16:creationId xmlns:a16="http://schemas.microsoft.com/office/drawing/2014/main" id="{A6698B56-FBF9-4509-A172-B8D6B6F7FE9A}"/>
               </a:ext>
             </a:extLst>
           </p:cNvPr>
@@ -18356,7 +18356,7 @@
     </p:spTree>
     <p:extLst>
       <p:ext uri="{BB962C8B-B14F-4D97-AF65-F5344CB8AC3E}">
-        <p14:creationId xmlns:p14="http://schemas.microsoft.com/office/powerpoint/2010/main" val="2079611919"/>
+        <p14:creationId xmlns:p14="http://schemas.microsoft.com/office/powerpoint/2010/main" val="1151860221"/>
       </p:ext>
     </p:extLst>
   </p:cSld>

</xml_diff>

<commit_message>
Fix slide 11 card padding
</commit_message>
<xml_diff>
--- a/presentations/102/deck/102-agent-harnesses.pptx
+++ b/presentations/102/deck/102-agent-harnesses.pptx
@@ -2,25 +2,25 @@
 <file path=ppt/presentation.xml><?xml version="1.0" encoding="utf-8"?>
 <p:presentation xmlns:p="http://schemas.openxmlformats.org/presentationml/2006/main">
   <p:sldMasterIdLst>
-    <p:sldMasterId xmlns:r="http://schemas.openxmlformats.org/officeDocument/2006/relationships" id="2147483648" r:id="R5b72697af73149f2"/>
+    <p:sldMasterId xmlns:r="http://schemas.openxmlformats.org/officeDocument/2006/relationships" id="2147483648" r:id="R4626a4c0bef14402"/>
   </p:sldMasterIdLst>
   <p:notesMasterIdLst>
-    <p:notesMasterId xmlns:r="http://schemas.openxmlformats.org/officeDocument/2006/relationships" r:id="Rbb83dfaec97b40f4"/>
+    <p:notesMasterId xmlns:r="http://schemas.openxmlformats.org/officeDocument/2006/relationships" r:id="R4544162a404747a7"/>
   </p:notesMasterIdLst>
   <p:sldIdLst>
-    <p:sldId xmlns:r="http://schemas.openxmlformats.org/officeDocument/2006/relationships" id="256" r:id="R2df93340bec14a1c"/>
-    <p:sldId xmlns:r="http://schemas.openxmlformats.org/officeDocument/2006/relationships" id="257" r:id="Raaefcf21252f4787"/>
-    <p:sldId xmlns:r="http://schemas.openxmlformats.org/officeDocument/2006/relationships" id="258" r:id="R4d21f001e70c4922"/>
-    <p:sldId xmlns:r="http://schemas.openxmlformats.org/officeDocument/2006/relationships" id="259" r:id="R0508566a458d4e94"/>
-    <p:sldId xmlns:r="http://schemas.openxmlformats.org/officeDocument/2006/relationships" id="260" r:id="Rca5f3e383f174e67"/>
-    <p:sldId xmlns:r="http://schemas.openxmlformats.org/officeDocument/2006/relationships" id="261" r:id="R44630132503143f5"/>
-    <p:sldId xmlns:r="http://schemas.openxmlformats.org/officeDocument/2006/relationships" id="262" r:id="R10dfbb18997e4b60"/>
-    <p:sldId xmlns:r="http://schemas.openxmlformats.org/officeDocument/2006/relationships" id="263" r:id="R7521f5715f474167"/>
-    <p:sldId xmlns:r="http://schemas.openxmlformats.org/officeDocument/2006/relationships" id="264" r:id="R27219817188d4589"/>
-    <p:sldId xmlns:r="http://schemas.openxmlformats.org/officeDocument/2006/relationships" id="265" r:id="R701a0a9ee44f451e"/>
-    <p:sldId xmlns:r="http://schemas.openxmlformats.org/officeDocument/2006/relationships" id="266" r:id="R1fd7a082d49a47b4"/>
-    <p:sldId xmlns:r="http://schemas.openxmlformats.org/officeDocument/2006/relationships" id="267" r:id="R6d1de94901464749"/>
-    <p:sldId xmlns:r="http://schemas.openxmlformats.org/officeDocument/2006/relationships" id="268" r:id="R0e62b67f279342a1"/>
+    <p:sldId xmlns:r="http://schemas.openxmlformats.org/officeDocument/2006/relationships" id="256" r:id="R29872f8832a549e2"/>
+    <p:sldId xmlns:r="http://schemas.openxmlformats.org/officeDocument/2006/relationships" id="257" r:id="Ra7f817b382ed4ddf"/>
+    <p:sldId xmlns:r="http://schemas.openxmlformats.org/officeDocument/2006/relationships" id="258" r:id="R122cf32d471049a8"/>
+    <p:sldId xmlns:r="http://schemas.openxmlformats.org/officeDocument/2006/relationships" id="259" r:id="R09fd44a669af49ca"/>
+    <p:sldId xmlns:r="http://schemas.openxmlformats.org/officeDocument/2006/relationships" id="260" r:id="Ra1419d12ac9340d0"/>
+    <p:sldId xmlns:r="http://schemas.openxmlformats.org/officeDocument/2006/relationships" id="261" r:id="R7fc85afe356a49dd"/>
+    <p:sldId xmlns:r="http://schemas.openxmlformats.org/officeDocument/2006/relationships" id="262" r:id="R2bfcf1f741154c97"/>
+    <p:sldId xmlns:r="http://schemas.openxmlformats.org/officeDocument/2006/relationships" id="263" r:id="R90c8ecd3cfe14804"/>
+    <p:sldId xmlns:r="http://schemas.openxmlformats.org/officeDocument/2006/relationships" id="264" r:id="R77abfd4b0d524c0e"/>
+    <p:sldId xmlns:r="http://schemas.openxmlformats.org/officeDocument/2006/relationships" id="265" r:id="Rd8b5956ac2af4c61"/>
+    <p:sldId xmlns:r="http://schemas.openxmlformats.org/officeDocument/2006/relationships" id="266" r:id="Rd76c1f4737cd42c8"/>
+    <p:sldId xmlns:r="http://schemas.openxmlformats.org/officeDocument/2006/relationships" id="267" r:id="R88f8ce7c3b094336"/>
+    <p:sldId xmlns:r="http://schemas.openxmlformats.org/officeDocument/2006/relationships" id="268" r:id="Re75ac1914cf5434e"/>
   </p:sldIdLst>
   <p:sldSz cx="12192000" cy="6858000"/>
   <p:notesSz cx="6858000" cy="9144000"/>
@@ -1359,7 +1359,7 @@
   </p:cSld>
   <p:clrMap bg1="lt1" tx1="dk1" bg2="lt2" tx2="dk2" accent1="accent1" accent2="accent2" accent3="accent3" accent4="accent4" accent5="accent5" accent6="accent6" hlink="hlink" folHlink="folHlink"/>
   <p:sldLayoutIdLst>
-    <p:sldLayoutId xmlns:r="http://schemas.openxmlformats.org/officeDocument/2006/relationships" id="2147483649" r:id="Rc64afb9ed6b4421c"/>
+    <p:sldLayoutId xmlns:r="http://schemas.openxmlformats.org/officeDocument/2006/relationships" id="2147483649" r:id="Rb4f6d304ffab40d5"/>
   </p:sldLayoutIdLst>
   <p:txStyles>
     <p:titleStyle>
@@ -1662,7 +1662,7 @@
           <p:nvPr/>
         </p:nvPicPr>
         <p:blipFill>
-          <a:blip xmlns:r="http://schemas.openxmlformats.org/officeDocument/2006/relationships" xmlns:a="http://schemas.openxmlformats.org/drawingml/2006/main" r:embed="R6a04bd021bac4df6"/>
+          <a:blip xmlns:r="http://schemas.openxmlformats.org/officeDocument/2006/relationships" xmlns:a="http://schemas.openxmlformats.org/drawingml/2006/main" r:embed="R22178fc7648440fd"/>
           <a:srcRect xmlns:a="http://schemas.openxmlformats.org/drawingml/2006/main" l="1515" t="0" r="1515" b="0"/>
           <a:stretch xmlns:a="http://schemas.openxmlformats.org/drawingml/2006/main">
             <a:fillRect l="0" t="0" r="0" b="0"/>
@@ -1683,7 +1683,7 @@
           <p:cNvPr id="2" name="">
             <a:extLst xmlns:a="http://schemas.openxmlformats.org/drawingml/2006/main">
               <a:ext uri="{FF2B5EF4-FFF2-40B4-BE49-F238E27FC236}">
-                <a16:creationId xmlns:a16="http://schemas.microsoft.com/office/drawing/2014/main" id="{D3DF54C6-3C97-491A-9405-EAB2289FC582}"/>
+                <a16:creationId xmlns:a16="http://schemas.microsoft.com/office/drawing/2014/main" id="{D16B0BD1-02F9-4AC3-9432-5E21C928FCD9}"/>
               </a:ext>
             </a:extLst>
           </p:cNvPr>
@@ -1715,7 +1715,7 @@
           <p:cNvPr id="3" name="">
             <a:extLst xmlns:a="http://schemas.openxmlformats.org/drawingml/2006/main">
               <a:ext uri="{FF2B5EF4-FFF2-40B4-BE49-F238E27FC236}">
-                <a16:creationId xmlns:a16="http://schemas.microsoft.com/office/drawing/2014/main" id="{8C4399DB-5F46-4AC6-BFC0-390910063908}"/>
+                <a16:creationId xmlns:a16="http://schemas.microsoft.com/office/drawing/2014/main" id="{919AC386-35BC-4137-801D-7981503E00B5}"/>
               </a:ext>
             </a:extLst>
           </p:cNvPr>
@@ -1749,7 +1749,7 @@
           <p:cNvPr id="4" name="">
             <a:extLst xmlns:a="http://schemas.openxmlformats.org/drawingml/2006/main">
               <a:ext uri="{FF2B5EF4-FFF2-40B4-BE49-F238E27FC236}">
-                <a16:creationId xmlns:a16="http://schemas.microsoft.com/office/drawing/2014/main" id="{BB678A96-EBF4-46BD-B65C-38EBDBA0ED35}"/>
+                <a16:creationId xmlns:a16="http://schemas.microsoft.com/office/drawing/2014/main" id="{BA90E69F-CF1C-4651-A034-F23E9FE08BB9}"/>
               </a:ext>
             </a:extLst>
           </p:cNvPr>
@@ -1779,7 +1779,7 @@
           <p:cNvPr id="5" name="">
             <a:extLst xmlns:a="http://schemas.openxmlformats.org/drawingml/2006/main">
               <a:ext uri="{FF2B5EF4-FFF2-40B4-BE49-F238E27FC236}">
-                <a16:creationId xmlns:a16="http://schemas.microsoft.com/office/drawing/2014/main" id="{F3CBE953-B345-44DA-9F01-12F7BAEEC306}"/>
+                <a16:creationId xmlns:a16="http://schemas.microsoft.com/office/drawing/2014/main" id="{F8687BA2-9978-4F86-9FEC-DD49F561EEB8}"/>
               </a:ext>
             </a:extLst>
           </p:cNvPr>
@@ -1811,7 +1811,7 @@
           <p:cNvPr id="6" name="">
             <a:extLst xmlns:a="http://schemas.openxmlformats.org/drawingml/2006/main">
               <a:ext uri="{FF2B5EF4-FFF2-40B4-BE49-F238E27FC236}">
-                <a16:creationId xmlns:a16="http://schemas.microsoft.com/office/drawing/2014/main" id="{15475C81-F0DE-4436-9854-A197FDD0BD14}"/>
+                <a16:creationId xmlns:a16="http://schemas.microsoft.com/office/drawing/2014/main" id="{038E17A9-A2CA-470A-A622-50F140F3B74E}"/>
               </a:ext>
             </a:extLst>
           </p:cNvPr>
@@ -1841,7 +1841,7 @@
           <p:cNvPr id="7" name="">
             <a:extLst xmlns:a="http://schemas.openxmlformats.org/drawingml/2006/main">
               <a:ext uri="{FF2B5EF4-FFF2-40B4-BE49-F238E27FC236}">
-                <a16:creationId xmlns:a16="http://schemas.microsoft.com/office/drawing/2014/main" id="{99B7DDF9-9D1B-4733-ADC3-525F0E72C33B}"/>
+                <a16:creationId xmlns:a16="http://schemas.microsoft.com/office/drawing/2014/main" id="{A2D771C8-4A33-468A-9437-F19465711CB6}"/>
               </a:ext>
             </a:extLst>
           </p:cNvPr>
@@ -1900,7 +1900,7 @@
           <p:cNvPr id="8" name="">
             <a:extLst xmlns:a="http://schemas.openxmlformats.org/drawingml/2006/main">
               <a:ext uri="{FF2B5EF4-FFF2-40B4-BE49-F238E27FC236}">
-                <a16:creationId xmlns:a16="http://schemas.microsoft.com/office/drawing/2014/main" id="{4067A2AC-A4D9-4D3E-BD43-BFB2BFA6A3D8}"/>
+                <a16:creationId xmlns:a16="http://schemas.microsoft.com/office/drawing/2014/main" id="{9EFD1E1F-6DD0-46E5-A0ED-B56279DB2C52}"/>
               </a:ext>
             </a:extLst>
           </p:cNvPr>
@@ -1959,7 +1959,7 @@
           <p:cNvPr id="9" name="">
             <a:extLst xmlns:a="http://schemas.openxmlformats.org/drawingml/2006/main">
               <a:ext uri="{FF2B5EF4-FFF2-40B4-BE49-F238E27FC236}">
-                <a16:creationId xmlns:a16="http://schemas.microsoft.com/office/drawing/2014/main" id="{65770A46-F5C6-40B2-8A15-299184185C53}"/>
+                <a16:creationId xmlns:a16="http://schemas.microsoft.com/office/drawing/2014/main" id="{9EE7660D-5ECC-4031-912F-CBBF1CB19ED4}"/>
               </a:ext>
             </a:extLst>
           </p:cNvPr>
@@ -2018,7 +2018,7 @@
           <p:cNvPr id="10" name="">
             <a:extLst xmlns:a="http://schemas.openxmlformats.org/drawingml/2006/main">
               <a:ext uri="{FF2B5EF4-FFF2-40B4-BE49-F238E27FC236}">
-                <a16:creationId xmlns:a16="http://schemas.microsoft.com/office/drawing/2014/main" id="{519FA876-9F51-4672-B590-4A9C4BAFA801}"/>
+                <a16:creationId xmlns:a16="http://schemas.microsoft.com/office/drawing/2014/main" id="{FBEA8554-A171-473F-836A-14B1FE14B19A}"/>
               </a:ext>
             </a:extLst>
           </p:cNvPr>
@@ -2050,7 +2050,7 @@
           <p:cNvPr id="11" name="">
             <a:extLst xmlns:a="http://schemas.openxmlformats.org/drawingml/2006/main">
               <a:ext uri="{FF2B5EF4-FFF2-40B4-BE49-F238E27FC236}">
-                <a16:creationId xmlns:a16="http://schemas.microsoft.com/office/drawing/2014/main" id="{E0FA484D-2400-4A93-89EC-006AE7A3CA4C}"/>
+                <a16:creationId xmlns:a16="http://schemas.microsoft.com/office/drawing/2014/main" id="{71C3CB52-A6A3-403F-8C45-B068039C3220}"/>
               </a:ext>
             </a:extLst>
           </p:cNvPr>
@@ -2109,7 +2109,7 @@
           <p:cNvPr id="12" name="">
             <a:extLst xmlns:a="http://schemas.openxmlformats.org/drawingml/2006/main">
               <a:ext uri="{FF2B5EF4-FFF2-40B4-BE49-F238E27FC236}">
-                <a16:creationId xmlns:a16="http://schemas.microsoft.com/office/drawing/2014/main" id="{CA233672-7BA1-44AD-AB1F-42E0F857C2F4}"/>
+                <a16:creationId xmlns:a16="http://schemas.microsoft.com/office/drawing/2014/main" id="{17A80613-12C5-447F-A49F-14B90F9F4A22}"/>
               </a:ext>
             </a:extLst>
           </p:cNvPr>
@@ -2141,7 +2141,7 @@
           <p:cNvPr id="13" name="">
             <a:extLst xmlns:a="http://schemas.openxmlformats.org/drawingml/2006/main">
               <a:ext uri="{FF2B5EF4-FFF2-40B4-BE49-F238E27FC236}">
-                <a16:creationId xmlns:a16="http://schemas.microsoft.com/office/drawing/2014/main" id="{50D18D25-5E76-4914-B56A-F6AA8102CB8A}"/>
+                <a16:creationId xmlns:a16="http://schemas.microsoft.com/office/drawing/2014/main" id="{8C014111-9BF0-40F2-AC18-0A853E0B2740}"/>
               </a:ext>
             </a:extLst>
           </p:cNvPr>
@@ -2200,7 +2200,7 @@
           <p:cNvPr id="14" name="">
             <a:extLst xmlns:a="http://schemas.openxmlformats.org/drawingml/2006/main">
               <a:ext uri="{FF2B5EF4-FFF2-40B4-BE49-F238E27FC236}">
-                <a16:creationId xmlns:a16="http://schemas.microsoft.com/office/drawing/2014/main" id="{A8729CD5-C5B4-453A-9DA8-5C493070107C}"/>
+                <a16:creationId xmlns:a16="http://schemas.microsoft.com/office/drawing/2014/main" id="{247C388A-7023-46FE-B653-F9421476E91D}"/>
               </a:ext>
             </a:extLst>
           </p:cNvPr>
@@ -2232,7 +2232,7 @@
           <p:cNvPr id="15" name="">
             <a:extLst xmlns:a="http://schemas.openxmlformats.org/drawingml/2006/main">
               <a:ext uri="{FF2B5EF4-FFF2-40B4-BE49-F238E27FC236}">
-                <a16:creationId xmlns:a16="http://schemas.microsoft.com/office/drawing/2014/main" id="{07294463-A7FE-4C75-BD49-9EA7BB19F693}"/>
+                <a16:creationId xmlns:a16="http://schemas.microsoft.com/office/drawing/2014/main" id="{FC9E8FB8-522B-40C0-8DD6-77FE31320853}"/>
               </a:ext>
             </a:extLst>
           </p:cNvPr>
@@ -2291,7 +2291,7 @@
           <p:cNvPr id="16" name="">
             <a:extLst xmlns:a="http://schemas.openxmlformats.org/drawingml/2006/main">
               <a:ext uri="{FF2B5EF4-FFF2-40B4-BE49-F238E27FC236}">
-                <a16:creationId xmlns:a16="http://schemas.microsoft.com/office/drawing/2014/main" id="{37425FD6-45E6-41B1-B457-88E2D48E55FC}"/>
+                <a16:creationId xmlns:a16="http://schemas.microsoft.com/office/drawing/2014/main" id="{FF3F7311-3421-4ACC-936C-C8436063D8AE}"/>
               </a:ext>
             </a:extLst>
           </p:cNvPr>
@@ -2323,7 +2323,7 @@
           <p:cNvPr id="17" name="">
             <a:extLst xmlns:a="http://schemas.openxmlformats.org/drawingml/2006/main">
               <a:ext uri="{FF2B5EF4-FFF2-40B4-BE49-F238E27FC236}">
-                <a16:creationId xmlns:a16="http://schemas.microsoft.com/office/drawing/2014/main" id="{052E6703-91F2-453A-8A53-9F75487F86E7}"/>
+                <a16:creationId xmlns:a16="http://schemas.microsoft.com/office/drawing/2014/main" id="{9A74CABB-CDD3-4030-AF29-435F9116E441}"/>
               </a:ext>
             </a:extLst>
           </p:cNvPr>
@@ -2382,7 +2382,7 @@
           <p:cNvPr id="18" name="">
             <a:extLst xmlns:a="http://schemas.openxmlformats.org/drawingml/2006/main">
               <a:ext uri="{FF2B5EF4-FFF2-40B4-BE49-F238E27FC236}">
-                <a16:creationId xmlns:a16="http://schemas.microsoft.com/office/drawing/2014/main" id="{2AA6D311-549A-431F-B010-96790383599D}"/>
+                <a16:creationId xmlns:a16="http://schemas.microsoft.com/office/drawing/2014/main" id="{A424B93E-6860-435A-9FDF-AD6494982BA4}"/>
               </a:ext>
             </a:extLst>
           </p:cNvPr>
@@ -2441,7 +2441,7 @@
           <p:cNvPr id="19" name="">
             <a:extLst xmlns:a="http://schemas.openxmlformats.org/drawingml/2006/main">
               <a:ext uri="{FF2B5EF4-FFF2-40B4-BE49-F238E27FC236}">
-                <a16:creationId xmlns:a16="http://schemas.microsoft.com/office/drawing/2014/main" id="{0AE8CC66-8A82-4A7A-AFD7-1F161D9CA2F7}"/>
+                <a16:creationId xmlns:a16="http://schemas.microsoft.com/office/drawing/2014/main" id="{942A8DB1-82E1-41D5-8514-67B9420E5ED9}"/>
               </a:ext>
             </a:extLst>
           </p:cNvPr>
@@ -2498,7 +2498,7 @@
     </p:spTree>
     <p:extLst>
       <p:ext uri="{BB962C8B-B14F-4D97-AF65-F5344CB8AC3E}">
-        <p14:creationId xmlns:p14="http://schemas.microsoft.com/office/powerpoint/2010/main" val="2127857156"/>
+        <p14:creationId xmlns:p14="http://schemas.microsoft.com/office/powerpoint/2010/main" val="142361160"/>
       </p:ext>
     </p:extLst>
   </p:cSld>
@@ -2522,7 +2522,7 @@
           <p:cNvPr id="1" name="">
             <a:extLst xmlns:a="http://schemas.openxmlformats.org/drawingml/2006/main">
               <a:ext uri="{FF2B5EF4-FFF2-40B4-BE49-F238E27FC236}">
-                <a16:creationId xmlns:a16="http://schemas.microsoft.com/office/drawing/2014/main" id="{F6740108-B680-4119-84BC-400AC8C9F5C9}"/>
+                <a16:creationId xmlns:a16="http://schemas.microsoft.com/office/drawing/2014/main" id="{EB1A4121-3A63-450B-85DC-697A01ABDD80}"/>
               </a:ext>
             </a:extLst>
           </p:cNvPr>
@@ -2552,7 +2552,7 @@
           <p:cNvPr id="2" name="">
             <a:extLst xmlns:a="http://schemas.openxmlformats.org/drawingml/2006/main">
               <a:ext uri="{FF2B5EF4-FFF2-40B4-BE49-F238E27FC236}">
-                <a16:creationId xmlns:a16="http://schemas.microsoft.com/office/drawing/2014/main" id="{F9E85515-B4FF-4C92-B41F-4D7A789417F9}"/>
+                <a16:creationId xmlns:a16="http://schemas.microsoft.com/office/drawing/2014/main" id="{35F0AAC2-0B8D-4A55-9CD6-B73AA7DD14ED}"/>
               </a:ext>
             </a:extLst>
           </p:cNvPr>
@@ -2582,7 +2582,7 @@
           <p:cNvPr id="3" name="">
             <a:extLst xmlns:a="http://schemas.openxmlformats.org/drawingml/2006/main">
               <a:ext uri="{FF2B5EF4-FFF2-40B4-BE49-F238E27FC236}">
-                <a16:creationId xmlns:a16="http://schemas.microsoft.com/office/drawing/2014/main" id="{8867CC03-25BD-4EF5-BAD1-BBFFA35BE1F2}"/>
+                <a16:creationId xmlns:a16="http://schemas.microsoft.com/office/drawing/2014/main" id="{67DAD97E-CE85-4A61-8EE1-862BD7856D12}"/>
               </a:ext>
             </a:extLst>
           </p:cNvPr>
@@ -2641,7 +2641,7 @@
           <p:cNvPr id="4" name="">
             <a:extLst xmlns:a="http://schemas.openxmlformats.org/drawingml/2006/main">
               <a:ext uri="{FF2B5EF4-FFF2-40B4-BE49-F238E27FC236}">
-                <a16:creationId xmlns:a16="http://schemas.microsoft.com/office/drawing/2014/main" id="{A36218FA-783C-41AA-890A-D44E60751B91}"/>
+                <a16:creationId xmlns:a16="http://schemas.microsoft.com/office/drawing/2014/main" id="{A1639503-25EB-4C67-AE82-DEF58BC2CDFC}"/>
               </a:ext>
             </a:extLst>
           </p:cNvPr>
@@ -2700,7 +2700,7 @@
           <p:cNvPr id="5" name="">
             <a:extLst xmlns:a="http://schemas.openxmlformats.org/drawingml/2006/main">
               <a:ext uri="{FF2B5EF4-FFF2-40B4-BE49-F238E27FC236}">
-                <a16:creationId xmlns:a16="http://schemas.microsoft.com/office/drawing/2014/main" id="{6927CDA5-B319-4DD1-9652-D58C620A9F0E}"/>
+                <a16:creationId xmlns:a16="http://schemas.microsoft.com/office/drawing/2014/main" id="{595D46F6-DC58-4E1D-A09D-B8915857F74D}"/>
               </a:ext>
             </a:extLst>
           </p:cNvPr>
@@ -2759,7 +2759,7 @@
           <p:cNvPr id="6" name="">
             <a:extLst xmlns:a="http://schemas.openxmlformats.org/drawingml/2006/main">
               <a:ext uri="{FF2B5EF4-FFF2-40B4-BE49-F238E27FC236}">
-                <a16:creationId xmlns:a16="http://schemas.microsoft.com/office/drawing/2014/main" id="{343510B2-557A-46E9-8FB4-54B19CAB2772}"/>
+                <a16:creationId xmlns:a16="http://schemas.microsoft.com/office/drawing/2014/main" id="{FD7FFA1D-B032-4130-AFA2-D1D07FDA9E47}"/>
               </a:ext>
             </a:extLst>
           </p:cNvPr>
@@ -2822,7 +2822,7 @@
           <p:nvPr/>
         </p:nvPicPr>
         <p:blipFill>
-          <a:blip xmlns:r="http://schemas.openxmlformats.org/officeDocument/2006/relationships" xmlns:a="http://schemas.openxmlformats.org/drawingml/2006/main" r:embed="R2f5730e568744089"/>
+          <a:blip xmlns:r="http://schemas.openxmlformats.org/officeDocument/2006/relationships" xmlns:a="http://schemas.openxmlformats.org/drawingml/2006/main" r:embed="R6ac46f0dd85c45ee"/>
           <a:srcRect xmlns:a="http://schemas.openxmlformats.org/drawingml/2006/main" l="568" t="0" r="568" b="0"/>
           <a:stretch xmlns:a="http://schemas.openxmlformats.org/drawingml/2006/main">
             <a:fillRect l="0" t="0" r="0" b="0"/>
@@ -2843,7 +2843,7 @@
           <p:cNvPr id="8" name="">
             <a:extLst xmlns:a="http://schemas.openxmlformats.org/drawingml/2006/main">
               <a:ext uri="{FF2B5EF4-FFF2-40B4-BE49-F238E27FC236}">
-                <a16:creationId xmlns:a16="http://schemas.microsoft.com/office/drawing/2014/main" id="{77F70350-D7F0-4959-8D37-2F26BD4495E4}"/>
+                <a16:creationId xmlns:a16="http://schemas.microsoft.com/office/drawing/2014/main" id="{FE0A525A-6E2F-401F-9DC2-4FECBEA27344}"/>
               </a:ext>
             </a:extLst>
           </p:cNvPr>
@@ -2875,7 +2875,7 @@
           <p:cNvPr id="9" name="">
             <a:extLst xmlns:a="http://schemas.openxmlformats.org/drawingml/2006/main">
               <a:ext uri="{FF2B5EF4-FFF2-40B4-BE49-F238E27FC236}">
-                <a16:creationId xmlns:a16="http://schemas.microsoft.com/office/drawing/2014/main" id="{1220FBA9-9432-4E56-A61B-793864C73823}"/>
+                <a16:creationId xmlns:a16="http://schemas.microsoft.com/office/drawing/2014/main" id="{1DDF30AD-E08C-4C33-9AC1-413F31A08EB7}"/>
               </a:ext>
             </a:extLst>
           </p:cNvPr>
@@ -2909,7 +2909,7 @@
           <p:cNvPr id="10" name="">
             <a:extLst xmlns:a="http://schemas.openxmlformats.org/drawingml/2006/main">
               <a:ext uri="{FF2B5EF4-FFF2-40B4-BE49-F238E27FC236}">
-                <a16:creationId xmlns:a16="http://schemas.microsoft.com/office/drawing/2014/main" id="{203BE91F-89FD-4BF5-AEAA-95F304104C61}"/>
+                <a16:creationId xmlns:a16="http://schemas.microsoft.com/office/drawing/2014/main" id="{CED57565-D0D4-46C7-9606-A75EE692180F}"/>
               </a:ext>
             </a:extLst>
           </p:cNvPr>
@@ -2941,7 +2941,7 @@
           <p:cNvPr id="11" name="">
             <a:extLst xmlns:a="http://schemas.openxmlformats.org/drawingml/2006/main">
               <a:ext uri="{FF2B5EF4-FFF2-40B4-BE49-F238E27FC236}">
-                <a16:creationId xmlns:a16="http://schemas.microsoft.com/office/drawing/2014/main" id="{3E56C3E1-F55A-41AF-903F-6C3C38EB45C3}"/>
+                <a16:creationId xmlns:a16="http://schemas.microsoft.com/office/drawing/2014/main" id="{63F4BB14-CA3D-4477-9B98-06131EF66407}"/>
               </a:ext>
             </a:extLst>
           </p:cNvPr>
@@ -2971,7 +2971,7 @@
           <p:cNvPr id="12" name="">
             <a:extLst xmlns:a="http://schemas.openxmlformats.org/drawingml/2006/main">
               <a:ext uri="{FF2B5EF4-FFF2-40B4-BE49-F238E27FC236}">
-                <a16:creationId xmlns:a16="http://schemas.microsoft.com/office/drawing/2014/main" id="{605E4E00-EB41-4BB4-B5D9-F0FAA7EF506C}"/>
+                <a16:creationId xmlns:a16="http://schemas.microsoft.com/office/drawing/2014/main" id="{3C704FAA-E13A-4747-A362-AE802450FE3D}"/>
               </a:ext>
             </a:extLst>
           </p:cNvPr>
@@ -3030,7 +3030,7 @@
           <p:cNvPr id="13" name="">
             <a:extLst xmlns:a="http://schemas.openxmlformats.org/drawingml/2006/main">
               <a:ext uri="{FF2B5EF4-FFF2-40B4-BE49-F238E27FC236}">
-                <a16:creationId xmlns:a16="http://schemas.microsoft.com/office/drawing/2014/main" id="{4C9DF925-DBB3-4F21-837B-2E23946B5E7C}"/>
+                <a16:creationId xmlns:a16="http://schemas.microsoft.com/office/drawing/2014/main" id="{AB2BC931-F309-4D9D-A345-6893DE5D1E88}"/>
               </a:ext>
             </a:extLst>
           </p:cNvPr>
@@ -3089,7 +3089,7 @@
           <p:cNvPr id="14" name="">
             <a:extLst xmlns:a="http://schemas.openxmlformats.org/drawingml/2006/main">
               <a:ext uri="{FF2B5EF4-FFF2-40B4-BE49-F238E27FC236}">
-                <a16:creationId xmlns:a16="http://schemas.microsoft.com/office/drawing/2014/main" id="{056E599C-A26B-4E9A-ABF6-0861597284A0}"/>
+                <a16:creationId xmlns:a16="http://schemas.microsoft.com/office/drawing/2014/main" id="{FDD728B0-7750-4D66-A144-92457607C075}"/>
               </a:ext>
             </a:extLst>
           </p:cNvPr>
@@ -3148,7 +3148,7 @@
           <p:cNvPr id="15" name="">
             <a:extLst xmlns:a="http://schemas.openxmlformats.org/drawingml/2006/main">
               <a:ext uri="{FF2B5EF4-FFF2-40B4-BE49-F238E27FC236}">
-                <a16:creationId xmlns:a16="http://schemas.microsoft.com/office/drawing/2014/main" id="{0171A7B5-BC80-412F-88F2-9217FC548AB5}"/>
+                <a16:creationId xmlns:a16="http://schemas.microsoft.com/office/drawing/2014/main" id="{A46AC00F-FA7E-4AD6-8C18-B695B741E40A}"/>
               </a:ext>
             </a:extLst>
           </p:cNvPr>
@@ -3180,7 +3180,7 @@
           <p:cNvPr id="16" name="">
             <a:extLst xmlns:a="http://schemas.openxmlformats.org/drawingml/2006/main">
               <a:ext uri="{FF2B5EF4-FFF2-40B4-BE49-F238E27FC236}">
-                <a16:creationId xmlns:a16="http://schemas.microsoft.com/office/drawing/2014/main" id="{57D20C35-5BF2-4894-A030-E7B97C39E2B3}"/>
+                <a16:creationId xmlns:a16="http://schemas.microsoft.com/office/drawing/2014/main" id="{3DE018DD-1943-48B1-BC91-7AC876FF2854}"/>
               </a:ext>
             </a:extLst>
           </p:cNvPr>
@@ -3210,7 +3210,7 @@
           <p:cNvPr id="17" name="">
             <a:extLst xmlns:a="http://schemas.openxmlformats.org/drawingml/2006/main">
               <a:ext uri="{FF2B5EF4-FFF2-40B4-BE49-F238E27FC236}">
-                <a16:creationId xmlns:a16="http://schemas.microsoft.com/office/drawing/2014/main" id="{2C21ED7B-E3D2-4BD2-ADE3-ABE4EA294F28}"/>
+                <a16:creationId xmlns:a16="http://schemas.microsoft.com/office/drawing/2014/main" id="{260C8942-A83F-4636-BE1E-B3C590A98E8F}"/>
               </a:ext>
             </a:extLst>
           </p:cNvPr>
@@ -3269,7 +3269,7 @@
           <p:cNvPr id="18" name="">
             <a:extLst xmlns:a="http://schemas.openxmlformats.org/drawingml/2006/main">
               <a:ext uri="{FF2B5EF4-FFF2-40B4-BE49-F238E27FC236}">
-                <a16:creationId xmlns:a16="http://schemas.microsoft.com/office/drawing/2014/main" id="{A4ECBDB9-6EF4-4AD2-AC47-8466DE504684}"/>
+                <a16:creationId xmlns:a16="http://schemas.microsoft.com/office/drawing/2014/main" id="{4E1A2B71-91F6-46E0-9BAE-925CF315E86F}"/>
               </a:ext>
             </a:extLst>
           </p:cNvPr>
@@ -3328,7 +3328,7 @@
           <p:cNvPr id="19" name="">
             <a:extLst xmlns:a="http://schemas.openxmlformats.org/drawingml/2006/main">
               <a:ext uri="{FF2B5EF4-FFF2-40B4-BE49-F238E27FC236}">
-                <a16:creationId xmlns:a16="http://schemas.microsoft.com/office/drawing/2014/main" id="{97365FD6-0E12-483B-8D54-A63DADFD0626}"/>
+                <a16:creationId xmlns:a16="http://schemas.microsoft.com/office/drawing/2014/main" id="{A572D30B-A79F-4122-9D49-EB2DF161E7A3}"/>
               </a:ext>
             </a:extLst>
           </p:cNvPr>
@@ -3387,7 +3387,7 @@
           <p:cNvPr id="20" name="">
             <a:extLst xmlns:a="http://schemas.openxmlformats.org/drawingml/2006/main">
               <a:ext uri="{FF2B5EF4-FFF2-40B4-BE49-F238E27FC236}">
-                <a16:creationId xmlns:a16="http://schemas.microsoft.com/office/drawing/2014/main" id="{39987DE6-E62A-4169-A1FA-B2DBE36FF043}"/>
+                <a16:creationId xmlns:a16="http://schemas.microsoft.com/office/drawing/2014/main" id="{8AFF2E14-A79E-4999-A595-5B68E4D5B571}"/>
               </a:ext>
             </a:extLst>
           </p:cNvPr>
@@ -3419,7 +3419,7 @@
           <p:cNvPr id="21" name="">
             <a:extLst xmlns:a="http://schemas.openxmlformats.org/drawingml/2006/main">
               <a:ext uri="{FF2B5EF4-FFF2-40B4-BE49-F238E27FC236}">
-                <a16:creationId xmlns:a16="http://schemas.microsoft.com/office/drawing/2014/main" id="{1B0A29EE-B4E6-4AFE-8E0E-3298E73FBF8A}"/>
+                <a16:creationId xmlns:a16="http://schemas.microsoft.com/office/drawing/2014/main" id="{016089F7-98D9-4C55-9100-C0178EF5825F}"/>
               </a:ext>
             </a:extLst>
           </p:cNvPr>
@@ -3449,7 +3449,7 @@
           <p:cNvPr id="22" name="">
             <a:extLst xmlns:a="http://schemas.openxmlformats.org/drawingml/2006/main">
               <a:ext uri="{FF2B5EF4-FFF2-40B4-BE49-F238E27FC236}">
-                <a16:creationId xmlns:a16="http://schemas.microsoft.com/office/drawing/2014/main" id="{265BF7DA-CB4B-4277-BE98-D23506E7454E}"/>
+                <a16:creationId xmlns:a16="http://schemas.microsoft.com/office/drawing/2014/main" id="{1C78144D-3D06-4244-8CA8-EB9F2F709C98}"/>
               </a:ext>
             </a:extLst>
           </p:cNvPr>
@@ -3508,7 +3508,7 @@
           <p:cNvPr id="23" name="">
             <a:extLst xmlns:a="http://schemas.openxmlformats.org/drawingml/2006/main">
               <a:ext uri="{FF2B5EF4-FFF2-40B4-BE49-F238E27FC236}">
-                <a16:creationId xmlns:a16="http://schemas.microsoft.com/office/drawing/2014/main" id="{01290E1F-1AF3-43D4-953D-4BA759839060}"/>
+                <a16:creationId xmlns:a16="http://schemas.microsoft.com/office/drawing/2014/main" id="{B9B58E22-8FB9-4D97-BC74-43177B349298}"/>
               </a:ext>
             </a:extLst>
           </p:cNvPr>
@@ -3567,7 +3567,7 @@
           <p:cNvPr id="24" name="">
             <a:extLst xmlns:a="http://schemas.openxmlformats.org/drawingml/2006/main">
               <a:ext uri="{FF2B5EF4-FFF2-40B4-BE49-F238E27FC236}">
-                <a16:creationId xmlns:a16="http://schemas.microsoft.com/office/drawing/2014/main" id="{C10DE524-23D9-4F88-9FCA-447A9B458AB4}"/>
+                <a16:creationId xmlns:a16="http://schemas.microsoft.com/office/drawing/2014/main" id="{BA0BD0F7-7F01-4656-BB66-1ADC40F7B4B6}"/>
               </a:ext>
             </a:extLst>
           </p:cNvPr>
@@ -3626,7 +3626,7 @@
           <p:cNvPr id="25" name="">
             <a:extLst xmlns:a="http://schemas.openxmlformats.org/drawingml/2006/main">
               <a:ext uri="{FF2B5EF4-FFF2-40B4-BE49-F238E27FC236}">
-                <a16:creationId xmlns:a16="http://schemas.microsoft.com/office/drawing/2014/main" id="{2CAC5881-06AF-4401-A82B-FE41898BA5F4}"/>
+                <a16:creationId xmlns:a16="http://schemas.microsoft.com/office/drawing/2014/main" id="{C9B0FBCB-2996-4E50-A43A-A7DF7DD441AA}"/>
               </a:ext>
             </a:extLst>
           </p:cNvPr>
@@ -3658,7 +3658,7 @@
           <p:cNvPr id="26" name="">
             <a:extLst xmlns:a="http://schemas.openxmlformats.org/drawingml/2006/main">
               <a:ext uri="{FF2B5EF4-FFF2-40B4-BE49-F238E27FC236}">
-                <a16:creationId xmlns:a16="http://schemas.microsoft.com/office/drawing/2014/main" id="{01553A75-FCA9-4532-937F-33D4371FF1C6}"/>
+                <a16:creationId xmlns:a16="http://schemas.microsoft.com/office/drawing/2014/main" id="{96762DE2-F76B-4E31-89F8-694CEDEB00AB}"/>
               </a:ext>
             </a:extLst>
           </p:cNvPr>
@@ -3688,7 +3688,7 @@
           <p:cNvPr id="27" name="">
             <a:extLst xmlns:a="http://schemas.openxmlformats.org/drawingml/2006/main">
               <a:ext uri="{FF2B5EF4-FFF2-40B4-BE49-F238E27FC236}">
-                <a16:creationId xmlns:a16="http://schemas.microsoft.com/office/drawing/2014/main" id="{0F78952F-8A8A-4EC6-953F-5D118C0C9A47}"/>
+                <a16:creationId xmlns:a16="http://schemas.microsoft.com/office/drawing/2014/main" id="{D875AF5D-7D6B-428C-B079-75F3CC459F2F}"/>
               </a:ext>
             </a:extLst>
           </p:cNvPr>
@@ -3747,7 +3747,7 @@
           <p:cNvPr id="28" name="">
             <a:extLst xmlns:a="http://schemas.openxmlformats.org/drawingml/2006/main">
               <a:ext uri="{FF2B5EF4-FFF2-40B4-BE49-F238E27FC236}">
-                <a16:creationId xmlns:a16="http://schemas.microsoft.com/office/drawing/2014/main" id="{954E074E-707E-4341-B7D6-D74786297C84}"/>
+                <a16:creationId xmlns:a16="http://schemas.microsoft.com/office/drawing/2014/main" id="{8B02D735-36E1-4E24-B06C-2D0059FBF23D}"/>
               </a:ext>
             </a:extLst>
           </p:cNvPr>
@@ -3806,7 +3806,7 @@
           <p:cNvPr id="29" name="">
             <a:extLst xmlns:a="http://schemas.openxmlformats.org/drawingml/2006/main">
               <a:ext uri="{FF2B5EF4-FFF2-40B4-BE49-F238E27FC236}">
-                <a16:creationId xmlns:a16="http://schemas.microsoft.com/office/drawing/2014/main" id="{40D7A21F-59AC-4D53-A041-D9789393A597}"/>
+                <a16:creationId xmlns:a16="http://schemas.microsoft.com/office/drawing/2014/main" id="{E43E5BD5-E7B9-4710-8E4B-1282D2538FF0}"/>
               </a:ext>
             </a:extLst>
           </p:cNvPr>
@@ -3836,7 +3836,7 @@
           <p:cNvPr id="30" name="">
             <a:extLst xmlns:a="http://schemas.openxmlformats.org/drawingml/2006/main">
               <a:ext uri="{FF2B5EF4-FFF2-40B4-BE49-F238E27FC236}">
-                <a16:creationId xmlns:a16="http://schemas.microsoft.com/office/drawing/2014/main" id="{F01A9639-8425-4848-9C13-0B17A8160155}"/>
+                <a16:creationId xmlns:a16="http://schemas.microsoft.com/office/drawing/2014/main" id="{796504F1-B636-4875-ACDD-3DD69149C7B1}"/>
               </a:ext>
             </a:extLst>
           </p:cNvPr>
@@ -3866,7 +3866,7 @@
           <p:cNvPr id="31" name="">
             <a:extLst xmlns:a="http://schemas.openxmlformats.org/drawingml/2006/main">
               <a:ext uri="{FF2B5EF4-FFF2-40B4-BE49-F238E27FC236}">
-                <a16:creationId xmlns:a16="http://schemas.microsoft.com/office/drawing/2014/main" id="{86B5BF7D-8802-4296-B3A6-D3B56671FA07}"/>
+                <a16:creationId xmlns:a16="http://schemas.microsoft.com/office/drawing/2014/main" id="{C38055A6-CC60-4982-8FEF-A86D3FC0431D}"/>
               </a:ext>
             </a:extLst>
           </p:cNvPr>
@@ -3923,7 +3923,7 @@
     </p:spTree>
     <p:extLst>
       <p:ext uri="{BB962C8B-B14F-4D97-AF65-F5344CB8AC3E}">
-        <p14:creationId xmlns:p14="http://schemas.microsoft.com/office/powerpoint/2010/main" val="1116153800"/>
+        <p14:creationId xmlns:p14="http://schemas.microsoft.com/office/powerpoint/2010/main" val="553939574"/>
       </p:ext>
     </p:extLst>
   </p:cSld>
@@ -3947,7 +3947,7 @@
           <p:cNvPr id="1" name="">
             <a:extLst xmlns:a="http://schemas.openxmlformats.org/drawingml/2006/main">
               <a:ext uri="{FF2B5EF4-FFF2-40B4-BE49-F238E27FC236}">
-                <a16:creationId xmlns:a16="http://schemas.microsoft.com/office/drawing/2014/main" id="{310EE498-7FC5-4D6E-BA2F-BCD39ED3312E}"/>
+                <a16:creationId xmlns:a16="http://schemas.microsoft.com/office/drawing/2014/main" id="{3AE68932-0E95-4F32-84B7-7E0DDEF1D68A}"/>
               </a:ext>
             </a:extLst>
           </p:cNvPr>
@@ -3977,7 +3977,7 @@
           <p:cNvPr id="2" name="">
             <a:extLst xmlns:a="http://schemas.openxmlformats.org/drawingml/2006/main">
               <a:ext uri="{FF2B5EF4-FFF2-40B4-BE49-F238E27FC236}">
-                <a16:creationId xmlns:a16="http://schemas.microsoft.com/office/drawing/2014/main" id="{BF0B9588-79D6-4FB6-A046-EC16741E13EF}"/>
+                <a16:creationId xmlns:a16="http://schemas.microsoft.com/office/drawing/2014/main" id="{6E7FB87E-C002-4FE3-9D1D-4DF80329857A}"/>
               </a:ext>
             </a:extLst>
           </p:cNvPr>
@@ -4007,7 +4007,7 @@
           <p:cNvPr id="3" name="">
             <a:extLst xmlns:a="http://schemas.openxmlformats.org/drawingml/2006/main">
               <a:ext uri="{FF2B5EF4-FFF2-40B4-BE49-F238E27FC236}">
-                <a16:creationId xmlns:a16="http://schemas.microsoft.com/office/drawing/2014/main" id="{E7DE203A-2304-4B45-899F-D163201B158B}"/>
+                <a16:creationId xmlns:a16="http://schemas.microsoft.com/office/drawing/2014/main" id="{23BF17D2-E456-47AF-A759-DD4D02E95027}"/>
               </a:ext>
             </a:extLst>
           </p:cNvPr>
@@ -4066,7 +4066,7 @@
           <p:cNvPr id="4" name="">
             <a:extLst xmlns:a="http://schemas.openxmlformats.org/drawingml/2006/main">
               <a:ext uri="{FF2B5EF4-FFF2-40B4-BE49-F238E27FC236}">
-                <a16:creationId xmlns:a16="http://schemas.microsoft.com/office/drawing/2014/main" id="{C2DB9ACE-71B7-4785-9799-70B9F7C6CACB}"/>
+                <a16:creationId xmlns:a16="http://schemas.microsoft.com/office/drawing/2014/main" id="{CAC77A09-BC4C-45BA-9B7C-8DED344F344B}"/>
               </a:ext>
             </a:extLst>
           </p:cNvPr>
@@ -4125,7 +4125,7 @@
           <p:cNvPr id="5" name="">
             <a:extLst xmlns:a="http://schemas.openxmlformats.org/drawingml/2006/main">
               <a:ext uri="{FF2B5EF4-FFF2-40B4-BE49-F238E27FC236}">
-                <a16:creationId xmlns:a16="http://schemas.microsoft.com/office/drawing/2014/main" id="{3613042A-4802-47B6-A700-98860DD4621B}"/>
+                <a16:creationId xmlns:a16="http://schemas.microsoft.com/office/drawing/2014/main" id="{880A9A62-07AE-409E-B483-045D42074392}"/>
               </a:ext>
             </a:extLst>
           </p:cNvPr>
@@ -4184,7 +4184,7 @@
           <p:cNvPr id="6" name="">
             <a:extLst xmlns:a="http://schemas.openxmlformats.org/drawingml/2006/main">
               <a:ext uri="{FF2B5EF4-FFF2-40B4-BE49-F238E27FC236}">
-                <a16:creationId xmlns:a16="http://schemas.microsoft.com/office/drawing/2014/main" id="{64F5C232-BC2A-46DB-9AF6-12037E4AE505}"/>
+                <a16:creationId xmlns:a16="http://schemas.microsoft.com/office/drawing/2014/main" id="{8F9544B6-EE5B-4B65-ADFD-C5C741621ECC}"/>
               </a:ext>
             </a:extLst>
           </p:cNvPr>
@@ -4247,7 +4247,7 @@
           <p:nvPr/>
         </p:nvPicPr>
         <p:blipFill>
-          <a:blip xmlns:r="http://schemas.openxmlformats.org/officeDocument/2006/relationships" xmlns:a="http://schemas.openxmlformats.org/drawingml/2006/main" r:embed="Rba6cb92767104e94"/>
+          <a:blip xmlns:r="http://schemas.openxmlformats.org/officeDocument/2006/relationships" xmlns:a="http://schemas.openxmlformats.org/drawingml/2006/main" r:embed="Rdab8242c72ed4351"/>
           <a:srcRect xmlns:a="http://schemas.openxmlformats.org/drawingml/2006/main" l="0" t="1111" r="0" b="1111"/>
           <a:stretch xmlns:a="http://schemas.openxmlformats.org/drawingml/2006/main">
             <a:fillRect l="0" t="0" r="0" b="0"/>
@@ -4268,7 +4268,7 @@
           <p:cNvPr id="8" name="">
             <a:extLst xmlns:a="http://schemas.openxmlformats.org/drawingml/2006/main">
               <a:ext uri="{FF2B5EF4-FFF2-40B4-BE49-F238E27FC236}">
-                <a16:creationId xmlns:a16="http://schemas.microsoft.com/office/drawing/2014/main" id="{13196B89-8BA3-40EA-9534-48A610804F34}"/>
+                <a16:creationId xmlns:a16="http://schemas.microsoft.com/office/drawing/2014/main" id="{633F70F4-C0C2-4897-9DE9-7454C5F067F6}"/>
               </a:ext>
             </a:extLst>
           </p:cNvPr>
@@ -4300,7 +4300,7 @@
           <p:cNvPr id="9" name="">
             <a:extLst xmlns:a="http://schemas.openxmlformats.org/drawingml/2006/main">
               <a:ext uri="{FF2B5EF4-FFF2-40B4-BE49-F238E27FC236}">
-                <a16:creationId xmlns:a16="http://schemas.microsoft.com/office/drawing/2014/main" id="{6C9685F1-5DBC-4159-9700-D7EC72864733}"/>
+                <a16:creationId xmlns:a16="http://schemas.microsoft.com/office/drawing/2014/main" id="{72915DFE-1CF0-4A66-9DA0-15523ADBDDDF}"/>
               </a:ext>
             </a:extLst>
           </p:cNvPr>
@@ -4334,7 +4334,7 @@
           <p:cNvPr id="10" name="">
             <a:extLst xmlns:a="http://schemas.openxmlformats.org/drawingml/2006/main">
               <a:ext uri="{FF2B5EF4-FFF2-40B4-BE49-F238E27FC236}">
-                <a16:creationId xmlns:a16="http://schemas.microsoft.com/office/drawing/2014/main" id="{B5C16BAC-FB88-4A4C-BE13-9E36C49D90C0}"/>
+                <a16:creationId xmlns:a16="http://schemas.microsoft.com/office/drawing/2014/main" id="{94986450-CE0F-44EA-99BD-6299BD5702A4}"/>
               </a:ext>
             </a:extLst>
           </p:cNvPr>
@@ -4366,7 +4366,7 @@
           <p:cNvPr id="11" name="">
             <a:extLst xmlns:a="http://schemas.openxmlformats.org/drawingml/2006/main">
               <a:ext uri="{FF2B5EF4-FFF2-40B4-BE49-F238E27FC236}">
-                <a16:creationId xmlns:a16="http://schemas.microsoft.com/office/drawing/2014/main" id="{D2E7AE69-3CB5-4AA0-8A59-B9F567B02C29}"/>
+                <a16:creationId xmlns:a16="http://schemas.microsoft.com/office/drawing/2014/main" id="{BA16A78F-BAB9-4203-BBD1-7002D08893C2}"/>
               </a:ext>
             </a:extLst>
           </p:cNvPr>
@@ -4425,7 +4425,7 @@
           <p:cNvPr id="12" name="">
             <a:extLst xmlns:a="http://schemas.openxmlformats.org/drawingml/2006/main">
               <a:ext uri="{FF2B5EF4-FFF2-40B4-BE49-F238E27FC236}">
-                <a16:creationId xmlns:a16="http://schemas.microsoft.com/office/drawing/2014/main" id="{CE24D247-AC59-4060-81BA-2953B9FC65B9}"/>
+                <a16:creationId xmlns:a16="http://schemas.microsoft.com/office/drawing/2014/main" id="{5DBE3D95-6C01-445E-9555-82045360DDA5}"/>
               </a:ext>
             </a:extLst>
           </p:cNvPr>
@@ -4484,7 +4484,7 @@
           <p:cNvPr id="13" name="">
             <a:extLst xmlns:a="http://schemas.openxmlformats.org/drawingml/2006/main">
               <a:ext uri="{FF2B5EF4-FFF2-40B4-BE49-F238E27FC236}">
-                <a16:creationId xmlns:a16="http://schemas.microsoft.com/office/drawing/2014/main" id="{775CD947-103D-445A-A302-AC823E2D64F2}"/>
+                <a16:creationId xmlns:a16="http://schemas.microsoft.com/office/drawing/2014/main" id="{036B6A10-28B8-4776-B604-B7CAD5777F0A}"/>
               </a:ext>
             </a:extLst>
           </p:cNvPr>
@@ -4516,7 +4516,7 @@
           <p:cNvPr id="14" name="">
             <a:extLst xmlns:a="http://schemas.openxmlformats.org/drawingml/2006/main">
               <a:ext uri="{FF2B5EF4-FFF2-40B4-BE49-F238E27FC236}">
-                <a16:creationId xmlns:a16="http://schemas.microsoft.com/office/drawing/2014/main" id="{1D0BFEE9-A835-416F-866A-C5C6EF38EF77}"/>
+                <a16:creationId xmlns:a16="http://schemas.microsoft.com/office/drawing/2014/main" id="{ACE4161A-C3BF-448A-80FF-01E41999AE52}"/>
               </a:ext>
             </a:extLst>
           </p:cNvPr>
@@ -4575,7 +4575,7 @@
           <p:cNvPr id="15" name="">
             <a:extLst xmlns:a="http://schemas.openxmlformats.org/drawingml/2006/main">
               <a:ext uri="{FF2B5EF4-FFF2-40B4-BE49-F238E27FC236}">
-                <a16:creationId xmlns:a16="http://schemas.microsoft.com/office/drawing/2014/main" id="{34EA9A54-7A6F-4ACB-932D-DA3CFE89A5E8}"/>
+                <a16:creationId xmlns:a16="http://schemas.microsoft.com/office/drawing/2014/main" id="{9C7FCEC0-9796-4ED6-AC9C-821D21B5E7CC}"/>
               </a:ext>
             </a:extLst>
           </p:cNvPr>
@@ -4634,7 +4634,7 @@
           <p:cNvPr id="16" name="">
             <a:extLst xmlns:a="http://schemas.openxmlformats.org/drawingml/2006/main">
               <a:ext uri="{FF2B5EF4-FFF2-40B4-BE49-F238E27FC236}">
-                <a16:creationId xmlns:a16="http://schemas.microsoft.com/office/drawing/2014/main" id="{6E546FA5-FD22-4BA3-8DA8-A6D887473F4D}"/>
+                <a16:creationId xmlns:a16="http://schemas.microsoft.com/office/drawing/2014/main" id="{4BF0E688-4322-413C-A103-27E403DE7C55}"/>
               </a:ext>
             </a:extLst>
           </p:cNvPr>
@@ -4666,7 +4666,7 @@
           <p:cNvPr id="17" name="">
             <a:extLst xmlns:a="http://schemas.openxmlformats.org/drawingml/2006/main">
               <a:ext uri="{FF2B5EF4-FFF2-40B4-BE49-F238E27FC236}">
-                <a16:creationId xmlns:a16="http://schemas.microsoft.com/office/drawing/2014/main" id="{4FBD3808-2D23-4CAC-BC1E-D9AA9405AE16}"/>
+                <a16:creationId xmlns:a16="http://schemas.microsoft.com/office/drawing/2014/main" id="{E49B2466-8C23-415C-82E0-91A35830067C}"/>
               </a:ext>
             </a:extLst>
           </p:cNvPr>
@@ -4725,7 +4725,7 @@
           <p:cNvPr id="18" name="">
             <a:extLst xmlns:a="http://schemas.openxmlformats.org/drawingml/2006/main">
               <a:ext uri="{FF2B5EF4-FFF2-40B4-BE49-F238E27FC236}">
-                <a16:creationId xmlns:a16="http://schemas.microsoft.com/office/drawing/2014/main" id="{B0B69067-5FF4-46A2-9AC3-8BFA2996BF38}"/>
+                <a16:creationId xmlns:a16="http://schemas.microsoft.com/office/drawing/2014/main" id="{1DED7A64-3962-441A-A810-D57EC818CFBA}"/>
               </a:ext>
             </a:extLst>
           </p:cNvPr>
@@ -4784,7 +4784,7 @@
           <p:cNvPr id="19" name="">
             <a:extLst xmlns:a="http://schemas.openxmlformats.org/drawingml/2006/main">
               <a:ext uri="{FF2B5EF4-FFF2-40B4-BE49-F238E27FC236}">
-                <a16:creationId xmlns:a16="http://schemas.microsoft.com/office/drawing/2014/main" id="{05F4DE28-95ED-4B7D-8803-E4189C7168EE}"/>
+                <a16:creationId xmlns:a16="http://schemas.microsoft.com/office/drawing/2014/main" id="{3E5A1E6D-B379-4C98-843A-2C756F6EB0A5}"/>
               </a:ext>
             </a:extLst>
           </p:cNvPr>
@@ -4816,7 +4816,7 @@
           <p:cNvPr id="20" name="">
             <a:extLst xmlns:a="http://schemas.openxmlformats.org/drawingml/2006/main">
               <a:ext uri="{FF2B5EF4-FFF2-40B4-BE49-F238E27FC236}">
-                <a16:creationId xmlns:a16="http://schemas.microsoft.com/office/drawing/2014/main" id="{6016BCFC-3839-4505-BBE7-C1E6CB8873B4}"/>
+                <a16:creationId xmlns:a16="http://schemas.microsoft.com/office/drawing/2014/main" id="{74791599-6B27-4A38-AC4F-52E7F20E4EC4}"/>
               </a:ext>
             </a:extLst>
           </p:cNvPr>
@@ -4875,19 +4875,19 @@
           <p:cNvPr id="21" name="">
             <a:extLst xmlns:a="http://schemas.openxmlformats.org/drawingml/2006/main">
               <a:ext uri="{FF2B5EF4-FFF2-40B4-BE49-F238E27FC236}">
-                <a16:creationId xmlns:a16="http://schemas.microsoft.com/office/drawing/2014/main" id="{3D3673A9-EF5B-43CF-AD2F-A1425CBFDD13}"/>
-              </a:ext>
-            </a:extLst>
-          </p:cNvPr>
-          <p:cNvSpPr>
-            <a:spLocks xmlns:a="http://schemas.openxmlformats.org/drawingml/2006/main" noGrp="1"/>
-          </p:cNvSpPr>
-          <p:nvPr/>
-        </p:nvSpPr>
-        <p:spPr>
-          <a:xfrm xmlns:a="http://schemas.openxmlformats.org/drawingml/2006/main">
-            <a:off x="704850" y="3105150"/>
-            <a:ext cx="2190750" cy="723900"/>
+                <a16:creationId xmlns:a16="http://schemas.microsoft.com/office/drawing/2014/main" id="{B401DA3C-4B70-49AD-BD53-D28BF2FE1CFE}"/>
+              </a:ext>
+            </a:extLst>
+          </p:cNvPr>
+          <p:cNvSpPr>
+            <a:spLocks xmlns:a="http://schemas.openxmlformats.org/drawingml/2006/main" noGrp="1"/>
+          </p:cNvSpPr>
+          <p:nvPr/>
+        </p:nvSpPr>
+        <p:spPr>
+          <a:xfrm xmlns:a="http://schemas.openxmlformats.org/drawingml/2006/main">
+            <a:off x="704850" y="3028950"/>
+            <a:ext cx="2190750" cy="876300"/>
           </a:xfrm>
           <a:prstGeom xmlns:a="http://schemas.openxmlformats.org/drawingml/2006/main" prst="rect">
             <a:avLst/>
@@ -4907,19 +4907,19 @@
           <p:cNvPr id="22" name="">
             <a:extLst xmlns:a="http://schemas.openxmlformats.org/drawingml/2006/main">
               <a:ext uri="{FF2B5EF4-FFF2-40B4-BE49-F238E27FC236}">
-                <a16:creationId xmlns:a16="http://schemas.microsoft.com/office/drawing/2014/main" id="{8D1B1EA5-AE2C-41CD-9088-55296D6E3F53}"/>
-              </a:ext>
-            </a:extLst>
-          </p:cNvPr>
-          <p:cNvSpPr>
-            <a:spLocks xmlns:a="http://schemas.openxmlformats.org/drawingml/2006/main" noGrp="1"/>
-          </p:cNvSpPr>
-          <p:nvPr/>
-        </p:nvSpPr>
-        <p:spPr>
-          <a:xfrm xmlns:a="http://schemas.openxmlformats.org/drawingml/2006/main">
-            <a:off x="704850" y="3105150"/>
-            <a:ext cx="47625" cy="723900"/>
+                <a16:creationId xmlns:a16="http://schemas.microsoft.com/office/drawing/2014/main" id="{8A224485-D9E0-48A8-816F-5FAC1504A378}"/>
+              </a:ext>
+            </a:extLst>
+          </p:cNvPr>
+          <p:cNvSpPr>
+            <a:spLocks xmlns:a="http://schemas.openxmlformats.org/drawingml/2006/main" noGrp="1"/>
+          </p:cNvSpPr>
+          <p:nvPr/>
+        </p:nvSpPr>
+        <p:spPr>
+          <a:xfrm xmlns:a="http://schemas.openxmlformats.org/drawingml/2006/main">
+            <a:off x="704850" y="3028950"/>
+            <a:ext cx="47625" cy="876300"/>
           </a:xfrm>
           <a:prstGeom xmlns:a="http://schemas.openxmlformats.org/drawingml/2006/main" prst="rect">
             <a:avLst/>
@@ -4937,18 +4937,18 @@
           <p:cNvPr id="23" name="">
             <a:extLst xmlns:a="http://schemas.openxmlformats.org/drawingml/2006/main">
               <a:ext uri="{FF2B5EF4-FFF2-40B4-BE49-F238E27FC236}">
-                <a16:creationId xmlns:a16="http://schemas.microsoft.com/office/drawing/2014/main" id="{92555EE3-1DB7-4B5B-8776-036806694816}"/>
-              </a:ext>
-            </a:extLst>
-          </p:cNvPr>
-          <p:cNvSpPr>
-            <a:spLocks xmlns:a="http://schemas.openxmlformats.org/drawingml/2006/main" noGrp="1"/>
-          </p:cNvSpPr>
-          <p:nvPr/>
-        </p:nvSpPr>
-        <p:spPr>
-          <a:xfrm xmlns:a="http://schemas.openxmlformats.org/drawingml/2006/main">
-            <a:off x="914400" y="3257550"/>
+                <a16:creationId xmlns:a16="http://schemas.microsoft.com/office/drawing/2014/main" id="{94810151-AD7A-4C44-B662-ED9C3FF4FD7C}"/>
+              </a:ext>
+            </a:extLst>
+          </p:cNvPr>
+          <p:cNvSpPr>
+            <a:spLocks xmlns:a="http://schemas.openxmlformats.org/drawingml/2006/main" noGrp="1"/>
+          </p:cNvSpPr>
+          <p:nvPr/>
+        </p:nvSpPr>
+        <p:spPr>
+          <a:xfrm xmlns:a="http://schemas.openxmlformats.org/drawingml/2006/main">
+            <a:off x="914400" y="3181350"/>
             <a:ext cx="1771650" cy="234791"/>
           </a:xfrm>
           <a:prstGeom xmlns:a="http://schemas.openxmlformats.org/drawingml/2006/main" prst="rect">
@@ -4996,18 +4996,18 @@
           <p:cNvPr id="24" name="">
             <a:extLst xmlns:a="http://schemas.openxmlformats.org/drawingml/2006/main">
               <a:ext uri="{FF2B5EF4-FFF2-40B4-BE49-F238E27FC236}">
-                <a16:creationId xmlns:a16="http://schemas.microsoft.com/office/drawing/2014/main" id="{B7CE5750-C68A-43DF-B1A4-355C2ADD20AC}"/>
-              </a:ext>
-            </a:extLst>
-          </p:cNvPr>
-          <p:cNvSpPr>
-            <a:spLocks xmlns:a="http://schemas.openxmlformats.org/drawingml/2006/main" noGrp="1"/>
-          </p:cNvSpPr>
-          <p:nvPr/>
-        </p:nvSpPr>
-        <p:spPr>
-          <a:xfrm xmlns:a="http://schemas.openxmlformats.org/drawingml/2006/main">
-            <a:off x="914400" y="3568541"/>
+                <a16:creationId xmlns:a16="http://schemas.microsoft.com/office/drawing/2014/main" id="{53ED854E-E087-4DF4-848F-4AADCBDDC97B}"/>
+              </a:ext>
+            </a:extLst>
+          </p:cNvPr>
+          <p:cNvSpPr>
+            <a:spLocks xmlns:a="http://schemas.openxmlformats.org/drawingml/2006/main" noGrp="1"/>
+          </p:cNvSpPr>
+          <p:nvPr/>
+        </p:nvSpPr>
+        <p:spPr>
+          <a:xfrm xmlns:a="http://schemas.openxmlformats.org/drawingml/2006/main">
+            <a:off x="914400" y="3492341"/>
             <a:ext cx="1771650" cy="266700"/>
           </a:xfrm>
           <a:prstGeom xmlns:a="http://schemas.openxmlformats.org/drawingml/2006/main" prst="rect">
@@ -5027,7 +5027,7 @@
           <a:lstStyle xmlns:a="http://schemas.openxmlformats.org/drawingml/2006/main"/>
           <a:p xmlns:a="http://schemas.openxmlformats.org/drawingml/2006/main">
             <a:pPr algn="l">
-              <a:defRPr sz="923" b="0">
+              <a:defRPr sz="960" b="0">
                 <a:solidFill>
                   <a:srgbClr val="526179"/>
                 </a:solidFill>
@@ -5037,7 +5037,7 @@
               </a:defRPr>
             </a:pPr>
             <a:r>
-              <a:rPr sz="923" b="0">
+              <a:rPr sz="960" b="0">
                 <a:solidFill>
                   <a:srgbClr val="526179"/>
                 </a:solidFill>
@@ -5055,19 +5055,19 @@
           <p:cNvPr id="25" name="">
             <a:extLst xmlns:a="http://schemas.openxmlformats.org/drawingml/2006/main">
               <a:ext uri="{FF2B5EF4-FFF2-40B4-BE49-F238E27FC236}">
-                <a16:creationId xmlns:a16="http://schemas.microsoft.com/office/drawing/2014/main" id="{B12EBF91-562D-4871-95DE-1ABB89BD948F}"/>
-              </a:ext>
-            </a:extLst>
-          </p:cNvPr>
-          <p:cNvSpPr>
-            <a:spLocks xmlns:a="http://schemas.openxmlformats.org/drawingml/2006/main" noGrp="1"/>
-          </p:cNvSpPr>
-          <p:nvPr/>
-        </p:nvSpPr>
-        <p:spPr>
-          <a:xfrm xmlns:a="http://schemas.openxmlformats.org/drawingml/2006/main">
-            <a:off x="3257550" y="3105150"/>
-            <a:ext cx="2190750" cy="723900"/>
+                <a16:creationId xmlns:a16="http://schemas.microsoft.com/office/drawing/2014/main" id="{0331FF98-8431-4AC4-9CE9-C95B95FDE8CC}"/>
+              </a:ext>
+            </a:extLst>
+          </p:cNvPr>
+          <p:cNvSpPr>
+            <a:spLocks xmlns:a="http://schemas.openxmlformats.org/drawingml/2006/main" noGrp="1"/>
+          </p:cNvSpPr>
+          <p:nvPr/>
+        </p:nvSpPr>
+        <p:spPr>
+          <a:xfrm xmlns:a="http://schemas.openxmlformats.org/drawingml/2006/main">
+            <a:off x="3257550" y="3028950"/>
+            <a:ext cx="2190750" cy="876300"/>
           </a:xfrm>
           <a:prstGeom xmlns:a="http://schemas.openxmlformats.org/drawingml/2006/main" prst="rect">
             <a:avLst/>
@@ -5087,19 +5087,19 @@
           <p:cNvPr id="26" name="">
             <a:extLst xmlns:a="http://schemas.openxmlformats.org/drawingml/2006/main">
               <a:ext uri="{FF2B5EF4-FFF2-40B4-BE49-F238E27FC236}">
-                <a16:creationId xmlns:a16="http://schemas.microsoft.com/office/drawing/2014/main" id="{99C63B20-466B-4580-B76B-B5CFAF157B0A}"/>
-              </a:ext>
-            </a:extLst>
-          </p:cNvPr>
-          <p:cNvSpPr>
-            <a:spLocks xmlns:a="http://schemas.openxmlformats.org/drawingml/2006/main" noGrp="1"/>
-          </p:cNvSpPr>
-          <p:nvPr/>
-        </p:nvSpPr>
-        <p:spPr>
-          <a:xfrm xmlns:a="http://schemas.openxmlformats.org/drawingml/2006/main">
-            <a:off x="3257550" y="3105150"/>
-            <a:ext cx="47625" cy="723900"/>
+                <a16:creationId xmlns:a16="http://schemas.microsoft.com/office/drawing/2014/main" id="{6925A148-3DAA-4C8C-A327-E2CEC8E03F37}"/>
+              </a:ext>
+            </a:extLst>
+          </p:cNvPr>
+          <p:cNvSpPr>
+            <a:spLocks xmlns:a="http://schemas.openxmlformats.org/drawingml/2006/main" noGrp="1"/>
+          </p:cNvSpPr>
+          <p:nvPr/>
+        </p:nvSpPr>
+        <p:spPr>
+          <a:xfrm xmlns:a="http://schemas.openxmlformats.org/drawingml/2006/main">
+            <a:off x="3257550" y="3028950"/>
+            <a:ext cx="47625" cy="876300"/>
           </a:xfrm>
           <a:prstGeom xmlns:a="http://schemas.openxmlformats.org/drawingml/2006/main" prst="rect">
             <a:avLst/>
@@ -5117,18 +5117,18 @@
           <p:cNvPr id="27" name="">
             <a:extLst xmlns:a="http://schemas.openxmlformats.org/drawingml/2006/main">
               <a:ext uri="{FF2B5EF4-FFF2-40B4-BE49-F238E27FC236}">
-                <a16:creationId xmlns:a16="http://schemas.microsoft.com/office/drawing/2014/main" id="{FF0E0665-0F12-4D96-B1DB-59EAE48130B8}"/>
-              </a:ext>
-            </a:extLst>
-          </p:cNvPr>
-          <p:cNvSpPr>
-            <a:spLocks xmlns:a="http://schemas.openxmlformats.org/drawingml/2006/main" noGrp="1"/>
-          </p:cNvSpPr>
-          <p:nvPr/>
-        </p:nvSpPr>
-        <p:spPr>
-          <a:xfrm xmlns:a="http://schemas.openxmlformats.org/drawingml/2006/main">
-            <a:off x="3467100" y="3257550"/>
+                <a16:creationId xmlns:a16="http://schemas.microsoft.com/office/drawing/2014/main" id="{7F5589DA-AEFF-43D1-A33A-2630E2BF6384}"/>
+              </a:ext>
+            </a:extLst>
+          </p:cNvPr>
+          <p:cNvSpPr>
+            <a:spLocks xmlns:a="http://schemas.openxmlformats.org/drawingml/2006/main" noGrp="1"/>
+          </p:cNvSpPr>
+          <p:nvPr/>
+        </p:nvSpPr>
+        <p:spPr>
+          <a:xfrm xmlns:a="http://schemas.openxmlformats.org/drawingml/2006/main">
+            <a:off x="3467100" y="3181350"/>
             <a:ext cx="1771650" cy="234791"/>
           </a:xfrm>
           <a:prstGeom xmlns:a="http://schemas.openxmlformats.org/drawingml/2006/main" prst="rect">
@@ -5176,18 +5176,18 @@
           <p:cNvPr id="28" name="">
             <a:extLst xmlns:a="http://schemas.openxmlformats.org/drawingml/2006/main">
               <a:ext uri="{FF2B5EF4-FFF2-40B4-BE49-F238E27FC236}">
-                <a16:creationId xmlns:a16="http://schemas.microsoft.com/office/drawing/2014/main" id="{55252031-98D6-4210-990B-09069B14770B}"/>
-              </a:ext>
-            </a:extLst>
-          </p:cNvPr>
-          <p:cNvSpPr>
-            <a:spLocks xmlns:a="http://schemas.openxmlformats.org/drawingml/2006/main" noGrp="1"/>
-          </p:cNvSpPr>
-          <p:nvPr/>
-        </p:nvSpPr>
-        <p:spPr>
-          <a:xfrm xmlns:a="http://schemas.openxmlformats.org/drawingml/2006/main">
-            <a:off x="3467100" y="3568541"/>
+                <a16:creationId xmlns:a16="http://schemas.microsoft.com/office/drawing/2014/main" id="{79715C29-4E19-42A6-A4F9-B370DFCB4949}"/>
+              </a:ext>
+            </a:extLst>
+          </p:cNvPr>
+          <p:cNvSpPr>
+            <a:spLocks xmlns:a="http://schemas.openxmlformats.org/drawingml/2006/main" noGrp="1"/>
+          </p:cNvSpPr>
+          <p:nvPr/>
+        </p:nvSpPr>
+        <p:spPr>
+          <a:xfrm xmlns:a="http://schemas.openxmlformats.org/drawingml/2006/main">
+            <a:off x="3467100" y="3492341"/>
             <a:ext cx="1771650" cy="266700"/>
           </a:xfrm>
           <a:prstGeom xmlns:a="http://schemas.openxmlformats.org/drawingml/2006/main" prst="rect">
@@ -5207,7 +5207,7 @@
           <a:lstStyle xmlns:a="http://schemas.openxmlformats.org/drawingml/2006/main"/>
           <a:p xmlns:a="http://schemas.openxmlformats.org/drawingml/2006/main">
             <a:pPr algn="l">
-              <a:defRPr sz="923" b="0">
+              <a:defRPr sz="960" b="0">
                 <a:solidFill>
                   <a:srgbClr val="526179"/>
                 </a:solidFill>
@@ -5217,7 +5217,7 @@
               </a:defRPr>
             </a:pPr>
             <a:r>
-              <a:rPr sz="923" b="0">
+              <a:rPr sz="960" b="0">
                 <a:solidFill>
                   <a:srgbClr val="526179"/>
                 </a:solidFill>
@@ -5235,19 +5235,19 @@
           <p:cNvPr id="29" name="">
             <a:extLst xmlns:a="http://schemas.openxmlformats.org/drawingml/2006/main">
               <a:ext uri="{FF2B5EF4-FFF2-40B4-BE49-F238E27FC236}">
-                <a16:creationId xmlns:a16="http://schemas.microsoft.com/office/drawing/2014/main" id="{50D07359-3154-4445-B1B5-A8B6391302EB}"/>
-              </a:ext>
-            </a:extLst>
-          </p:cNvPr>
-          <p:cNvSpPr>
-            <a:spLocks xmlns:a="http://schemas.openxmlformats.org/drawingml/2006/main" noGrp="1"/>
-          </p:cNvSpPr>
-          <p:nvPr/>
-        </p:nvSpPr>
-        <p:spPr>
-          <a:xfrm xmlns:a="http://schemas.openxmlformats.org/drawingml/2006/main">
-            <a:off x="704850" y="4019550"/>
-            <a:ext cx="2190750" cy="723900"/>
+                <a16:creationId xmlns:a16="http://schemas.microsoft.com/office/drawing/2014/main" id="{9CBEE1F2-FA83-43A7-8096-62D1546BFD88}"/>
+              </a:ext>
+            </a:extLst>
+          </p:cNvPr>
+          <p:cNvSpPr>
+            <a:spLocks xmlns:a="http://schemas.openxmlformats.org/drawingml/2006/main" noGrp="1"/>
+          </p:cNvSpPr>
+          <p:nvPr/>
+        </p:nvSpPr>
+        <p:spPr>
+          <a:xfrm xmlns:a="http://schemas.openxmlformats.org/drawingml/2006/main">
+            <a:off x="704850" y="4057650"/>
+            <a:ext cx="2190750" cy="876300"/>
           </a:xfrm>
           <a:prstGeom xmlns:a="http://schemas.openxmlformats.org/drawingml/2006/main" prst="rect">
             <a:avLst/>
@@ -5267,19 +5267,19 @@
           <p:cNvPr id="30" name="">
             <a:extLst xmlns:a="http://schemas.openxmlformats.org/drawingml/2006/main">
               <a:ext uri="{FF2B5EF4-FFF2-40B4-BE49-F238E27FC236}">
-                <a16:creationId xmlns:a16="http://schemas.microsoft.com/office/drawing/2014/main" id="{E319AB31-1224-4DA0-BF70-506D8FB897D5}"/>
-              </a:ext>
-            </a:extLst>
-          </p:cNvPr>
-          <p:cNvSpPr>
-            <a:spLocks xmlns:a="http://schemas.openxmlformats.org/drawingml/2006/main" noGrp="1"/>
-          </p:cNvSpPr>
-          <p:nvPr/>
-        </p:nvSpPr>
-        <p:spPr>
-          <a:xfrm xmlns:a="http://schemas.openxmlformats.org/drawingml/2006/main">
-            <a:off x="704850" y="4019550"/>
-            <a:ext cx="47625" cy="723900"/>
+                <a16:creationId xmlns:a16="http://schemas.microsoft.com/office/drawing/2014/main" id="{5C441B44-C824-4350-82B5-BAE71FEF2ECA}"/>
+              </a:ext>
+            </a:extLst>
+          </p:cNvPr>
+          <p:cNvSpPr>
+            <a:spLocks xmlns:a="http://schemas.openxmlformats.org/drawingml/2006/main" noGrp="1"/>
+          </p:cNvSpPr>
+          <p:nvPr/>
+        </p:nvSpPr>
+        <p:spPr>
+          <a:xfrm xmlns:a="http://schemas.openxmlformats.org/drawingml/2006/main">
+            <a:off x="704850" y="4057650"/>
+            <a:ext cx="47625" cy="876300"/>
           </a:xfrm>
           <a:prstGeom xmlns:a="http://schemas.openxmlformats.org/drawingml/2006/main" prst="rect">
             <a:avLst/>
@@ -5297,18 +5297,18 @@
           <p:cNvPr id="31" name="">
             <a:extLst xmlns:a="http://schemas.openxmlformats.org/drawingml/2006/main">
               <a:ext uri="{FF2B5EF4-FFF2-40B4-BE49-F238E27FC236}">
-                <a16:creationId xmlns:a16="http://schemas.microsoft.com/office/drawing/2014/main" id="{0A7C70BA-9D3F-4802-B519-1B732C62F1D0}"/>
-              </a:ext>
-            </a:extLst>
-          </p:cNvPr>
-          <p:cNvSpPr>
-            <a:spLocks xmlns:a="http://schemas.openxmlformats.org/drawingml/2006/main" noGrp="1"/>
-          </p:cNvSpPr>
-          <p:nvPr/>
-        </p:nvSpPr>
-        <p:spPr>
-          <a:xfrm xmlns:a="http://schemas.openxmlformats.org/drawingml/2006/main">
-            <a:off x="914400" y="4171950"/>
+                <a16:creationId xmlns:a16="http://schemas.microsoft.com/office/drawing/2014/main" id="{F97307AD-BFA0-4770-B93B-B995075002CE}"/>
+              </a:ext>
+            </a:extLst>
+          </p:cNvPr>
+          <p:cNvSpPr>
+            <a:spLocks xmlns:a="http://schemas.openxmlformats.org/drawingml/2006/main" noGrp="1"/>
+          </p:cNvSpPr>
+          <p:nvPr/>
+        </p:nvSpPr>
+        <p:spPr>
+          <a:xfrm xmlns:a="http://schemas.openxmlformats.org/drawingml/2006/main">
+            <a:off x="914400" y="4210050"/>
             <a:ext cx="1771650" cy="234791"/>
           </a:xfrm>
           <a:prstGeom xmlns:a="http://schemas.openxmlformats.org/drawingml/2006/main" prst="rect">
@@ -5356,18 +5356,18 @@
           <p:cNvPr id="32" name="">
             <a:extLst xmlns:a="http://schemas.openxmlformats.org/drawingml/2006/main">
               <a:ext uri="{FF2B5EF4-FFF2-40B4-BE49-F238E27FC236}">
-                <a16:creationId xmlns:a16="http://schemas.microsoft.com/office/drawing/2014/main" id="{21171244-632F-411B-8083-41041FBC9CD2}"/>
-              </a:ext>
-            </a:extLst>
-          </p:cNvPr>
-          <p:cNvSpPr>
-            <a:spLocks xmlns:a="http://schemas.openxmlformats.org/drawingml/2006/main" noGrp="1"/>
-          </p:cNvSpPr>
-          <p:nvPr/>
-        </p:nvSpPr>
-        <p:spPr>
-          <a:xfrm xmlns:a="http://schemas.openxmlformats.org/drawingml/2006/main">
-            <a:off x="914400" y="4482941"/>
+                <a16:creationId xmlns:a16="http://schemas.microsoft.com/office/drawing/2014/main" id="{EE8850E0-640E-4145-9A1D-726A19F75335}"/>
+              </a:ext>
+            </a:extLst>
+          </p:cNvPr>
+          <p:cNvSpPr>
+            <a:spLocks xmlns:a="http://schemas.openxmlformats.org/drawingml/2006/main" noGrp="1"/>
+          </p:cNvSpPr>
+          <p:nvPr/>
+        </p:nvSpPr>
+        <p:spPr>
+          <a:xfrm xmlns:a="http://schemas.openxmlformats.org/drawingml/2006/main">
+            <a:off x="914400" y="4521041"/>
             <a:ext cx="1771650" cy="266700"/>
           </a:xfrm>
           <a:prstGeom xmlns:a="http://schemas.openxmlformats.org/drawingml/2006/main" prst="rect">
@@ -5387,7 +5387,7 @@
           <a:lstStyle xmlns:a="http://schemas.openxmlformats.org/drawingml/2006/main"/>
           <a:p xmlns:a="http://schemas.openxmlformats.org/drawingml/2006/main">
             <a:pPr algn="l">
-              <a:defRPr sz="923" b="0">
+              <a:defRPr sz="960" b="0">
                 <a:solidFill>
                   <a:srgbClr val="526179"/>
                 </a:solidFill>
@@ -5397,7 +5397,7 @@
               </a:defRPr>
             </a:pPr>
             <a:r>
-              <a:rPr sz="923" b="0">
+              <a:rPr sz="960" b="0">
                 <a:solidFill>
                   <a:srgbClr val="526179"/>
                 </a:solidFill>
@@ -5415,19 +5415,19 @@
           <p:cNvPr id="33" name="">
             <a:extLst xmlns:a="http://schemas.openxmlformats.org/drawingml/2006/main">
               <a:ext uri="{FF2B5EF4-FFF2-40B4-BE49-F238E27FC236}">
-                <a16:creationId xmlns:a16="http://schemas.microsoft.com/office/drawing/2014/main" id="{55F050FD-E02C-4BF2-A96B-93C227157855}"/>
-              </a:ext>
-            </a:extLst>
-          </p:cNvPr>
-          <p:cNvSpPr>
-            <a:spLocks xmlns:a="http://schemas.openxmlformats.org/drawingml/2006/main" noGrp="1"/>
-          </p:cNvSpPr>
-          <p:nvPr/>
-        </p:nvSpPr>
-        <p:spPr>
-          <a:xfrm xmlns:a="http://schemas.openxmlformats.org/drawingml/2006/main">
-            <a:off x="3257550" y="4019550"/>
-            <a:ext cx="2190750" cy="723900"/>
+                <a16:creationId xmlns:a16="http://schemas.microsoft.com/office/drawing/2014/main" id="{8C0AE33B-E2BB-4560-8E9D-62BD8E94B23D}"/>
+              </a:ext>
+            </a:extLst>
+          </p:cNvPr>
+          <p:cNvSpPr>
+            <a:spLocks xmlns:a="http://schemas.openxmlformats.org/drawingml/2006/main" noGrp="1"/>
+          </p:cNvSpPr>
+          <p:nvPr/>
+        </p:nvSpPr>
+        <p:spPr>
+          <a:xfrm xmlns:a="http://schemas.openxmlformats.org/drawingml/2006/main">
+            <a:off x="3257550" y="4057650"/>
+            <a:ext cx="2190750" cy="876300"/>
           </a:xfrm>
           <a:prstGeom xmlns:a="http://schemas.openxmlformats.org/drawingml/2006/main" prst="rect">
             <a:avLst/>
@@ -5447,19 +5447,19 @@
           <p:cNvPr id="34" name="">
             <a:extLst xmlns:a="http://schemas.openxmlformats.org/drawingml/2006/main">
               <a:ext uri="{FF2B5EF4-FFF2-40B4-BE49-F238E27FC236}">
-                <a16:creationId xmlns:a16="http://schemas.microsoft.com/office/drawing/2014/main" id="{45D149FD-0DDD-4CF4-953A-121BB85E17C8}"/>
-              </a:ext>
-            </a:extLst>
-          </p:cNvPr>
-          <p:cNvSpPr>
-            <a:spLocks xmlns:a="http://schemas.openxmlformats.org/drawingml/2006/main" noGrp="1"/>
-          </p:cNvSpPr>
-          <p:nvPr/>
-        </p:nvSpPr>
-        <p:spPr>
-          <a:xfrm xmlns:a="http://schemas.openxmlformats.org/drawingml/2006/main">
-            <a:off x="3257550" y="4019550"/>
-            <a:ext cx="47625" cy="723900"/>
+                <a16:creationId xmlns:a16="http://schemas.microsoft.com/office/drawing/2014/main" id="{A69247B8-1ECC-4F9D-BF14-C35E4F06B830}"/>
+              </a:ext>
+            </a:extLst>
+          </p:cNvPr>
+          <p:cNvSpPr>
+            <a:spLocks xmlns:a="http://schemas.openxmlformats.org/drawingml/2006/main" noGrp="1"/>
+          </p:cNvSpPr>
+          <p:nvPr/>
+        </p:nvSpPr>
+        <p:spPr>
+          <a:xfrm xmlns:a="http://schemas.openxmlformats.org/drawingml/2006/main">
+            <a:off x="3257550" y="4057650"/>
+            <a:ext cx="47625" cy="876300"/>
           </a:xfrm>
           <a:prstGeom xmlns:a="http://schemas.openxmlformats.org/drawingml/2006/main" prst="rect">
             <a:avLst/>
@@ -5477,18 +5477,18 @@
           <p:cNvPr id="35" name="">
             <a:extLst xmlns:a="http://schemas.openxmlformats.org/drawingml/2006/main">
               <a:ext uri="{FF2B5EF4-FFF2-40B4-BE49-F238E27FC236}">
-                <a16:creationId xmlns:a16="http://schemas.microsoft.com/office/drawing/2014/main" id="{C0CAEC59-F950-4F4E-9704-B19F05C10A4A}"/>
-              </a:ext>
-            </a:extLst>
-          </p:cNvPr>
-          <p:cNvSpPr>
-            <a:spLocks xmlns:a="http://schemas.openxmlformats.org/drawingml/2006/main" noGrp="1"/>
-          </p:cNvSpPr>
-          <p:nvPr/>
-        </p:nvSpPr>
-        <p:spPr>
-          <a:xfrm xmlns:a="http://schemas.openxmlformats.org/drawingml/2006/main">
-            <a:off x="3467100" y="4171950"/>
+                <a16:creationId xmlns:a16="http://schemas.microsoft.com/office/drawing/2014/main" id="{7B0BD99F-7BFE-4A68-B0CD-DB55AE19F643}"/>
+              </a:ext>
+            </a:extLst>
+          </p:cNvPr>
+          <p:cNvSpPr>
+            <a:spLocks xmlns:a="http://schemas.openxmlformats.org/drawingml/2006/main" noGrp="1"/>
+          </p:cNvSpPr>
+          <p:nvPr/>
+        </p:nvSpPr>
+        <p:spPr>
+          <a:xfrm xmlns:a="http://schemas.openxmlformats.org/drawingml/2006/main">
+            <a:off x="3467100" y="4210050"/>
             <a:ext cx="1771650" cy="234791"/>
           </a:xfrm>
           <a:prstGeom xmlns:a="http://schemas.openxmlformats.org/drawingml/2006/main" prst="rect">
@@ -5536,18 +5536,18 @@
           <p:cNvPr id="36" name="">
             <a:extLst xmlns:a="http://schemas.openxmlformats.org/drawingml/2006/main">
               <a:ext uri="{FF2B5EF4-FFF2-40B4-BE49-F238E27FC236}">
-                <a16:creationId xmlns:a16="http://schemas.microsoft.com/office/drawing/2014/main" id="{E41446E7-9CB4-44E8-AFB6-E59B6CCE9A4A}"/>
-              </a:ext>
-            </a:extLst>
-          </p:cNvPr>
-          <p:cNvSpPr>
-            <a:spLocks xmlns:a="http://schemas.openxmlformats.org/drawingml/2006/main" noGrp="1"/>
-          </p:cNvSpPr>
-          <p:nvPr/>
-        </p:nvSpPr>
-        <p:spPr>
-          <a:xfrm xmlns:a="http://schemas.openxmlformats.org/drawingml/2006/main">
-            <a:off x="3467100" y="4482941"/>
+                <a16:creationId xmlns:a16="http://schemas.microsoft.com/office/drawing/2014/main" id="{2A5E6673-6247-47EE-9B09-6E9A15E576A0}"/>
+              </a:ext>
+            </a:extLst>
+          </p:cNvPr>
+          <p:cNvSpPr>
+            <a:spLocks xmlns:a="http://schemas.openxmlformats.org/drawingml/2006/main" noGrp="1"/>
+          </p:cNvSpPr>
+          <p:nvPr/>
+        </p:nvSpPr>
+        <p:spPr>
+          <a:xfrm xmlns:a="http://schemas.openxmlformats.org/drawingml/2006/main">
+            <a:off x="3467100" y="4521041"/>
             <a:ext cx="1771650" cy="266700"/>
           </a:xfrm>
           <a:prstGeom xmlns:a="http://schemas.openxmlformats.org/drawingml/2006/main" prst="rect">
@@ -5567,7 +5567,7 @@
           <a:lstStyle xmlns:a="http://schemas.openxmlformats.org/drawingml/2006/main"/>
           <a:p xmlns:a="http://schemas.openxmlformats.org/drawingml/2006/main">
             <a:pPr algn="l">
-              <a:defRPr sz="923" b="0">
+              <a:defRPr sz="960" b="0">
                 <a:solidFill>
                   <a:srgbClr val="526179"/>
                 </a:solidFill>
@@ -5577,7 +5577,7 @@
               </a:defRPr>
             </a:pPr>
             <a:r>
-              <a:rPr sz="923" b="0">
+              <a:rPr sz="960" b="0">
                 <a:solidFill>
                   <a:srgbClr val="526179"/>
                 </a:solidFill>
@@ -5585,7 +5585,7 @@
                 <a:ea typeface="Aptos"/>
                 <a:cs typeface="Aptos"/>
               </a:rPr>
-              <a:t>Add a checklist or diagnostic skill.</a:t>
+              <a:t>Add checklist or diagnostic skill.</a:t>
             </a:r>
           </a:p>
         </p:txBody>
@@ -5595,7 +5595,7 @@
           <p:cNvPr id="37" name="">
             <a:extLst xmlns:a="http://schemas.openxmlformats.org/drawingml/2006/main">
               <a:ext uri="{FF2B5EF4-FFF2-40B4-BE49-F238E27FC236}">
-                <a16:creationId xmlns:a16="http://schemas.microsoft.com/office/drawing/2014/main" id="{6C77FD35-0652-4267-BB5C-5B60BC8F8BE0}"/>
+                <a16:creationId xmlns:a16="http://schemas.microsoft.com/office/drawing/2014/main" id="{00A2A782-FCDF-46D8-A1DA-B2DAE4FA5C70}"/>
               </a:ext>
             </a:extLst>
           </p:cNvPr>
@@ -5627,7 +5627,7 @@
           <p:cNvPr id="38" name="">
             <a:extLst xmlns:a="http://schemas.openxmlformats.org/drawingml/2006/main">
               <a:ext uri="{FF2B5EF4-FFF2-40B4-BE49-F238E27FC236}">
-                <a16:creationId xmlns:a16="http://schemas.microsoft.com/office/drawing/2014/main" id="{88721B6B-C2C7-42DE-9772-FB9D41C20503}"/>
+                <a16:creationId xmlns:a16="http://schemas.microsoft.com/office/drawing/2014/main" id="{6771EBBC-137D-4F5C-A600-F1E26CB5E4BD}"/>
               </a:ext>
             </a:extLst>
           </p:cNvPr>
@@ -5684,7 +5684,7 @@
     </p:spTree>
     <p:extLst>
       <p:ext uri="{BB962C8B-B14F-4D97-AF65-F5344CB8AC3E}">
-        <p14:creationId xmlns:p14="http://schemas.microsoft.com/office/powerpoint/2010/main" val="765995606"/>
+        <p14:creationId xmlns:p14="http://schemas.microsoft.com/office/powerpoint/2010/main" val="2046799727"/>
       </p:ext>
     </p:extLst>
   </p:cSld>
@@ -5708,7 +5708,7 @@
           <p:cNvPr id="1" name="">
             <a:extLst xmlns:a="http://schemas.openxmlformats.org/drawingml/2006/main">
               <a:ext uri="{FF2B5EF4-FFF2-40B4-BE49-F238E27FC236}">
-                <a16:creationId xmlns:a16="http://schemas.microsoft.com/office/drawing/2014/main" id="{C0F81682-6BC4-4EBF-99FA-05A42E979955}"/>
+                <a16:creationId xmlns:a16="http://schemas.microsoft.com/office/drawing/2014/main" id="{989DEB69-0D51-40E1-93C4-922CE3BD67B5}"/>
               </a:ext>
             </a:extLst>
           </p:cNvPr>
@@ -5738,7 +5738,7 @@
           <p:cNvPr id="2" name="">
             <a:extLst xmlns:a="http://schemas.openxmlformats.org/drawingml/2006/main">
               <a:ext uri="{FF2B5EF4-FFF2-40B4-BE49-F238E27FC236}">
-                <a16:creationId xmlns:a16="http://schemas.microsoft.com/office/drawing/2014/main" id="{EF04125E-23F8-481E-BFE6-C12E3A24257E}"/>
+                <a16:creationId xmlns:a16="http://schemas.microsoft.com/office/drawing/2014/main" id="{6384CE59-A2F9-40E1-B6F1-06D15289673B}"/>
               </a:ext>
             </a:extLst>
           </p:cNvPr>
@@ -5768,7 +5768,7 @@
           <p:cNvPr id="3" name="">
             <a:extLst xmlns:a="http://schemas.openxmlformats.org/drawingml/2006/main">
               <a:ext uri="{FF2B5EF4-FFF2-40B4-BE49-F238E27FC236}">
-                <a16:creationId xmlns:a16="http://schemas.microsoft.com/office/drawing/2014/main" id="{38F79F6E-9E6F-454B-863A-F161EF35B2D6}"/>
+                <a16:creationId xmlns:a16="http://schemas.microsoft.com/office/drawing/2014/main" id="{1C894F91-A2AA-4AF3-B236-CA65EA6ED6F0}"/>
               </a:ext>
             </a:extLst>
           </p:cNvPr>
@@ -5827,7 +5827,7 @@
           <p:cNvPr id="4" name="">
             <a:extLst xmlns:a="http://schemas.openxmlformats.org/drawingml/2006/main">
               <a:ext uri="{FF2B5EF4-FFF2-40B4-BE49-F238E27FC236}">
-                <a16:creationId xmlns:a16="http://schemas.microsoft.com/office/drawing/2014/main" id="{F5609489-00DD-44BE-90E5-A2BE49AC31A1}"/>
+                <a16:creationId xmlns:a16="http://schemas.microsoft.com/office/drawing/2014/main" id="{A88B0A1B-E937-47B8-A4AC-7E06386856FD}"/>
               </a:ext>
             </a:extLst>
           </p:cNvPr>
@@ -5886,7 +5886,7 @@
           <p:cNvPr id="5" name="">
             <a:extLst xmlns:a="http://schemas.openxmlformats.org/drawingml/2006/main">
               <a:ext uri="{FF2B5EF4-FFF2-40B4-BE49-F238E27FC236}">
-                <a16:creationId xmlns:a16="http://schemas.microsoft.com/office/drawing/2014/main" id="{D5614061-F018-420D-8474-1C9D38921EFF}"/>
+                <a16:creationId xmlns:a16="http://schemas.microsoft.com/office/drawing/2014/main" id="{EC0EFF25-FAB9-497B-A185-FFFF7CE17CE1}"/>
               </a:ext>
             </a:extLst>
           </p:cNvPr>
@@ -5945,7 +5945,7 @@
           <p:cNvPr id="6" name="">
             <a:extLst xmlns:a="http://schemas.openxmlformats.org/drawingml/2006/main">
               <a:ext uri="{FF2B5EF4-FFF2-40B4-BE49-F238E27FC236}">
-                <a16:creationId xmlns:a16="http://schemas.microsoft.com/office/drawing/2014/main" id="{A0AD69D2-F8B5-48F4-8AAF-CF1F4D1E4FAF}"/>
+                <a16:creationId xmlns:a16="http://schemas.microsoft.com/office/drawing/2014/main" id="{E7B0E6A5-3A7E-4D0F-A916-3E7FAF261C89}"/>
               </a:ext>
             </a:extLst>
           </p:cNvPr>
@@ -6008,7 +6008,7 @@
           <p:nvPr/>
         </p:nvPicPr>
         <p:blipFill>
-          <a:blip xmlns:r="http://schemas.openxmlformats.org/officeDocument/2006/relationships" xmlns:a="http://schemas.openxmlformats.org/drawingml/2006/main" r:embed="R926b541c7c5e412b"/>
+          <a:blip xmlns:r="http://schemas.openxmlformats.org/officeDocument/2006/relationships" xmlns:a="http://schemas.openxmlformats.org/drawingml/2006/main" r:embed="R79158f910fe540f4"/>
           <a:srcRect xmlns:a="http://schemas.openxmlformats.org/drawingml/2006/main" l="0" t="914" r="0" b="914"/>
           <a:stretch xmlns:a="http://schemas.openxmlformats.org/drawingml/2006/main">
             <a:fillRect l="0" t="0" r="0" b="0"/>
@@ -6029,7 +6029,7 @@
           <p:cNvPr id="8" name="">
             <a:extLst xmlns:a="http://schemas.openxmlformats.org/drawingml/2006/main">
               <a:ext uri="{FF2B5EF4-FFF2-40B4-BE49-F238E27FC236}">
-                <a16:creationId xmlns:a16="http://schemas.microsoft.com/office/drawing/2014/main" id="{09354B63-E563-4520-A330-BD27C5E2573F}"/>
+                <a16:creationId xmlns:a16="http://schemas.microsoft.com/office/drawing/2014/main" id="{54F9B944-FEB9-4134-BB73-9BD3F950176A}"/>
               </a:ext>
             </a:extLst>
           </p:cNvPr>
@@ -6061,7 +6061,7 @@
           <p:cNvPr id="9" name="">
             <a:extLst xmlns:a="http://schemas.openxmlformats.org/drawingml/2006/main">
               <a:ext uri="{FF2B5EF4-FFF2-40B4-BE49-F238E27FC236}">
-                <a16:creationId xmlns:a16="http://schemas.microsoft.com/office/drawing/2014/main" id="{CC8D14D8-82DD-4E43-B2CD-3F638BA688E9}"/>
+                <a16:creationId xmlns:a16="http://schemas.microsoft.com/office/drawing/2014/main" id="{240BCD10-8DD8-417B-89FB-7F4797C93795}"/>
               </a:ext>
             </a:extLst>
           </p:cNvPr>
@@ -6095,7 +6095,7 @@
           <p:cNvPr id="10" name="">
             <a:extLst xmlns:a="http://schemas.openxmlformats.org/drawingml/2006/main">
               <a:ext uri="{FF2B5EF4-FFF2-40B4-BE49-F238E27FC236}">
-                <a16:creationId xmlns:a16="http://schemas.microsoft.com/office/drawing/2014/main" id="{477C12E9-0B8C-44D9-B552-1F27D56BC76E}"/>
+                <a16:creationId xmlns:a16="http://schemas.microsoft.com/office/drawing/2014/main" id="{E533F0FB-4513-41F8-8CE5-FD8C42BA6480}"/>
               </a:ext>
             </a:extLst>
           </p:cNvPr>
@@ -6127,7 +6127,7 @@
           <p:cNvPr id="11" name="">
             <a:extLst xmlns:a="http://schemas.openxmlformats.org/drawingml/2006/main">
               <a:ext uri="{FF2B5EF4-FFF2-40B4-BE49-F238E27FC236}">
-                <a16:creationId xmlns:a16="http://schemas.microsoft.com/office/drawing/2014/main" id="{889CD8CD-D4F0-4DF5-B2B6-024ADFDCADC9}"/>
+                <a16:creationId xmlns:a16="http://schemas.microsoft.com/office/drawing/2014/main" id="{BFE2F40A-11A8-4E57-AE8E-95A0D1905E13}"/>
               </a:ext>
             </a:extLst>
           </p:cNvPr>
@@ -6157,7 +6157,7 @@
           <p:cNvPr id="12" name="">
             <a:extLst xmlns:a="http://schemas.openxmlformats.org/drawingml/2006/main">
               <a:ext uri="{FF2B5EF4-FFF2-40B4-BE49-F238E27FC236}">
-                <a16:creationId xmlns:a16="http://schemas.microsoft.com/office/drawing/2014/main" id="{1F1A7446-1B4A-4832-9952-50F69EC09E45}"/>
+                <a16:creationId xmlns:a16="http://schemas.microsoft.com/office/drawing/2014/main" id="{97D83BA4-8AA7-4A08-A4AB-5837F46417FD}"/>
               </a:ext>
             </a:extLst>
           </p:cNvPr>
@@ -6216,7 +6216,7 @@
           <p:cNvPr id="13" name="">
             <a:extLst xmlns:a="http://schemas.openxmlformats.org/drawingml/2006/main">
               <a:ext uri="{FF2B5EF4-FFF2-40B4-BE49-F238E27FC236}">
-                <a16:creationId xmlns:a16="http://schemas.microsoft.com/office/drawing/2014/main" id="{7CB60FF2-7665-4BE3-8043-D96B8AD1622A}"/>
+                <a16:creationId xmlns:a16="http://schemas.microsoft.com/office/drawing/2014/main" id="{19C7C62C-783C-479A-85F3-D73606E74CE1}"/>
               </a:ext>
             </a:extLst>
           </p:cNvPr>
@@ -6275,7 +6275,7 @@
           <p:cNvPr id="14" name="">
             <a:extLst xmlns:a="http://schemas.openxmlformats.org/drawingml/2006/main">
               <a:ext uri="{FF2B5EF4-FFF2-40B4-BE49-F238E27FC236}">
-                <a16:creationId xmlns:a16="http://schemas.microsoft.com/office/drawing/2014/main" id="{64A41E25-94FC-49E1-B336-C46DAC53AE68}"/>
+                <a16:creationId xmlns:a16="http://schemas.microsoft.com/office/drawing/2014/main" id="{66995B74-E199-4AC5-9B9F-18F616A6EE34}"/>
               </a:ext>
             </a:extLst>
           </p:cNvPr>
@@ -6307,7 +6307,7 @@
           <p:cNvPr id="15" name="">
             <a:extLst xmlns:a="http://schemas.openxmlformats.org/drawingml/2006/main">
               <a:ext uri="{FF2B5EF4-FFF2-40B4-BE49-F238E27FC236}">
-                <a16:creationId xmlns:a16="http://schemas.microsoft.com/office/drawing/2014/main" id="{C9C51CB2-CD6D-4E08-B919-5D27A4F44260}"/>
+                <a16:creationId xmlns:a16="http://schemas.microsoft.com/office/drawing/2014/main" id="{4BE1BC25-321B-4062-A8D5-8CF3BCA7EC6F}"/>
               </a:ext>
             </a:extLst>
           </p:cNvPr>
@@ -6337,7 +6337,7 @@
           <p:cNvPr id="16" name="">
             <a:extLst xmlns:a="http://schemas.openxmlformats.org/drawingml/2006/main">
               <a:ext uri="{FF2B5EF4-FFF2-40B4-BE49-F238E27FC236}">
-                <a16:creationId xmlns:a16="http://schemas.microsoft.com/office/drawing/2014/main" id="{A9F8BBA5-EC22-461A-9FFC-78F06A9F9EF0}"/>
+                <a16:creationId xmlns:a16="http://schemas.microsoft.com/office/drawing/2014/main" id="{12FAD0FE-1309-42E6-BDA8-01ACCACD7B2D}"/>
               </a:ext>
             </a:extLst>
           </p:cNvPr>
@@ -6396,7 +6396,7 @@
           <p:cNvPr id="17" name="">
             <a:extLst xmlns:a="http://schemas.openxmlformats.org/drawingml/2006/main">
               <a:ext uri="{FF2B5EF4-FFF2-40B4-BE49-F238E27FC236}">
-                <a16:creationId xmlns:a16="http://schemas.microsoft.com/office/drawing/2014/main" id="{EB6DBB16-ECB7-4E8C-9964-4D3B9CBB0A15}"/>
+                <a16:creationId xmlns:a16="http://schemas.microsoft.com/office/drawing/2014/main" id="{C58FEEEB-8FA9-4CB3-9C7F-6C59EB6ED9B2}"/>
               </a:ext>
             </a:extLst>
           </p:cNvPr>
@@ -6455,7 +6455,7 @@
           <p:cNvPr id="18" name="">
             <a:extLst xmlns:a="http://schemas.openxmlformats.org/drawingml/2006/main">
               <a:ext uri="{FF2B5EF4-FFF2-40B4-BE49-F238E27FC236}">
-                <a16:creationId xmlns:a16="http://schemas.microsoft.com/office/drawing/2014/main" id="{1A8091F5-78F1-4745-9AFD-42A689CE2BF7}"/>
+                <a16:creationId xmlns:a16="http://schemas.microsoft.com/office/drawing/2014/main" id="{792E1119-ED6A-4B17-8B15-851FF2756F20}"/>
               </a:ext>
             </a:extLst>
           </p:cNvPr>
@@ -6487,7 +6487,7 @@
           <p:cNvPr id="19" name="">
             <a:extLst xmlns:a="http://schemas.openxmlformats.org/drawingml/2006/main">
               <a:ext uri="{FF2B5EF4-FFF2-40B4-BE49-F238E27FC236}">
-                <a16:creationId xmlns:a16="http://schemas.microsoft.com/office/drawing/2014/main" id="{C6A419F1-90D2-4A4C-950B-677CFBE08D83}"/>
+                <a16:creationId xmlns:a16="http://schemas.microsoft.com/office/drawing/2014/main" id="{E1D9E291-CC84-4044-82FC-18119DA6C787}"/>
               </a:ext>
             </a:extLst>
           </p:cNvPr>
@@ -6517,7 +6517,7 @@
           <p:cNvPr id="20" name="">
             <a:extLst xmlns:a="http://schemas.openxmlformats.org/drawingml/2006/main">
               <a:ext uri="{FF2B5EF4-FFF2-40B4-BE49-F238E27FC236}">
-                <a16:creationId xmlns:a16="http://schemas.microsoft.com/office/drawing/2014/main" id="{9977C6DF-4D58-412E-9B35-B3DD0FBAFCED}"/>
+                <a16:creationId xmlns:a16="http://schemas.microsoft.com/office/drawing/2014/main" id="{0FDC2044-9722-40BE-8024-53521C2B994B}"/>
               </a:ext>
             </a:extLst>
           </p:cNvPr>
@@ -6576,7 +6576,7 @@
           <p:cNvPr id="21" name="">
             <a:extLst xmlns:a="http://schemas.openxmlformats.org/drawingml/2006/main">
               <a:ext uri="{FF2B5EF4-FFF2-40B4-BE49-F238E27FC236}">
-                <a16:creationId xmlns:a16="http://schemas.microsoft.com/office/drawing/2014/main" id="{BF7933FD-F786-43C1-BA1C-142358F8D1AD}"/>
+                <a16:creationId xmlns:a16="http://schemas.microsoft.com/office/drawing/2014/main" id="{41E0E0D2-18BF-4B98-A3BE-D1E528403BC4}"/>
               </a:ext>
             </a:extLst>
           </p:cNvPr>
@@ -6635,7 +6635,7 @@
           <p:cNvPr id="22" name="">
             <a:extLst xmlns:a="http://schemas.openxmlformats.org/drawingml/2006/main">
               <a:ext uri="{FF2B5EF4-FFF2-40B4-BE49-F238E27FC236}">
-                <a16:creationId xmlns:a16="http://schemas.microsoft.com/office/drawing/2014/main" id="{015BD43A-D8BB-46BD-B56C-20F11D6AC9B9}"/>
+                <a16:creationId xmlns:a16="http://schemas.microsoft.com/office/drawing/2014/main" id="{3C544A59-06D1-43FB-B60E-0A2285DF9E3D}"/>
               </a:ext>
             </a:extLst>
           </p:cNvPr>
@@ -6665,7 +6665,7 @@
           <p:cNvPr id="23" name="">
             <a:extLst xmlns:a="http://schemas.openxmlformats.org/drawingml/2006/main">
               <a:ext uri="{FF2B5EF4-FFF2-40B4-BE49-F238E27FC236}">
-                <a16:creationId xmlns:a16="http://schemas.microsoft.com/office/drawing/2014/main" id="{A0F354FD-AF37-4B78-94BB-B04DA3466653}"/>
+                <a16:creationId xmlns:a16="http://schemas.microsoft.com/office/drawing/2014/main" id="{DB146E74-C94C-41CA-9094-F13755689C73}"/>
               </a:ext>
             </a:extLst>
           </p:cNvPr>
@@ -6695,7 +6695,7 @@
           <p:cNvPr id="24" name="">
             <a:extLst xmlns:a="http://schemas.openxmlformats.org/drawingml/2006/main">
               <a:ext uri="{FF2B5EF4-FFF2-40B4-BE49-F238E27FC236}">
-                <a16:creationId xmlns:a16="http://schemas.microsoft.com/office/drawing/2014/main" id="{59DFBE31-7E1B-4720-8089-684048693700}"/>
+                <a16:creationId xmlns:a16="http://schemas.microsoft.com/office/drawing/2014/main" id="{FFA6EE8E-DBA1-4240-A2F2-BCC492EF6372}"/>
               </a:ext>
             </a:extLst>
           </p:cNvPr>
@@ -6752,7 +6752,7 @@
     </p:spTree>
     <p:extLst>
       <p:ext uri="{BB962C8B-B14F-4D97-AF65-F5344CB8AC3E}">
-        <p14:creationId xmlns:p14="http://schemas.microsoft.com/office/powerpoint/2010/main" val="844174266"/>
+        <p14:creationId xmlns:p14="http://schemas.microsoft.com/office/powerpoint/2010/main" val="835040722"/>
       </p:ext>
     </p:extLst>
   </p:cSld>
@@ -6776,7 +6776,7 @@
           <p:cNvPr id="1" name="">
             <a:extLst xmlns:a="http://schemas.openxmlformats.org/drawingml/2006/main">
               <a:ext uri="{FF2B5EF4-FFF2-40B4-BE49-F238E27FC236}">
-                <a16:creationId xmlns:a16="http://schemas.microsoft.com/office/drawing/2014/main" id="{85B00199-47FB-4E5C-9DC6-5F6C71AA24BC}"/>
+                <a16:creationId xmlns:a16="http://schemas.microsoft.com/office/drawing/2014/main" id="{F6BA5770-EE4B-47B5-B6DC-A09370ECE29F}"/>
               </a:ext>
             </a:extLst>
           </p:cNvPr>
@@ -6806,7 +6806,7 @@
           <p:cNvPr id="2" name="">
             <a:extLst xmlns:a="http://schemas.openxmlformats.org/drawingml/2006/main">
               <a:ext uri="{FF2B5EF4-FFF2-40B4-BE49-F238E27FC236}">
-                <a16:creationId xmlns:a16="http://schemas.microsoft.com/office/drawing/2014/main" id="{6D1EEEAE-E55D-44B2-9698-1E3D96B1BE67}"/>
+                <a16:creationId xmlns:a16="http://schemas.microsoft.com/office/drawing/2014/main" id="{9D7F489E-1E60-4E55-9A13-AE05D4BA9A33}"/>
               </a:ext>
             </a:extLst>
           </p:cNvPr>
@@ -6836,7 +6836,7 @@
           <p:cNvPr id="3" name="">
             <a:extLst xmlns:a="http://schemas.openxmlformats.org/drawingml/2006/main">
               <a:ext uri="{FF2B5EF4-FFF2-40B4-BE49-F238E27FC236}">
-                <a16:creationId xmlns:a16="http://schemas.microsoft.com/office/drawing/2014/main" id="{831E9431-F000-4684-B32E-F83137E9EDC6}"/>
+                <a16:creationId xmlns:a16="http://schemas.microsoft.com/office/drawing/2014/main" id="{CF8C9E85-DC8B-4494-8C83-F2FB10E65F05}"/>
               </a:ext>
             </a:extLst>
           </p:cNvPr>
@@ -6895,7 +6895,7 @@
           <p:cNvPr id="4" name="">
             <a:extLst xmlns:a="http://schemas.openxmlformats.org/drawingml/2006/main">
               <a:ext uri="{FF2B5EF4-FFF2-40B4-BE49-F238E27FC236}">
-                <a16:creationId xmlns:a16="http://schemas.microsoft.com/office/drawing/2014/main" id="{7D4F1A75-94F0-4539-B154-DDA860B45154}"/>
+                <a16:creationId xmlns:a16="http://schemas.microsoft.com/office/drawing/2014/main" id="{00C310DA-5E7C-4308-AD52-55FDF334D3B5}"/>
               </a:ext>
             </a:extLst>
           </p:cNvPr>
@@ -6954,7 +6954,7 @@
           <p:cNvPr id="5" name="">
             <a:extLst xmlns:a="http://schemas.openxmlformats.org/drawingml/2006/main">
               <a:ext uri="{FF2B5EF4-FFF2-40B4-BE49-F238E27FC236}">
-                <a16:creationId xmlns:a16="http://schemas.microsoft.com/office/drawing/2014/main" id="{0663E109-3FF3-41F2-9245-6004853C2EF1}"/>
+                <a16:creationId xmlns:a16="http://schemas.microsoft.com/office/drawing/2014/main" id="{1FE7FB1C-0B97-49CD-9FFB-D0473AEDE6C1}"/>
               </a:ext>
             </a:extLst>
           </p:cNvPr>
@@ -7013,7 +7013,7 @@
           <p:cNvPr id="6" name="">
             <a:extLst xmlns:a="http://schemas.openxmlformats.org/drawingml/2006/main">
               <a:ext uri="{FF2B5EF4-FFF2-40B4-BE49-F238E27FC236}">
-                <a16:creationId xmlns:a16="http://schemas.microsoft.com/office/drawing/2014/main" id="{C7A2AB37-7A28-48A3-8911-20FB5CF4FB82}"/>
+                <a16:creationId xmlns:a16="http://schemas.microsoft.com/office/drawing/2014/main" id="{4024EBA7-F6DA-4557-9605-BE001C0D0A23}"/>
               </a:ext>
             </a:extLst>
           </p:cNvPr>
@@ -7072,7 +7072,7 @@
           <p:cNvPr id="7" name="">
             <a:extLst xmlns:a="http://schemas.openxmlformats.org/drawingml/2006/main">
               <a:ext uri="{FF2B5EF4-FFF2-40B4-BE49-F238E27FC236}">
-                <a16:creationId xmlns:a16="http://schemas.microsoft.com/office/drawing/2014/main" id="{4BD91FE9-82BE-4007-86B8-5777EC9FE6BA}"/>
+                <a16:creationId xmlns:a16="http://schemas.microsoft.com/office/drawing/2014/main" id="{0A50059C-BCC7-440C-BB1E-F96889E2599B}"/>
               </a:ext>
             </a:extLst>
           </p:cNvPr>
@@ -7102,7 +7102,7 @@
           <p:cNvPr id="8" name="">
             <a:extLst xmlns:a="http://schemas.openxmlformats.org/drawingml/2006/main">
               <a:ext uri="{FF2B5EF4-FFF2-40B4-BE49-F238E27FC236}">
-                <a16:creationId xmlns:a16="http://schemas.microsoft.com/office/drawing/2014/main" id="{2870B502-114A-4498-9DF2-73E54C4868E5}"/>
+                <a16:creationId xmlns:a16="http://schemas.microsoft.com/office/drawing/2014/main" id="{C840E36C-F7C8-4BE3-BF35-D1CCC8AE5C62}"/>
               </a:ext>
             </a:extLst>
           </p:cNvPr>
@@ -7132,7 +7132,7 @@
           <p:cNvPr id="9" name="">
             <a:extLst xmlns:a="http://schemas.openxmlformats.org/drawingml/2006/main">
               <a:ext uri="{FF2B5EF4-FFF2-40B4-BE49-F238E27FC236}">
-                <a16:creationId xmlns:a16="http://schemas.microsoft.com/office/drawing/2014/main" id="{833BAD5E-4BB9-44F8-A21E-0A2FC6659315}"/>
+                <a16:creationId xmlns:a16="http://schemas.microsoft.com/office/drawing/2014/main" id="{36A361AC-ED99-4379-8154-CF24AD4E9460}"/>
               </a:ext>
             </a:extLst>
           </p:cNvPr>
@@ -7191,7 +7191,7 @@
           <p:cNvPr id="10" name="">
             <a:extLst xmlns:a="http://schemas.openxmlformats.org/drawingml/2006/main">
               <a:ext uri="{FF2B5EF4-FFF2-40B4-BE49-F238E27FC236}">
-                <a16:creationId xmlns:a16="http://schemas.microsoft.com/office/drawing/2014/main" id="{F433216F-1F13-4D2C-83A1-9D937B02AEF8}"/>
+                <a16:creationId xmlns:a16="http://schemas.microsoft.com/office/drawing/2014/main" id="{7D70CA78-575F-4720-81E9-BC0AE9701E6E}"/>
               </a:ext>
             </a:extLst>
           </p:cNvPr>
@@ -7223,7 +7223,7 @@
           <p:cNvPr id="11" name="">
             <a:extLst xmlns:a="http://schemas.openxmlformats.org/drawingml/2006/main">
               <a:ext uri="{FF2B5EF4-FFF2-40B4-BE49-F238E27FC236}">
-                <a16:creationId xmlns:a16="http://schemas.microsoft.com/office/drawing/2014/main" id="{15B5E4BE-290A-4320-830F-2B3B4BDC69E7}"/>
+                <a16:creationId xmlns:a16="http://schemas.microsoft.com/office/drawing/2014/main" id="{5B360C77-0165-4414-A214-C060909B5C86}"/>
               </a:ext>
             </a:extLst>
           </p:cNvPr>
@@ -7253,7 +7253,7 @@
           <p:cNvPr id="12" name="">
             <a:extLst xmlns:a="http://schemas.openxmlformats.org/drawingml/2006/main">
               <a:ext uri="{FF2B5EF4-FFF2-40B4-BE49-F238E27FC236}">
-                <a16:creationId xmlns:a16="http://schemas.microsoft.com/office/drawing/2014/main" id="{8030BC76-B672-430B-A32B-73F5A610A71D}"/>
+                <a16:creationId xmlns:a16="http://schemas.microsoft.com/office/drawing/2014/main" id="{A26CAEE1-10C2-428F-BC47-C4463A0C4D41}"/>
               </a:ext>
             </a:extLst>
           </p:cNvPr>
@@ -7312,7 +7312,7 @@
           <p:cNvPr id="13" name="">
             <a:extLst xmlns:a="http://schemas.openxmlformats.org/drawingml/2006/main">
               <a:ext uri="{FF2B5EF4-FFF2-40B4-BE49-F238E27FC236}">
-                <a16:creationId xmlns:a16="http://schemas.microsoft.com/office/drawing/2014/main" id="{9AFF342D-BC2B-45B2-AD3D-789A18911FB1}"/>
+                <a16:creationId xmlns:a16="http://schemas.microsoft.com/office/drawing/2014/main" id="{18D9C272-222E-4419-BE43-E9A854CAE901}"/>
               </a:ext>
             </a:extLst>
           </p:cNvPr>
@@ -7371,7 +7371,7 @@
           <p:cNvPr id="14" name="">
             <a:extLst xmlns:a="http://schemas.openxmlformats.org/drawingml/2006/main">
               <a:ext uri="{FF2B5EF4-FFF2-40B4-BE49-F238E27FC236}">
-                <a16:creationId xmlns:a16="http://schemas.microsoft.com/office/drawing/2014/main" id="{3C60868B-F738-4028-A491-385128A20DCF}"/>
+                <a16:creationId xmlns:a16="http://schemas.microsoft.com/office/drawing/2014/main" id="{7C39B84C-9335-4441-9ED8-CF2E37687D50}"/>
               </a:ext>
             </a:extLst>
           </p:cNvPr>
@@ -7403,7 +7403,7 @@
           <p:cNvPr id="15" name="">
             <a:extLst xmlns:a="http://schemas.openxmlformats.org/drawingml/2006/main">
               <a:ext uri="{FF2B5EF4-FFF2-40B4-BE49-F238E27FC236}">
-                <a16:creationId xmlns:a16="http://schemas.microsoft.com/office/drawing/2014/main" id="{9FC95186-2CA2-41C0-A4DA-8D8B87155552}"/>
+                <a16:creationId xmlns:a16="http://schemas.microsoft.com/office/drawing/2014/main" id="{10C62E97-7A16-4087-9E7D-E367A1A0817D}"/>
               </a:ext>
             </a:extLst>
           </p:cNvPr>
@@ -7433,7 +7433,7 @@
           <p:cNvPr id="16" name="">
             <a:extLst xmlns:a="http://schemas.openxmlformats.org/drawingml/2006/main">
               <a:ext uri="{FF2B5EF4-FFF2-40B4-BE49-F238E27FC236}">
-                <a16:creationId xmlns:a16="http://schemas.microsoft.com/office/drawing/2014/main" id="{9112A08E-4558-471F-B945-66F0AE9AD9E5}"/>
+                <a16:creationId xmlns:a16="http://schemas.microsoft.com/office/drawing/2014/main" id="{7DDC099C-D778-4DC6-90BD-C822DF2452F1}"/>
               </a:ext>
             </a:extLst>
           </p:cNvPr>
@@ -7492,7 +7492,7 @@
           <p:cNvPr id="17" name="">
             <a:extLst xmlns:a="http://schemas.openxmlformats.org/drawingml/2006/main">
               <a:ext uri="{FF2B5EF4-FFF2-40B4-BE49-F238E27FC236}">
-                <a16:creationId xmlns:a16="http://schemas.microsoft.com/office/drawing/2014/main" id="{E3E1E1EB-ADBC-4256-960B-FC7CFAF433B4}"/>
+                <a16:creationId xmlns:a16="http://schemas.microsoft.com/office/drawing/2014/main" id="{A4121BBE-E1C5-4B43-A47F-B2B631698C46}"/>
               </a:ext>
             </a:extLst>
           </p:cNvPr>
@@ -7551,7 +7551,7 @@
           <p:cNvPr id="18" name="">
             <a:extLst xmlns:a="http://schemas.openxmlformats.org/drawingml/2006/main">
               <a:ext uri="{FF2B5EF4-FFF2-40B4-BE49-F238E27FC236}">
-                <a16:creationId xmlns:a16="http://schemas.microsoft.com/office/drawing/2014/main" id="{11CA839B-AD54-4552-9126-540B82B92A65}"/>
+                <a16:creationId xmlns:a16="http://schemas.microsoft.com/office/drawing/2014/main" id="{19C1C782-F238-442E-9892-57E1353B93FE}"/>
               </a:ext>
             </a:extLst>
           </p:cNvPr>
@@ -7583,7 +7583,7 @@
           <p:cNvPr id="19" name="">
             <a:extLst xmlns:a="http://schemas.openxmlformats.org/drawingml/2006/main">
               <a:ext uri="{FF2B5EF4-FFF2-40B4-BE49-F238E27FC236}">
-                <a16:creationId xmlns:a16="http://schemas.microsoft.com/office/drawing/2014/main" id="{168AB2F1-A361-4EEB-8D20-8037D868C933}"/>
+                <a16:creationId xmlns:a16="http://schemas.microsoft.com/office/drawing/2014/main" id="{C6658654-8BDF-4139-B8EF-922D0FC97ABB}"/>
               </a:ext>
             </a:extLst>
           </p:cNvPr>
@@ -7613,7 +7613,7 @@
           <p:cNvPr id="20" name="">
             <a:extLst xmlns:a="http://schemas.openxmlformats.org/drawingml/2006/main">
               <a:ext uri="{FF2B5EF4-FFF2-40B4-BE49-F238E27FC236}">
-                <a16:creationId xmlns:a16="http://schemas.microsoft.com/office/drawing/2014/main" id="{5DE5F3C6-C5E1-480C-B87F-5900B211D1EC}"/>
+                <a16:creationId xmlns:a16="http://schemas.microsoft.com/office/drawing/2014/main" id="{B3344C22-4981-44B2-9C05-DC473CAF9017}"/>
               </a:ext>
             </a:extLst>
           </p:cNvPr>
@@ -7672,7 +7672,7 @@
           <p:cNvPr id="21" name="">
             <a:extLst xmlns:a="http://schemas.openxmlformats.org/drawingml/2006/main">
               <a:ext uri="{FF2B5EF4-FFF2-40B4-BE49-F238E27FC236}">
-                <a16:creationId xmlns:a16="http://schemas.microsoft.com/office/drawing/2014/main" id="{99069926-5350-45B5-99A5-96054278D7D0}"/>
+                <a16:creationId xmlns:a16="http://schemas.microsoft.com/office/drawing/2014/main" id="{F872D75F-A4F0-4385-A7C4-CB87294E6C1F}"/>
               </a:ext>
             </a:extLst>
           </p:cNvPr>
@@ -7731,7 +7731,7 @@
           <p:cNvPr id="22" name="">
             <a:extLst xmlns:a="http://schemas.openxmlformats.org/drawingml/2006/main">
               <a:ext uri="{FF2B5EF4-FFF2-40B4-BE49-F238E27FC236}">
-                <a16:creationId xmlns:a16="http://schemas.microsoft.com/office/drawing/2014/main" id="{03800874-1DF2-4686-A211-B0C2268E947F}"/>
+                <a16:creationId xmlns:a16="http://schemas.microsoft.com/office/drawing/2014/main" id="{FAF46974-37F3-4079-B05B-AF0CDDF1308F}"/>
               </a:ext>
             </a:extLst>
           </p:cNvPr>
@@ -7763,7 +7763,7 @@
           <p:cNvPr id="23" name="">
             <a:extLst xmlns:a="http://schemas.openxmlformats.org/drawingml/2006/main">
               <a:ext uri="{FF2B5EF4-FFF2-40B4-BE49-F238E27FC236}">
-                <a16:creationId xmlns:a16="http://schemas.microsoft.com/office/drawing/2014/main" id="{99C12B99-BA8A-4BC0-838A-C872E1E199AC}"/>
+                <a16:creationId xmlns:a16="http://schemas.microsoft.com/office/drawing/2014/main" id="{C960DEDF-6B80-4C5B-849D-5ACBC77D2373}"/>
               </a:ext>
             </a:extLst>
           </p:cNvPr>
@@ -7793,7 +7793,7 @@
           <p:cNvPr id="24" name="">
             <a:extLst xmlns:a="http://schemas.openxmlformats.org/drawingml/2006/main">
               <a:ext uri="{FF2B5EF4-FFF2-40B4-BE49-F238E27FC236}">
-                <a16:creationId xmlns:a16="http://schemas.microsoft.com/office/drawing/2014/main" id="{1D7E13F5-FEC5-48CA-810A-3C5004C18D24}"/>
+                <a16:creationId xmlns:a16="http://schemas.microsoft.com/office/drawing/2014/main" id="{835E0B5B-C6AE-4E60-9757-B38F5757FF25}"/>
               </a:ext>
             </a:extLst>
           </p:cNvPr>
@@ -7852,7 +7852,7 @@
           <p:cNvPr id="25" name="">
             <a:extLst xmlns:a="http://schemas.openxmlformats.org/drawingml/2006/main">
               <a:ext uri="{FF2B5EF4-FFF2-40B4-BE49-F238E27FC236}">
-                <a16:creationId xmlns:a16="http://schemas.microsoft.com/office/drawing/2014/main" id="{72072156-45E5-44C6-92EF-CB1EE409CC79}"/>
+                <a16:creationId xmlns:a16="http://schemas.microsoft.com/office/drawing/2014/main" id="{AF30EC6B-2031-499D-9320-7713AF37DAB4}"/>
               </a:ext>
             </a:extLst>
           </p:cNvPr>
@@ -7911,7 +7911,7 @@
           <p:cNvPr id="26" name="">
             <a:extLst xmlns:a="http://schemas.openxmlformats.org/drawingml/2006/main">
               <a:ext uri="{FF2B5EF4-FFF2-40B4-BE49-F238E27FC236}">
-                <a16:creationId xmlns:a16="http://schemas.microsoft.com/office/drawing/2014/main" id="{E4F53751-FABF-482F-9496-8E6C8FB1231A}"/>
+                <a16:creationId xmlns:a16="http://schemas.microsoft.com/office/drawing/2014/main" id="{CE73E324-592B-4110-9381-DCEA6F0FB9A0}"/>
               </a:ext>
             </a:extLst>
           </p:cNvPr>
@@ -7968,7 +7968,7 @@
     </p:spTree>
     <p:extLst>
       <p:ext uri="{BB962C8B-B14F-4D97-AF65-F5344CB8AC3E}">
-        <p14:creationId xmlns:p14="http://schemas.microsoft.com/office/powerpoint/2010/main" val="2068687304"/>
+        <p14:creationId xmlns:p14="http://schemas.microsoft.com/office/powerpoint/2010/main" val="426752162"/>
       </p:ext>
     </p:extLst>
   </p:cSld>
@@ -7992,7 +7992,7 @@
           <p:cNvPr id="1" name="">
             <a:extLst xmlns:a="http://schemas.openxmlformats.org/drawingml/2006/main">
               <a:ext uri="{FF2B5EF4-FFF2-40B4-BE49-F238E27FC236}">
-                <a16:creationId xmlns:a16="http://schemas.microsoft.com/office/drawing/2014/main" id="{65FCD863-9F5F-4506-BE66-0889C6EBE879}"/>
+                <a16:creationId xmlns:a16="http://schemas.microsoft.com/office/drawing/2014/main" id="{1649BD53-B90B-42CC-93C2-E3264B4DC98A}"/>
               </a:ext>
             </a:extLst>
           </p:cNvPr>
@@ -8022,7 +8022,7 @@
           <p:cNvPr id="2" name="">
             <a:extLst xmlns:a="http://schemas.openxmlformats.org/drawingml/2006/main">
               <a:ext uri="{FF2B5EF4-FFF2-40B4-BE49-F238E27FC236}">
-                <a16:creationId xmlns:a16="http://schemas.microsoft.com/office/drawing/2014/main" id="{1D565D83-02ED-40D5-BE80-902C60179CFD}"/>
+                <a16:creationId xmlns:a16="http://schemas.microsoft.com/office/drawing/2014/main" id="{C036D75C-2341-4EC8-9319-A67203B8B1D5}"/>
               </a:ext>
             </a:extLst>
           </p:cNvPr>
@@ -8052,7 +8052,7 @@
           <p:cNvPr id="3" name="">
             <a:extLst xmlns:a="http://schemas.openxmlformats.org/drawingml/2006/main">
               <a:ext uri="{FF2B5EF4-FFF2-40B4-BE49-F238E27FC236}">
-                <a16:creationId xmlns:a16="http://schemas.microsoft.com/office/drawing/2014/main" id="{E9A7BE99-5CD4-43E9-B8A7-E708E3E52C6C}"/>
+                <a16:creationId xmlns:a16="http://schemas.microsoft.com/office/drawing/2014/main" id="{1D34EE0E-6B82-4E4B-BE0F-5311CA72F086}"/>
               </a:ext>
             </a:extLst>
           </p:cNvPr>
@@ -8111,7 +8111,7 @@
           <p:cNvPr id="4" name="">
             <a:extLst xmlns:a="http://schemas.openxmlformats.org/drawingml/2006/main">
               <a:ext uri="{FF2B5EF4-FFF2-40B4-BE49-F238E27FC236}">
-                <a16:creationId xmlns:a16="http://schemas.microsoft.com/office/drawing/2014/main" id="{0AC22BCB-A22D-4A59-87BB-654A9DC3ADA6}"/>
+                <a16:creationId xmlns:a16="http://schemas.microsoft.com/office/drawing/2014/main" id="{8C0AEBE7-3F29-4312-BBFE-2BA2793DBCF9}"/>
               </a:ext>
             </a:extLst>
           </p:cNvPr>
@@ -8170,7 +8170,7 @@
           <p:cNvPr id="5" name="">
             <a:extLst xmlns:a="http://schemas.openxmlformats.org/drawingml/2006/main">
               <a:ext uri="{FF2B5EF4-FFF2-40B4-BE49-F238E27FC236}">
-                <a16:creationId xmlns:a16="http://schemas.microsoft.com/office/drawing/2014/main" id="{14F97515-C574-420E-BD07-833687427F72}"/>
+                <a16:creationId xmlns:a16="http://schemas.microsoft.com/office/drawing/2014/main" id="{99EB95ED-0025-476B-8325-E9F39AC6BE98}"/>
               </a:ext>
             </a:extLst>
           </p:cNvPr>
@@ -8229,7 +8229,7 @@
           <p:cNvPr id="6" name="">
             <a:extLst xmlns:a="http://schemas.openxmlformats.org/drawingml/2006/main">
               <a:ext uri="{FF2B5EF4-FFF2-40B4-BE49-F238E27FC236}">
-                <a16:creationId xmlns:a16="http://schemas.microsoft.com/office/drawing/2014/main" id="{AD57E3E9-4D83-4275-A298-79BA4925491F}"/>
+                <a16:creationId xmlns:a16="http://schemas.microsoft.com/office/drawing/2014/main" id="{A6BAFE25-E477-4A33-9693-8D4DC23909AC}"/>
               </a:ext>
             </a:extLst>
           </p:cNvPr>
@@ -8292,7 +8292,7 @@
           <p:nvPr/>
         </p:nvPicPr>
         <p:blipFill>
-          <a:blip xmlns:r="http://schemas.openxmlformats.org/officeDocument/2006/relationships" xmlns:a="http://schemas.openxmlformats.org/drawingml/2006/main" r:embed="R64c46c9be1954662"/>
+          <a:blip xmlns:r="http://schemas.openxmlformats.org/officeDocument/2006/relationships" xmlns:a="http://schemas.openxmlformats.org/drawingml/2006/main" r:embed="R16d461df2a0247e9"/>
           <a:srcRect xmlns:a="http://schemas.openxmlformats.org/drawingml/2006/main" l="2184" t="0" r="2184" b="0"/>
           <a:stretch xmlns:a="http://schemas.openxmlformats.org/drawingml/2006/main">
             <a:fillRect l="0" t="0" r="0" b="0"/>
@@ -8313,7 +8313,7 @@
           <p:cNvPr id="8" name="">
             <a:extLst xmlns:a="http://schemas.openxmlformats.org/drawingml/2006/main">
               <a:ext uri="{FF2B5EF4-FFF2-40B4-BE49-F238E27FC236}">
-                <a16:creationId xmlns:a16="http://schemas.microsoft.com/office/drawing/2014/main" id="{5D34F900-F6F3-42AE-92D5-638576299346}"/>
+                <a16:creationId xmlns:a16="http://schemas.microsoft.com/office/drawing/2014/main" id="{9450B84F-BFF1-40F1-B0BF-8463FEA95F61}"/>
               </a:ext>
             </a:extLst>
           </p:cNvPr>
@@ -8345,7 +8345,7 @@
           <p:cNvPr id="9" name="">
             <a:extLst xmlns:a="http://schemas.openxmlformats.org/drawingml/2006/main">
               <a:ext uri="{FF2B5EF4-FFF2-40B4-BE49-F238E27FC236}">
-                <a16:creationId xmlns:a16="http://schemas.microsoft.com/office/drawing/2014/main" id="{2DAF6FE6-B603-4D88-B67C-238690CA8D8D}"/>
+                <a16:creationId xmlns:a16="http://schemas.microsoft.com/office/drawing/2014/main" id="{33C71BE4-1774-4136-9C63-75CDBB6AF891}"/>
               </a:ext>
             </a:extLst>
           </p:cNvPr>
@@ -8379,7 +8379,7 @@
           <p:cNvPr id="10" name="">
             <a:extLst xmlns:a="http://schemas.openxmlformats.org/drawingml/2006/main">
               <a:ext uri="{FF2B5EF4-FFF2-40B4-BE49-F238E27FC236}">
-                <a16:creationId xmlns:a16="http://schemas.microsoft.com/office/drawing/2014/main" id="{7B2D0508-6E2B-48BC-B7D4-88D915D23FF2}"/>
+                <a16:creationId xmlns:a16="http://schemas.microsoft.com/office/drawing/2014/main" id="{F12F32DE-AFFA-49F1-A87A-70CB6F46AF4B}"/>
               </a:ext>
             </a:extLst>
           </p:cNvPr>
@@ -8409,7 +8409,7 @@
           <p:cNvPr id="11" name="">
             <a:extLst xmlns:a="http://schemas.openxmlformats.org/drawingml/2006/main">
               <a:ext uri="{FF2B5EF4-FFF2-40B4-BE49-F238E27FC236}">
-                <a16:creationId xmlns:a16="http://schemas.microsoft.com/office/drawing/2014/main" id="{86ABEF52-87F4-4666-A4E7-49C84E52750C}"/>
+                <a16:creationId xmlns:a16="http://schemas.microsoft.com/office/drawing/2014/main" id="{32CB06EF-C79F-49B7-A66A-444D15A8CB7D}"/>
               </a:ext>
             </a:extLst>
           </p:cNvPr>
@@ -8468,7 +8468,7 @@
           <p:cNvPr id="12" name="">
             <a:extLst xmlns:a="http://schemas.openxmlformats.org/drawingml/2006/main">
               <a:ext uri="{FF2B5EF4-FFF2-40B4-BE49-F238E27FC236}">
-                <a16:creationId xmlns:a16="http://schemas.microsoft.com/office/drawing/2014/main" id="{E414710D-ED2B-439E-8167-2FE75BDCCA10}"/>
+                <a16:creationId xmlns:a16="http://schemas.microsoft.com/office/drawing/2014/main" id="{A14B0053-FE4B-4DDD-9F9E-7F651C8D7002}"/>
               </a:ext>
             </a:extLst>
           </p:cNvPr>
@@ -8500,7 +8500,7 @@
           <p:cNvPr id="13" name="">
             <a:extLst xmlns:a="http://schemas.openxmlformats.org/drawingml/2006/main">
               <a:ext uri="{FF2B5EF4-FFF2-40B4-BE49-F238E27FC236}">
-                <a16:creationId xmlns:a16="http://schemas.microsoft.com/office/drawing/2014/main" id="{67C6AE66-05B0-487B-A6B0-D9FF9381D262}"/>
+                <a16:creationId xmlns:a16="http://schemas.microsoft.com/office/drawing/2014/main" id="{7691FC8A-7808-4E04-A71E-35DA4F89C3D5}"/>
               </a:ext>
             </a:extLst>
           </p:cNvPr>
@@ -8530,7 +8530,7 @@
           <p:cNvPr id="14" name="">
             <a:extLst xmlns:a="http://schemas.openxmlformats.org/drawingml/2006/main">
               <a:ext uri="{FF2B5EF4-FFF2-40B4-BE49-F238E27FC236}">
-                <a16:creationId xmlns:a16="http://schemas.microsoft.com/office/drawing/2014/main" id="{84C4E7FB-52BC-4AA7-9DBB-BAF4105767B3}"/>
+                <a16:creationId xmlns:a16="http://schemas.microsoft.com/office/drawing/2014/main" id="{DB754B00-EF98-44C6-8E89-433C942D4294}"/>
               </a:ext>
             </a:extLst>
           </p:cNvPr>
@@ -8589,7 +8589,7 @@
           <p:cNvPr id="15" name="">
             <a:extLst xmlns:a="http://schemas.openxmlformats.org/drawingml/2006/main">
               <a:ext uri="{FF2B5EF4-FFF2-40B4-BE49-F238E27FC236}">
-                <a16:creationId xmlns:a16="http://schemas.microsoft.com/office/drawing/2014/main" id="{69DF3D3D-C71A-4C52-B5DB-B4B8E171AB08}"/>
+                <a16:creationId xmlns:a16="http://schemas.microsoft.com/office/drawing/2014/main" id="{CAA7852B-CB5B-4E7B-8A13-4976D6D1F60D}"/>
               </a:ext>
             </a:extLst>
           </p:cNvPr>
@@ -8648,7 +8648,7 @@
           <p:cNvPr id="16" name="">
             <a:extLst xmlns:a="http://schemas.openxmlformats.org/drawingml/2006/main">
               <a:ext uri="{FF2B5EF4-FFF2-40B4-BE49-F238E27FC236}">
-                <a16:creationId xmlns:a16="http://schemas.microsoft.com/office/drawing/2014/main" id="{95255632-3033-40FE-8B38-8AE389FA2505}"/>
+                <a16:creationId xmlns:a16="http://schemas.microsoft.com/office/drawing/2014/main" id="{9C191DCB-BA5B-4EB9-A49D-862D4DD8822B}"/>
               </a:ext>
             </a:extLst>
           </p:cNvPr>
@@ -8680,7 +8680,7 @@
           <p:cNvPr id="17" name="">
             <a:extLst xmlns:a="http://schemas.openxmlformats.org/drawingml/2006/main">
               <a:ext uri="{FF2B5EF4-FFF2-40B4-BE49-F238E27FC236}">
-                <a16:creationId xmlns:a16="http://schemas.microsoft.com/office/drawing/2014/main" id="{7C537A93-CBBC-4061-BCD6-577206109BC4}"/>
+                <a16:creationId xmlns:a16="http://schemas.microsoft.com/office/drawing/2014/main" id="{5D777FD2-EA8C-4811-AB0F-759A64D60635}"/>
               </a:ext>
             </a:extLst>
           </p:cNvPr>
@@ -8710,7 +8710,7 @@
           <p:cNvPr id="18" name="">
             <a:extLst xmlns:a="http://schemas.openxmlformats.org/drawingml/2006/main">
               <a:ext uri="{FF2B5EF4-FFF2-40B4-BE49-F238E27FC236}">
-                <a16:creationId xmlns:a16="http://schemas.microsoft.com/office/drawing/2014/main" id="{AA8CE70D-C1E6-4FC1-9208-64A3E2A7151A}"/>
+                <a16:creationId xmlns:a16="http://schemas.microsoft.com/office/drawing/2014/main" id="{610ADAB9-CBF6-4A6B-85D8-E52A3AC0CC7E}"/>
               </a:ext>
             </a:extLst>
           </p:cNvPr>
@@ -8769,7 +8769,7 @@
           <p:cNvPr id="19" name="">
             <a:extLst xmlns:a="http://schemas.openxmlformats.org/drawingml/2006/main">
               <a:ext uri="{FF2B5EF4-FFF2-40B4-BE49-F238E27FC236}">
-                <a16:creationId xmlns:a16="http://schemas.microsoft.com/office/drawing/2014/main" id="{567DC6BC-5DE0-481C-A583-EF500B778499}"/>
+                <a16:creationId xmlns:a16="http://schemas.microsoft.com/office/drawing/2014/main" id="{7E350900-E7BF-4C39-A9E6-22CD82D2B1DE}"/>
               </a:ext>
             </a:extLst>
           </p:cNvPr>
@@ -8828,7 +8828,7 @@
           <p:cNvPr id="20" name="">
             <a:extLst xmlns:a="http://schemas.openxmlformats.org/drawingml/2006/main">
               <a:ext uri="{FF2B5EF4-FFF2-40B4-BE49-F238E27FC236}">
-                <a16:creationId xmlns:a16="http://schemas.microsoft.com/office/drawing/2014/main" id="{5878B142-BD64-48D2-AA3F-AC21F5C2AE33}"/>
+                <a16:creationId xmlns:a16="http://schemas.microsoft.com/office/drawing/2014/main" id="{B4F9BC3C-5EB4-4856-AE27-C084CDACD786}"/>
               </a:ext>
             </a:extLst>
           </p:cNvPr>
@@ -8860,7 +8860,7 @@
           <p:cNvPr id="21" name="">
             <a:extLst xmlns:a="http://schemas.openxmlformats.org/drawingml/2006/main">
               <a:ext uri="{FF2B5EF4-FFF2-40B4-BE49-F238E27FC236}">
-                <a16:creationId xmlns:a16="http://schemas.microsoft.com/office/drawing/2014/main" id="{950DC6C1-3306-49CB-BC13-E6EB695C1480}"/>
+                <a16:creationId xmlns:a16="http://schemas.microsoft.com/office/drawing/2014/main" id="{9BF93BF0-CD3F-4F96-A4FF-CA8AD0D4B39B}"/>
               </a:ext>
             </a:extLst>
           </p:cNvPr>
@@ -8917,7 +8917,7 @@
     </p:spTree>
     <p:extLst>
       <p:ext uri="{BB962C8B-B14F-4D97-AF65-F5344CB8AC3E}">
-        <p14:creationId xmlns:p14="http://schemas.microsoft.com/office/powerpoint/2010/main" val="2007800949"/>
+        <p14:creationId xmlns:p14="http://schemas.microsoft.com/office/powerpoint/2010/main" val="1352478135"/>
       </p:ext>
     </p:extLst>
   </p:cSld>
@@ -8941,7 +8941,7 @@
           <p:cNvPr id="1" name="">
             <a:extLst xmlns:a="http://schemas.openxmlformats.org/drawingml/2006/main">
               <a:ext uri="{FF2B5EF4-FFF2-40B4-BE49-F238E27FC236}">
-                <a16:creationId xmlns:a16="http://schemas.microsoft.com/office/drawing/2014/main" id="{42372E64-F84D-4D13-96A3-7901E7AAA3EE}"/>
+                <a16:creationId xmlns:a16="http://schemas.microsoft.com/office/drawing/2014/main" id="{385E7396-B1C3-4C8E-B0D4-1AE383FEB57D}"/>
               </a:ext>
             </a:extLst>
           </p:cNvPr>
@@ -8971,7 +8971,7 @@
           <p:cNvPr id="2" name="">
             <a:extLst xmlns:a="http://schemas.openxmlformats.org/drawingml/2006/main">
               <a:ext uri="{FF2B5EF4-FFF2-40B4-BE49-F238E27FC236}">
-                <a16:creationId xmlns:a16="http://schemas.microsoft.com/office/drawing/2014/main" id="{A80F3A43-0D21-49B2-A180-597F432E73DD}"/>
+                <a16:creationId xmlns:a16="http://schemas.microsoft.com/office/drawing/2014/main" id="{9E0E12D4-7365-4D9C-BCE6-7B66674A9E63}"/>
               </a:ext>
             </a:extLst>
           </p:cNvPr>
@@ -9001,7 +9001,7 @@
           <p:cNvPr id="3" name="">
             <a:extLst xmlns:a="http://schemas.openxmlformats.org/drawingml/2006/main">
               <a:ext uri="{FF2B5EF4-FFF2-40B4-BE49-F238E27FC236}">
-                <a16:creationId xmlns:a16="http://schemas.microsoft.com/office/drawing/2014/main" id="{BF6B1EAE-7B03-4633-A90C-4A5A299B45F4}"/>
+                <a16:creationId xmlns:a16="http://schemas.microsoft.com/office/drawing/2014/main" id="{ADC6F7C0-2C72-49B8-B8BC-10B66D787DB5}"/>
               </a:ext>
             </a:extLst>
           </p:cNvPr>
@@ -9060,7 +9060,7 @@
           <p:cNvPr id="4" name="">
             <a:extLst xmlns:a="http://schemas.openxmlformats.org/drawingml/2006/main">
               <a:ext uri="{FF2B5EF4-FFF2-40B4-BE49-F238E27FC236}">
-                <a16:creationId xmlns:a16="http://schemas.microsoft.com/office/drawing/2014/main" id="{FE2A4125-3424-40C0-B640-E38B112FF5D7}"/>
+                <a16:creationId xmlns:a16="http://schemas.microsoft.com/office/drawing/2014/main" id="{47A79D89-2A35-4AAB-B833-6650FEBCA9E3}"/>
               </a:ext>
             </a:extLst>
           </p:cNvPr>
@@ -9119,7 +9119,7 @@
           <p:cNvPr id="5" name="">
             <a:extLst xmlns:a="http://schemas.openxmlformats.org/drawingml/2006/main">
               <a:ext uri="{FF2B5EF4-FFF2-40B4-BE49-F238E27FC236}">
-                <a16:creationId xmlns:a16="http://schemas.microsoft.com/office/drawing/2014/main" id="{05AAEED5-9EFE-42DA-A64F-7AF63B456160}"/>
+                <a16:creationId xmlns:a16="http://schemas.microsoft.com/office/drawing/2014/main" id="{05FA4090-AD8F-46DC-A6F0-438CCD5B80A8}"/>
               </a:ext>
             </a:extLst>
           </p:cNvPr>
@@ -9178,7 +9178,7 @@
           <p:cNvPr id="6" name="">
             <a:extLst xmlns:a="http://schemas.openxmlformats.org/drawingml/2006/main">
               <a:ext uri="{FF2B5EF4-FFF2-40B4-BE49-F238E27FC236}">
-                <a16:creationId xmlns:a16="http://schemas.microsoft.com/office/drawing/2014/main" id="{7FFFC9B9-E855-40DD-846A-53BE6E4AE6BF}"/>
+                <a16:creationId xmlns:a16="http://schemas.microsoft.com/office/drawing/2014/main" id="{7A5C31AF-C244-4265-AADF-9485CABD8165}"/>
               </a:ext>
             </a:extLst>
           </p:cNvPr>
@@ -9241,7 +9241,7 @@
           <p:nvPr/>
         </p:nvPicPr>
         <p:blipFill>
-          <a:blip xmlns:r="http://schemas.openxmlformats.org/officeDocument/2006/relationships" xmlns:a="http://schemas.openxmlformats.org/drawingml/2006/main" r:embed="R31a1e48f9059485d"/>
+          <a:blip xmlns:r="http://schemas.openxmlformats.org/officeDocument/2006/relationships" xmlns:a="http://schemas.openxmlformats.org/drawingml/2006/main" r:embed="R3ae20195184d4b59"/>
           <a:srcRect xmlns:a="http://schemas.openxmlformats.org/drawingml/2006/main" l="4380" t="0" r="4380" b="0"/>
           <a:stretch xmlns:a="http://schemas.openxmlformats.org/drawingml/2006/main">
             <a:fillRect l="0" t="0" r="0" b="0"/>
@@ -9262,7 +9262,7 @@
           <p:cNvPr id="8" name="">
             <a:extLst xmlns:a="http://schemas.openxmlformats.org/drawingml/2006/main">
               <a:ext uri="{FF2B5EF4-FFF2-40B4-BE49-F238E27FC236}">
-                <a16:creationId xmlns:a16="http://schemas.microsoft.com/office/drawing/2014/main" id="{4EA08B64-9CFF-4A1D-AC66-8754E9DC215A}"/>
+                <a16:creationId xmlns:a16="http://schemas.microsoft.com/office/drawing/2014/main" id="{FED1397A-DAB3-4587-8193-9DC62716F490}"/>
               </a:ext>
             </a:extLst>
           </p:cNvPr>
@@ -9294,7 +9294,7 @@
           <p:cNvPr id="9" name="">
             <a:extLst xmlns:a="http://schemas.openxmlformats.org/drawingml/2006/main">
               <a:ext uri="{FF2B5EF4-FFF2-40B4-BE49-F238E27FC236}">
-                <a16:creationId xmlns:a16="http://schemas.microsoft.com/office/drawing/2014/main" id="{9EBAE281-8239-44E6-800C-E7E3F2DFF350}"/>
+                <a16:creationId xmlns:a16="http://schemas.microsoft.com/office/drawing/2014/main" id="{0F1CE8B5-5D09-4BA9-B96F-5364C6EBF531}"/>
               </a:ext>
             </a:extLst>
           </p:cNvPr>
@@ -9328,7 +9328,7 @@
           <p:cNvPr id="10" name="">
             <a:extLst xmlns:a="http://schemas.openxmlformats.org/drawingml/2006/main">
               <a:ext uri="{FF2B5EF4-FFF2-40B4-BE49-F238E27FC236}">
-                <a16:creationId xmlns:a16="http://schemas.microsoft.com/office/drawing/2014/main" id="{C3F34BB1-5C88-4453-AE1F-38319FC12606}"/>
+                <a16:creationId xmlns:a16="http://schemas.microsoft.com/office/drawing/2014/main" id="{A7177268-554D-4E0C-B997-9FA82E0A039E}"/>
               </a:ext>
             </a:extLst>
           </p:cNvPr>
@@ -9360,7 +9360,7 @@
           <p:cNvPr id="11" name="">
             <a:extLst xmlns:a="http://schemas.openxmlformats.org/drawingml/2006/main">
               <a:ext uri="{FF2B5EF4-FFF2-40B4-BE49-F238E27FC236}">
-                <a16:creationId xmlns:a16="http://schemas.microsoft.com/office/drawing/2014/main" id="{3E7E06CD-093C-4917-BC79-F3BA70194040}"/>
+                <a16:creationId xmlns:a16="http://schemas.microsoft.com/office/drawing/2014/main" id="{00E2A596-7F31-46D4-910A-BE3B5FEB7F01}"/>
               </a:ext>
             </a:extLst>
           </p:cNvPr>
@@ -9390,7 +9390,7 @@
           <p:cNvPr id="12" name="">
             <a:extLst xmlns:a="http://schemas.openxmlformats.org/drawingml/2006/main">
               <a:ext uri="{FF2B5EF4-FFF2-40B4-BE49-F238E27FC236}">
-                <a16:creationId xmlns:a16="http://schemas.microsoft.com/office/drawing/2014/main" id="{FD0A059A-B26E-4C8C-B426-0DB2F952D04E}"/>
+                <a16:creationId xmlns:a16="http://schemas.microsoft.com/office/drawing/2014/main" id="{03264357-2C28-46BB-8390-8951B9B5CBFE}"/>
               </a:ext>
             </a:extLst>
           </p:cNvPr>
@@ -9449,7 +9449,7 @@
           <p:cNvPr id="13" name="">
             <a:extLst xmlns:a="http://schemas.openxmlformats.org/drawingml/2006/main">
               <a:ext uri="{FF2B5EF4-FFF2-40B4-BE49-F238E27FC236}">
-                <a16:creationId xmlns:a16="http://schemas.microsoft.com/office/drawing/2014/main" id="{F8FBD620-A848-453F-A798-487569ED30C2}"/>
+                <a16:creationId xmlns:a16="http://schemas.microsoft.com/office/drawing/2014/main" id="{BDF20EDC-5E22-4E1C-B480-BA6F1F4C533F}"/>
               </a:ext>
             </a:extLst>
           </p:cNvPr>
@@ -9508,7 +9508,7 @@
           <p:cNvPr id="14" name="">
             <a:extLst xmlns:a="http://schemas.openxmlformats.org/drawingml/2006/main">
               <a:ext uri="{FF2B5EF4-FFF2-40B4-BE49-F238E27FC236}">
-                <a16:creationId xmlns:a16="http://schemas.microsoft.com/office/drawing/2014/main" id="{027F371B-FF6C-45A3-A6CF-992F3A62FDB4}"/>
+                <a16:creationId xmlns:a16="http://schemas.microsoft.com/office/drawing/2014/main" id="{024C73CE-C119-4ABA-9EE6-C2F98E4F6759}"/>
               </a:ext>
             </a:extLst>
           </p:cNvPr>
@@ -9540,7 +9540,7 @@
           <p:cNvPr id="15" name="">
             <a:extLst xmlns:a="http://schemas.openxmlformats.org/drawingml/2006/main">
               <a:ext uri="{FF2B5EF4-FFF2-40B4-BE49-F238E27FC236}">
-                <a16:creationId xmlns:a16="http://schemas.microsoft.com/office/drawing/2014/main" id="{974C8A86-3AB3-4997-9535-F60275674851}"/>
+                <a16:creationId xmlns:a16="http://schemas.microsoft.com/office/drawing/2014/main" id="{91D22049-1B2F-4F5A-B7A8-5074182C43C5}"/>
               </a:ext>
             </a:extLst>
           </p:cNvPr>
@@ -9570,7 +9570,7 @@
           <p:cNvPr id="16" name="">
             <a:extLst xmlns:a="http://schemas.openxmlformats.org/drawingml/2006/main">
               <a:ext uri="{FF2B5EF4-FFF2-40B4-BE49-F238E27FC236}">
-                <a16:creationId xmlns:a16="http://schemas.microsoft.com/office/drawing/2014/main" id="{6CAFF1B8-72D6-4257-88DF-1CB2A42B2490}"/>
+                <a16:creationId xmlns:a16="http://schemas.microsoft.com/office/drawing/2014/main" id="{42BA2012-D619-4945-8F80-36569E71E5F7}"/>
               </a:ext>
             </a:extLst>
           </p:cNvPr>
@@ -9629,7 +9629,7 @@
           <p:cNvPr id="17" name="">
             <a:extLst xmlns:a="http://schemas.openxmlformats.org/drawingml/2006/main">
               <a:ext uri="{FF2B5EF4-FFF2-40B4-BE49-F238E27FC236}">
-                <a16:creationId xmlns:a16="http://schemas.microsoft.com/office/drawing/2014/main" id="{42AE636D-A20D-4DF6-8CF7-5FF921B2088E}"/>
+                <a16:creationId xmlns:a16="http://schemas.microsoft.com/office/drawing/2014/main" id="{90D0E76D-35E1-4D91-AB6B-D35D7F466404}"/>
               </a:ext>
             </a:extLst>
           </p:cNvPr>
@@ -9688,7 +9688,7 @@
           <p:cNvPr id="18" name="">
             <a:extLst xmlns:a="http://schemas.openxmlformats.org/drawingml/2006/main">
               <a:ext uri="{FF2B5EF4-FFF2-40B4-BE49-F238E27FC236}">
-                <a16:creationId xmlns:a16="http://schemas.microsoft.com/office/drawing/2014/main" id="{0EEFEBCB-F324-4559-B285-E9F2CB57888A}"/>
+                <a16:creationId xmlns:a16="http://schemas.microsoft.com/office/drawing/2014/main" id="{72554F47-C7FC-4507-A610-4D042885D455}"/>
               </a:ext>
             </a:extLst>
           </p:cNvPr>
@@ -9720,7 +9720,7 @@
           <p:cNvPr id="19" name="">
             <a:extLst xmlns:a="http://schemas.openxmlformats.org/drawingml/2006/main">
               <a:ext uri="{FF2B5EF4-FFF2-40B4-BE49-F238E27FC236}">
-                <a16:creationId xmlns:a16="http://schemas.microsoft.com/office/drawing/2014/main" id="{B967C870-FD6B-4C5C-B2D0-BF4230CB186B}"/>
+                <a16:creationId xmlns:a16="http://schemas.microsoft.com/office/drawing/2014/main" id="{E97B7A75-6A51-4E22-8038-2013F469972C}"/>
               </a:ext>
             </a:extLst>
           </p:cNvPr>
@@ -9750,7 +9750,7 @@
           <p:cNvPr id="20" name="">
             <a:extLst xmlns:a="http://schemas.openxmlformats.org/drawingml/2006/main">
               <a:ext uri="{FF2B5EF4-FFF2-40B4-BE49-F238E27FC236}">
-                <a16:creationId xmlns:a16="http://schemas.microsoft.com/office/drawing/2014/main" id="{BD432DEF-60AD-465B-9A95-C70674CE6B05}"/>
+                <a16:creationId xmlns:a16="http://schemas.microsoft.com/office/drawing/2014/main" id="{79EBCBD1-51DD-4BBB-8677-0BCF3018A1C5}"/>
               </a:ext>
             </a:extLst>
           </p:cNvPr>
@@ -9809,7 +9809,7 @@
           <p:cNvPr id="21" name="">
             <a:extLst xmlns:a="http://schemas.openxmlformats.org/drawingml/2006/main">
               <a:ext uri="{FF2B5EF4-FFF2-40B4-BE49-F238E27FC236}">
-                <a16:creationId xmlns:a16="http://schemas.microsoft.com/office/drawing/2014/main" id="{5BD5DDCD-DF7B-423C-A456-62311CFEEFB6}"/>
+                <a16:creationId xmlns:a16="http://schemas.microsoft.com/office/drawing/2014/main" id="{76456272-2FA8-4C16-8351-A0769CC0B5DE}"/>
               </a:ext>
             </a:extLst>
           </p:cNvPr>
@@ -9868,7 +9868,7 @@
           <p:cNvPr id="22" name="">
             <a:extLst xmlns:a="http://schemas.openxmlformats.org/drawingml/2006/main">
               <a:ext uri="{FF2B5EF4-FFF2-40B4-BE49-F238E27FC236}">
-                <a16:creationId xmlns:a16="http://schemas.microsoft.com/office/drawing/2014/main" id="{2DFD6B7C-333E-4808-A55C-496E4436F724}"/>
+                <a16:creationId xmlns:a16="http://schemas.microsoft.com/office/drawing/2014/main" id="{5008201B-B2F8-4DD0-8E57-C5AA828C3548}"/>
               </a:ext>
             </a:extLst>
           </p:cNvPr>
@@ -9900,7 +9900,7 @@
           <p:cNvPr id="23" name="">
             <a:extLst xmlns:a="http://schemas.openxmlformats.org/drawingml/2006/main">
               <a:ext uri="{FF2B5EF4-FFF2-40B4-BE49-F238E27FC236}">
-                <a16:creationId xmlns:a16="http://schemas.microsoft.com/office/drawing/2014/main" id="{3AB18A32-8D80-424C-8D91-F9B69E32D35E}"/>
+                <a16:creationId xmlns:a16="http://schemas.microsoft.com/office/drawing/2014/main" id="{5E71D245-E464-4F8E-8501-2F4041251BC2}"/>
               </a:ext>
             </a:extLst>
           </p:cNvPr>
@@ -9930,7 +9930,7 @@
           <p:cNvPr id="24" name="">
             <a:extLst xmlns:a="http://schemas.openxmlformats.org/drawingml/2006/main">
               <a:ext uri="{FF2B5EF4-FFF2-40B4-BE49-F238E27FC236}">
-                <a16:creationId xmlns:a16="http://schemas.microsoft.com/office/drawing/2014/main" id="{DE9A063C-1DEF-4761-8173-BF388EAAB4F6}"/>
+                <a16:creationId xmlns:a16="http://schemas.microsoft.com/office/drawing/2014/main" id="{CA49293B-B979-4E90-B1DE-13B92328B70E}"/>
               </a:ext>
             </a:extLst>
           </p:cNvPr>
@@ -9989,7 +9989,7 @@
           <p:cNvPr id="25" name="">
             <a:extLst xmlns:a="http://schemas.openxmlformats.org/drawingml/2006/main">
               <a:ext uri="{FF2B5EF4-FFF2-40B4-BE49-F238E27FC236}">
-                <a16:creationId xmlns:a16="http://schemas.microsoft.com/office/drawing/2014/main" id="{A332D009-4BD3-4B5F-A745-EDCAAF8A5356}"/>
+                <a16:creationId xmlns:a16="http://schemas.microsoft.com/office/drawing/2014/main" id="{476625E6-A298-4D0B-91B2-2BF18A5A7913}"/>
               </a:ext>
             </a:extLst>
           </p:cNvPr>
@@ -10048,7 +10048,7 @@
           <p:cNvPr id="26" name="">
             <a:extLst xmlns:a="http://schemas.openxmlformats.org/drawingml/2006/main">
               <a:ext uri="{FF2B5EF4-FFF2-40B4-BE49-F238E27FC236}">
-                <a16:creationId xmlns:a16="http://schemas.microsoft.com/office/drawing/2014/main" id="{E918308A-8719-4349-A96C-98A46320088D}"/>
+                <a16:creationId xmlns:a16="http://schemas.microsoft.com/office/drawing/2014/main" id="{DCE7AA1D-88F5-45AB-9B4E-7ED3E9838F59}"/>
               </a:ext>
             </a:extLst>
           </p:cNvPr>
@@ -10078,7 +10078,7 @@
           <p:cNvPr id="27" name="">
             <a:extLst xmlns:a="http://schemas.openxmlformats.org/drawingml/2006/main">
               <a:ext uri="{FF2B5EF4-FFF2-40B4-BE49-F238E27FC236}">
-                <a16:creationId xmlns:a16="http://schemas.microsoft.com/office/drawing/2014/main" id="{F9B5DE6C-918E-47E3-BE87-1FDB8BEA7E3C}"/>
+                <a16:creationId xmlns:a16="http://schemas.microsoft.com/office/drawing/2014/main" id="{1C706E49-819B-4380-AD28-7F2062AD8080}"/>
               </a:ext>
             </a:extLst>
           </p:cNvPr>
@@ -10108,7 +10108,7 @@
           <p:cNvPr id="28" name="">
             <a:extLst xmlns:a="http://schemas.openxmlformats.org/drawingml/2006/main">
               <a:ext uri="{FF2B5EF4-FFF2-40B4-BE49-F238E27FC236}">
-                <a16:creationId xmlns:a16="http://schemas.microsoft.com/office/drawing/2014/main" id="{1D6A56C4-B2A2-4471-9315-B15C67AA2897}"/>
+                <a16:creationId xmlns:a16="http://schemas.microsoft.com/office/drawing/2014/main" id="{541408FE-B341-4FA8-8CE7-574DAAC656B4}"/>
               </a:ext>
             </a:extLst>
           </p:cNvPr>
@@ -10165,7 +10165,7 @@
     </p:spTree>
     <p:extLst>
       <p:ext uri="{BB962C8B-B14F-4D97-AF65-F5344CB8AC3E}">
-        <p14:creationId xmlns:p14="http://schemas.microsoft.com/office/powerpoint/2010/main" val="1157937816"/>
+        <p14:creationId xmlns:p14="http://schemas.microsoft.com/office/powerpoint/2010/main" val="1797246311"/>
       </p:ext>
     </p:extLst>
   </p:cSld>
@@ -10189,7 +10189,7 @@
           <p:cNvPr id="1" name="">
             <a:extLst xmlns:a="http://schemas.openxmlformats.org/drawingml/2006/main">
               <a:ext uri="{FF2B5EF4-FFF2-40B4-BE49-F238E27FC236}">
-                <a16:creationId xmlns:a16="http://schemas.microsoft.com/office/drawing/2014/main" id="{796AC90A-398A-4477-94A8-329BF24DFAAA}"/>
+                <a16:creationId xmlns:a16="http://schemas.microsoft.com/office/drawing/2014/main" id="{9DFE2BE9-8CB3-49CB-94ED-56862281727F}"/>
               </a:ext>
             </a:extLst>
           </p:cNvPr>
@@ -10219,7 +10219,7 @@
           <p:cNvPr id="2" name="">
             <a:extLst xmlns:a="http://schemas.openxmlformats.org/drawingml/2006/main">
               <a:ext uri="{FF2B5EF4-FFF2-40B4-BE49-F238E27FC236}">
-                <a16:creationId xmlns:a16="http://schemas.microsoft.com/office/drawing/2014/main" id="{9FC09008-8D6B-4E80-9357-7E06B52002BC}"/>
+                <a16:creationId xmlns:a16="http://schemas.microsoft.com/office/drawing/2014/main" id="{6B6D7033-35B2-45C9-9FD0-2D177648E843}"/>
               </a:ext>
             </a:extLst>
           </p:cNvPr>
@@ -10249,7 +10249,7 @@
           <p:cNvPr id="3" name="">
             <a:extLst xmlns:a="http://schemas.openxmlformats.org/drawingml/2006/main">
               <a:ext uri="{FF2B5EF4-FFF2-40B4-BE49-F238E27FC236}">
-                <a16:creationId xmlns:a16="http://schemas.microsoft.com/office/drawing/2014/main" id="{7539164F-38BD-45DA-B8F3-F7ED13C5CDA3}"/>
+                <a16:creationId xmlns:a16="http://schemas.microsoft.com/office/drawing/2014/main" id="{2BCF8514-562F-4819-9261-BA7A3D0EE25B}"/>
               </a:ext>
             </a:extLst>
           </p:cNvPr>
@@ -10308,7 +10308,7 @@
           <p:cNvPr id="4" name="">
             <a:extLst xmlns:a="http://schemas.openxmlformats.org/drawingml/2006/main">
               <a:ext uri="{FF2B5EF4-FFF2-40B4-BE49-F238E27FC236}">
-                <a16:creationId xmlns:a16="http://schemas.microsoft.com/office/drawing/2014/main" id="{087537C5-F0CD-45E6-A053-FE8A99E89AA6}"/>
+                <a16:creationId xmlns:a16="http://schemas.microsoft.com/office/drawing/2014/main" id="{610687D6-F5A6-455A-8604-8BC050624B7C}"/>
               </a:ext>
             </a:extLst>
           </p:cNvPr>
@@ -10367,7 +10367,7 @@
           <p:cNvPr id="5" name="">
             <a:extLst xmlns:a="http://schemas.openxmlformats.org/drawingml/2006/main">
               <a:ext uri="{FF2B5EF4-FFF2-40B4-BE49-F238E27FC236}">
-                <a16:creationId xmlns:a16="http://schemas.microsoft.com/office/drawing/2014/main" id="{09F2725F-D5C4-4D75-B552-CBBD7D7E181E}"/>
+                <a16:creationId xmlns:a16="http://schemas.microsoft.com/office/drawing/2014/main" id="{39BEB450-6BA3-4925-A1B8-4EE37AD9E87A}"/>
               </a:ext>
             </a:extLst>
           </p:cNvPr>
@@ -10426,7 +10426,7 @@
           <p:cNvPr id="6" name="">
             <a:extLst xmlns:a="http://schemas.openxmlformats.org/drawingml/2006/main">
               <a:ext uri="{FF2B5EF4-FFF2-40B4-BE49-F238E27FC236}">
-                <a16:creationId xmlns:a16="http://schemas.microsoft.com/office/drawing/2014/main" id="{039AAB20-66C8-4880-B635-1BAF55369DB4}"/>
+                <a16:creationId xmlns:a16="http://schemas.microsoft.com/office/drawing/2014/main" id="{E5427E85-C13C-4AD3-9D95-FC91D4C5D651}"/>
               </a:ext>
             </a:extLst>
           </p:cNvPr>
@@ -10489,7 +10489,7 @@
           <p:nvPr/>
         </p:nvPicPr>
         <p:blipFill>
-          <a:blip xmlns:r="http://schemas.openxmlformats.org/officeDocument/2006/relationships" xmlns:a="http://schemas.openxmlformats.org/drawingml/2006/main" r:embed="R1e3b9ffd952f49db"/>
+          <a:blip xmlns:r="http://schemas.openxmlformats.org/officeDocument/2006/relationships" xmlns:a="http://schemas.openxmlformats.org/drawingml/2006/main" r:embed="R97d0a5de3f404d22"/>
           <a:srcRect xmlns:a="http://schemas.openxmlformats.org/drawingml/2006/main" l="0" t="410" r="0" b="410"/>
           <a:stretch xmlns:a="http://schemas.openxmlformats.org/drawingml/2006/main">
             <a:fillRect l="0" t="0" r="0" b="0"/>
@@ -10510,7 +10510,7 @@
           <p:cNvPr id="8" name="">
             <a:extLst xmlns:a="http://schemas.openxmlformats.org/drawingml/2006/main">
               <a:ext uri="{FF2B5EF4-FFF2-40B4-BE49-F238E27FC236}">
-                <a16:creationId xmlns:a16="http://schemas.microsoft.com/office/drawing/2014/main" id="{F98CE58D-D687-4210-B919-5C7C6542C803}"/>
+                <a16:creationId xmlns:a16="http://schemas.microsoft.com/office/drawing/2014/main" id="{A79C0200-2F4D-4761-9C65-3A35522694A7}"/>
               </a:ext>
             </a:extLst>
           </p:cNvPr>
@@ -10542,7 +10542,7 @@
           <p:cNvPr id="9" name="">
             <a:extLst xmlns:a="http://schemas.openxmlformats.org/drawingml/2006/main">
               <a:ext uri="{FF2B5EF4-FFF2-40B4-BE49-F238E27FC236}">
-                <a16:creationId xmlns:a16="http://schemas.microsoft.com/office/drawing/2014/main" id="{9181A712-BB0F-4F28-ADED-8581F25E0653}"/>
+                <a16:creationId xmlns:a16="http://schemas.microsoft.com/office/drawing/2014/main" id="{CC98659B-7D1E-41FA-8B79-50DAFCC5FAF6}"/>
               </a:ext>
             </a:extLst>
           </p:cNvPr>
@@ -10576,7 +10576,7 @@
           <p:cNvPr id="10" name="">
             <a:extLst xmlns:a="http://schemas.openxmlformats.org/drawingml/2006/main">
               <a:ext uri="{FF2B5EF4-FFF2-40B4-BE49-F238E27FC236}">
-                <a16:creationId xmlns:a16="http://schemas.microsoft.com/office/drawing/2014/main" id="{392F3EB8-9E71-4C1C-8F49-D01BF863DC07}"/>
+                <a16:creationId xmlns:a16="http://schemas.microsoft.com/office/drawing/2014/main" id="{A5F006BF-2379-400C-B330-2BF2B790E9C2}"/>
               </a:ext>
             </a:extLst>
           </p:cNvPr>
@@ -10606,7 +10606,7 @@
           <p:cNvPr id="11" name="">
             <a:extLst xmlns:a="http://schemas.openxmlformats.org/drawingml/2006/main">
               <a:ext uri="{FF2B5EF4-FFF2-40B4-BE49-F238E27FC236}">
-                <a16:creationId xmlns:a16="http://schemas.microsoft.com/office/drawing/2014/main" id="{B3C6903C-C7C9-4925-901D-BDE9B54E24AC}"/>
+                <a16:creationId xmlns:a16="http://schemas.microsoft.com/office/drawing/2014/main" id="{7BC561BF-AC6F-49CE-90AF-0DEFE63C0366}"/>
               </a:ext>
             </a:extLst>
           </p:cNvPr>
@@ -10665,7 +10665,7 @@
           <p:cNvPr id="12" name="">
             <a:extLst xmlns:a="http://schemas.openxmlformats.org/drawingml/2006/main">
               <a:ext uri="{FF2B5EF4-FFF2-40B4-BE49-F238E27FC236}">
-                <a16:creationId xmlns:a16="http://schemas.microsoft.com/office/drawing/2014/main" id="{285CDC0B-B023-4500-B4D8-C0BD1390A43F}"/>
+                <a16:creationId xmlns:a16="http://schemas.microsoft.com/office/drawing/2014/main" id="{31092ABD-011A-46E1-85CC-7E6A9C80F584}"/>
               </a:ext>
             </a:extLst>
           </p:cNvPr>
@@ -10695,7 +10695,7 @@
           <p:cNvPr id="13" name="">
             <a:extLst xmlns:a="http://schemas.openxmlformats.org/drawingml/2006/main">
               <a:ext uri="{FF2B5EF4-FFF2-40B4-BE49-F238E27FC236}">
-                <a16:creationId xmlns:a16="http://schemas.microsoft.com/office/drawing/2014/main" id="{3A70A067-203F-4712-9BD8-D7E1120C4006}"/>
+                <a16:creationId xmlns:a16="http://schemas.microsoft.com/office/drawing/2014/main" id="{9BB2EDC7-7C74-4BE4-8342-52CF3E3F54FC}"/>
               </a:ext>
             </a:extLst>
           </p:cNvPr>
@@ -10725,7 +10725,7 @@
           <p:cNvPr id="14" name="">
             <a:extLst xmlns:a="http://schemas.openxmlformats.org/drawingml/2006/main">
               <a:ext uri="{FF2B5EF4-FFF2-40B4-BE49-F238E27FC236}">
-                <a16:creationId xmlns:a16="http://schemas.microsoft.com/office/drawing/2014/main" id="{89CE5481-2DC6-4B59-ABAE-B777A82AFAD1}"/>
+                <a16:creationId xmlns:a16="http://schemas.microsoft.com/office/drawing/2014/main" id="{7A4407F6-4D17-4E0C-A624-BCD7D23E603B}"/>
               </a:ext>
             </a:extLst>
           </p:cNvPr>
@@ -10784,7 +10784,7 @@
           <p:cNvPr id="15" name="">
             <a:extLst xmlns:a="http://schemas.openxmlformats.org/drawingml/2006/main">
               <a:ext uri="{FF2B5EF4-FFF2-40B4-BE49-F238E27FC236}">
-                <a16:creationId xmlns:a16="http://schemas.microsoft.com/office/drawing/2014/main" id="{3A1CA335-82B9-4D34-84BA-9B116BD30AFF}"/>
+                <a16:creationId xmlns:a16="http://schemas.microsoft.com/office/drawing/2014/main" id="{78890FA4-0611-42A3-A69B-3006926A4B05}"/>
               </a:ext>
             </a:extLst>
           </p:cNvPr>
@@ -10816,7 +10816,7 @@
           <p:cNvPr id="16" name="">
             <a:extLst xmlns:a="http://schemas.openxmlformats.org/drawingml/2006/main">
               <a:ext uri="{FF2B5EF4-FFF2-40B4-BE49-F238E27FC236}">
-                <a16:creationId xmlns:a16="http://schemas.microsoft.com/office/drawing/2014/main" id="{DE0754B9-A3C8-44B6-845C-3E57A67643C1}"/>
+                <a16:creationId xmlns:a16="http://schemas.microsoft.com/office/drawing/2014/main" id="{55294FEB-1FF4-4E2A-8ADC-D41C32C1F61A}"/>
               </a:ext>
             </a:extLst>
           </p:cNvPr>
@@ -10846,7 +10846,7 @@
           <p:cNvPr id="17" name="">
             <a:extLst xmlns:a="http://schemas.openxmlformats.org/drawingml/2006/main">
               <a:ext uri="{FF2B5EF4-FFF2-40B4-BE49-F238E27FC236}">
-                <a16:creationId xmlns:a16="http://schemas.microsoft.com/office/drawing/2014/main" id="{EFE8A660-14FB-4A6F-B185-1B70449DAD96}"/>
+                <a16:creationId xmlns:a16="http://schemas.microsoft.com/office/drawing/2014/main" id="{7795B38F-2A20-4F64-B03F-6B2C414C1666}"/>
               </a:ext>
             </a:extLst>
           </p:cNvPr>
@@ -10905,7 +10905,7 @@
           <p:cNvPr id="18" name="">
             <a:extLst xmlns:a="http://schemas.openxmlformats.org/drawingml/2006/main">
               <a:ext uri="{FF2B5EF4-FFF2-40B4-BE49-F238E27FC236}">
-                <a16:creationId xmlns:a16="http://schemas.microsoft.com/office/drawing/2014/main" id="{1A3D673C-DFD9-4F60-B57D-5578D215734A}"/>
+                <a16:creationId xmlns:a16="http://schemas.microsoft.com/office/drawing/2014/main" id="{E08B9595-71D6-4095-ADD1-F32059585251}"/>
               </a:ext>
             </a:extLst>
           </p:cNvPr>
@@ -10964,7 +10964,7 @@
           <p:cNvPr id="19" name="">
             <a:extLst xmlns:a="http://schemas.openxmlformats.org/drawingml/2006/main">
               <a:ext uri="{FF2B5EF4-FFF2-40B4-BE49-F238E27FC236}">
-                <a16:creationId xmlns:a16="http://schemas.microsoft.com/office/drawing/2014/main" id="{279DC393-FFA0-4703-9FD9-9B3F323816C5}"/>
+                <a16:creationId xmlns:a16="http://schemas.microsoft.com/office/drawing/2014/main" id="{77B6EF71-669B-46ED-BA02-44630B534812}"/>
               </a:ext>
             </a:extLst>
           </p:cNvPr>
@@ -10996,7 +10996,7 @@
           <p:cNvPr id="20" name="">
             <a:extLst xmlns:a="http://schemas.openxmlformats.org/drawingml/2006/main">
               <a:ext uri="{FF2B5EF4-FFF2-40B4-BE49-F238E27FC236}">
-                <a16:creationId xmlns:a16="http://schemas.microsoft.com/office/drawing/2014/main" id="{C8AB1B67-75C0-4FFE-A6EB-E4585105A378}"/>
+                <a16:creationId xmlns:a16="http://schemas.microsoft.com/office/drawing/2014/main" id="{ED3877DC-DE39-4F35-9EBC-D35EF9D89E0B}"/>
               </a:ext>
             </a:extLst>
           </p:cNvPr>
@@ -11026,7 +11026,7 @@
           <p:cNvPr id="21" name="">
             <a:extLst xmlns:a="http://schemas.openxmlformats.org/drawingml/2006/main">
               <a:ext uri="{FF2B5EF4-FFF2-40B4-BE49-F238E27FC236}">
-                <a16:creationId xmlns:a16="http://schemas.microsoft.com/office/drawing/2014/main" id="{5B5C798E-DB99-44CC-B268-6A7C1FB1F10C}"/>
+                <a16:creationId xmlns:a16="http://schemas.microsoft.com/office/drawing/2014/main" id="{ACD2E8AB-2F92-443B-A0C7-951C2F5E7AAB}"/>
               </a:ext>
             </a:extLst>
           </p:cNvPr>
@@ -11085,7 +11085,7 @@
           <p:cNvPr id="22" name="">
             <a:extLst xmlns:a="http://schemas.openxmlformats.org/drawingml/2006/main">
               <a:ext uri="{FF2B5EF4-FFF2-40B4-BE49-F238E27FC236}">
-                <a16:creationId xmlns:a16="http://schemas.microsoft.com/office/drawing/2014/main" id="{8AA33A28-15A8-4111-8200-3DC712FD06EC}"/>
+                <a16:creationId xmlns:a16="http://schemas.microsoft.com/office/drawing/2014/main" id="{30E8ED28-6A88-40FD-BFCD-079C69B4F6FB}"/>
               </a:ext>
             </a:extLst>
           </p:cNvPr>
@@ -11144,7 +11144,7 @@
           <p:cNvPr id="23" name="">
             <a:extLst xmlns:a="http://schemas.openxmlformats.org/drawingml/2006/main">
               <a:ext uri="{FF2B5EF4-FFF2-40B4-BE49-F238E27FC236}">
-                <a16:creationId xmlns:a16="http://schemas.microsoft.com/office/drawing/2014/main" id="{C71791A0-ACD2-4475-AEA8-280D8BDA8B38}"/>
+                <a16:creationId xmlns:a16="http://schemas.microsoft.com/office/drawing/2014/main" id="{98014181-29EC-498D-BD51-300C7EB2A0C0}"/>
               </a:ext>
             </a:extLst>
           </p:cNvPr>
@@ -11176,7 +11176,7 @@
           <p:cNvPr id="24" name="">
             <a:extLst xmlns:a="http://schemas.openxmlformats.org/drawingml/2006/main">
               <a:ext uri="{FF2B5EF4-FFF2-40B4-BE49-F238E27FC236}">
-                <a16:creationId xmlns:a16="http://schemas.microsoft.com/office/drawing/2014/main" id="{39E28B89-58E1-49DD-BA8B-7DE7307D39CA}"/>
+                <a16:creationId xmlns:a16="http://schemas.microsoft.com/office/drawing/2014/main" id="{3855D2A4-19E7-47EE-927F-79E13A6FE62B}"/>
               </a:ext>
             </a:extLst>
           </p:cNvPr>
@@ -11206,7 +11206,7 @@
           <p:cNvPr id="25" name="">
             <a:extLst xmlns:a="http://schemas.openxmlformats.org/drawingml/2006/main">
               <a:ext uri="{FF2B5EF4-FFF2-40B4-BE49-F238E27FC236}">
-                <a16:creationId xmlns:a16="http://schemas.microsoft.com/office/drawing/2014/main" id="{8E288396-2A7D-41C8-A601-9D676AB837C3}"/>
+                <a16:creationId xmlns:a16="http://schemas.microsoft.com/office/drawing/2014/main" id="{97B77DD3-94B0-45C4-A2B7-D7C821AD90A2}"/>
               </a:ext>
             </a:extLst>
           </p:cNvPr>
@@ -11265,7 +11265,7 @@
           <p:cNvPr id="26" name="">
             <a:extLst xmlns:a="http://schemas.openxmlformats.org/drawingml/2006/main">
               <a:ext uri="{FF2B5EF4-FFF2-40B4-BE49-F238E27FC236}">
-                <a16:creationId xmlns:a16="http://schemas.microsoft.com/office/drawing/2014/main" id="{EF04C5B9-84D7-461A-B923-519B5B806411}"/>
+                <a16:creationId xmlns:a16="http://schemas.microsoft.com/office/drawing/2014/main" id="{7359BECB-CD32-45BD-9057-9725128E2ECB}"/>
               </a:ext>
             </a:extLst>
           </p:cNvPr>
@@ -11324,7 +11324,7 @@
           <p:cNvPr id="27" name="">
             <a:extLst xmlns:a="http://schemas.openxmlformats.org/drawingml/2006/main">
               <a:ext uri="{FF2B5EF4-FFF2-40B4-BE49-F238E27FC236}">
-                <a16:creationId xmlns:a16="http://schemas.microsoft.com/office/drawing/2014/main" id="{2260A95E-107A-441C-8CE5-467016DFE314}"/>
+                <a16:creationId xmlns:a16="http://schemas.microsoft.com/office/drawing/2014/main" id="{7BDFC451-20C4-40D2-A58B-B1680152E9E8}"/>
               </a:ext>
             </a:extLst>
           </p:cNvPr>
@@ -11356,7 +11356,7 @@
           <p:cNvPr id="28" name="">
             <a:extLst xmlns:a="http://schemas.openxmlformats.org/drawingml/2006/main">
               <a:ext uri="{FF2B5EF4-FFF2-40B4-BE49-F238E27FC236}">
-                <a16:creationId xmlns:a16="http://schemas.microsoft.com/office/drawing/2014/main" id="{92E1B024-CD96-4C2F-A3B7-E9804060C910}"/>
+                <a16:creationId xmlns:a16="http://schemas.microsoft.com/office/drawing/2014/main" id="{BE492781-74F9-44D5-9D79-CDB02171BBF6}"/>
               </a:ext>
             </a:extLst>
           </p:cNvPr>
@@ -11386,7 +11386,7 @@
           <p:cNvPr id="29" name="">
             <a:extLst xmlns:a="http://schemas.openxmlformats.org/drawingml/2006/main">
               <a:ext uri="{FF2B5EF4-FFF2-40B4-BE49-F238E27FC236}">
-                <a16:creationId xmlns:a16="http://schemas.microsoft.com/office/drawing/2014/main" id="{832CC6B5-119C-4E03-A5C4-472A97872B86}"/>
+                <a16:creationId xmlns:a16="http://schemas.microsoft.com/office/drawing/2014/main" id="{96210674-2BCD-4FB7-B34B-B9E695A73DCB}"/>
               </a:ext>
             </a:extLst>
           </p:cNvPr>
@@ -11445,7 +11445,7 @@
           <p:cNvPr id="30" name="">
             <a:extLst xmlns:a="http://schemas.openxmlformats.org/drawingml/2006/main">
               <a:ext uri="{FF2B5EF4-FFF2-40B4-BE49-F238E27FC236}">
-                <a16:creationId xmlns:a16="http://schemas.microsoft.com/office/drawing/2014/main" id="{26991D18-0CEC-42C0-9E36-DA079AA82BEE}"/>
+                <a16:creationId xmlns:a16="http://schemas.microsoft.com/office/drawing/2014/main" id="{66F0DA6E-227D-4E0B-9CD8-925D67A87680}"/>
               </a:ext>
             </a:extLst>
           </p:cNvPr>
@@ -11502,7 +11502,7 @@
     </p:spTree>
     <p:extLst>
       <p:ext uri="{BB962C8B-B14F-4D97-AF65-F5344CB8AC3E}">
-        <p14:creationId xmlns:p14="http://schemas.microsoft.com/office/powerpoint/2010/main" val="960013846"/>
+        <p14:creationId xmlns:p14="http://schemas.microsoft.com/office/powerpoint/2010/main" val="1019143181"/>
       </p:ext>
     </p:extLst>
   </p:cSld>
@@ -11526,7 +11526,7 @@
           <p:cNvPr id="1" name="">
             <a:extLst xmlns:a="http://schemas.openxmlformats.org/drawingml/2006/main">
               <a:ext uri="{FF2B5EF4-FFF2-40B4-BE49-F238E27FC236}">
-                <a16:creationId xmlns:a16="http://schemas.microsoft.com/office/drawing/2014/main" id="{17486668-4FF9-44F7-B330-9C54A73D0A75}"/>
+                <a16:creationId xmlns:a16="http://schemas.microsoft.com/office/drawing/2014/main" id="{9A3D2E29-C753-490F-BD34-AB8D9786F4DD}"/>
               </a:ext>
             </a:extLst>
           </p:cNvPr>
@@ -11556,7 +11556,7 @@
           <p:cNvPr id="2" name="">
             <a:extLst xmlns:a="http://schemas.openxmlformats.org/drawingml/2006/main">
               <a:ext uri="{FF2B5EF4-FFF2-40B4-BE49-F238E27FC236}">
-                <a16:creationId xmlns:a16="http://schemas.microsoft.com/office/drawing/2014/main" id="{8283901E-D7BD-4F2D-8A3A-590C77578137}"/>
+                <a16:creationId xmlns:a16="http://schemas.microsoft.com/office/drawing/2014/main" id="{0B709EE5-613D-461D-AC5F-120E5CB263CD}"/>
               </a:ext>
             </a:extLst>
           </p:cNvPr>
@@ -11586,7 +11586,7 @@
           <p:cNvPr id="3" name="">
             <a:extLst xmlns:a="http://schemas.openxmlformats.org/drawingml/2006/main">
               <a:ext uri="{FF2B5EF4-FFF2-40B4-BE49-F238E27FC236}">
-                <a16:creationId xmlns:a16="http://schemas.microsoft.com/office/drawing/2014/main" id="{C70E5486-3C76-438F-B731-22DCA82125C8}"/>
+                <a16:creationId xmlns:a16="http://schemas.microsoft.com/office/drawing/2014/main" id="{9B00EE5D-DA48-4331-8C83-F6091372ABC6}"/>
               </a:ext>
             </a:extLst>
           </p:cNvPr>
@@ -11645,7 +11645,7 @@
           <p:cNvPr id="4" name="">
             <a:extLst xmlns:a="http://schemas.openxmlformats.org/drawingml/2006/main">
               <a:ext uri="{FF2B5EF4-FFF2-40B4-BE49-F238E27FC236}">
-                <a16:creationId xmlns:a16="http://schemas.microsoft.com/office/drawing/2014/main" id="{1627BC6A-CB4F-4893-8C05-6BCF6563032A}"/>
+                <a16:creationId xmlns:a16="http://schemas.microsoft.com/office/drawing/2014/main" id="{16979DA3-34D0-4704-AB8E-AC853D2506E0}"/>
               </a:ext>
             </a:extLst>
           </p:cNvPr>
@@ -11704,7 +11704,7 @@
           <p:cNvPr id="5" name="">
             <a:extLst xmlns:a="http://schemas.openxmlformats.org/drawingml/2006/main">
               <a:ext uri="{FF2B5EF4-FFF2-40B4-BE49-F238E27FC236}">
-                <a16:creationId xmlns:a16="http://schemas.microsoft.com/office/drawing/2014/main" id="{FB597D4E-7F5B-4F09-A77A-1C3FB8DF36B8}"/>
+                <a16:creationId xmlns:a16="http://schemas.microsoft.com/office/drawing/2014/main" id="{EDE5C0FA-8E13-468D-916D-FFC75C221AEB}"/>
               </a:ext>
             </a:extLst>
           </p:cNvPr>
@@ -11763,7 +11763,7 @@
           <p:cNvPr id="6" name="">
             <a:extLst xmlns:a="http://schemas.openxmlformats.org/drawingml/2006/main">
               <a:ext uri="{FF2B5EF4-FFF2-40B4-BE49-F238E27FC236}">
-                <a16:creationId xmlns:a16="http://schemas.microsoft.com/office/drawing/2014/main" id="{91A36302-5F89-4120-B07C-8BCB47BE315D}"/>
+                <a16:creationId xmlns:a16="http://schemas.microsoft.com/office/drawing/2014/main" id="{9844015C-0533-4197-B5F9-53D125029ECE}"/>
               </a:ext>
             </a:extLst>
           </p:cNvPr>
@@ -11826,7 +11826,7 @@
           <p:nvPr/>
         </p:nvPicPr>
         <p:blipFill>
-          <a:blip xmlns:r="http://schemas.openxmlformats.org/officeDocument/2006/relationships" xmlns:a="http://schemas.openxmlformats.org/drawingml/2006/main" r:embed="Rd5bfd379c0ba44ec"/>
+          <a:blip xmlns:r="http://schemas.openxmlformats.org/officeDocument/2006/relationships" xmlns:a="http://schemas.openxmlformats.org/drawingml/2006/main" r:embed="R4375b40623e04bb9"/>
           <a:srcRect xmlns:a="http://schemas.openxmlformats.org/drawingml/2006/main" l="568" t="0" r="568" b="0"/>
           <a:stretch xmlns:a="http://schemas.openxmlformats.org/drawingml/2006/main">
             <a:fillRect l="0" t="0" r="0" b="0"/>
@@ -11847,7 +11847,7 @@
           <p:cNvPr id="8" name="">
             <a:extLst xmlns:a="http://schemas.openxmlformats.org/drawingml/2006/main">
               <a:ext uri="{FF2B5EF4-FFF2-40B4-BE49-F238E27FC236}">
-                <a16:creationId xmlns:a16="http://schemas.microsoft.com/office/drawing/2014/main" id="{9C6A4456-4E8E-4AEA-8520-2290DAB803E2}"/>
+                <a16:creationId xmlns:a16="http://schemas.microsoft.com/office/drawing/2014/main" id="{D68392FD-1B6E-487F-9AD5-5CEC472DAA17}"/>
               </a:ext>
             </a:extLst>
           </p:cNvPr>
@@ -11879,7 +11879,7 @@
           <p:cNvPr id="9" name="">
             <a:extLst xmlns:a="http://schemas.openxmlformats.org/drawingml/2006/main">
               <a:ext uri="{FF2B5EF4-FFF2-40B4-BE49-F238E27FC236}">
-                <a16:creationId xmlns:a16="http://schemas.microsoft.com/office/drawing/2014/main" id="{F15173CC-03BE-4B21-8BCF-863F7E9C5A3A}"/>
+                <a16:creationId xmlns:a16="http://schemas.microsoft.com/office/drawing/2014/main" id="{11927B5E-8C44-4070-9B77-0AD42BF22532}"/>
               </a:ext>
             </a:extLst>
           </p:cNvPr>
@@ -11913,7 +11913,7 @@
           <p:cNvPr id="10" name="">
             <a:extLst xmlns:a="http://schemas.openxmlformats.org/drawingml/2006/main">
               <a:ext uri="{FF2B5EF4-FFF2-40B4-BE49-F238E27FC236}">
-                <a16:creationId xmlns:a16="http://schemas.microsoft.com/office/drawing/2014/main" id="{0B9D6470-2B0D-403C-9CA6-F7670DEEAE67}"/>
+                <a16:creationId xmlns:a16="http://schemas.microsoft.com/office/drawing/2014/main" id="{F8F5D035-551F-40B9-87DB-BE8E56FC106D}"/>
               </a:ext>
             </a:extLst>
           </p:cNvPr>
@@ -11945,7 +11945,7 @@
           <p:cNvPr id="11" name="">
             <a:extLst xmlns:a="http://schemas.openxmlformats.org/drawingml/2006/main">
               <a:ext uri="{FF2B5EF4-FFF2-40B4-BE49-F238E27FC236}">
-                <a16:creationId xmlns:a16="http://schemas.microsoft.com/office/drawing/2014/main" id="{C4537C02-E320-4EA4-94DF-4FD1E2401C09}"/>
+                <a16:creationId xmlns:a16="http://schemas.microsoft.com/office/drawing/2014/main" id="{907F9E9F-731B-449B-9B68-3B645256A036}"/>
               </a:ext>
             </a:extLst>
           </p:cNvPr>
@@ -12004,7 +12004,7 @@
           <p:cNvPr id="12" name="">
             <a:extLst xmlns:a="http://schemas.openxmlformats.org/drawingml/2006/main">
               <a:ext uri="{FF2B5EF4-FFF2-40B4-BE49-F238E27FC236}">
-                <a16:creationId xmlns:a16="http://schemas.microsoft.com/office/drawing/2014/main" id="{0788A661-47F5-417D-B4A4-493B5C75D887}"/>
+                <a16:creationId xmlns:a16="http://schemas.microsoft.com/office/drawing/2014/main" id="{FB31CC87-85B2-426C-90FE-3ABDCF116791}"/>
               </a:ext>
             </a:extLst>
           </p:cNvPr>
@@ -12063,7 +12063,7 @@
           <p:cNvPr id="13" name="">
             <a:extLst xmlns:a="http://schemas.openxmlformats.org/drawingml/2006/main">
               <a:ext uri="{FF2B5EF4-FFF2-40B4-BE49-F238E27FC236}">
-                <a16:creationId xmlns:a16="http://schemas.microsoft.com/office/drawing/2014/main" id="{B38216C6-E757-4F54-8D1E-54517E8E65CB}"/>
+                <a16:creationId xmlns:a16="http://schemas.microsoft.com/office/drawing/2014/main" id="{09BEDA0D-1507-4E93-AD45-4550CC214818}"/>
               </a:ext>
             </a:extLst>
           </p:cNvPr>
@@ -12095,7 +12095,7 @@
           <p:cNvPr id="14" name="">
             <a:extLst xmlns:a="http://schemas.openxmlformats.org/drawingml/2006/main">
               <a:ext uri="{FF2B5EF4-FFF2-40B4-BE49-F238E27FC236}">
-                <a16:creationId xmlns:a16="http://schemas.microsoft.com/office/drawing/2014/main" id="{33F0F3A0-E1E9-41A1-8606-25B29E8DF1CC}"/>
+                <a16:creationId xmlns:a16="http://schemas.microsoft.com/office/drawing/2014/main" id="{87048039-C07B-4909-9CE2-0ED162DE97B2}"/>
               </a:ext>
             </a:extLst>
           </p:cNvPr>
@@ -12154,7 +12154,7 @@
           <p:cNvPr id="15" name="">
             <a:extLst xmlns:a="http://schemas.openxmlformats.org/drawingml/2006/main">
               <a:ext uri="{FF2B5EF4-FFF2-40B4-BE49-F238E27FC236}">
-                <a16:creationId xmlns:a16="http://schemas.microsoft.com/office/drawing/2014/main" id="{C65744F6-C5BF-437F-840A-C8EC3B1B48BD}"/>
+                <a16:creationId xmlns:a16="http://schemas.microsoft.com/office/drawing/2014/main" id="{B4D88FAC-6993-4FE6-9CC1-B0821AF3E173}"/>
               </a:ext>
             </a:extLst>
           </p:cNvPr>
@@ -12213,7 +12213,7 @@
           <p:cNvPr id="16" name="">
             <a:extLst xmlns:a="http://schemas.openxmlformats.org/drawingml/2006/main">
               <a:ext uri="{FF2B5EF4-FFF2-40B4-BE49-F238E27FC236}">
-                <a16:creationId xmlns:a16="http://schemas.microsoft.com/office/drawing/2014/main" id="{689364A6-79F2-4123-B638-27047B881937}"/>
+                <a16:creationId xmlns:a16="http://schemas.microsoft.com/office/drawing/2014/main" id="{12F73346-DFA8-473C-B0D7-E526FC412938}"/>
               </a:ext>
             </a:extLst>
           </p:cNvPr>
@@ -12245,7 +12245,7 @@
           <p:cNvPr id="17" name="">
             <a:extLst xmlns:a="http://schemas.openxmlformats.org/drawingml/2006/main">
               <a:ext uri="{FF2B5EF4-FFF2-40B4-BE49-F238E27FC236}">
-                <a16:creationId xmlns:a16="http://schemas.microsoft.com/office/drawing/2014/main" id="{05CDBDBD-88EE-41DE-B4BE-9AB135AC5ECF}"/>
+                <a16:creationId xmlns:a16="http://schemas.microsoft.com/office/drawing/2014/main" id="{487EBF33-B7CA-40E4-B457-7340B5AA0D05}"/>
               </a:ext>
             </a:extLst>
           </p:cNvPr>
@@ -12304,7 +12304,7 @@
           <p:cNvPr id="18" name="">
             <a:extLst xmlns:a="http://schemas.openxmlformats.org/drawingml/2006/main">
               <a:ext uri="{FF2B5EF4-FFF2-40B4-BE49-F238E27FC236}">
-                <a16:creationId xmlns:a16="http://schemas.microsoft.com/office/drawing/2014/main" id="{C9EDF68E-43BD-43D2-9920-5544898E6E28}"/>
+                <a16:creationId xmlns:a16="http://schemas.microsoft.com/office/drawing/2014/main" id="{D9A2E3E3-9FD4-4DA6-88FA-CCE290282003}"/>
               </a:ext>
             </a:extLst>
           </p:cNvPr>
@@ -12363,7 +12363,7 @@
           <p:cNvPr id="19" name="">
             <a:extLst xmlns:a="http://schemas.openxmlformats.org/drawingml/2006/main">
               <a:ext uri="{FF2B5EF4-FFF2-40B4-BE49-F238E27FC236}">
-                <a16:creationId xmlns:a16="http://schemas.microsoft.com/office/drawing/2014/main" id="{0D447B7C-B43A-4AD3-889C-F01A982FA361}"/>
+                <a16:creationId xmlns:a16="http://schemas.microsoft.com/office/drawing/2014/main" id="{EC86CF93-7C4D-4D83-950E-444846165062}"/>
               </a:ext>
             </a:extLst>
           </p:cNvPr>
@@ -12395,7 +12395,7 @@
           <p:cNvPr id="20" name="">
             <a:extLst xmlns:a="http://schemas.openxmlformats.org/drawingml/2006/main">
               <a:ext uri="{FF2B5EF4-FFF2-40B4-BE49-F238E27FC236}">
-                <a16:creationId xmlns:a16="http://schemas.microsoft.com/office/drawing/2014/main" id="{D84F115E-926B-44F1-8679-417FAA21D72D}"/>
+                <a16:creationId xmlns:a16="http://schemas.microsoft.com/office/drawing/2014/main" id="{E05D949B-CD68-4427-89DE-D1F318655968}"/>
               </a:ext>
             </a:extLst>
           </p:cNvPr>
@@ -12454,7 +12454,7 @@
           <p:cNvPr id="21" name="">
             <a:extLst xmlns:a="http://schemas.openxmlformats.org/drawingml/2006/main">
               <a:ext uri="{FF2B5EF4-FFF2-40B4-BE49-F238E27FC236}">
-                <a16:creationId xmlns:a16="http://schemas.microsoft.com/office/drawing/2014/main" id="{DBFB9B2C-7C19-4925-92A9-AE063168E4BE}"/>
+                <a16:creationId xmlns:a16="http://schemas.microsoft.com/office/drawing/2014/main" id="{11976B7B-967D-4968-8612-E1EDCD233DD0}"/>
               </a:ext>
             </a:extLst>
           </p:cNvPr>
@@ -12513,7 +12513,7 @@
           <p:cNvPr id="22" name="">
             <a:extLst xmlns:a="http://schemas.openxmlformats.org/drawingml/2006/main">
               <a:ext uri="{FF2B5EF4-FFF2-40B4-BE49-F238E27FC236}">
-                <a16:creationId xmlns:a16="http://schemas.microsoft.com/office/drawing/2014/main" id="{30D49BAA-C3FC-417A-88EE-22C5E7876F4E}"/>
+                <a16:creationId xmlns:a16="http://schemas.microsoft.com/office/drawing/2014/main" id="{2AE2E368-DD08-4B58-B4FF-DD2E7F5D9292}"/>
               </a:ext>
             </a:extLst>
           </p:cNvPr>
@@ -12545,7 +12545,7 @@
           <p:cNvPr id="23" name="">
             <a:extLst xmlns:a="http://schemas.openxmlformats.org/drawingml/2006/main">
               <a:ext uri="{FF2B5EF4-FFF2-40B4-BE49-F238E27FC236}">
-                <a16:creationId xmlns:a16="http://schemas.microsoft.com/office/drawing/2014/main" id="{A826D7EB-9E56-4AF1-A872-74709C219E60}"/>
+                <a16:creationId xmlns:a16="http://schemas.microsoft.com/office/drawing/2014/main" id="{6FF09285-B02E-4BFF-831C-A222E1A7C920}"/>
               </a:ext>
             </a:extLst>
           </p:cNvPr>
@@ -12575,7 +12575,7 @@
           <p:cNvPr id="24" name="">
             <a:extLst xmlns:a="http://schemas.openxmlformats.org/drawingml/2006/main">
               <a:ext uri="{FF2B5EF4-FFF2-40B4-BE49-F238E27FC236}">
-                <a16:creationId xmlns:a16="http://schemas.microsoft.com/office/drawing/2014/main" id="{5F274629-3B32-4C47-BDA9-01C4845BA676}"/>
+                <a16:creationId xmlns:a16="http://schemas.microsoft.com/office/drawing/2014/main" id="{92EBBB46-F49A-4B58-BD04-CAFD042F2B22}"/>
               </a:ext>
             </a:extLst>
           </p:cNvPr>
@@ -12634,7 +12634,7 @@
           <p:cNvPr id="25" name="">
             <a:extLst xmlns:a="http://schemas.openxmlformats.org/drawingml/2006/main">
               <a:ext uri="{FF2B5EF4-FFF2-40B4-BE49-F238E27FC236}">
-                <a16:creationId xmlns:a16="http://schemas.microsoft.com/office/drawing/2014/main" id="{80993AD1-46CE-47AC-90AA-16F1D0323523}"/>
+                <a16:creationId xmlns:a16="http://schemas.microsoft.com/office/drawing/2014/main" id="{72A49895-D683-46EB-93CA-FAB03D79DE7B}"/>
               </a:ext>
             </a:extLst>
           </p:cNvPr>
@@ -12693,7 +12693,7 @@
           <p:cNvPr id="26" name="">
             <a:extLst xmlns:a="http://schemas.openxmlformats.org/drawingml/2006/main">
               <a:ext uri="{FF2B5EF4-FFF2-40B4-BE49-F238E27FC236}">
-                <a16:creationId xmlns:a16="http://schemas.microsoft.com/office/drawing/2014/main" id="{20BC6C59-549D-48EB-B160-8642F7BFCAB0}"/>
+                <a16:creationId xmlns:a16="http://schemas.microsoft.com/office/drawing/2014/main" id="{A103CCB7-1AC4-4755-99C7-9F7BA4355AEA}"/>
               </a:ext>
             </a:extLst>
           </p:cNvPr>
@@ -12725,7 +12725,7 @@
           <p:cNvPr id="27" name="">
             <a:extLst xmlns:a="http://schemas.openxmlformats.org/drawingml/2006/main">
               <a:ext uri="{FF2B5EF4-FFF2-40B4-BE49-F238E27FC236}">
-                <a16:creationId xmlns:a16="http://schemas.microsoft.com/office/drawing/2014/main" id="{55BF6FFB-F42A-4B2C-955E-2B63C6DCC191}"/>
+                <a16:creationId xmlns:a16="http://schemas.microsoft.com/office/drawing/2014/main" id="{DACE92D7-93FC-4EB9-9D6F-212AD03CB3D7}"/>
               </a:ext>
             </a:extLst>
           </p:cNvPr>
@@ -12755,7 +12755,7 @@
           <p:cNvPr id="28" name="">
             <a:extLst xmlns:a="http://schemas.openxmlformats.org/drawingml/2006/main">
               <a:ext uri="{FF2B5EF4-FFF2-40B4-BE49-F238E27FC236}">
-                <a16:creationId xmlns:a16="http://schemas.microsoft.com/office/drawing/2014/main" id="{CE3E272D-FA1E-4ABD-9EE0-B3EF6D81F5E2}"/>
+                <a16:creationId xmlns:a16="http://schemas.microsoft.com/office/drawing/2014/main" id="{6A0DC94C-0EE4-4E34-B982-D1B4DA6F6A72}"/>
               </a:ext>
             </a:extLst>
           </p:cNvPr>
@@ -12814,7 +12814,7 @@
           <p:cNvPr id="29" name="">
             <a:extLst xmlns:a="http://schemas.openxmlformats.org/drawingml/2006/main">
               <a:ext uri="{FF2B5EF4-FFF2-40B4-BE49-F238E27FC236}">
-                <a16:creationId xmlns:a16="http://schemas.microsoft.com/office/drawing/2014/main" id="{BE413BBB-E940-4D7E-A72C-4AAEF8541292}"/>
+                <a16:creationId xmlns:a16="http://schemas.microsoft.com/office/drawing/2014/main" id="{1B0DF796-D571-4F0A-8BD2-E9690A8B1198}"/>
               </a:ext>
             </a:extLst>
           </p:cNvPr>
@@ -12873,7 +12873,7 @@
           <p:cNvPr id="30" name="">
             <a:extLst xmlns:a="http://schemas.openxmlformats.org/drawingml/2006/main">
               <a:ext uri="{FF2B5EF4-FFF2-40B4-BE49-F238E27FC236}">
-                <a16:creationId xmlns:a16="http://schemas.microsoft.com/office/drawing/2014/main" id="{F79EEFE3-D505-4E74-B2FA-C3B81AC68B2B}"/>
+                <a16:creationId xmlns:a16="http://schemas.microsoft.com/office/drawing/2014/main" id="{383665A6-D724-4235-A413-BD00899C9B93}"/>
               </a:ext>
             </a:extLst>
           </p:cNvPr>
@@ -12905,7 +12905,7 @@
           <p:cNvPr id="31" name="">
             <a:extLst xmlns:a="http://schemas.openxmlformats.org/drawingml/2006/main">
               <a:ext uri="{FF2B5EF4-FFF2-40B4-BE49-F238E27FC236}">
-                <a16:creationId xmlns:a16="http://schemas.microsoft.com/office/drawing/2014/main" id="{919E35D7-DDD8-43F4-BC34-15DD2B54920A}"/>
+                <a16:creationId xmlns:a16="http://schemas.microsoft.com/office/drawing/2014/main" id="{A1DBB2C3-DD4F-42D3-9885-4C470D36B0F1}"/>
               </a:ext>
             </a:extLst>
           </p:cNvPr>
@@ -12935,7 +12935,7 @@
           <p:cNvPr id="32" name="">
             <a:extLst xmlns:a="http://schemas.openxmlformats.org/drawingml/2006/main">
               <a:ext uri="{FF2B5EF4-FFF2-40B4-BE49-F238E27FC236}">
-                <a16:creationId xmlns:a16="http://schemas.microsoft.com/office/drawing/2014/main" id="{0384AC86-8272-4714-8D05-FDE6D2C47A1B}"/>
+                <a16:creationId xmlns:a16="http://schemas.microsoft.com/office/drawing/2014/main" id="{7675B15F-6195-41B0-9985-D20ADE42F6B4}"/>
               </a:ext>
             </a:extLst>
           </p:cNvPr>
@@ -12994,7 +12994,7 @@
           <p:cNvPr id="33" name="">
             <a:extLst xmlns:a="http://schemas.openxmlformats.org/drawingml/2006/main">
               <a:ext uri="{FF2B5EF4-FFF2-40B4-BE49-F238E27FC236}">
-                <a16:creationId xmlns:a16="http://schemas.microsoft.com/office/drawing/2014/main" id="{C1870208-533F-48FC-9B81-329377841836}"/>
+                <a16:creationId xmlns:a16="http://schemas.microsoft.com/office/drawing/2014/main" id="{C6E770BF-E9C4-4100-A85B-29976A15C952}"/>
               </a:ext>
             </a:extLst>
           </p:cNvPr>
@@ -13053,7 +13053,7 @@
           <p:cNvPr id="34" name="">
             <a:extLst xmlns:a="http://schemas.openxmlformats.org/drawingml/2006/main">
               <a:ext uri="{FF2B5EF4-FFF2-40B4-BE49-F238E27FC236}">
-                <a16:creationId xmlns:a16="http://schemas.microsoft.com/office/drawing/2014/main" id="{7EE4E0B6-1DB8-41F6-A935-74D1AA9F6E8A}"/>
+                <a16:creationId xmlns:a16="http://schemas.microsoft.com/office/drawing/2014/main" id="{9013DFE3-18F2-4EDA-BC63-B9361EE297E4}"/>
               </a:ext>
             </a:extLst>
           </p:cNvPr>
@@ -13085,7 +13085,7 @@
           <p:cNvPr id="35" name="">
             <a:extLst xmlns:a="http://schemas.openxmlformats.org/drawingml/2006/main">
               <a:ext uri="{FF2B5EF4-FFF2-40B4-BE49-F238E27FC236}">
-                <a16:creationId xmlns:a16="http://schemas.microsoft.com/office/drawing/2014/main" id="{62C10CE5-698C-41DE-B454-A848EEE38550}"/>
+                <a16:creationId xmlns:a16="http://schemas.microsoft.com/office/drawing/2014/main" id="{AE04BEA9-2886-4A7B-B450-C4C54E0E1C89}"/>
               </a:ext>
             </a:extLst>
           </p:cNvPr>
@@ -13142,7 +13142,7 @@
     </p:spTree>
     <p:extLst>
       <p:ext uri="{BB962C8B-B14F-4D97-AF65-F5344CB8AC3E}">
-        <p14:creationId xmlns:p14="http://schemas.microsoft.com/office/powerpoint/2010/main" val="1497820234"/>
+        <p14:creationId xmlns:p14="http://schemas.microsoft.com/office/powerpoint/2010/main" val="1973109827"/>
       </p:ext>
     </p:extLst>
   </p:cSld>
@@ -13166,7 +13166,7 @@
           <p:cNvPr id="1" name="">
             <a:extLst xmlns:a="http://schemas.openxmlformats.org/drawingml/2006/main">
               <a:ext uri="{FF2B5EF4-FFF2-40B4-BE49-F238E27FC236}">
-                <a16:creationId xmlns:a16="http://schemas.microsoft.com/office/drawing/2014/main" id="{48C80C64-8FE1-42CE-8187-D15C18E10771}"/>
+                <a16:creationId xmlns:a16="http://schemas.microsoft.com/office/drawing/2014/main" id="{1EF74E95-9376-4125-A7DA-709A07A531B6}"/>
               </a:ext>
             </a:extLst>
           </p:cNvPr>
@@ -13196,7 +13196,7 @@
           <p:cNvPr id="2" name="">
             <a:extLst xmlns:a="http://schemas.openxmlformats.org/drawingml/2006/main">
               <a:ext uri="{FF2B5EF4-FFF2-40B4-BE49-F238E27FC236}">
-                <a16:creationId xmlns:a16="http://schemas.microsoft.com/office/drawing/2014/main" id="{E7ACB8BD-D817-49A2-B05C-5B41810C5E67}"/>
+                <a16:creationId xmlns:a16="http://schemas.microsoft.com/office/drawing/2014/main" id="{81AE56CA-99CA-49B7-802C-26C2D484076F}"/>
               </a:ext>
             </a:extLst>
           </p:cNvPr>
@@ -13226,7 +13226,7 @@
           <p:cNvPr id="3" name="">
             <a:extLst xmlns:a="http://schemas.openxmlformats.org/drawingml/2006/main">
               <a:ext uri="{FF2B5EF4-FFF2-40B4-BE49-F238E27FC236}">
-                <a16:creationId xmlns:a16="http://schemas.microsoft.com/office/drawing/2014/main" id="{7AD23AF9-4E1E-428C-8E1A-ADA2211C8812}"/>
+                <a16:creationId xmlns:a16="http://schemas.microsoft.com/office/drawing/2014/main" id="{34BFE85C-84F0-439D-B499-06D3ECBB424A}"/>
               </a:ext>
             </a:extLst>
           </p:cNvPr>
@@ -13285,7 +13285,7 @@
           <p:cNvPr id="4" name="">
             <a:extLst xmlns:a="http://schemas.openxmlformats.org/drawingml/2006/main">
               <a:ext uri="{FF2B5EF4-FFF2-40B4-BE49-F238E27FC236}">
-                <a16:creationId xmlns:a16="http://schemas.microsoft.com/office/drawing/2014/main" id="{009B167D-D0FA-472B-B703-9907279AEBED}"/>
+                <a16:creationId xmlns:a16="http://schemas.microsoft.com/office/drawing/2014/main" id="{4F4E0591-E272-44D0-BD0D-17F1A1F5B0D0}"/>
               </a:ext>
             </a:extLst>
           </p:cNvPr>
@@ -13344,7 +13344,7 @@
           <p:cNvPr id="5" name="">
             <a:extLst xmlns:a="http://schemas.openxmlformats.org/drawingml/2006/main">
               <a:ext uri="{FF2B5EF4-FFF2-40B4-BE49-F238E27FC236}">
-                <a16:creationId xmlns:a16="http://schemas.microsoft.com/office/drawing/2014/main" id="{096E94CA-EE34-4CDF-AA49-CEBF570727AD}"/>
+                <a16:creationId xmlns:a16="http://schemas.microsoft.com/office/drawing/2014/main" id="{0D0D3CC0-98C3-40F3-B213-16BC18E1095E}"/>
               </a:ext>
             </a:extLst>
           </p:cNvPr>
@@ -13403,7 +13403,7 @@
           <p:cNvPr id="6" name="">
             <a:extLst xmlns:a="http://schemas.openxmlformats.org/drawingml/2006/main">
               <a:ext uri="{FF2B5EF4-FFF2-40B4-BE49-F238E27FC236}">
-                <a16:creationId xmlns:a16="http://schemas.microsoft.com/office/drawing/2014/main" id="{87924974-E43A-4662-B42A-2F5685D52E7A}"/>
+                <a16:creationId xmlns:a16="http://schemas.microsoft.com/office/drawing/2014/main" id="{C9DACC21-83DA-4F72-A52C-77BAEBC3447A}"/>
               </a:ext>
             </a:extLst>
           </p:cNvPr>
@@ -13466,7 +13466,7 @@
           <p:nvPr/>
         </p:nvPicPr>
         <p:blipFill>
-          <a:blip xmlns:r="http://schemas.openxmlformats.org/officeDocument/2006/relationships" xmlns:a="http://schemas.openxmlformats.org/drawingml/2006/main" r:embed="R7aa6a3553f7e4844"/>
+          <a:blip xmlns:r="http://schemas.openxmlformats.org/officeDocument/2006/relationships" xmlns:a="http://schemas.openxmlformats.org/drawingml/2006/main" r:embed="R74dba8ca9a9543eb"/>
           <a:srcRect xmlns:a="http://schemas.openxmlformats.org/drawingml/2006/main" l="413" t="0" r="413" b="0"/>
           <a:stretch xmlns:a="http://schemas.openxmlformats.org/drawingml/2006/main">
             <a:fillRect l="0" t="0" r="0" b="0"/>
@@ -13487,7 +13487,7 @@
           <p:cNvPr id="8" name="">
             <a:extLst xmlns:a="http://schemas.openxmlformats.org/drawingml/2006/main">
               <a:ext uri="{FF2B5EF4-FFF2-40B4-BE49-F238E27FC236}">
-                <a16:creationId xmlns:a16="http://schemas.microsoft.com/office/drawing/2014/main" id="{93704DB8-429B-4718-9B31-6FA45DEA0BC0}"/>
+                <a16:creationId xmlns:a16="http://schemas.microsoft.com/office/drawing/2014/main" id="{25F4DFC7-2D46-4DAB-BD82-4432A92EECE8}"/>
               </a:ext>
             </a:extLst>
           </p:cNvPr>
@@ -13519,7 +13519,7 @@
           <p:cNvPr id="9" name="">
             <a:extLst xmlns:a="http://schemas.openxmlformats.org/drawingml/2006/main">
               <a:ext uri="{FF2B5EF4-FFF2-40B4-BE49-F238E27FC236}">
-                <a16:creationId xmlns:a16="http://schemas.microsoft.com/office/drawing/2014/main" id="{D60ECF03-DDB5-4B9D-ADB5-A5351C9AB64E}"/>
+                <a16:creationId xmlns:a16="http://schemas.microsoft.com/office/drawing/2014/main" id="{C95607EE-3DC1-4DDF-B1A6-6D262007D889}"/>
               </a:ext>
             </a:extLst>
           </p:cNvPr>
@@ -13553,7 +13553,7 @@
           <p:cNvPr id="10" name="">
             <a:extLst xmlns:a="http://schemas.openxmlformats.org/drawingml/2006/main">
               <a:ext uri="{FF2B5EF4-FFF2-40B4-BE49-F238E27FC236}">
-                <a16:creationId xmlns:a16="http://schemas.microsoft.com/office/drawing/2014/main" id="{EFC507BF-5EA7-45A8-B0ED-F4D13C5DB297}"/>
+                <a16:creationId xmlns:a16="http://schemas.microsoft.com/office/drawing/2014/main" id="{351024A7-5EC9-4E9D-9BC3-342B58E3CDF2}"/>
               </a:ext>
             </a:extLst>
           </p:cNvPr>
@@ -13583,7 +13583,7 @@
           <p:cNvPr id="11" name="">
             <a:extLst xmlns:a="http://schemas.openxmlformats.org/drawingml/2006/main">
               <a:ext uri="{FF2B5EF4-FFF2-40B4-BE49-F238E27FC236}">
-                <a16:creationId xmlns:a16="http://schemas.microsoft.com/office/drawing/2014/main" id="{AE702EBE-026B-48EC-A315-491DA96C4EE3}"/>
+                <a16:creationId xmlns:a16="http://schemas.microsoft.com/office/drawing/2014/main" id="{AB8D3F50-A6F1-4D17-8448-D8432026F2AB}"/>
               </a:ext>
             </a:extLst>
           </p:cNvPr>
@@ -13613,7 +13613,7 @@
           <p:cNvPr id="12" name="">
             <a:extLst xmlns:a="http://schemas.openxmlformats.org/drawingml/2006/main">
               <a:ext uri="{FF2B5EF4-FFF2-40B4-BE49-F238E27FC236}">
-                <a16:creationId xmlns:a16="http://schemas.microsoft.com/office/drawing/2014/main" id="{1BEEC4E7-2BA3-4599-BE47-8900A27DEE3F}"/>
+                <a16:creationId xmlns:a16="http://schemas.microsoft.com/office/drawing/2014/main" id="{B0C8CCE0-3E0C-4533-9882-E93BC2FDB55C}"/>
               </a:ext>
             </a:extLst>
           </p:cNvPr>
@@ -13672,7 +13672,7 @@
           <p:cNvPr id="13" name="">
             <a:extLst xmlns:a="http://schemas.openxmlformats.org/drawingml/2006/main">
               <a:ext uri="{FF2B5EF4-FFF2-40B4-BE49-F238E27FC236}">
-                <a16:creationId xmlns:a16="http://schemas.microsoft.com/office/drawing/2014/main" id="{DE22BE0C-07E4-404E-8839-B12F63F7E06E}"/>
+                <a16:creationId xmlns:a16="http://schemas.microsoft.com/office/drawing/2014/main" id="{35AFBC89-6F98-4EB9-8435-E216856E5599}"/>
               </a:ext>
             </a:extLst>
           </p:cNvPr>
@@ -13704,7 +13704,7 @@
           <p:cNvPr id="14" name="">
             <a:extLst xmlns:a="http://schemas.openxmlformats.org/drawingml/2006/main">
               <a:ext uri="{FF2B5EF4-FFF2-40B4-BE49-F238E27FC236}">
-                <a16:creationId xmlns:a16="http://schemas.microsoft.com/office/drawing/2014/main" id="{250C888C-B79A-4F59-97DE-84B2FE334F37}"/>
+                <a16:creationId xmlns:a16="http://schemas.microsoft.com/office/drawing/2014/main" id="{C56B723A-4E6C-433C-837E-BF2B981FC461}"/>
               </a:ext>
             </a:extLst>
           </p:cNvPr>
@@ -13734,7 +13734,7 @@
           <p:cNvPr id="15" name="">
             <a:extLst xmlns:a="http://schemas.openxmlformats.org/drawingml/2006/main">
               <a:ext uri="{FF2B5EF4-FFF2-40B4-BE49-F238E27FC236}">
-                <a16:creationId xmlns:a16="http://schemas.microsoft.com/office/drawing/2014/main" id="{AB2560A6-AE2E-4DA8-82B4-4D89E76F5BFE}"/>
+                <a16:creationId xmlns:a16="http://schemas.microsoft.com/office/drawing/2014/main" id="{45B6844B-1011-4B4A-8CF0-A4F706D7FD32}"/>
               </a:ext>
             </a:extLst>
           </p:cNvPr>
@@ -13793,7 +13793,7 @@
           <p:cNvPr id="16" name="">
             <a:extLst xmlns:a="http://schemas.openxmlformats.org/drawingml/2006/main">
               <a:ext uri="{FF2B5EF4-FFF2-40B4-BE49-F238E27FC236}">
-                <a16:creationId xmlns:a16="http://schemas.microsoft.com/office/drawing/2014/main" id="{8EA1CBCA-A1AA-4339-BBE0-6EB2201B0D53}"/>
+                <a16:creationId xmlns:a16="http://schemas.microsoft.com/office/drawing/2014/main" id="{56F15984-EB91-4FDD-9724-EB402D5524AC}"/>
               </a:ext>
             </a:extLst>
           </p:cNvPr>
@@ -13852,7 +13852,7 @@
           <p:cNvPr id="17" name="">
             <a:extLst xmlns:a="http://schemas.openxmlformats.org/drawingml/2006/main">
               <a:ext uri="{FF2B5EF4-FFF2-40B4-BE49-F238E27FC236}">
-                <a16:creationId xmlns:a16="http://schemas.microsoft.com/office/drawing/2014/main" id="{6BD91107-2309-4153-9579-896BF7E24F23}"/>
+                <a16:creationId xmlns:a16="http://schemas.microsoft.com/office/drawing/2014/main" id="{73D033FA-275B-4802-9638-567203369D68}"/>
               </a:ext>
             </a:extLst>
           </p:cNvPr>
@@ -13884,7 +13884,7 @@
           <p:cNvPr id="18" name="">
             <a:extLst xmlns:a="http://schemas.openxmlformats.org/drawingml/2006/main">
               <a:ext uri="{FF2B5EF4-FFF2-40B4-BE49-F238E27FC236}">
-                <a16:creationId xmlns:a16="http://schemas.microsoft.com/office/drawing/2014/main" id="{568DFD8D-E0CA-4D94-8AD8-888E51891C0C}"/>
+                <a16:creationId xmlns:a16="http://schemas.microsoft.com/office/drawing/2014/main" id="{D123823F-DE49-4BAD-86B4-C0020ED540AE}"/>
               </a:ext>
             </a:extLst>
           </p:cNvPr>
@@ -13914,7 +13914,7 @@
           <p:cNvPr id="19" name="">
             <a:extLst xmlns:a="http://schemas.openxmlformats.org/drawingml/2006/main">
               <a:ext uri="{FF2B5EF4-FFF2-40B4-BE49-F238E27FC236}">
-                <a16:creationId xmlns:a16="http://schemas.microsoft.com/office/drawing/2014/main" id="{E15B2A80-D9F7-48DB-9CF2-AF9136D6E664}"/>
+                <a16:creationId xmlns:a16="http://schemas.microsoft.com/office/drawing/2014/main" id="{43BDF121-B5AB-4B20-9A93-87D6638A19DD}"/>
               </a:ext>
             </a:extLst>
           </p:cNvPr>
@@ -13973,7 +13973,7 @@
           <p:cNvPr id="20" name="">
             <a:extLst xmlns:a="http://schemas.openxmlformats.org/drawingml/2006/main">
               <a:ext uri="{FF2B5EF4-FFF2-40B4-BE49-F238E27FC236}">
-                <a16:creationId xmlns:a16="http://schemas.microsoft.com/office/drawing/2014/main" id="{7B082445-276A-4B45-8EA3-5004A17FE6FC}"/>
+                <a16:creationId xmlns:a16="http://schemas.microsoft.com/office/drawing/2014/main" id="{4CA0BE2E-84CA-42AA-A2FC-FCAA301F593E}"/>
               </a:ext>
             </a:extLst>
           </p:cNvPr>
@@ -14032,7 +14032,7 @@
           <p:cNvPr id="21" name="">
             <a:extLst xmlns:a="http://schemas.openxmlformats.org/drawingml/2006/main">
               <a:ext uri="{FF2B5EF4-FFF2-40B4-BE49-F238E27FC236}">
-                <a16:creationId xmlns:a16="http://schemas.microsoft.com/office/drawing/2014/main" id="{04EECC10-D62A-4EDD-A047-B7321175AA4D}"/>
+                <a16:creationId xmlns:a16="http://schemas.microsoft.com/office/drawing/2014/main" id="{12A7013A-D341-4102-A537-880A7CD8A60A}"/>
               </a:ext>
             </a:extLst>
           </p:cNvPr>
@@ -14064,7 +14064,7 @@
           <p:cNvPr id="22" name="">
             <a:extLst xmlns:a="http://schemas.openxmlformats.org/drawingml/2006/main">
               <a:ext uri="{FF2B5EF4-FFF2-40B4-BE49-F238E27FC236}">
-                <a16:creationId xmlns:a16="http://schemas.microsoft.com/office/drawing/2014/main" id="{93C0A2E5-439A-4E7B-8D75-98C6DCDECB7A}"/>
+                <a16:creationId xmlns:a16="http://schemas.microsoft.com/office/drawing/2014/main" id="{C72A76E0-9554-4A98-B6BA-8DFEE1F01B0C}"/>
               </a:ext>
             </a:extLst>
           </p:cNvPr>
@@ -14094,7 +14094,7 @@
           <p:cNvPr id="23" name="">
             <a:extLst xmlns:a="http://schemas.openxmlformats.org/drawingml/2006/main">
               <a:ext uri="{FF2B5EF4-FFF2-40B4-BE49-F238E27FC236}">
-                <a16:creationId xmlns:a16="http://schemas.microsoft.com/office/drawing/2014/main" id="{83B8B70A-16E3-4C8C-A2A7-67BDBD04420D}"/>
+                <a16:creationId xmlns:a16="http://schemas.microsoft.com/office/drawing/2014/main" id="{53F7A7C4-9E71-429E-98A7-EE8AB76A8564}"/>
               </a:ext>
             </a:extLst>
           </p:cNvPr>
@@ -14153,7 +14153,7 @@
           <p:cNvPr id="24" name="">
             <a:extLst xmlns:a="http://schemas.openxmlformats.org/drawingml/2006/main">
               <a:ext uri="{FF2B5EF4-FFF2-40B4-BE49-F238E27FC236}">
-                <a16:creationId xmlns:a16="http://schemas.microsoft.com/office/drawing/2014/main" id="{036F8CDA-3B85-4C97-A7FF-575ADC008828}"/>
+                <a16:creationId xmlns:a16="http://schemas.microsoft.com/office/drawing/2014/main" id="{54710A7E-C102-4919-987D-25A264A574AB}"/>
               </a:ext>
             </a:extLst>
           </p:cNvPr>
@@ -14212,7 +14212,7 @@
           <p:cNvPr id="25" name="">
             <a:extLst xmlns:a="http://schemas.openxmlformats.org/drawingml/2006/main">
               <a:ext uri="{FF2B5EF4-FFF2-40B4-BE49-F238E27FC236}">
-                <a16:creationId xmlns:a16="http://schemas.microsoft.com/office/drawing/2014/main" id="{F02D46E7-60FE-4656-BDD9-3DF0C19EA840}"/>
+                <a16:creationId xmlns:a16="http://schemas.microsoft.com/office/drawing/2014/main" id="{79756804-F4C5-4325-B0DC-A4CB3F215BB3}"/>
               </a:ext>
             </a:extLst>
           </p:cNvPr>
@@ -14244,7 +14244,7 @@
           <p:cNvPr id="26" name="">
             <a:extLst xmlns:a="http://schemas.openxmlformats.org/drawingml/2006/main">
               <a:ext uri="{FF2B5EF4-FFF2-40B4-BE49-F238E27FC236}">
-                <a16:creationId xmlns:a16="http://schemas.microsoft.com/office/drawing/2014/main" id="{03C8278F-5044-412F-B484-1DFDC256E5E7}"/>
+                <a16:creationId xmlns:a16="http://schemas.microsoft.com/office/drawing/2014/main" id="{587377A7-E668-4731-9A3B-362E84BBDA23}"/>
               </a:ext>
             </a:extLst>
           </p:cNvPr>
@@ -14303,7 +14303,7 @@
           <p:cNvPr id="27" name="">
             <a:extLst xmlns:a="http://schemas.openxmlformats.org/drawingml/2006/main">
               <a:ext uri="{FF2B5EF4-FFF2-40B4-BE49-F238E27FC236}">
-                <a16:creationId xmlns:a16="http://schemas.microsoft.com/office/drawing/2014/main" id="{EA4E99FE-E19C-4E07-8AD1-38547C5463A3}"/>
+                <a16:creationId xmlns:a16="http://schemas.microsoft.com/office/drawing/2014/main" id="{9F20AF62-0BF9-4C30-9E24-BA1C991DBB61}"/>
               </a:ext>
             </a:extLst>
           </p:cNvPr>
@@ -14335,7 +14335,7 @@
           <p:cNvPr id="28" name="">
             <a:extLst xmlns:a="http://schemas.openxmlformats.org/drawingml/2006/main">
               <a:ext uri="{FF2B5EF4-FFF2-40B4-BE49-F238E27FC236}">
-                <a16:creationId xmlns:a16="http://schemas.microsoft.com/office/drawing/2014/main" id="{3729EC91-9075-4993-AD66-D0633AD5212A}"/>
+                <a16:creationId xmlns:a16="http://schemas.microsoft.com/office/drawing/2014/main" id="{156D3B5E-E6CF-4371-B20D-67DA4B31E9EE}"/>
               </a:ext>
             </a:extLst>
           </p:cNvPr>
@@ -14394,7 +14394,7 @@
           <p:cNvPr id="29" name="">
             <a:extLst xmlns:a="http://schemas.openxmlformats.org/drawingml/2006/main">
               <a:ext uri="{FF2B5EF4-FFF2-40B4-BE49-F238E27FC236}">
-                <a16:creationId xmlns:a16="http://schemas.microsoft.com/office/drawing/2014/main" id="{E1F224E9-C049-4193-9F2C-9AC63951AB71}"/>
+                <a16:creationId xmlns:a16="http://schemas.microsoft.com/office/drawing/2014/main" id="{1F27FCAF-500A-4932-AC7E-2A78428BE321}"/>
               </a:ext>
             </a:extLst>
           </p:cNvPr>
@@ -14426,7 +14426,7 @@
           <p:cNvPr id="30" name="">
             <a:extLst xmlns:a="http://schemas.openxmlformats.org/drawingml/2006/main">
               <a:ext uri="{FF2B5EF4-FFF2-40B4-BE49-F238E27FC236}">
-                <a16:creationId xmlns:a16="http://schemas.microsoft.com/office/drawing/2014/main" id="{40038B83-2C12-462F-82FE-ED689AC23FBE}"/>
+                <a16:creationId xmlns:a16="http://schemas.microsoft.com/office/drawing/2014/main" id="{F60AEB31-48E0-477D-BB10-D27CEB0DE3B0}"/>
               </a:ext>
             </a:extLst>
           </p:cNvPr>
@@ -14485,7 +14485,7 @@
           <p:cNvPr id="31" name="">
             <a:extLst xmlns:a="http://schemas.openxmlformats.org/drawingml/2006/main">
               <a:ext uri="{FF2B5EF4-FFF2-40B4-BE49-F238E27FC236}">
-                <a16:creationId xmlns:a16="http://schemas.microsoft.com/office/drawing/2014/main" id="{F13AF3E4-E333-42F0-B7F0-EA958DCFF5EB}"/>
+                <a16:creationId xmlns:a16="http://schemas.microsoft.com/office/drawing/2014/main" id="{3D207036-B3DD-4220-90E3-D067B47A1D2D}"/>
               </a:ext>
             </a:extLst>
           </p:cNvPr>
@@ -14517,7 +14517,7 @@
           <p:cNvPr id="32" name="">
             <a:extLst xmlns:a="http://schemas.openxmlformats.org/drawingml/2006/main">
               <a:ext uri="{FF2B5EF4-FFF2-40B4-BE49-F238E27FC236}">
-                <a16:creationId xmlns:a16="http://schemas.microsoft.com/office/drawing/2014/main" id="{A9189C9A-CDCB-4A76-BB72-3D8DE889771A}"/>
+                <a16:creationId xmlns:a16="http://schemas.microsoft.com/office/drawing/2014/main" id="{9A44B77A-6852-4D77-ABDF-16B78BE12FB7}"/>
               </a:ext>
             </a:extLst>
           </p:cNvPr>
@@ -14574,7 +14574,7 @@
     </p:spTree>
     <p:extLst>
       <p:ext uri="{BB962C8B-B14F-4D97-AF65-F5344CB8AC3E}">
-        <p14:creationId xmlns:p14="http://schemas.microsoft.com/office/powerpoint/2010/main" val="1029189049"/>
+        <p14:creationId xmlns:p14="http://schemas.microsoft.com/office/powerpoint/2010/main" val="647946975"/>
       </p:ext>
     </p:extLst>
   </p:cSld>
@@ -14598,7 +14598,7 @@
           <p:cNvPr id="1" name="">
             <a:extLst xmlns:a="http://schemas.openxmlformats.org/drawingml/2006/main">
               <a:ext uri="{FF2B5EF4-FFF2-40B4-BE49-F238E27FC236}">
-                <a16:creationId xmlns:a16="http://schemas.microsoft.com/office/drawing/2014/main" id="{38C76B2D-0363-47D8-9050-AF3AE4215FCD}"/>
+                <a16:creationId xmlns:a16="http://schemas.microsoft.com/office/drawing/2014/main" id="{6D963BB3-49B4-49B3-9DD5-E592658048F0}"/>
               </a:ext>
             </a:extLst>
           </p:cNvPr>
@@ -14628,7 +14628,7 @@
           <p:cNvPr id="2" name="">
             <a:extLst xmlns:a="http://schemas.openxmlformats.org/drawingml/2006/main">
               <a:ext uri="{FF2B5EF4-FFF2-40B4-BE49-F238E27FC236}">
-                <a16:creationId xmlns:a16="http://schemas.microsoft.com/office/drawing/2014/main" id="{380695FB-8CF6-42E2-BFBE-4BC6FADC309B}"/>
+                <a16:creationId xmlns:a16="http://schemas.microsoft.com/office/drawing/2014/main" id="{06887530-4B3C-47F2-AFEF-636664DE2708}"/>
               </a:ext>
             </a:extLst>
           </p:cNvPr>
@@ -14658,7 +14658,7 @@
           <p:cNvPr id="3" name="">
             <a:extLst xmlns:a="http://schemas.openxmlformats.org/drawingml/2006/main">
               <a:ext uri="{FF2B5EF4-FFF2-40B4-BE49-F238E27FC236}">
-                <a16:creationId xmlns:a16="http://schemas.microsoft.com/office/drawing/2014/main" id="{3379189B-A34F-46BE-A853-796A57B06483}"/>
+                <a16:creationId xmlns:a16="http://schemas.microsoft.com/office/drawing/2014/main" id="{7FE17643-9FCD-44A4-B6C9-08A9A5B42855}"/>
               </a:ext>
             </a:extLst>
           </p:cNvPr>
@@ -14717,7 +14717,7 @@
           <p:cNvPr id="4" name="">
             <a:extLst xmlns:a="http://schemas.openxmlformats.org/drawingml/2006/main">
               <a:ext uri="{FF2B5EF4-FFF2-40B4-BE49-F238E27FC236}">
-                <a16:creationId xmlns:a16="http://schemas.microsoft.com/office/drawing/2014/main" id="{213C4A84-604D-46F9-B4CE-C988FC55A5F0}"/>
+                <a16:creationId xmlns:a16="http://schemas.microsoft.com/office/drawing/2014/main" id="{9743F1B7-4084-4967-B6A3-430F20E2126F}"/>
               </a:ext>
             </a:extLst>
           </p:cNvPr>
@@ -14776,7 +14776,7 @@
           <p:cNvPr id="5" name="">
             <a:extLst xmlns:a="http://schemas.openxmlformats.org/drawingml/2006/main">
               <a:ext uri="{FF2B5EF4-FFF2-40B4-BE49-F238E27FC236}">
-                <a16:creationId xmlns:a16="http://schemas.microsoft.com/office/drawing/2014/main" id="{0FF39C6C-FFED-4C2F-816F-2FB7B575775F}"/>
+                <a16:creationId xmlns:a16="http://schemas.microsoft.com/office/drawing/2014/main" id="{6F1854F9-9A08-47EC-AC0B-A78DFAFD3E30}"/>
               </a:ext>
             </a:extLst>
           </p:cNvPr>
@@ -14835,7 +14835,7 @@
           <p:cNvPr id="6" name="">
             <a:extLst xmlns:a="http://schemas.openxmlformats.org/drawingml/2006/main">
               <a:ext uri="{FF2B5EF4-FFF2-40B4-BE49-F238E27FC236}">
-                <a16:creationId xmlns:a16="http://schemas.microsoft.com/office/drawing/2014/main" id="{6315DC62-826F-48D6-A14D-0F4B430F2632}"/>
+                <a16:creationId xmlns:a16="http://schemas.microsoft.com/office/drawing/2014/main" id="{5F117F94-7D40-47D1-A545-A49E188D31DB}"/>
               </a:ext>
             </a:extLst>
           </p:cNvPr>
@@ -14898,7 +14898,7 @@
           <p:nvPr/>
         </p:nvPicPr>
         <p:blipFill>
-          <a:blip xmlns:r="http://schemas.openxmlformats.org/officeDocument/2006/relationships" xmlns:a="http://schemas.openxmlformats.org/drawingml/2006/main" r:embed="Rbf45841091324c30"/>
+          <a:blip xmlns:r="http://schemas.openxmlformats.org/officeDocument/2006/relationships" xmlns:a="http://schemas.openxmlformats.org/drawingml/2006/main" r:embed="R840272d9b0e44eec"/>
           <a:srcRect xmlns:a="http://schemas.openxmlformats.org/drawingml/2006/main" l="0" t="1738" r="0" b="1738"/>
           <a:stretch xmlns:a="http://schemas.openxmlformats.org/drawingml/2006/main">
             <a:fillRect l="0" t="0" r="0" b="0"/>
@@ -14919,7 +14919,7 @@
           <p:cNvPr id="8" name="">
             <a:extLst xmlns:a="http://schemas.openxmlformats.org/drawingml/2006/main">
               <a:ext uri="{FF2B5EF4-FFF2-40B4-BE49-F238E27FC236}">
-                <a16:creationId xmlns:a16="http://schemas.microsoft.com/office/drawing/2014/main" id="{FFFE6028-2E0C-43BA-83FF-93CF1498FF23}"/>
+                <a16:creationId xmlns:a16="http://schemas.microsoft.com/office/drawing/2014/main" id="{DA28C0EF-98D5-4D7B-81CA-0F489359C416}"/>
               </a:ext>
             </a:extLst>
           </p:cNvPr>
@@ -14951,7 +14951,7 @@
           <p:cNvPr id="9" name="">
             <a:extLst xmlns:a="http://schemas.openxmlformats.org/drawingml/2006/main">
               <a:ext uri="{FF2B5EF4-FFF2-40B4-BE49-F238E27FC236}">
-                <a16:creationId xmlns:a16="http://schemas.microsoft.com/office/drawing/2014/main" id="{2B670B9C-85B0-4CAC-802E-386DD9B4426D}"/>
+                <a16:creationId xmlns:a16="http://schemas.microsoft.com/office/drawing/2014/main" id="{FC17BA0A-42EA-4EF2-82D9-4505D7DDE8C7}"/>
               </a:ext>
             </a:extLst>
           </p:cNvPr>
@@ -14985,7 +14985,7 @@
           <p:cNvPr id="10" name="">
             <a:extLst xmlns:a="http://schemas.openxmlformats.org/drawingml/2006/main">
               <a:ext uri="{FF2B5EF4-FFF2-40B4-BE49-F238E27FC236}">
-                <a16:creationId xmlns:a16="http://schemas.microsoft.com/office/drawing/2014/main" id="{389DCC84-D713-44D4-9A6C-C04FC92433E9}"/>
+                <a16:creationId xmlns:a16="http://schemas.microsoft.com/office/drawing/2014/main" id="{08BF7920-B5C6-41F3-898B-281C9E020D08}"/>
               </a:ext>
             </a:extLst>
           </p:cNvPr>
@@ -15017,7 +15017,7 @@
           <p:cNvPr id="11" name="">
             <a:extLst xmlns:a="http://schemas.openxmlformats.org/drawingml/2006/main">
               <a:ext uri="{FF2B5EF4-FFF2-40B4-BE49-F238E27FC236}">
-                <a16:creationId xmlns:a16="http://schemas.microsoft.com/office/drawing/2014/main" id="{CC41CB53-FB8C-4842-879D-559EA0D44180}"/>
+                <a16:creationId xmlns:a16="http://schemas.microsoft.com/office/drawing/2014/main" id="{5CEF40F8-2002-4AC9-9053-FE28A14B41FF}"/>
               </a:ext>
             </a:extLst>
           </p:cNvPr>
@@ -15047,7 +15047,7 @@
           <p:cNvPr id="12" name="">
             <a:extLst xmlns:a="http://schemas.openxmlformats.org/drawingml/2006/main">
               <a:ext uri="{FF2B5EF4-FFF2-40B4-BE49-F238E27FC236}">
-                <a16:creationId xmlns:a16="http://schemas.microsoft.com/office/drawing/2014/main" id="{5249FF4B-E80E-47FB-B7F6-CD7EA2444F0E}"/>
+                <a16:creationId xmlns:a16="http://schemas.microsoft.com/office/drawing/2014/main" id="{7B038D2D-4330-47A3-ADBB-31A18887344F}"/>
               </a:ext>
             </a:extLst>
           </p:cNvPr>
@@ -15106,7 +15106,7 @@
           <p:cNvPr id="13" name="">
             <a:extLst xmlns:a="http://schemas.openxmlformats.org/drawingml/2006/main">
               <a:ext uri="{FF2B5EF4-FFF2-40B4-BE49-F238E27FC236}">
-                <a16:creationId xmlns:a16="http://schemas.microsoft.com/office/drawing/2014/main" id="{1496845A-9F7F-4BA1-999E-D62C1B325640}"/>
+                <a16:creationId xmlns:a16="http://schemas.microsoft.com/office/drawing/2014/main" id="{DBCAD01F-5E09-47A8-A302-BD855CFCF990}"/>
               </a:ext>
             </a:extLst>
           </p:cNvPr>
@@ -15165,7 +15165,7 @@
           <p:cNvPr id="14" name="">
             <a:extLst xmlns:a="http://schemas.openxmlformats.org/drawingml/2006/main">
               <a:ext uri="{FF2B5EF4-FFF2-40B4-BE49-F238E27FC236}">
-                <a16:creationId xmlns:a16="http://schemas.microsoft.com/office/drawing/2014/main" id="{26BCB31A-4A62-4476-874B-D0CC3C56A829}"/>
+                <a16:creationId xmlns:a16="http://schemas.microsoft.com/office/drawing/2014/main" id="{83D7032F-5366-4301-A341-64952B8486E6}"/>
               </a:ext>
             </a:extLst>
           </p:cNvPr>
@@ -15197,7 +15197,7 @@
           <p:cNvPr id="15" name="">
             <a:extLst xmlns:a="http://schemas.openxmlformats.org/drawingml/2006/main">
               <a:ext uri="{FF2B5EF4-FFF2-40B4-BE49-F238E27FC236}">
-                <a16:creationId xmlns:a16="http://schemas.microsoft.com/office/drawing/2014/main" id="{7873F959-D5A0-4C20-B121-1CAA107779A0}"/>
+                <a16:creationId xmlns:a16="http://schemas.microsoft.com/office/drawing/2014/main" id="{283B2FEA-65A5-45F2-9E67-48A8F1AC571B}"/>
               </a:ext>
             </a:extLst>
           </p:cNvPr>
@@ -15227,7 +15227,7 @@
           <p:cNvPr id="16" name="">
             <a:extLst xmlns:a="http://schemas.openxmlformats.org/drawingml/2006/main">
               <a:ext uri="{FF2B5EF4-FFF2-40B4-BE49-F238E27FC236}">
-                <a16:creationId xmlns:a16="http://schemas.microsoft.com/office/drawing/2014/main" id="{61037E21-0705-4C7D-9417-707B8148ABAD}"/>
+                <a16:creationId xmlns:a16="http://schemas.microsoft.com/office/drawing/2014/main" id="{06631296-1EA2-4CC5-B3D8-1AA198A4EACA}"/>
               </a:ext>
             </a:extLst>
           </p:cNvPr>
@@ -15286,7 +15286,7 @@
           <p:cNvPr id="17" name="">
             <a:extLst xmlns:a="http://schemas.openxmlformats.org/drawingml/2006/main">
               <a:ext uri="{FF2B5EF4-FFF2-40B4-BE49-F238E27FC236}">
-                <a16:creationId xmlns:a16="http://schemas.microsoft.com/office/drawing/2014/main" id="{E0F6D775-FC1D-4651-8E78-A4190413BD11}"/>
+                <a16:creationId xmlns:a16="http://schemas.microsoft.com/office/drawing/2014/main" id="{2348C8C1-00C1-43FE-9D19-B681EFF0D014}"/>
               </a:ext>
             </a:extLst>
           </p:cNvPr>
@@ -15345,7 +15345,7 @@
           <p:cNvPr id="18" name="">
             <a:extLst xmlns:a="http://schemas.openxmlformats.org/drawingml/2006/main">
               <a:ext uri="{FF2B5EF4-FFF2-40B4-BE49-F238E27FC236}">
-                <a16:creationId xmlns:a16="http://schemas.microsoft.com/office/drawing/2014/main" id="{7F504005-1189-45C2-B7F8-2681D72A6F90}"/>
+                <a16:creationId xmlns:a16="http://schemas.microsoft.com/office/drawing/2014/main" id="{46E96E2D-3A3F-4D57-AE07-90D61F9B13CB}"/>
               </a:ext>
             </a:extLst>
           </p:cNvPr>
@@ -15377,7 +15377,7 @@
           <p:cNvPr id="19" name="">
             <a:extLst xmlns:a="http://schemas.openxmlformats.org/drawingml/2006/main">
               <a:ext uri="{FF2B5EF4-FFF2-40B4-BE49-F238E27FC236}">
-                <a16:creationId xmlns:a16="http://schemas.microsoft.com/office/drawing/2014/main" id="{D0A22DD4-AC88-4EF3-8BE7-FC35154BF459}"/>
+                <a16:creationId xmlns:a16="http://schemas.microsoft.com/office/drawing/2014/main" id="{85C7F41A-D7BF-47CC-B48C-A4E22F36FD18}"/>
               </a:ext>
             </a:extLst>
           </p:cNvPr>
@@ -15407,7 +15407,7 @@
           <p:cNvPr id="20" name="">
             <a:extLst xmlns:a="http://schemas.openxmlformats.org/drawingml/2006/main">
               <a:ext uri="{FF2B5EF4-FFF2-40B4-BE49-F238E27FC236}">
-                <a16:creationId xmlns:a16="http://schemas.microsoft.com/office/drawing/2014/main" id="{EFA3E9FB-35EF-41A2-B5F8-E8D135AD883C}"/>
+                <a16:creationId xmlns:a16="http://schemas.microsoft.com/office/drawing/2014/main" id="{9C12D938-122F-46D3-A89E-688317CBB317}"/>
               </a:ext>
             </a:extLst>
           </p:cNvPr>
@@ -15466,7 +15466,7 @@
           <p:cNvPr id="21" name="">
             <a:extLst xmlns:a="http://schemas.openxmlformats.org/drawingml/2006/main">
               <a:ext uri="{FF2B5EF4-FFF2-40B4-BE49-F238E27FC236}">
-                <a16:creationId xmlns:a16="http://schemas.microsoft.com/office/drawing/2014/main" id="{0B08B83E-6897-41ED-8F08-B93CA560CE0B}"/>
+                <a16:creationId xmlns:a16="http://schemas.microsoft.com/office/drawing/2014/main" id="{2A9C2609-FDFC-4D5F-B779-5538CC944A80}"/>
               </a:ext>
             </a:extLst>
           </p:cNvPr>
@@ -15525,7 +15525,7 @@
           <p:cNvPr id="22" name="">
             <a:extLst xmlns:a="http://schemas.openxmlformats.org/drawingml/2006/main">
               <a:ext uri="{FF2B5EF4-FFF2-40B4-BE49-F238E27FC236}">
-                <a16:creationId xmlns:a16="http://schemas.microsoft.com/office/drawing/2014/main" id="{A6764F1F-0919-4F29-9350-3988AD97B5A5}"/>
+                <a16:creationId xmlns:a16="http://schemas.microsoft.com/office/drawing/2014/main" id="{9DB1C7DD-7F6E-44BB-A0D1-03D3B282A681}"/>
               </a:ext>
             </a:extLst>
           </p:cNvPr>
@@ -15557,7 +15557,7 @@
           <p:cNvPr id="23" name="">
             <a:extLst xmlns:a="http://schemas.openxmlformats.org/drawingml/2006/main">
               <a:ext uri="{FF2B5EF4-FFF2-40B4-BE49-F238E27FC236}">
-                <a16:creationId xmlns:a16="http://schemas.microsoft.com/office/drawing/2014/main" id="{B5F56476-AAAB-42A7-85F8-A165325086AD}"/>
+                <a16:creationId xmlns:a16="http://schemas.microsoft.com/office/drawing/2014/main" id="{EBEA6943-E059-4548-AADF-CA9F175A30C5}"/>
               </a:ext>
             </a:extLst>
           </p:cNvPr>
@@ -15587,7 +15587,7 @@
           <p:cNvPr id="24" name="">
             <a:extLst xmlns:a="http://schemas.openxmlformats.org/drawingml/2006/main">
               <a:ext uri="{FF2B5EF4-FFF2-40B4-BE49-F238E27FC236}">
-                <a16:creationId xmlns:a16="http://schemas.microsoft.com/office/drawing/2014/main" id="{74742B0E-81DE-44F8-9CF6-A73FD2890983}"/>
+                <a16:creationId xmlns:a16="http://schemas.microsoft.com/office/drawing/2014/main" id="{8945A7F3-F040-4BD9-A905-7122A12EA465}"/>
               </a:ext>
             </a:extLst>
           </p:cNvPr>
@@ -15646,7 +15646,7 @@
           <p:cNvPr id="25" name="">
             <a:extLst xmlns:a="http://schemas.openxmlformats.org/drawingml/2006/main">
               <a:ext uri="{FF2B5EF4-FFF2-40B4-BE49-F238E27FC236}">
-                <a16:creationId xmlns:a16="http://schemas.microsoft.com/office/drawing/2014/main" id="{397C7B8C-CDCC-4CE8-AFF8-645A71B97F3D}"/>
+                <a16:creationId xmlns:a16="http://schemas.microsoft.com/office/drawing/2014/main" id="{6CE1CA38-0FC8-43DD-8843-BB77ADCA919A}"/>
               </a:ext>
             </a:extLst>
           </p:cNvPr>
@@ -15705,7 +15705,7 @@
           <p:cNvPr id="26" name="">
             <a:extLst xmlns:a="http://schemas.openxmlformats.org/drawingml/2006/main">
               <a:ext uri="{FF2B5EF4-FFF2-40B4-BE49-F238E27FC236}">
-                <a16:creationId xmlns:a16="http://schemas.microsoft.com/office/drawing/2014/main" id="{4BC168F6-A7B4-4A57-AF1A-E70CDFA68026}"/>
+                <a16:creationId xmlns:a16="http://schemas.microsoft.com/office/drawing/2014/main" id="{E7270391-08D0-479B-86D0-7214901594CD}"/>
               </a:ext>
             </a:extLst>
           </p:cNvPr>
@@ -15737,7 +15737,7 @@
           <p:cNvPr id="27" name="">
             <a:extLst xmlns:a="http://schemas.openxmlformats.org/drawingml/2006/main">
               <a:ext uri="{FF2B5EF4-FFF2-40B4-BE49-F238E27FC236}">
-                <a16:creationId xmlns:a16="http://schemas.microsoft.com/office/drawing/2014/main" id="{4FE80E17-026B-4687-BD54-A37ED9516B9C}"/>
+                <a16:creationId xmlns:a16="http://schemas.microsoft.com/office/drawing/2014/main" id="{C7C34063-972A-45FB-8715-CD28DA268E38}"/>
               </a:ext>
             </a:extLst>
           </p:cNvPr>
@@ -15794,7 +15794,7 @@
     </p:spTree>
     <p:extLst>
       <p:ext uri="{BB962C8B-B14F-4D97-AF65-F5344CB8AC3E}">
-        <p14:creationId xmlns:p14="http://schemas.microsoft.com/office/powerpoint/2010/main" val="1491759993"/>
+        <p14:creationId xmlns:p14="http://schemas.microsoft.com/office/powerpoint/2010/main" val="248330171"/>
       </p:ext>
     </p:extLst>
   </p:cSld>
@@ -15818,7 +15818,7 @@
           <p:cNvPr id="1" name="">
             <a:extLst xmlns:a="http://schemas.openxmlformats.org/drawingml/2006/main">
               <a:ext uri="{FF2B5EF4-FFF2-40B4-BE49-F238E27FC236}">
-                <a16:creationId xmlns:a16="http://schemas.microsoft.com/office/drawing/2014/main" id="{416B166F-4754-4BFB-8DB1-882786582947}"/>
+                <a16:creationId xmlns:a16="http://schemas.microsoft.com/office/drawing/2014/main" id="{2EAC5025-43C6-470E-91E1-DECAD7BF788D}"/>
               </a:ext>
             </a:extLst>
           </p:cNvPr>
@@ -15848,7 +15848,7 @@
           <p:cNvPr id="2" name="">
             <a:extLst xmlns:a="http://schemas.openxmlformats.org/drawingml/2006/main">
               <a:ext uri="{FF2B5EF4-FFF2-40B4-BE49-F238E27FC236}">
-                <a16:creationId xmlns:a16="http://schemas.microsoft.com/office/drawing/2014/main" id="{287B447B-BFC5-4D03-8F92-85A65C8F2F22}"/>
+                <a16:creationId xmlns:a16="http://schemas.microsoft.com/office/drawing/2014/main" id="{C7F5BAED-3D17-49CA-B234-49DCB7ED86C6}"/>
               </a:ext>
             </a:extLst>
           </p:cNvPr>
@@ -15878,7 +15878,7 @@
           <p:cNvPr id="3" name="">
             <a:extLst xmlns:a="http://schemas.openxmlformats.org/drawingml/2006/main">
               <a:ext uri="{FF2B5EF4-FFF2-40B4-BE49-F238E27FC236}">
-                <a16:creationId xmlns:a16="http://schemas.microsoft.com/office/drawing/2014/main" id="{D698C82B-330A-42EE-BAFC-8B975211A5E4}"/>
+                <a16:creationId xmlns:a16="http://schemas.microsoft.com/office/drawing/2014/main" id="{82CBD9E2-D3C7-431D-A7AF-9E2206B4DCF2}"/>
               </a:ext>
             </a:extLst>
           </p:cNvPr>
@@ -15937,7 +15937,7 @@
           <p:cNvPr id="4" name="">
             <a:extLst xmlns:a="http://schemas.openxmlformats.org/drawingml/2006/main">
               <a:ext uri="{FF2B5EF4-FFF2-40B4-BE49-F238E27FC236}">
-                <a16:creationId xmlns:a16="http://schemas.microsoft.com/office/drawing/2014/main" id="{73BCC154-808E-43A1-AB6E-CB67CBA9C6F8}"/>
+                <a16:creationId xmlns:a16="http://schemas.microsoft.com/office/drawing/2014/main" id="{28FF4606-E0B9-4E43-9972-681A409FE240}"/>
               </a:ext>
             </a:extLst>
           </p:cNvPr>
@@ -15996,7 +15996,7 @@
           <p:cNvPr id="5" name="">
             <a:extLst xmlns:a="http://schemas.openxmlformats.org/drawingml/2006/main">
               <a:ext uri="{FF2B5EF4-FFF2-40B4-BE49-F238E27FC236}">
-                <a16:creationId xmlns:a16="http://schemas.microsoft.com/office/drawing/2014/main" id="{949C908F-2C8E-4368-9E5B-520910CDDF0D}"/>
+                <a16:creationId xmlns:a16="http://schemas.microsoft.com/office/drawing/2014/main" id="{72772E22-97A9-41A7-85E4-BDD5B4D94204}"/>
               </a:ext>
             </a:extLst>
           </p:cNvPr>
@@ -16055,7 +16055,7 @@
           <p:cNvPr id="6" name="">
             <a:extLst xmlns:a="http://schemas.openxmlformats.org/drawingml/2006/main">
               <a:ext uri="{FF2B5EF4-FFF2-40B4-BE49-F238E27FC236}">
-                <a16:creationId xmlns:a16="http://schemas.microsoft.com/office/drawing/2014/main" id="{74757386-8C35-4C3F-8706-1D6FD25FFAA4}"/>
+                <a16:creationId xmlns:a16="http://schemas.microsoft.com/office/drawing/2014/main" id="{B67A45D0-7AFF-4264-A871-77E8E1CE91DD}"/>
               </a:ext>
             </a:extLst>
           </p:cNvPr>
@@ -16118,7 +16118,7 @@
           <p:nvPr/>
         </p:nvPicPr>
         <p:blipFill>
-          <a:blip xmlns:r="http://schemas.openxmlformats.org/officeDocument/2006/relationships" xmlns:a="http://schemas.openxmlformats.org/drawingml/2006/main" r:embed="R65abe3070cf94655"/>
+          <a:blip xmlns:r="http://schemas.openxmlformats.org/officeDocument/2006/relationships" xmlns:a="http://schemas.openxmlformats.org/drawingml/2006/main" r:embed="R484298a6c655447b"/>
           <a:srcRect xmlns:a="http://schemas.openxmlformats.org/drawingml/2006/main" l="0" t="1435" r="0" b="1435"/>
           <a:stretch xmlns:a="http://schemas.openxmlformats.org/drawingml/2006/main">
             <a:fillRect l="0" t="0" r="0" b="0"/>
@@ -16139,7 +16139,7 @@
           <p:cNvPr id="8" name="">
             <a:extLst xmlns:a="http://schemas.openxmlformats.org/drawingml/2006/main">
               <a:ext uri="{FF2B5EF4-FFF2-40B4-BE49-F238E27FC236}">
-                <a16:creationId xmlns:a16="http://schemas.microsoft.com/office/drawing/2014/main" id="{B5887948-DB62-4AB1-A805-7EFE064FFFD6}"/>
+                <a16:creationId xmlns:a16="http://schemas.microsoft.com/office/drawing/2014/main" id="{01263047-3635-43A0-85B3-01C2B9A0C420}"/>
               </a:ext>
             </a:extLst>
           </p:cNvPr>
@@ -16171,7 +16171,7 @@
           <p:cNvPr id="9" name="">
             <a:extLst xmlns:a="http://schemas.openxmlformats.org/drawingml/2006/main">
               <a:ext uri="{FF2B5EF4-FFF2-40B4-BE49-F238E27FC236}">
-                <a16:creationId xmlns:a16="http://schemas.microsoft.com/office/drawing/2014/main" id="{654F1F08-1CBA-456F-A782-A373B8FF94C6}"/>
+                <a16:creationId xmlns:a16="http://schemas.microsoft.com/office/drawing/2014/main" id="{D31D624B-223F-458A-8B5D-3467EE468CA1}"/>
               </a:ext>
             </a:extLst>
           </p:cNvPr>
@@ -16205,7 +16205,7 @@
           <p:cNvPr id="10" name="">
             <a:extLst xmlns:a="http://schemas.openxmlformats.org/drawingml/2006/main">
               <a:ext uri="{FF2B5EF4-FFF2-40B4-BE49-F238E27FC236}">
-                <a16:creationId xmlns:a16="http://schemas.microsoft.com/office/drawing/2014/main" id="{C1F98F3E-4C81-4EC1-8C1F-28AA67F4733A}"/>
+                <a16:creationId xmlns:a16="http://schemas.microsoft.com/office/drawing/2014/main" id="{801C023E-3470-49E4-9D06-A3D65A612F58}"/>
               </a:ext>
             </a:extLst>
           </p:cNvPr>
@@ -16235,7 +16235,7 @@
           <p:cNvPr id="11" name="">
             <a:extLst xmlns:a="http://schemas.openxmlformats.org/drawingml/2006/main">
               <a:ext uri="{FF2B5EF4-FFF2-40B4-BE49-F238E27FC236}">
-                <a16:creationId xmlns:a16="http://schemas.microsoft.com/office/drawing/2014/main" id="{341DC21A-B6B5-4A13-873A-2370F083B55D}"/>
+                <a16:creationId xmlns:a16="http://schemas.microsoft.com/office/drawing/2014/main" id="{04BFDB75-5414-4A32-BCC5-E818A5924FAF}"/>
               </a:ext>
             </a:extLst>
           </p:cNvPr>
@@ -16265,7 +16265,7 @@
           <p:cNvPr id="12" name="">
             <a:extLst xmlns:a="http://schemas.openxmlformats.org/drawingml/2006/main">
               <a:ext uri="{FF2B5EF4-FFF2-40B4-BE49-F238E27FC236}">
-                <a16:creationId xmlns:a16="http://schemas.microsoft.com/office/drawing/2014/main" id="{800D608B-042C-4171-ADF1-67AA552E926E}"/>
+                <a16:creationId xmlns:a16="http://schemas.microsoft.com/office/drawing/2014/main" id="{A24BF2BE-20CE-4EC3-9FEB-EBA34AAF99B7}"/>
               </a:ext>
             </a:extLst>
           </p:cNvPr>
@@ -16324,7 +16324,7 @@
           <p:cNvPr id="13" name="">
             <a:extLst xmlns:a="http://schemas.openxmlformats.org/drawingml/2006/main">
               <a:ext uri="{FF2B5EF4-FFF2-40B4-BE49-F238E27FC236}">
-                <a16:creationId xmlns:a16="http://schemas.microsoft.com/office/drawing/2014/main" id="{4EF5B75E-1A4D-4D5E-8EE5-D65EEB95CE53}"/>
+                <a16:creationId xmlns:a16="http://schemas.microsoft.com/office/drawing/2014/main" id="{68177998-64C5-4AAB-901F-79C5B43C7D7D}"/>
               </a:ext>
             </a:extLst>
           </p:cNvPr>
@@ -16356,7 +16356,7 @@
           <p:cNvPr id="14" name="">
             <a:extLst xmlns:a="http://schemas.openxmlformats.org/drawingml/2006/main">
               <a:ext uri="{FF2B5EF4-FFF2-40B4-BE49-F238E27FC236}">
-                <a16:creationId xmlns:a16="http://schemas.microsoft.com/office/drawing/2014/main" id="{25795040-B4F9-4D93-9D90-96063B8BFF02}"/>
+                <a16:creationId xmlns:a16="http://schemas.microsoft.com/office/drawing/2014/main" id="{02C97774-E1E4-4364-B8F9-2A72461D9368}"/>
               </a:ext>
             </a:extLst>
           </p:cNvPr>
@@ -16415,7 +16415,7 @@
           <p:cNvPr id="15" name="">
             <a:extLst xmlns:a="http://schemas.openxmlformats.org/drawingml/2006/main">
               <a:ext uri="{FF2B5EF4-FFF2-40B4-BE49-F238E27FC236}">
-                <a16:creationId xmlns:a16="http://schemas.microsoft.com/office/drawing/2014/main" id="{69CFB475-AE7E-4EAC-B376-1E03D0B37EE2}"/>
+                <a16:creationId xmlns:a16="http://schemas.microsoft.com/office/drawing/2014/main" id="{0ACFB102-869E-45A2-8CBA-7ADB16EFE5D8}"/>
               </a:ext>
             </a:extLst>
           </p:cNvPr>
@@ -16474,7 +16474,7 @@
           <p:cNvPr id="16" name="">
             <a:extLst xmlns:a="http://schemas.openxmlformats.org/drawingml/2006/main">
               <a:ext uri="{FF2B5EF4-FFF2-40B4-BE49-F238E27FC236}">
-                <a16:creationId xmlns:a16="http://schemas.microsoft.com/office/drawing/2014/main" id="{CC7B3212-5098-4E81-B8B8-710C6682601F}"/>
+                <a16:creationId xmlns:a16="http://schemas.microsoft.com/office/drawing/2014/main" id="{94CA187B-F9D1-4F3C-ADE0-FAAE4DDFDABB}"/>
               </a:ext>
             </a:extLst>
           </p:cNvPr>
@@ -16506,7 +16506,7 @@
           <p:cNvPr id="17" name="">
             <a:extLst xmlns:a="http://schemas.openxmlformats.org/drawingml/2006/main">
               <a:ext uri="{FF2B5EF4-FFF2-40B4-BE49-F238E27FC236}">
-                <a16:creationId xmlns:a16="http://schemas.microsoft.com/office/drawing/2014/main" id="{E568D2E9-4A18-4FAC-A687-25C530D5CF4A}"/>
+                <a16:creationId xmlns:a16="http://schemas.microsoft.com/office/drawing/2014/main" id="{495F8D4F-4F42-4896-89B0-2DC4DCF8E7FF}"/>
               </a:ext>
             </a:extLst>
           </p:cNvPr>
@@ -16565,7 +16565,7 @@
           <p:cNvPr id="18" name="">
             <a:extLst xmlns:a="http://schemas.openxmlformats.org/drawingml/2006/main">
               <a:ext uri="{FF2B5EF4-FFF2-40B4-BE49-F238E27FC236}">
-                <a16:creationId xmlns:a16="http://schemas.microsoft.com/office/drawing/2014/main" id="{12EE83B8-148D-4AF2-96A6-9FFA20A2975A}"/>
+                <a16:creationId xmlns:a16="http://schemas.microsoft.com/office/drawing/2014/main" id="{CCBCD4C5-FAA6-432E-AB94-F147152236B8}"/>
               </a:ext>
             </a:extLst>
           </p:cNvPr>
@@ -16624,7 +16624,7 @@
           <p:cNvPr id="19" name="">
             <a:extLst xmlns:a="http://schemas.openxmlformats.org/drawingml/2006/main">
               <a:ext uri="{FF2B5EF4-FFF2-40B4-BE49-F238E27FC236}">
-                <a16:creationId xmlns:a16="http://schemas.microsoft.com/office/drawing/2014/main" id="{7BEEF06C-334F-4C9F-ABD3-74E984CC0784}"/>
+                <a16:creationId xmlns:a16="http://schemas.microsoft.com/office/drawing/2014/main" id="{22D514D8-B62B-42A6-99B3-751B2D2EFDBD}"/>
               </a:ext>
             </a:extLst>
           </p:cNvPr>
@@ -16656,7 +16656,7 @@
           <p:cNvPr id="20" name="">
             <a:extLst xmlns:a="http://schemas.openxmlformats.org/drawingml/2006/main">
               <a:ext uri="{FF2B5EF4-FFF2-40B4-BE49-F238E27FC236}">
-                <a16:creationId xmlns:a16="http://schemas.microsoft.com/office/drawing/2014/main" id="{E41A6A36-CD53-4613-8384-3D751094CF35}"/>
+                <a16:creationId xmlns:a16="http://schemas.microsoft.com/office/drawing/2014/main" id="{77202A64-20BB-4CD1-86A6-C4D5AD6540BF}"/>
               </a:ext>
             </a:extLst>
           </p:cNvPr>
@@ -16715,7 +16715,7 @@
           <p:cNvPr id="21" name="">
             <a:extLst xmlns:a="http://schemas.openxmlformats.org/drawingml/2006/main">
               <a:ext uri="{FF2B5EF4-FFF2-40B4-BE49-F238E27FC236}">
-                <a16:creationId xmlns:a16="http://schemas.microsoft.com/office/drawing/2014/main" id="{7642C7FA-C2E5-4B79-87DB-7991926B30BE}"/>
+                <a16:creationId xmlns:a16="http://schemas.microsoft.com/office/drawing/2014/main" id="{290CE2DA-AB5F-4A07-9B38-FF0246F0B1F4}"/>
               </a:ext>
             </a:extLst>
           </p:cNvPr>
@@ -16774,7 +16774,7 @@
           <p:cNvPr id="22" name="">
             <a:extLst xmlns:a="http://schemas.openxmlformats.org/drawingml/2006/main">
               <a:ext uri="{FF2B5EF4-FFF2-40B4-BE49-F238E27FC236}">
-                <a16:creationId xmlns:a16="http://schemas.microsoft.com/office/drawing/2014/main" id="{05FE3691-062E-46AB-95FB-51F20E1BE9BE}"/>
+                <a16:creationId xmlns:a16="http://schemas.microsoft.com/office/drawing/2014/main" id="{C481434F-1238-4EB0-9E9C-EF344DF0C1FF}"/>
               </a:ext>
             </a:extLst>
           </p:cNvPr>
@@ -16806,7 +16806,7 @@
           <p:cNvPr id="23" name="">
             <a:extLst xmlns:a="http://schemas.openxmlformats.org/drawingml/2006/main">
               <a:ext uri="{FF2B5EF4-FFF2-40B4-BE49-F238E27FC236}">
-                <a16:creationId xmlns:a16="http://schemas.microsoft.com/office/drawing/2014/main" id="{9098F091-17C9-49A1-8260-5557A22DDC83}"/>
+                <a16:creationId xmlns:a16="http://schemas.microsoft.com/office/drawing/2014/main" id="{8332F424-ABF6-4891-85B3-24AD7707505C}"/>
               </a:ext>
             </a:extLst>
           </p:cNvPr>
@@ -16865,7 +16865,7 @@
           <p:cNvPr id="24" name="">
             <a:extLst xmlns:a="http://schemas.openxmlformats.org/drawingml/2006/main">
               <a:ext uri="{FF2B5EF4-FFF2-40B4-BE49-F238E27FC236}">
-                <a16:creationId xmlns:a16="http://schemas.microsoft.com/office/drawing/2014/main" id="{CF31BF2D-E1DA-4D12-BFA8-1C394364381F}"/>
+                <a16:creationId xmlns:a16="http://schemas.microsoft.com/office/drawing/2014/main" id="{1A8CC04E-4173-4AAF-8C0C-424CB5617ECE}"/>
               </a:ext>
             </a:extLst>
           </p:cNvPr>
@@ -16922,7 +16922,7 @@
     </p:spTree>
     <p:extLst>
       <p:ext uri="{BB962C8B-B14F-4D97-AF65-F5344CB8AC3E}">
-        <p14:creationId xmlns:p14="http://schemas.microsoft.com/office/powerpoint/2010/main" val="1654347277"/>
+        <p14:creationId xmlns:p14="http://schemas.microsoft.com/office/powerpoint/2010/main" val="2058152613"/>
       </p:ext>
     </p:extLst>
   </p:cSld>
@@ -16946,7 +16946,7 @@
           <p:cNvPr id="1" name="">
             <a:extLst xmlns:a="http://schemas.openxmlformats.org/drawingml/2006/main">
               <a:ext uri="{FF2B5EF4-FFF2-40B4-BE49-F238E27FC236}">
-                <a16:creationId xmlns:a16="http://schemas.microsoft.com/office/drawing/2014/main" id="{83AB1EC9-2650-49B6-B825-EBAC86E8AB1F}"/>
+                <a16:creationId xmlns:a16="http://schemas.microsoft.com/office/drawing/2014/main" id="{E0B43FF4-6193-49D5-9D25-2FC8A4305CEF}"/>
               </a:ext>
             </a:extLst>
           </p:cNvPr>
@@ -16976,7 +16976,7 @@
           <p:cNvPr id="2" name="">
             <a:extLst xmlns:a="http://schemas.openxmlformats.org/drawingml/2006/main">
               <a:ext uri="{FF2B5EF4-FFF2-40B4-BE49-F238E27FC236}">
-                <a16:creationId xmlns:a16="http://schemas.microsoft.com/office/drawing/2014/main" id="{6CCFF7ED-7981-4F79-9EFC-D39121C7BC18}"/>
+                <a16:creationId xmlns:a16="http://schemas.microsoft.com/office/drawing/2014/main" id="{59073D71-EAFD-4C54-9072-8D6559155F5D}"/>
               </a:ext>
             </a:extLst>
           </p:cNvPr>
@@ -17006,7 +17006,7 @@
           <p:cNvPr id="3" name="">
             <a:extLst xmlns:a="http://schemas.openxmlformats.org/drawingml/2006/main">
               <a:ext uri="{FF2B5EF4-FFF2-40B4-BE49-F238E27FC236}">
-                <a16:creationId xmlns:a16="http://schemas.microsoft.com/office/drawing/2014/main" id="{31F7B3BD-A578-4E77-BF3F-FDFE0BD9673F}"/>
+                <a16:creationId xmlns:a16="http://schemas.microsoft.com/office/drawing/2014/main" id="{5AF419E1-8EFC-4906-9DB3-072C02EB1BA9}"/>
               </a:ext>
             </a:extLst>
           </p:cNvPr>
@@ -17065,7 +17065,7 @@
           <p:cNvPr id="4" name="">
             <a:extLst xmlns:a="http://schemas.openxmlformats.org/drawingml/2006/main">
               <a:ext uri="{FF2B5EF4-FFF2-40B4-BE49-F238E27FC236}">
-                <a16:creationId xmlns:a16="http://schemas.microsoft.com/office/drawing/2014/main" id="{B1C4EC2F-7520-4182-BB66-26E76E62C296}"/>
+                <a16:creationId xmlns:a16="http://schemas.microsoft.com/office/drawing/2014/main" id="{98F121F6-7FAF-4EBF-91DD-370C5E9729A0}"/>
               </a:ext>
             </a:extLst>
           </p:cNvPr>
@@ -17124,7 +17124,7 @@
           <p:cNvPr id="5" name="">
             <a:extLst xmlns:a="http://schemas.openxmlformats.org/drawingml/2006/main">
               <a:ext uri="{FF2B5EF4-FFF2-40B4-BE49-F238E27FC236}">
-                <a16:creationId xmlns:a16="http://schemas.microsoft.com/office/drawing/2014/main" id="{BA20CC1F-5805-42C3-9B8F-48B0C53CC692}"/>
+                <a16:creationId xmlns:a16="http://schemas.microsoft.com/office/drawing/2014/main" id="{89E06A49-450A-42CA-9EF8-8EA25883E78E}"/>
               </a:ext>
             </a:extLst>
           </p:cNvPr>
@@ -17183,7 +17183,7 @@
           <p:cNvPr id="6" name="">
             <a:extLst xmlns:a="http://schemas.openxmlformats.org/drawingml/2006/main">
               <a:ext uri="{FF2B5EF4-FFF2-40B4-BE49-F238E27FC236}">
-                <a16:creationId xmlns:a16="http://schemas.microsoft.com/office/drawing/2014/main" id="{DDFADEEB-D15D-4180-B81B-21AB51692335}"/>
+                <a16:creationId xmlns:a16="http://schemas.microsoft.com/office/drawing/2014/main" id="{23B7A83D-6B5F-49CA-A830-301957614992}"/>
               </a:ext>
             </a:extLst>
           </p:cNvPr>
@@ -17246,7 +17246,7 @@
           <p:nvPr/>
         </p:nvPicPr>
         <p:blipFill>
-          <a:blip xmlns:r="http://schemas.openxmlformats.org/officeDocument/2006/relationships" xmlns:a="http://schemas.openxmlformats.org/drawingml/2006/main" r:embed="Rce55846775464057"/>
+          <a:blip xmlns:r="http://schemas.openxmlformats.org/officeDocument/2006/relationships" xmlns:a="http://schemas.openxmlformats.org/drawingml/2006/main" r:embed="Re6c493c95dfc4469"/>
           <a:srcRect xmlns:a="http://schemas.openxmlformats.org/drawingml/2006/main" l="0" t="282" r="0" b="282"/>
           <a:stretch xmlns:a="http://schemas.openxmlformats.org/drawingml/2006/main">
             <a:fillRect l="0" t="0" r="0" b="0"/>
@@ -17267,7 +17267,7 @@
           <p:cNvPr id="8" name="">
             <a:extLst xmlns:a="http://schemas.openxmlformats.org/drawingml/2006/main">
               <a:ext uri="{FF2B5EF4-FFF2-40B4-BE49-F238E27FC236}">
-                <a16:creationId xmlns:a16="http://schemas.microsoft.com/office/drawing/2014/main" id="{EDC95FBB-CCF7-4E67-8FC9-8C8617B22BB9}"/>
+                <a16:creationId xmlns:a16="http://schemas.microsoft.com/office/drawing/2014/main" id="{8FFD7464-E904-4597-883C-572319A11B56}"/>
               </a:ext>
             </a:extLst>
           </p:cNvPr>
@@ -17299,7 +17299,7 @@
           <p:cNvPr id="9" name="">
             <a:extLst xmlns:a="http://schemas.openxmlformats.org/drawingml/2006/main">
               <a:ext uri="{FF2B5EF4-FFF2-40B4-BE49-F238E27FC236}">
-                <a16:creationId xmlns:a16="http://schemas.microsoft.com/office/drawing/2014/main" id="{0E3B032D-62E6-49D1-B1D2-C1ED6D7C1523}"/>
+                <a16:creationId xmlns:a16="http://schemas.microsoft.com/office/drawing/2014/main" id="{6E8196F7-23FD-4723-A23E-876A3DF0A15A}"/>
               </a:ext>
             </a:extLst>
           </p:cNvPr>
@@ -17333,7 +17333,7 @@
           <p:cNvPr id="10" name="">
             <a:extLst xmlns:a="http://schemas.openxmlformats.org/drawingml/2006/main">
               <a:ext uri="{FF2B5EF4-FFF2-40B4-BE49-F238E27FC236}">
-                <a16:creationId xmlns:a16="http://schemas.microsoft.com/office/drawing/2014/main" id="{518FBA20-B2B9-4F53-AC67-FE80436093EA}"/>
+                <a16:creationId xmlns:a16="http://schemas.microsoft.com/office/drawing/2014/main" id="{B7901296-00FE-45C8-865B-8BA356CE6C29}"/>
               </a:ext>
             </a:extLst>
           </p:cNvPr>
@@ -17363,7 +17363,7 @@
           <p:cNvPr id="11" name="">
             <a:extLst xmlns:a="http://schemas.openxmlformats.org/drawingml/2006/main">
               <a:ext uri="{FF2B5EF4-FFF2-40B4-BE49-F238E27FC236}">
-                <a16:creationId xmlns:a16="http://schemas.microsoft.com/office/drawing/2014/main" id="{4A05070B-3BEE-499F-B427-33744843FDBA}"/>
+                <a16:creationId xmlns:a16="http://schemas.microsoft.com/office/drawing/2014/main" id="{19E47725-61D7-4507-8D6B-7781DCC8510C}"/>
               </a:ext>
             </a:extLst>
           </p:cNvPr>
@@ -17393,7 +17393,7 @@
           <p:cNvPr id="12" name="">
             <a:extLst xmlns:a="http://schemas.openxmlformats.org/drawingml/2006/main">
               <a:ext uri="{FF2B5EF4-FFF2-40B4-BE49-F238E27FC236}">
-                <a16:creationId xmlns:a16="http://schemas.microsoft.com/office/drawing/2014/main" id="{8D3B7A63-BA86-4A6C-8477-76B5E195FEB5}"/>
+                <a16:creationId xmlns:a16="http://schemas.microsoft.com/office/drawing/2014/main" id="{308D2EE6-AB8D-4A0D-8D7B-8B52B3BBEB0B}"/>
               </a:ext>
             </a:extLst>
           </p:cNvPr>
@@ -17452,7 +17452,7 @@
           <p:cNvPr id="13" name="">
             <a:extLst xmlns:a="http://schemas.openxmlformats.org/drawingml/2006/main">
               <a:ext uri="{FF2B5EF4-FFF2-40B4-BE49-F238E27FC236}">
-                <a16:creationId xmlns:a16="http://schemas.microsoft.com/office/drawing/2014/main" id="{351E90EA-C1E8-4FA5-9271-E8D75F861F68}"/>
+                <a16:creationId xmlns:a16="http://schemas.microsoft.com/office/drawing/2014/main" id="{3ADF7624-EB0F-46C8-B47D-3677BE10C9DB}"/>
               </a:ext>
             </a:extLst>
           </p:cNvPr>
@@ -17484,7 +17484,7 @@
           <p:cNvPr id="14" name="">
             <a:extLst xmlns:a="http://schemas.openxmlformats.org/drawingml/2006/main">
               <a:ext uri="{FF2B5EF4-FFF2-40B4-BE49-F238E27FC236}">
-                <a16:creationId xmlns:a16="http://schemas.microsoft.com/office/drawing/2014/main" id="{FEF69A1A-613E-42D1-835B-52DEE1B6DCB0}"/>
+                <a16:creationId xmlns:a16="http://schemas.microsoft.com/office/drawing/2014/main" id="{00DEFF7C-527D-4438-B58D-9F080A9B779B}"/>
               </a:ext>
             </a:extLst>
           </p:cNvPr>
@@ -17514,7 +17514,7 @@
           <p:cNvPr id="15" name="">
             <a:extLst xmlns:a="http://schemas.openxmlformats.org/drawingml/2006/main">
               <a:ext uri="{FF2B5EF4-FFF2-40B4-BE49-F238E27FC236}">
-                <a16:creationId xmlns:a16="http://schemas.microsoft.com/office/drawing/2014/main" id="{F9044062-0853-4568-A490-DAA432646C54}"/>
+                <a16:creationId xmlns:a16="http://schemas.microsoft.com/office/drawing/2014/main" id="{420E3524-7E5D-427A-B59F-A628C6E3211F}"/>
               </a:ext>
             </a:extLst>
           </p:cNvPr>
@@ -17573,7 +17573,7 @@
           <p:cNvPr id="16" name="">
             <a:extLst xmlns:a="http://schemas.openxmlformats.org/drawingml/2006/main">
               <a:ext uri="{FF2B5EF4-FFF2-40B4-BE49-F238E27FC236}">
-                <a16:creationId xmlns:a16="http://schemas.microsoft.com/office/drawing/2014/main" id="{88BD42B3-087D-4A3E-AF90-D1D934818D59}"/>
+                <a16:creationId xmlns:a16="http://schemas.microsoft.com/office/drawing/2014/main" id="{38414B8A-9E6D-45C8-8BDD-4D0305D02E88}"/>
               </a:ext>
             </a:extLst>
           </p:cNvPr>
@@ -17632,7 +17632,7 @@
           <p:cNvPr id="17" name="">
             <a:extLst xmlns:a="http://schemas.openxmlformats.org/drawingml/2006/main">
               <a:ext uri="{FF2B5EF4-FFF2-40B4-BE49-F238E27FC236}">
-                <a16:creationId xmlns:a16="http://schemas.microsoft.com/office/drawing/2014/main" id="{C4113A1C-A98A-4519-A1E3-E580412DD8CD}"/>
+                <a16:creationId xmlns:a16="http://schemas.microsoft.com/office/drawing/2014/main" id="{7C25FA63-1671-494E-97DB-1A9477ADBDD8}"/>
               </a:ext>
             </a:extLst>
           </p:cNvPr>
@@ -17664,7 +17664,7 @@
           <p:cNvPr id="18" name="">
             <a:extLst xmlns:a="http://schemas.openxmlformats.org/drawingml/2006/main">
               <a:ext uri="{FF2B5EF4-FFF2-40B4-BE49-F238E27FC236}">
-                <a16:creationId xmlns:a16="http://schemas.microsoft.com/office/drawing/2014/main" id="{04DF91F4-6D65-45FB-B106-F2054FF87431}"/>
+                <a16:creationId xmlns:a16="http://schemas.microsoft.com/office/drawing/2014/main" id="{C630DE43-99E8-47EF-BEB9-316C981D9FF2}"/>
               </a:ext>
             </a:extLst>
           </p:cNvPr>
@@ -17694,7 +17694,7 @@
           <p:cNvPr id="19" name="">
             <a:extLst xmlns:a="http://schemas.openxmlformats.org/drawingml/2006/main">
               <a:ext uri="{FF2B5EF4-FFF2-40B4-BE49-F238E27FC236}">
-                <a16:creationId xmlns:a16="http://schemas.microsoft.com/office/drawing/2014/main" id="{5FF6187C-7C02-4AE2-B76D-012897CDD92D}"/>
+                <a16:creationId xmlns:a16="http://schemas.microsoft.com/office/drawing/2014/main" id="{BD640025-D53E-4021-9310-0ABAAC04909D}"/>
               </a:ext>
             </a:extLst>
           </p:cNvPr>
@@ -17753,7 +17753,7 @@
           <p:cNvPr id="20" name="">
             <a:extLst xmlns:a="http://schemas.openxmlformats.org/drawingml/2006/main">
               <a:ext uri="{FF2B5EF4-FFF2-40B4-BE49-F238E27FC236}">
-                <a16:creationId xmlns:a16="http://schemas.microsoft.com/office/drawing/2014/main" id="{ADF9A8D3-BBFB-4C0C-9DBD-5657F20973F1}"/>
+                <a16:creationId xmlns:a16="http://schemas.microsoft.com/office/drawing/2014/main" id="{A86CAE02-2953-4873-B5B1-4A6F6ACD8B5C}"/>
               </a:ext>
             </a:extLst>
           </p:cNvPr>
@@ -17812,7 +17812,7 @@
           <p:cNvPr id="21" name="">
             <a:extLst xmlns:a="http://schemas.openxmlformats.org/drawingml/2006/main">
               <a:ext uri="{FF2B5EF4-FFF2-40B4-BE49-F238E27FC236}">
-                <a16:creationId xmlns:a16="http://schemas.microsoft.com/office/drawing/2014/main" id="{17132F90-45B1-4A29-96E2-077E629E5D99}"/>
+                <a16:creationId xmlns:a16="http://schemas.microsoft.com/office/drawing/2014/main" id="{EEDC033A-3EB7-49AE-A324-C83BB9425509}"/>
               </a:ext>
             </a:extLst>
           </p:cNvPr>
@@ -17844,7 +17844,7 @@
           <p:cNvPr id="22" name="">
             <a:extLst xmlns:a="http://schemas.openxmlformats.org/drawingml/2006/main">
               <a:ext uri="{FF2B5EF4-FFF2-40B4-BE49-F238E27FC236}">
-                <a16:creationId xmlns:a16="http://schemas.microsoft.com/office/drawing/2014/main" id="{B158C943-FC09-44F9-BDBC-2E5D0B95B887}"/>
+                <a16:creationId xmlns:a16="http://schemas.microsoft.com/office/drawing/2014/main" id="{11E6292F-FF4C-4551-98A3-AA5234BA4BFF}"/>
               </a:ext>
             </a:extLst>
           </p:cNvPr>
@@ -17903,7 +17903,7 @@
           <p:cNvPr id="23" name="">
             <a:extLst xmlns:a="http://schemas.openxmlformats.org/drawingml/2006/main">
               <a:ext uri="{FF2B5EF4-FFF2-40B4-BE49-F238E27FC236}">
-                <a16:creationId xmlns:a16="http://schemas.microsoft.com/office/drawing/2014/main" id="{46C4CD4D-4DD4-4B6A-80AA-ACBE2DB21143}"/>
+                <a16:creationId xmlns:a16="http://schemas.microsoft.com/office/drawing/2014/main" id="{1F539023-72C1-4130-94E3-BF13400D0EE5}"/>
               </a:ext>
             </a:extLst>
           </p:cNvPr>
@@ -17935,7 +17935,7 @@
           <p:cNvPr id="24" name="">
             <a:extLst xmlns:a="http://schemas.openxmlformats.org/drawingml/2006/main">
               <a:ext uri="{FF2B5EF4-FFF2-40B4-BE49-F238E27FC236}">
-                <a16:creationId xmlns:a16="http://schemas.microsoft.com/office/drawing/2014/main" id="{08E336D8-FB86-4163-95ED-E4B05ACE6B60}"/>
+                <a16:creationId xmlns:a16="http://schemas.microsoft.com/office/drawing/2014/main" id="{82425B93-476E-4829-A233-F7516D236C89}"/>
               </a:ext>
             </a:extLst>
           </p:cNvPr>
@@ -17994,7 +17994,7 @@
           <p:cNvPr id="25" name="">
             <a:extLst xmlns:a="http://schemas.openxmlformats.org/drawingml/2006/main">
               <a:ext uri="{FF2B5EF4-FFF2-40B4-BE49-F238E27FC236}">
-                <a16:creationId xmlns:a16="http://schemas.microsoft.com/office/drawing/2014/main" id="{119D75E7-2169-4713-88CE-B28596E00E36}"/>
+                <a16:creationId xmlns:a16="http://schemas.microsoft.com/office/drawing/2014/main" id="{1F4F3A82-DAC6-4F94-AD3C-7A494971C80C}"/>
               </a:ext>
             </a:extLst>
           </p:cNvPr>
@@ -18026,7 +18026,7 @@
           <p:cNvPr id="26" name="">
             <a:extLst xmlns:a="http://schemas.openxmlformats.org/drawingml/2006/main">
               <a:ext uri="{FF2B5EF4-FFF2-40B4-BE49-F238E27FC236}">
-                <a16:creationId xmlns:a16="http://schemas.microsoft.com/office/drawing/2014/main" id="{7034C1F0-FF29-4516-9C8E-31DF5FE41BAE}"/>
+                <a16:creationId xmlns:a16="http://schemas.microsoft.com/office/drawing/2014/main" id="{48593053-F21E-4FC8-AB66-248A12FE1CE2}"/>
               </a:ext>
             </a:extLst>
           </p:cNvPr>
@@ -18085,7 +18085,7 @@
           <p:cNvPr id="27" name="">
             <a:extLst xmlns:a="http://schemas.openxmlformats.org/drawingml/2006/main">
               <a:ext uri="{FF2B5EF4-FFF2-40B4-BE49-F238E27FC236}">
-                <a16:creationId xmlns:a16="http://schemas.microsoft.com/office/drawing/2014/main" id="{42D511CB-514B-4547-B1E1-1DFD4395CE01}"/>
+                <a16:creationId xmlns:a16="http://schemas.microsoft.com/office/drawing/2014/main" id="{2FC4A0F4-040F-4E88-9C2E-2B5C3A9090AA}"/>
               </a:ext>
             </a:extLst>
           </p:cNvPr>
@@ -18117,7 +18117,7 @@
           <p:cNvPr id="28" name="">
             <a:extLst xmlns:a="http://schemas.openxmlformats.org/drawingml/2006/main">
               <a:ext uri="{FF2B5EF4-FFF2-40B4-BE49-F238E27FC236}">
-                <a16:creationId xmlns:a16="http://schemas.microsoft.com/office/drawing/2014/main" id="{B5875E74-284F-4474-9E2F-253AFC370D15}"/>
+                <a16:creationId xmlns:a16="http://schemas.microsoft.com/office/drawing/2014/main" id="{91591934-6354-431B-8DD0-34B9E628DE1F}"/>
               </a:ext>
             </a:extLst>
           </p:cNvPr>
@@ -18176,7 +18176,7 @@
           <p:cNvPr id="29" name="">
             <a:extLst xmlns:a="http://schemas.openxmlformats.org/drawingml/2006/main">
               <a:ext uri="{FF2B5EF4-FFF2-40B4-BE49-F238E27FC236}">
-                <a16:creationId xmlns:a16="http://schemas.microsoft.com/office/drawing/2014/main" id="{BCC6B335-90E0-4919-9AA3-F764C26FD204}"/>
+                <a16:creationId xmlns:a16="http://schemas.microsoft.com/office/drawing/2014/main" id="{7EC983B8-3EA1-45C8-90B0-F1A17AF9C94E}"/>
               </a:ext>
             </a:extLst>
           </p:cNvPr>
@@ -18208,7 +18208,7 @@
           <p:cNvPr id="30" name="">
             <a:extLst xmlns:a="http://schemas.openxmlformats.org/drawingml/2006/main">
               <a:ext uri="{FF2B5EF4-FFF2-40B4-BE49-F238E27FC236}">
-                <a16:creationId xmlns:a16="http://schemas.microsoft.com/office/drawing/2014/main" id="{03D4B967-0A65-4F9F-9E7D-753BE9432658}"/>
+                <a16:creationId xmlns:a16="http://schemas.microsoft.com/office/drawing/2014/main" id="{5354A997-B416-4545-8644-7207D5D16218}"/>
               </a:ext>
             </a:extLst>
           </p:cNvPr>
@@ -18267,7 +18267,7 @@
           <p:cNvPr id="31" name="">
             <a:extLst xmlns:a="http://schemas.openxmlformats.org/drawingml/2006/main">
               <a:ext uri="{FF2B5EF4-FFF2-40B4-BE49-F238E27FC236}">
-                <a16:creationId xmlns:a16="http://schemas.microsoft.com/office/drawing/2014/main" id="{058661E8-978F-42E5-AC50-D693FDFD5030}"/>
+                <a16:creationId xmlns:a16="http://schemas.microsoft.com/office/drawing/2014/main" id="{049CDDEE-EFFE-4136-9C07-8AE036BB73D3}"/>
               </a:ext>
             </a:extLst>
           </p:cNvPr>
@@ -18299,7 +18299,7 @@
           <p:cNvPr id="32" name="">
             <a:extLst xmlns:a="http://schemas.openxmlformats.org/drawingml/2006/main">
               <a:ext uri="{FF2B5EF4-FFF2-40B4-BE49-F238E27FC236}">
-                <a16:creationId xmlns:a16="http://schemas.microsoft.com/office/drawing/2014/main" id="{A6698B56-FBF9-4509-A172-B8D6B6F7FE9A}"/>
+                <a16:creationId xmlns:a16="http://schemas.microsoft.com/office/drawing/2014/main" id="{F5A9AFEF-96B7-44C7-AF59-3A9036C7D30E}"/>
               </a:ext>
             </a:extLst>
           </p:cNvPr>
@@ -18356,7 +18356,7 @@
     </p:spTree>
     <p:extLst>
       <p:ext uri="{BB962C8B-B14F-4D97-AF65-F5344CB8AC3E}">
-        <p14:creationId xmlns:p14="http://schemas.microsoft.com/office/powerpoint/2010/main" val="1151860221"/>
+        <p14:creationId xmlns:p14="http://schemas.microsoft.com/office/powerpoint/2010/main" val="1619641641"/>
       </p:ext>
     </p:extLst>
   </p:cSld>

</xml_diff>